<commit_message>
S6: July proj rev = confirmed FC (.8k/81%); S12: Kraken -> Committed
Co-Authored-By: Claude Opus 4.8 <noreply@anthropic.com>
</commit_message>
<xml_diff>
--- a/June_2026_NAM_MBR.pptx
+++ b/June_2026_NAM_MBR.pptx
@@ -8061,13 +8061,13 @@
                       <a:r>
                         <a:rPr lang="en-US" sz="1000" b="1" dirty="0">
                           <a:solidFill>
-                            <a:srgbClr val="FDCB6E"/>
+                            <a:srgbClr val="00B894"/>
                           </a:solidFill>
                           <a:latin typeface="Calibri" pitchFamily="34" charset="0"/>
                           <a:ea typeface="Calibri" pitchFamily="34" charset="-122"/>
                           <a:cs typeface="Calibri" pitchFamily="34" charset="-120"/>
                         </a:rPr>
-                        <a:t>Pending Sales Ops reopen</a:t>
+                        <a:t>Committed</a:t>
                       </a:r>
                       <a:endParaRPr lang="en-US" sz="1000" dirty="0">
                         <a:latin typeface="Calibri" charset="0"/>
@@ -10051,7 +10051,7 @@
                 <a:ea typeface="Calibri" pitchFamily="34" charset="-122"/>
                 <a:cs typeface="Calibri" pitchFamily="34" charset="-120"/>
               </a:rPr>
-              <a:t>July opens 197% weighted-covered with $18.8k already committed (81%) on the reduced $23.4k quota — coverage is not the risk. A no-anchor portfolio (largest weighted RLE $10k) converts on MEDDICC breadth; Upwork (85%, legal/DPA) is the strongest signal. Kraken pending Sales Ops; HubSpot|MCP moved to Aug.</a:t>
+              <a:t>July opens 197% weighted-covered with $18.8k already committed (81%) on the reduced $23.4k quota — coverage is not the risk. A no-anchor portfolio (largest weighted RLE $10k) converts on MEDDICC breadth; Upwork (85%, legal/DPA) is the strongest signal. HubSpot|MCP moved to Aug.</a:t>
             </a:r>
             <a:endParaRPr lang="en-US" sz="1050" dirty="0"/>
           </a:p>
@@ -20674,7 +20674,7 @@
                           <a:ea typeface="Calibri" pitchFamily="34" charset="-122"/>
                           <a:cs typeface="Calibri" pitchFamily="34" charset="-120"/>
                         </a:rPr>
-                        <a:t>$46.1k wtd</a:t>
+                        <a:t>$18.8k conf</a:t>
                       </a:r>
                       <a:endParaRPr lang="en-US" sz="1150" dirty="0">
                         <a:latin typeface="Calibri" charset="0"/>
@@ -20742,7 +20742,7 @@
                           <a:ea typeface="Calibri" pitchFamily="34" charset="-122"/>
                           <a:cs typeface="Calibri" pitchFamily="34" charset="-120"/>
                         </a:rPr>
-                        <a:t>197%</a:t>
+                        <a:t>81%</a:t>
                       </a:r>
                       <a:endParaRPr lang="en-US" sz="1150" dirty="0">
                         <a:latin typeface="Calibri" charset="0"/>
@@ -21653,7 +21653,7 @@
                 <a:ea typeface="Calibri" pitchFamily="34" charset="-122"/>
                 <a:cs typeface="Calibri" pitchFamily="34" charset="-120"/>
               </a:rPr>
-              <a:t>Jul over-covered on the reduced quota. Aug–Oct pace ~85% at the current ~$43k/mo pipe × 29% yield — the KAM book's expansion + renewals must close the ~15% gap (Sep–Oct carry seasonal upside; both strong in 2025).</a:t>
+              <a:t>Jul = confirmed FC ($18.8k, 81%) with weighted upside to $46.1k (197%). Aug–Oct pace ~85% at the current ~$43k/mo pipe × 29% yield — the KAM book's expansion + renewals must close the ~15% gap (Sep–Oct carry seasonal upside; both strong in 2025).</a:t>
             </a:r>
             <a:endParaRPr lang="en-US" sz="950" dirty="0"/>
           </a:p>

</xml_diff>

<commit_message>
S6 seasonal projection, S10 two-month ramp, drop Hawaiian + MEDDICC appendix
- S6: replaced the flat ~$40k Aug–Oct projection with a seasonally-adjusted
  one (Aug ~$42k/90%, Sep ~$58k/124%, Oct ~$62k/133%) — grounded in 2025,
  where Sep/Oct were the strongest months (~$63k each). H2 paces above quota.
- S10: reworked from a one-month plan into a two-month Jul→Aug KAM ramp
  (Month 1 learn & cover, Month 2 plan & drive).
- Removed the Hawaiian Airlines account-plan slide and the MEDDICC leave-behind
  appendix; renumbered coaching to slide 13. Deck is now 13 slides.

Co-Authored-By: Claude Opus 4.8 <noreply@anthropic.com>
</commit_message>
<xml_diff>
--- a/June_2026_NAM_MBR.pptx
+++ b/June_2026_NAM_MBR.pptx
@@ -18,11 +18,9 @@
     <p:sldId id="266" r:id="rId12"/>
     <p:sldId id="267" r:id="rId13"/>
     <p:sldId id="268" r:id="rId14"/>
-    <p:sldId id="269" r:id="rId15"/>
-    <p:sldId id="270" r:id="rId16"/>
   </p:sldIdLst>
   <p:notesMasterIdLst>
-    <p:notesMasterId r:id="rId17"/>
+    <p:notesMasterId r:id="rId15"/>
   </p:notesMasterIdLst>
   <p:sldSz cx="12192000" cy="6858000"/>
   <p:notesSz cx="6858000" cy="12192000"/>
@@ -892,182 +890,6 @@
             <a:fld id="{F7021451-1387-4CA6-816F-3879F97B5CBC}" type="slidenum">
               <a:rPr lang="en-US"/>
               <a:t>13</a:t>
-            </a:fld>
-            <a:endParaRPr lang="en-US"/>
-          </a:p>
-        </p:txBody>
-      </p:sp>
-    </p:spTree>
-    <p:extLst>
-      <p:ext uri="{BB962C8B-B14F-4D97-AF65-F5344CB8AC3E}">
-        <p14:creationId xmlns:p14="http://schemas.microsoft.com/office/powerpoint/2010/main" val="1024086991"/>
-      </p:ext>
-    </p:extLst>
-  </p:cSld>
-  <p:clrMapOvr>
-    <a:masterClrMapping/>
-  </p:clrMapOvr>
-</p:notes>
-</file>
-
-<file path=ppt/notesSlides/notesSlide14.xml><?xml version="1.0" encoding="utf-8"?>
-<p:notes xmlns:a="http://schemas.openxmlformats.org/drawingml/2006/main" xmlns:r="http://schemas.openxmlformats.org/officeDocument/2006/relationships" xmlns:p="http://schemas.openxmlformats.org/presentationml/2006/main">
-  <p:cSld>
-    <p:spTree>
-      <p:nvGrpSpPr>
-        <p:cNvPr id="1" name=""/>
-        <p:cNvGrpSpPr/>
-        <p:nvPr/>
-      </p:nvGrpSpPr>
-      <p:grpSpPr>
-        <a:xfrm>
-          <a:off x="0" y="0"/>
-          <a:ext cx="0" cy="0"/>
-          <a:chOff x="0" y="0"/>
-          <a:chExt cx="0" cy="0"/>
-        </a:xfrm>
-      </p:grpSpPr>
-      <p:sp>
-        <p:nvSpPr>
-          <p:cNvPr id="2" name="Slide Image Placeholder 1"/>
-          <p:cNvSpPr>
-            <a:spLocks noGrp="1" noRot="1" noChangeAspect="1"/>
-          </p:cNvSpPr>
-          <p:nvPr>
-            <p:ph type="sldImg"/>
-          </p:nvPr>
-        </p:nvSpPr>
-        <p:spPr/>
-      </p:sp>
-      <p:sp>
-        <p:nvSpPr>
-          <p:cNvPr id="3" name="Notes Placeholder 2"/>
-          <p:cNvSpPr>
-            <a:spLocks noGrp="1"/>
-          </p:cNvSpPr>
-          <p:nvPr>
-            <p:ph type="body" idx="1"/>
-          </p:nvPr>
-        </p:nvSpPr>
-        <p:spPr/>
-        <p:txBody>
-          <a:bodyPr/>
-          <a:lstStyle/>
-          <a:p>
-            <a:r>
-              <a:rPr lang="en-US" dirty="0"/>
-              <a:t/>
-            </a:r>
-            <a:endParaRPr lang="en-US" dirty="0"/>
-          </a:p>
-        </p:txBody>
-      </p:sp>
-      <p:sp>
-        <p:nvSpPr>
-          <p:cNvPr id="4" name="Slide Number Placeholder 3"/>
-          <p:cNvSpPr>
-            <a:spLocks noGrp="1"/>
-          </p:cNvSpPr>
-          <p:nvPr>
-            <p:ph type="sldNum" sz="quarter" idx="10"/>
-          </p:nvPr>
-        </p:nvSpPr>
-        <p:spPr/>
-        <p:txBody>
-          <a:bodyPr/>
-          <a:lstStyle/>
-          <a:p>
-            <a:fld id="{F7021451-1387-4CA6-816F-3879F97B5CBC}" type="slidenum">
-              <a:rPr lang="en-US"/>
-              <a:t>14</a:t>
-            </a:fld>
-            <a:endParaRPr lang="en-US"/>
-          </a:p>
-        </p:txBody>
-      </p:sp>
-    </p:spTree>
-    <p:extLst>
-      <p:ext uri="{BB962C8B-B14F-4D97-AF65-F5344CB8AC3E}">
-        <p14:creationId xmlns:p14="http://schemas.microsoft.com/office/powerpoint/2010/main" val="1024086991"/>
-      </p:ext>
-    </p:extLst>
-  </p:cSld>
-  <p:clrMapOvr>
-    <a:masterClrMapping/>
-  </p:clrMapOvr>
-</p:notes>
-</file>
-
-<file path=ppt/notesSlides/notesSlide15.xml><?xml version="1.0" encoding="utf-8"?>
-<p:notes xmlns:a="http://schemas.openxmlformats.org/drawingml/2006/main" xmlns:r="http://schemas.openxmlformats.org/officeDocument/2006/relationships" xmlns:p="http://schemas.openxmlformats.org/presentationml/2006/main">
-  <p:cSld>
-    <p:spTree>
-      <p:nvGrpSpPr>
-        <p:cNvPr id="1" name=""/>
-        <p:cNvGrpSpPr/>
-        <p:nvPr/>
-      </p:nvGrpSpPr>
-      <p:grpSpPr>
-        <a:xfrm>
-          <a:off x="0" y="0"/>
-          <a:ext cx="0" cy="0"/>
-          <a:chOff x="0" y="0"/>
-          <a:chExt cx="0" cy="0"/>
-        </a:xfrm>
-      </p:grpSpPr>
-      <p:sp>
-        <p:nvSpPr>
-          <p:cNvPr id="2" name="Slide Image Placeholder 1"/>
-          <p:cNvSpPr>
-            <a:spLocks noGrp="1" noRot="1" noChangeAspect="1"/>
-          </p:cNvSpPr>
-          <p:nvPr>
-            <p:ph type="sldImg"/>
-          </p:nvPr>
-        </p:nvSpPr>
-        <p:spPr/>
-      </p:sp>
-      <p:sp>
-        <p:nvSpPr>
-          <p:cNvPr id="3" name="Notes Placeholder 2"/>
-          <p:cNvSpPr>
-            <a:spLocks noGrp="1"/>
-          </p:cNvSpPr>
-          <p:nvPr>
-            <p:ph type="body" idx="1"/>
-          </p:nvPr>
-        </p:nvSpPr>
-        <p:spPr/>
-        <p:txBody>
-          <a:bodyPr/>
-          <a:lstStyle/>
-          <a:p>
-            <a:r>
-              <a:rPr lang="en-US" dirty="0"/>
-              <a:t/>
-            </a:r>
-            <a:endParaRPr lang="en-US" dirty="0"/>
-          </a:p>
-        </p:txBody>
-      </p:sp>
-      <p:sp>
-        <p:nvSpPr>
-          <p:cNvPr id="4" name="Slide Number Placeholder 3"/>
-          <p:cNvSpPr>
-            <a:spLocks noGrp="1"/>
-          </p:cNvSpPr>
-          <p:nvPr>
-            <p:ph type="sldNum" sz="quarter" idx="10"/>
-          </p:nvPr>
-        </p:nvSpPr>
-        <p:spPr/>
-        <p:txBody>
-          <a:bodyPr/>
-          <a:lstStyle/>
-          <a:p>
-            <a:fld id="{F7021451-1387-4CA6-816F-3879F97B5CBC}" type="slidenum">
-              <a:rPr lang="en-US"/>
-              <a:t>15</a:t>
             </a:fld>
             <a:endParaRPr lang="en-US"/>
           </a:p>
@@ -2512,7 +2334,7 @@
                 <a:ea typeface="Calibri" pitchFamily="34" charset="-122"/>
                 <a:cs typeface="Calibri" pitchFamily="34" charset="-120"/>
               </a:rPr>
-              <a:t>July KAM Activity Plan — Working the Book</a:t>
+              <a:t>KAM Ramp — Spread Across July &amp; August</a:t>
             </a:r>
             <a:endParaRPr lang="en-US" sz="2800" dirty="0"/>
           </a:p>
@@ -2543,7 +2365,7 @@
               <a:buNone/>
             </a:pPr>
             <a:r>
-              <a:rPr lang="en-US" sz="1100" dirty="0">
+              <a:rPr lang="en-US" sz="1250" dirty="0">
                 <a:solidFill>
                   <a:srgbClr val="8B8FA3"/>
                 </a:solidFill>
@@ -2551,1965 +2373,595 @@
                 <a:ea typeface="Calibri" pitchFamily="34" charset="-122"/>
                 <a:cs typeface="Calibri" pitchFamily="34" charset="-120"/>
               </a:rPr>
-              <a:t>The KAM motion replaces cold-outbound targets with book coverage. 22 working days in July (Jul 3 holiday). The measure this month is the Gold base mapped, planned, and touched — not dials.</a:t>
-            </a:r>
-            <a:endParaRPr lang="en-US" sz="1100" dirty="0"/>
+              <a:t>Covering ~145 accounts and building account plans is a two-month job, not one. Split the ramp: July to learn &amp; cover, August to plan &amp; drive. Book coverage is the metric — not dials.</a:t>
+            </a:r>
+            <a:endParaRPr lang="en-US" sz="1250" dirty="0"/>
           </a:p>
         </p:txBody>
       </p:sp>
-      <p:graphicFrame>
-        <p:nvGraphicFramePr>
-          <p:cNvPr id="11" name="Table 0"/>
-          <p:cNvGraphicFramePr>
-            <a:graphicFrameLocks noGrp="1"/>
-          </p:cNvGraphicFramePr>
-          <p:nvPr>
-            <p:extLst>
-              <p:ext uri="{D42A27DB-BD31-4B8C-83A1-F6EECF244321}">
-                <p14:modId xmlns:p14="http://schemas.microsoft.com/office/powerpoint/2010/main" val="1579011935"/>
-              </p:ext>
-            </p:extLst>
-          </p:nvPr>
-        </p:nvGraphicFramePr>
-        <p:xfrm>
-          <a:off x="365760" y="1645920"/>
-          <a:ext cx="11475720" cy="914400"/>
-        </p:xfrm>
-        <a:graphic>
-          <a:graphicData uri="http://schemas.openxmlformats.org/drawingml/2006/table">
-            <a:tbl>
-              <a:tblPr/>
-              <a:tblGrid>
-                <a:gridCol w="3108960"/>
-                <a:gridCol w="1371600"/>
-                <a:gridCol w="1463040"/>
-                <a:gridCol w="5532120"/>
-              </a:tblGrid>
-              <a:tr h="457200">
-                <a:tc>
-                  <a:txBody>
-                    <a:bodyPr/>
-                    <a:lstStyle/>
-                    <a:p>
-                      <a:pPr algn="l" indent="0" marL="0">
-                        <a:buNone/>
-                      </a:pPr>
-                      <a:r>
-                        <a:rPr lang="en-US" sz="1100" b="1" dirty="0">
-                          <a:solidFill>
-                            <a:srgbClr val="8B8FA3"/>
-                          </a:solidFill>
-                          <a:latin typeface="Calibri" pitchFamily="34" charset="0"/>
-                          <a:ea typeface="Calibri" pitchFamily="34" charset="-122"/>
-                          <a:cs typeface="Calibri" pitchFamily="34" charset="-120"/>
-                        </a:rPr>
-                        <a:t>KAM Activity</a:t>
-                      </a:r>
-                      <a:endParaRPr lang="en-US" sz="1100" dirty="0">
-                        <a:latin typeface="Calibri" charset="0"/>
-                        <a:ea typeface="Calibri" charset="0"/>
-                        <a:cs typeface="Calibri" charset="0"/>
-                      </a:endParaRPr>
-                    </a:p>
-                  </a:txBody>
-                  <a:tcPr marL="91440" marR="91440" marT="45720" marB="45720">
-                    <a:lnL w="6350" cap="flat" cmpd="sng" algn="ctr">
-                      <a:solidFill>
-                        <a:srgbClr val="2A2E3B"/>
-                      </a:solidFill>
-                      <a:prstDash val="solid"/>
-                      <a:round/>
-                      <a:headEnd type="none" w="med" len="med"/>
-                      <a:tailEnd type="none" w="med" len="med"/>
-                    </a:lnL>
-                    <a:lnR w="6350" cap="flat" cmpd="sng" algn="ctr">
-                      <a:solidFill>
-                        <a:srgbClr val="2A2E3B"/>
-                      </a:solidFill>
-                      <a:prstDash val="solid"/>
-                      <a:round/>
-                      <a:headEnd type="none" w="med" len="med"/>
-                      <a:tailEnd type="none" w="med" len="med"/>
-                    </a:lnR>
-                    <a:lnT w="6350" cap="flat" cmpd="sng" algn="ctr">
-                      <a:solidFill>
-                        <a:srgbClr val="2A2E3B"/>
-                      </a:solidFill>
-                      <a:prstDash val="solid"/>
-                      <a:round/>
-                      <a:headEnd type="none" w="med" len="med"/>
-                      <a:tailEnd type="none" w="med" len="med"/>
-                    </a:lnT>
-                    <a:lnB w="6350" cap="flat" cmpd="sng" algn="ctr">
-                      <a:solidFill>
-                        <a:srgbClr val="2A2E3B"/>
-                      </a:solidFill>
-                      <a:prstDash val="solid"/>
-                      <a:round/>
-                      <a:headEnd type="none" w="med" len="med"/>
-                      <a:tailEnd type="none" w="med" len="med"/>
-                    </a:lnB>
-                    <a:solidFill>
-                      <a:srgbClr val="222632"/>
-                    </a:solidFill>
-                  </a:tcPr>
-                </a:tc>
-                <a:tc>
-                  <a:txBody>
-                    <a:bodyPr/>
-                    <a:lstStyle/>
-                    <a:p>
-                      <a:pPr algn="r" indent="0" marL="0">
-                        <a:buNone/>
-                      </a:pPr>
-                      <a:r>
-                        <a:rPr lang="en-US" sz="1100" b="1" dirty="0">
-                          <a:solidFill>
-                            <a:srgbClr val="8B8FA3"/>
-                          </a:solidFill>
-                          <a:latin typeface="Calibri" pitchFamily="34" charset="0"/>
-                          <a:ea typeface="Calibri" pitchFamily="34" charset="-122"/>
-                          <a:cs typeface="Calibri" pitchFamily="34" charset="-120"/>
-                        </a:rPr>
-                        <a:t>Monthly</a:t>
-                      </a:r>
-                      <a:endParaRPr lang="en-US" sz="1100" dirty="0">
-                        <a:latin typeface="Calibri" charset="0"/>
-                        <a:ea typeface="Calibri" charset="0"/>
-                        <a:cs typeface="Calibri" charset="0"/>
-                      </a:endParaRPr>
-                    </a:p>
-                  </a:txBody>
-                  <a:tcPr marL="91440" marR="91440" marT="45720" marB="45720">
-                    <a:lnL w="6350" cap="flat" cmpd="sng" algn="ctr">
-                      <a:solidFill>
-                        <a:srgbClr val="2A2E3B"/>
-                      </a:solidFill>
-                      <a:prstDash val="solid"/>
-                      <a:round/>
-                      <a:headEnd type="none" w="med" len="med"/>
-                      <a:tailEnd type="none" w="med" len="med"/>
-                    </a:lnL>
-                    <a:lnR w="6350" cap="flat" cmpd="sng" algn="ctr">
-                      <a:solidFill>
-                        <a:srgbClr val="2A2E3B"/>
-                      </a:solidFill>
-                      <a:prstDash val="solid"/>
-                      <a:round/>
-                      <a:headEnd type="none" w="med" len="med"/>
-                      <a:tailEnd type="none" w="med" len="med"/>
-                    </a:lnR>
-                    <a:lnT w="6350" cap="flat" cmpd="sng" algn="ctr">
-                      <a:solidFill>
-                        <a:srgbClr val="2A2E3B"/>
-                      </a:solidFill>
-                      <a:prstDash val="solid"/>
-                      <a:round/>
-                      <a:headEnd type="none" w="med" len="med"/>
-                      <a:tailEnd type="none" w="med" len="med"/>
-                    </a:lnT>
-                    <a:lnB w="6350" cap="flat" cmpd="sng" algn="ctr">
-                      <a:solidFill>
-                        <a:srgbClr val="2A2E3B"/>
-                      </a:solidFill>
-                      <a:prstDash val="solid"/>
-                      <a:round/>
-                      <a:headEnd type="none" w="med" len="med"/>
-                      <a:tailEnd type="none" w="med" len="med"/>
-                    </a:lnB>
-                    <a:solidFill>
-                      <a:srgbClr val="222632"/>
-                    </a:solidFill>
-                  </a:tcPr>
-                </a:tc>
-                <a:tc>
-                  <a:txBody>
-                    <a:bodyPr/>
-                    <a:lstStyle/>
-                    <a:p>
-                      <a:pPr algn="r" indent="0" marL="0">
-                        <a:buNone/>
-                      </a:pPr>
-                      <a:r>
-                        <a:rPr lang="en-US" sz="1100" b="1" dirty="0">
-                          <a:solidFill>
-                            <a:srgbClr val="8B8FA3"/>
-                          </a:solidFill>
-                          <a:latin typeface="Calibri" pitchFamily="34" charset="0"/>
-                          <a:ea typeface="Calibri" pitchFamily="34" charset="-122"/>
-                          <a:cs typeface="Calibri" pitchFamily="34" charset="-120"/>
-                        </a:rPr>
-                        <a:t>Weekly (avg)</a:t>
-                      </a:r>
-                      <a:endParaRPr lang="en-US" sz="1100" dirty="0">
-                        <a:latin typeface="Calibri" charset="0"/>
-                        <a:ea typeface="Calibri" charset="0"/>
-                        <a:cs typeface="Calibri" charset="0"/>
-                      </a:endParaRPr>
-                    </a:p>
-                  </a:txBody>
-                  <a:tcPr marL="91440" marR="91440" marT="45720" marB="45720">
-                    <a:lnL w="6350" cap="flat" cmpd="sng" algn="ctr">
-                      <a:solidFill>
-                        <a:srgbClr val="2A2E3B"/>
-                      </a:solidFill>
-                      <a:prstDash val="solid"/>
-                      <a:round/>
-                      <a:headEnd type="none" w="med" len="med"/>
-                      <a:tailEnd type="none" w="med" len="med"/>
-                    </a:lnL>
-                    <a:lnR w="6350" cap="flat" cmpd="sng" algn="ctr">
-                      <a:solidFill>
-                        <a:srgbClr val="2A2E3B"/>
-                      </a:solidFill>
-                      <a:prstDash val="solid"/>
-                      <a:round/>
-                      <a:headEnd type="none" w="med" len="med"/>
-                      <a:tailEnd type="none" w="med" len="med"/>
-                    </a:lnR>
-                    <a:lnT w="6350" cap="flat" cmpd="sng" algn="ctr">
-                      <a:solidFill>
-                        <a:srgbClr val="2A2E3B"/>
-                      </a:solidFill>
-                      <a:prstDash val="solid"/>
-                      <a:round/>
-                      <a:headEnd type="none" w="med" len="med"/>
-                      <a:tailEnd type="none" w="med" len="med"/>
-                    </a:lnT>
-                    <a:lnB w="6350" cap="flat" cmpd="sng" algn="ctr">
-                      <a:solidFill>
-                        <a:srgbClr val="2A2E3B"/>
-                      </a:solidFill>
-                      <a:prstDash val="solid"/>
-                      <a:round/>
-                      <a:headEnd type="none" w="med" len="med"/>
-                      <a:tailEnd type="none" w="med" len="med"/>
-                    </a:lnB>
-                    <a:solidFill>
-                      <a:srgbClr val="222632"/>
-                    </a:solidFill>
-                  </a:tcPr>
-                </a:tc>
-                <a:tc>
-                  <a:txBody>
-                    <a:bodyPr/>
-                    <a:lstStyle/>
-                    <a:p>
-                      <a:pPr algn="l" indent="0" marL="0">
-                        <a:buNone/>
-                      </a:pPr>
-                      <a:r>
-                        <a:rPr lang="en-US" sz="1100" b="1" dirty="0">
-                          <a:solidFill>
-                            <a:srgbClr val="8B8FA3"/>
-                          </a:solidFill>
-                          <a:latin typeface="Calibri" pitchFamily="34" charset="0"/>
-                          <a:ea typeface="Calibri" pitchFamily="34" charset="-122"/>
-                          <a:cs typeface="Calibri" pitchFamily="34" charset="-120"/>
-                        </a:rPr>
-                        <a:t>Notes</a:t>
-                      </a:r>
-                      <a:endParaRPr lang="en-US" sz="1100" dirty="0">
-                        <a:latin typeface="Calibri" charset="0"/>
-                        <a:ea typeface="Calibri" charset="0"/>
-                        <a:cs typeface="Calibri" charset="0"/>
-                      </a:endParaRPr>
-                    </a:p>
-                  </a:txBody>
-                  <a:tcPr marL="91440" marR="91440" marT="45720" marB="45720">
-                    <a:lnL w="6350" cap="flat" cmpd="sng" algn="ctr">
-                      <a:solidFill>
-                        <a:srgbClr val="2A2E3B"/>
-                      </a:solidFill>
-                      <a:prstDash val="solid"/>
-                      <a:round/>
-                      <a:headEnd type="none" w="med" len="med"/>
-                      <a:tailEnd type="none" w="med" len="med"/>
-                    </a:lnL>
-                    <a:lnR w="6350" cap="flat" cmpd="sng" algn="ctr">
-                      <a:solidFill>
-                        <a:srgbClr val="2A2E3B"/>
-                      </a:solidFill>
-                      <a:prstDash val="solid"/>
-                      <a:round/>
-                      <a:headEnd type="none" w="med" len="med"/>
-                      <a:tailEnd type="none" w="med" len="med"/>
-                    </a:lnR>
-                    <a:lnT w="6350" cap="flat" cmpd="sng" algn="ctr">
-                      <a:solidFill>
-                        <a:srgbClr val="2A2E3B"/>
-                      </a:solidFill>
-                      <a:prstDash val="solid"/>
-                      <a:round/>
-                      <a:headEnd type="none" w="med" len="med"/>
-                      <a:tailEnd type="none" w="med" len="med"/>
-                    </a:lnT>
-                    <a:lnB w="6350" cap="flat" cmpd="sng" algn="ctr">
-                      <a:solidFill>
-                        <a:srgbClr val="2A2E3B"/>
-                      </a:solidFill>
-                      <a:prstDash val="solid"/>
-                      <a:round/>
-                      <a:headEnd type="none" w="med" len="med"/>
-                      <a:tailEnd type="none" w="med" len="med"/>
-                    </a:lnB>
-                    <a:solidFill>
-                      <a:srgbClr val="222632"/>
-                    </a:solidFill>
-                  </a:tcPr>
-                </a:tc>
-              </a:tr>
-              <a:tr h="457200">
-                <a:tc>
-                  <a:txBody>
-                    <a:bodyPr/>
-                    <a:lstStyle/>
-                    <a:p>
-                      <a:pPr indent="0" marL="0">
-                        <a:buNone/>
-                      </a:pPr>
-                      <a:r>
-                        <a:rPr lang="en-US" sz="1200" b="1" dirty="0">
-                          <a:solidFill>
-                            <a:srgbClr val="E4E6ED"/>
-                          </a:solidFill>
-                          <a:latin typeface="Calibri" pitchFamily="34" charset="0"/>
-                          <a:ea typeface="Calibri" pitchFamily="34" charset="-122"/>
-                          <a:cs typeface="Calibri" pitchFamily="34" charset="-120"/>
-                        </a:rPr>
-                        <a:t>Gold accounts reviewed &amp; tiered</a:t>
-                      </a:r>
-                      <a:endParaRPr lang="en-US" sz="1200" dirty="0">
-                        <a:latin typeface="Calibri" charset="0"/>
-                        <a:ea typeface="Calibri" charset="0"/>
-                        <a:cs typeface="Calibri" charset="0"/>
-                      </a:endParaRPr>
-                    </a:p>
-                  </a:txBody>
-                  <a:tcPr marL="91440" marR="91440" marT="45720" marB="45720">
-                    <a:lnL w="6350" cap="flat" cmpd="sng" algn="ctr">
-                      <a:solidFill>
-                        <a:srgbClr val="2A2E3B"/>
-                      </a:solidFill>
-                      <a:prstDash val="solid"/>
-                      <a:round/>
-                      <a:headEnd type="none" w="med" len="med"/>
-                      <a:tailEnd type="none" w="med" len="med"/>
-                    </a:lnL>
-                    <a:lnR w="6350" cap="flat" cmpd="sng" algn="ctr">
-                      <a:solidFill>
-                        <a:srgbClr val="2A2E3B"/>
-                      </a:solidFill>
-                      <a:prstDash val="solid"/>
-                      <a:round/>
-                      <a:headEnd type="none" w="med" len="med"/>
-                      <a:tailEnd type="none" w="med" len="med"/>
-                    </a:lnR>
-                    <a:lnT w="6350" cap="flat" cmpd="sng" algn="ctr">
-                      <a:solidFill>
-                        <a:srgbClr val="2A2E3B"/>
-                      </a:solidFill>
-                      <a:prstDash val="solid"/>
-                      <a:round/>
-                      <a:headEnd type="none" w="med" len="med"/>
-                      <a:tailEnd type="none" w="med" len="med"/>
-                    </a:lnT>
-                    <a:lnB w="6350" cap="flat" cmpd="sng" algn="ctr">
-                      <a:solidFill>
-                        <a:srgbClr val="2A2E3B"/>
-                      </a:solidFill>
-                      <a:prstDash val="solid"/>
-                      <a:round/>
-                      <a:headEnd type="none" w="med" len="med"/>
-                      <a:tailEnd type="none" w="med" len="med"/>
-                    </a:lnB>
-                    <a:solidFill>
-                      <a:srgbClr val="222632"/>
-                    </a:solidFill>
-                  </a:tcPr>
-                </a:tc>
-                <a:tc>
-                  <a:txBody>
-                    <a:bodyPr/>
-                    <a:lstStyle/>
-                    <a:p>
-                      <a:pPr algn="r" indent="0" marL="0">
-                        <a:buNone/>
-                      </a:pPr>
-                      <a:r>
-                        <a:rPr lang="en-US" sz="1200" dirty="0">
-                          <a:solidFill>
-                            <a:srgbClr val="E4E6ED"/>
-                          </a:solidFill>
-                          <a:latin typeface="Calibri" pitchFamily="34" charset="0"/>
-                          <a:ea typeface="Calibri" pitchFamily="34" charset="-122"/>
-                          <a:cs typeface="Calibri" pitchFamily="34" charset="-120"/>
-                        </a:rPr>
-                        <a:t>75</a:t>
-                      </a:r>
-                      <a:endParaRPr lang="en-US" sz="1200" dirty="0">
-                        <a:latin typeface="Calibri" charset="0"/>
-                        <a:ea typeface="Calibri" charset="0"/>
-                        <a:cs typeface="Calibri" charset="0"/>
-                      </a:endParaRPr>
-                    </a:p>
-                  </a:txBody>
-                  <a:tcPr marL="91440" marR="91440" marT="45720" marB="45720">
-                    <a:lnL w="6350" cap="flat" cmpd="sng" algn="ctr">
-                      <a:solidFill>
-                        <a:srgbClr val="2A2E3B"/>
-                      </a:solidFill>
-                      <a:prstDash val="solid"/>
-                      <a:round/>
-                      <a:headEnd type="none" w="med" len="med"/>
-                      <a:tailEnd type="none" w="med" len="med"/>
-                    </a:lnL>
-                    <a:lnR w="6350" cap="flat" cmpd="sng" algn="ctr">
-                      <a:solidFill>
-                        <a:srgbClr val="2A2E3B"/>
-                      </a:solidFill>
-                      <a:prstDash val="solid"/>
-                      <a:round/>
-                      <a:headEnd type="none" w="med" len="med"/>
-                      <a:tailEnd type="none" w="med" len="med"/>
-                    </a:lnR>
-                    <a:lnT w="6350" cap="flat" cmpd="sng" algn="ctr">
-                      <a:solidFill>
-                        <a:srgbClr val="2A2E3B"/>
-                      </a:solidFill>
-                      <a:prstDash val="solid"/>
-                      <a:round/>
-                      <a:headEnd type="none" w="med" len="med"/>
-                      <a:tailEnd type="none" w="med" len="med"/>
-                    </a:lnT>
-                    <a:lnB w="6350" cap="flat" cmpd="sng" algn="ctr">
-                      <a:solidFill>
-                        <a:srgbClr val="2A2E3B"/>
-                      </a:solidFill>
-                      <a:prstDash val="solid"/>
-                      <a:round/>
-                      <a:headEnd type="none" w="med" len="med"/>
-                      <a:tailEnd type="none" w="med" len="med"/>
-                    </a:lnB>
-                    <a:solidFill>
-                      <a:srgbClr val="222632"/>
-                    </a:solidFill>
-                  </a:tcPr>
-                </a:tc>
-                <a:tc>
-                  <a:txBody>
-                    <a:bodyPr/>
-                    <a:lstStyle/>
-                    <a:p>
-                      <a:pPr algn="r" indent="0" marL="0">
-                        <a:buNone/>
-                      </a:pPr>
-                      <a:r>
-                        <a:rPr lang="en-US" sz="1200" b="1" dirty="0">
-                          <a:solidFill>
-                            <a:srgbClr val="74B9FF"/>
-                          </a:solidFill>
-                          <a:latin typeface="Calibri" pitchFamily="34" charset="0"/>
-                          <a:ea typeface="Calibri" pitchFamily="34" charset="-122"/>
-                          <a:cs typeface="Calibri" pitchFamily="34" charset="-120"/>
-                        </a:rPr>
-                        <a:t>~19</a:t>
-                      </a:r>
-                      <a:endParaRPr lang="en-US" sz="1200" dirty="0">
-                        <a:latin typeface="Calibri" charset="0"/>
-                        <a:ea typeface="Calibri" charset="0"/>
-                        <a:cs typeface="Calibri" charset="0"/>
-                      </a:endParaRPr>
-                    </a:p>
-                  </a:txBody>
-                  <a:tcPr marL="91440" marR="91440" marT="45720" marB="45720">
-                    <a:lnL w="6350" cap="flat" cmpd="sng" algn="ctr">
-                      <a:solidFill>
-                        <a:srgbClr val="2A2E3B"/>
-                      </a:solidFill>
-                      <a:prstDash val="solid"/>
-                      <a:round/>
-                      <a:headEnd type="none" w="med" len="med"/>
-                      <a:tailEnd type="none" w="med" len="med"/>
-                    </a:lnL>
-                    <a:lnR w="6350" cap="flat" cmpd="sng" algn="ctr">
-                      <a:solidFill>
-                        <a:srgbClr val="2A2E3B"/>
-                      </a:solidFill>
-                      <a:prstDash val="solid"/>
-                      <a:round/>
-                      <a:headEnd type="none" w="med" len="med"/>
-                      <a:tailEnd type="none" w="med" len="med"/>
-                    </a:lnR>
-                    <a:lnT w="6350" cap="flat" cmpd="sng" algn="ctr">
-                      <a:solidFill>
-                        <a:srgbClr val="2A2E3B"/>
-                      </a:solidFill>
-                      <a:prstDash val="solid"/>
-                      <a:round/>
-                      <a:headEnd type="none" w="med" len="med"/>
-                      <a:tailEnd type="none" w="med" len="med"/>
-                    </a:lnT>
-                    <a:lnB w="6350" cap="flat" cmpd="sng" algn="ctr">
-                      <a:solidFill>
-                        <a:srgbClr val="2A2E3B"/>
-                      </a:solidFill>
-                      <a:prstDash val="solid"/>
-                      <a:round/>
-                      <a:headEnd type="none" w="med" len="med"/>
-                      <a:tailEnd type="none" w="med" len="med"/>
-                    </a:lnB>
-                    <a:solidFill>
-                      <a:srgbClr val="222632"/>
-                    </a:solidFill>
-                  </a:tcPr>
-                </a:tc>
-                <a:tc>
-                  <a:txBody>
-                    <a:bodyPr/>
-                    <a:lstStyle/>
-                    <a:p>
-                      <a:pPr indent="0" marL="0">
-                        <a:buNone/>
-                      </a:pPr>
-                      <a:r>
-                        <a:rPr lang="en-US" sz="1000" dirty="0">
-                          <a:solidFill>
-                            <a:srgbClr val="8B8FA3"/>
-                          </a:solidFill>
-                          <a:latin typeface="Calibri" pitchFamily="34" charset="0"/>
-                          <a:ea typeface="Calibri" pitchFamily="34" charset="-122"/>
-                          <a:cs typeface="Calibri" pitchFamily="34" charset="-120"/>
-                        </a:rPr>
-                        <a:t>Cover the full Gold base at least once — health, spend, whitespace</a:t>
-                      </a:r>
-                      <a:endParaRPr lang="en-US" sz="1000" dirty="0">
-                        <a:latin typeface="Calibri" charset="0"/>
-                        <a:ea typeface="Calibri" charset="0"/>
-                        <a:cs typeface="Calibri" charset="0"/>
-                      </a:endParaRPr>
-                    </a:p>
-                  </a:txBody>
-                  <a:tcPr marL="91440" marR="91440" marT="45720" marB="45720">
-                    <a:lnL w="6350" cap="flat" cmpd="sng" algn="ctr">
-                      <a:solidFill>
-                        <a:srgbClr val="2A2E3B"/>
-                      </a:solidFill>
-                      <a:prstDash val="solid"/>
-                      <a:round/>
-                      <a:headEnd type="none" w="med" len="med"/>
-                      <a:tailEnd type="none" w="med" len="med"/>
-                    </a:lnL>
-                    <a:lnR w="6350" cap="flat" cmpd="sng" algn="ctr">
-                      <a:solidFill>
-                        <a:srgbClr val="2A2E3B"/>
-                      </a:solidFill>
-                      <a:prstDash val="solid"/>
-                      <a:round/>
-                      <a:headEnd type="none" w="med" len="med"/>
-                      <a:tailEnd type="none" w="med" len="med"/>
-                    </a:lnR>
-                    <a:lnT w="6350" cap="flat" cmpd="sng" algn="ctr">
-                      <a:solidFill>
-                        <a:srgbClr val="2A2E3B"/>
-                      </a:solidFill>
-                      <a:prstDash val="solid"/>
-                      <a:round/>
-                      <a:headEnd type="none" w="med" len="med"/>
-                      <a:tailEnd type="none" w="med" len="med"/>
-                    </a:lnT>
-                    <a:lnB w="6350" cap="flat" cmpd="sng" algn="ctr">
-                      <a:solidFill>
-                        <a:srgbClr val="2A2E3B"/>
-                      </a:solidFill>
-                      <a:prstDash val="solid"/>
-                      <a:round/>
-                      <a:headEnd type="none" w="med" len="med"/>
-                      <a:tailEnd type="none" w="med" len="med"/>
-                    </a:lnB>
-                    <a:solidFill>
-                      <a:srgbClr val="222632"/>
-                    </a:solidFill>
-                  </a:tcPr>
-                </a:tc>
-              </a:tr>
-              <a:tr h="457200">
-                <a:tc>
-                  <a:txBody>
-                    <a:bodyPr/>
-                    <a:lstStyle/>
-                    <a:p>
-                      <a:pPr indent="0" marL="0">
-                        <a:buNone/>
-                      </a:pPr>
-                      <a:r>
-                        <a:rPr lang="en-US" sz="1200" dirty="0">
-                          <a:solidFill>
-                            <a:srgbClr val="E4E6ED"/>
-                          </a:solidFill>
-                          <a:latin typeface="Calibri" pitchFamily="34" charset="0"/>
-                          <a:ea typeface="Calibri" pitchFamily="34" charset="-122"/>
-                          <a:cs typeface="Calibri" pitchFamily="34" charset="-120"/>
-                        </a:rPr>
-                        <a:t>Account plans built</a:t>
-                      </a:r>
-                      <a:endParaRPr lang="en-US" sz="1200" dirty="0">
-                        <a:latin typeface="Calibri" charset="0"/>
-                        <a:ea typeface="Calibri" charset="0"/>
-                        <a:cs typeface="Calibri" charset="0"/>
-                      </a:endParaRPr>
-                    </a:p>
-                  </a:txBody>
-                  <a:tcPr marL="91440" marR="91440" marT="45720" marB="45720">
-                    <a:lnL w="6350" cap="flat" cmpd="sng" algn="ctr">
-                      <a:solidFill>
-                        <a:srgbClr val="2A2E3B"/>
-                      </a:solidFill>
-                      <a:prstDash val="solid"/>
-                      <a:round/>
-                      <a:headEnd type="none" w="med" len="med"/>
-                      <a:tailEnd type="none" w="med" len="med"/>
-                    </a:lnL>
-                    <a:lnR w="6350" cap="flat" cmpd="sng" algn="ctr">
-                      <a:solidFill>
-                        <a:srgbClr val="2A2E3B"/>
-                      </a:solidFill>
-                      <a:prstDash val="solid"/>
-                      <a:round/>
-                      <a:headEnd type="none" w="med" len="med"/>
-                      <a:tailEnd type="none" w="med" len="med"/>
-                    </a:lnR>
-                    <a:lnT w="6350" cap="flat" cmpd="sng" algn="ctr">
-                      <a:solidFill>
-                        <a:srgbClr val="2A2E3B"/>
-                      </a:solidFill>
-                      <a:prstDash val="solid"/>
-                      <a:round/>
-                      <a:headEnd type="none" w="med" len="med"/>
-                      <a:tailEnd type="none" w="med" len="med"/>
-                    </a:lnT>
-                    <a:lnB w="6350" cap="flat" cmpd="sng" algn="ctr">
-                      <a:solidFill>
-                        <a:srgbClr val="2A2E3B"/>
-                      </a:solidFill>
-                      <a:prstDash val="solid"/>
-                      <a:round/>
-                      <a:headEnd type="none" w="med" len="med"/>
-                      <a:tailEnd type="none" w="med" len="med"/>
-                    </a:lnB>
-                    <a:solidFill>
-                      <a:srgbClr val="1A1D27"/>
-                    </a:solidFill>
-                  </a:tcPr>
-                </a:tc>
-                <a:tc>
-                  <a:txBody>
-                    <a:bodyPr/>
-                    <a:lstStyle/>
-                    <a:p>
-                      <a:pPr algn="r" indent="0" marL="0">
-                        <a:buNone/>
-                      </a:pPr>
-                      <a:r>
-                        <a:rPr lang="en-US" sz="1200" dirty="0">
-                          <a:solidFill>
-                            <a:srgbClr val="E4E6ED"/>
-                          </a:solidFill>
-                          <a:latin typeface="Calibri" pitchFamily="34" charset="0"/>
-                          <a:ea typeface="Calibri" pitchFamily="34" charset="-122"/>
-                          <a:cs typeface="Calibri" pitchFamily="34" charset="-120"/>
-                        </a:rPr>
-                        <a:t>~20</a:t>
-                      </a:r>
-                      <a:endParaRPr lang="en-US" sz="1200" dirty="0">
-                        <a:latin typeface="Calibri" charset="0"/>
-                        <a:ea typeface="Calibri" charset="0"/>
-                        <a:cs typeface="Calibri" charset="0"/>
-                      </a:endParaRPr>
-                    </a:p>
-                  </a:txBody>
-                  <a:tcPr marL="91440" marR="91440" marT="45720" marB="45720">
-                    <a:lnL w="6350" cap="flat" cmpd="sng" algn="ctr">
-                      <a:solidFill>
-                        <a:srgbClr val="2A2E3B"/>
-                      </a:solidFill>
-                      <a:prstDash val="solid"/>
-                      <a:round/>
-                      <a:headEnd type="none" w="med" len="med"/>
-                      <a:tailEnd type="none" w="med" len="med"/>
-                    </a:lnL>
-                    <a:lnR w="6350" cap="flat" cmpd="sng" algn="ctr">
-                      <a:solidFill>
-                        <a:srgbClr val="2A2E3B"/>
-                      </a:solidFill>
-                      <a:prstDash val="solid"/>
-                      <a:round/>
-                      <a:headEnd type="none" w="med" len="med"/>
-                      <a:tailEnd type="none" w="med" len="med"/>
-                    </a:lnR>
-                    <a:lnT w="6350" cap="flat" cmpd="sng" algn="ctr">
-                      <a:solidFill>
-                        <a:srgbClr val="2A2E3B"/>
-                      </a:solidFill>
-                      <a:prstDash val="solid"/>
-                      <a:round/>
-                      <a:headEnd type="none" w="med" len="med"/>
-                      <a:tailEnd type="none" w="med" len="med"/>
-                    </a:lnT>
-                    <a:lnB w="6350" cap="flat" cmpd="sng" algn="ctr">
-                      <a:solidFill>
-                        <a:srgbClr val="2A2E3B"/>
-                      </a:solidFill>
-                      <a:prstDash val="solid"/>
-                      <a:round/>
-                      <a:headEnd type="none" w="med" len="med"/>
-                      <a:tailEnd type="none" w="med" len="med"/>
-                    </a:lnB>
-                    <a:solidFill>
-                      <a:srgbClr val="1A1D27"/>
-                    </a:solidFill>
-                  </a:tcPr>
-                </a:tc>
-                <a:tc>
-                  <a:txBody>
-                    <a:bodyPr/>
-                    <a:lstStyle/>
-                    <a:p>
-                      <a:pPr algn="r" indent="0" marL="0">
-                        <a:buNone/>
-                      </a:pPr>
-                      <a:r>
-                        <a:rPr lang="en-US" sz="1200" b="1" dirty="0">
-                          <a:solidFill>
-                            <a:srgbClr val="74B9FF"/>
-                          </a:solidFill>
-                          <a:latin typeface="Calibri" pitchFamily="34" charset="0"/>
-                          <a:ea typeface="Calibri" pitchFamily="34" charset="-122"/>
-                          <a:cs typeface="Calibri" pitchFamily="34" charset="-120"/>
-                        </a:rPr>
-                        <a:t>~5</a:t>
-                      </a:r>
-                      <a:endParaRPr lang="en-US" sz="1200" dirty="0">
-                        <a:latin typeface="Calibri" charset="0"/>
-                        <a:ea typeface="Calibri" charset="0"/>
-                        <a:cs typeface="Calibri" charset="0"/>
-                      </a:endParaRPr>
-                    </a:p>
-                  </a:txBody>
-                  <a:tcPr marL="91440" marR="91440" marT="45720" marB="45720">
-                    <a:lnL w="6350" cap="flat" cmpd="sng" algn="ctr">
-                      <a:solidFill>
-                        <a:srgbClr val="2A2E3B"/>
-                      </a:solidFill>
-                      <a:prstDash val="solid"/>
-                      <a:round/>
-                      <a:headEnd type="none" w="med" len="med"/>
-                      <a:tailEnd type="none" w="med" len="med"/>
-                    </a:lnL>
-                    <a:lnR w="6350" cap="flat" cmpd="sng" algn="ctr">
-                      <a:solidFill>
-                        <a:srgbClr val="2A2E3B"/>
-                      </a:solidFill>
-                      <a:prstDash val="solid"/>
-                      <a:round/>
-                      <a:headEnd type="none" w="med" len="med"/>
-                      <a:tailEnd type="none" w="med" len="med"/>
-                    </a:lnR>
-                    <a:lnT w="6350" cap="flat" cmpd="sng" algn="ctr">
-                      <a:solidFill>
-                        <a:srgbClr val="2A2E3B"/>
-                      </a:solidFill>
-                      <a:prstDash val="solid"/>
-                      <a:round/>
-                      <a:headEnd type="none" w="med" len="med"/>
-                      <a:tailEnd type="none" w="med" len="med"/>
-                    </a:lnT>
-                    <a:lnB w="6350" cap="flat" cmpd="sng" algn="ctr">
-                      <a:solidFill>
-                        <a:srgbClr val="2A2E3B"/>
-                      </a:solidFill>
-                      <a:prstDash val="solid"/>
-                      <a:round/>
-                      <a:headEnd type="none" w="med" len="med"/>
-                      <a:tailEnd type="none" w="med" len="med"/>
-                    </a:lnB>
-                    <a:solidFill>
-                      <a:srgbClr val="1A1D27"/>
-                    </a:solidFill>
-                  </a:tcPr>
-                </a:tc>
-                <a:tc>
-                  <a:txBody>
-                    <a:bodyPr/>
-                    <a:lstStyle/>
-                    <a:p>
-                      <a:pPr indent="0" marL="0">
-                        <a:buNone/>
-                      </a:pPr>
-                      <a:r>
-                        <a:rPr lang="en-US" sz="1000" dirty="0">
-                          <a:solidFill>
-                            <a:srgbClr val="8B8FA3"/>
-                          </a:solidFill>
-                          <a:latin typeface="Calibri" pitchFamily="34" charset="0"/>
-                          <a:ea typeface="Calibri" pitchFamily="34" charset="-122"/>
-                          <a:cs typeface="Calibri" pitchFamily="34" charset="-120"/>
-                        </a:rPr>
-                        <a:t>Top Gold accounts first (biggest ARR / nearest renewals)</a:t>
-                      </a:r>
-                      <a:endParaRPr lang="en-US" sz="1000" dirty="0">
-                        <a:latin typeface="Calibri" charset="0"/>
-                        <a:ea typeface="Calibri" charset="0"/>
-                        <a:cs typeface="Calibri" charset="0"/>
-                      </a:endParaRPr>
-                    </a:p>
-                  </a:txBody>
-                  <a:tcPr marL="91440" marR="91440" marT="45720" marB="45720">
-                    <a:lnL w="6350" cap="flat" cmpd="sng" algn="ctr">
-                      <a:solidFill>
-                        <a:srgbClr val="2A2E3B"/>
-                      </a:solidFill>
-                      <a:prstDash val="solid"/>
-                      <a:round/>
-                      <a:headEnd type="none" w="med" len="med"/>
-                      <a:tailEnd type="none" w="med" len="med"/>
-                    </a:lnL>
-                    <a:lnR w="6350" cap="flat" cmpd="sng" algn="ctr">
-                      <a:solidFill>
-                        <a:srgbClr val="2A2E3B"/>
-                      </a:solidFill>
-                      <a:prstDash val="solid"/>
-                      <a:round/>
-                      <a:headEnd type="none" w="med" len="med"/>
-                      <a:tailEnd type="none" w="med" len="med"/>
-                    </a:lnR>
-                    <a:lnT w="6350" cap="flat" cmpd="sng" algn="ctr">
-                      <a:solidFill>
-                        <a:srgbClr val="2A2E3B"/>
-                      </a:solidFill>
-                      <a:prstDash val="solid"/>
-                      <a:round/>
-                      <a:headEnd type="none" w="med" len="med"/>
-                      <a:tailEnd type="none" w="med" len="med"/>
-                    </a:lnT>
-                    <a:lnB w="6350" cap="flat" cmpd="sng" algn="ctr">
-                      <a:solidFill>
-                        <a:srgbClr val="2A2E3B"/>
-                      </a:solidFill>
-                      <a:prstDash val="solid"/>
-                      <a:round/>
-                      <a:headEnd type="none" w="med" len="med"/>
-                      <a:tailEnd type="none" w="med" len="med"/>
-                    </a:lnB>
-                    <a:solidFill>
-                      <a:srgbClr val="1A1D27"/>
-                    </a:solidFill>
-                  </a:tcPr>
-                </a:tc>
-              </a:tr>
-              <a:tr h="457200">
-                <a:tc>
-                  <a:txBody>
-                    <a:bodyPr/>
-                    <a:lstStyle/>
-                    <a:p>
-                      <a:pPr indent="0" marL="0">
-                        <a:buNone/>
-                      </a:pPr>
-                      <a:r>
-                        <a:rPr lang="en-US" sz="1200" dirty="0">
-                          <a:solidFill>
-                            <a:srgbClr val="E4E6ED"/>
-                          </a:solidFill>
-                          <a:latin typeface="Calibri" pitchFamily="34" charset="0"/>
-                          <a:ea typeface="Calibri" pitchFamily="34" charset="-122"/>
-                          <a:cs typeface="Calibri" pitchFamily="34" charset="-120"/>
-                        </a:rPr>
-                        <a:t>Customer meetings / QBRs</a:t>
-                      </a:r>
-                      <a:endParaRPr lang="en-US" sz="1200" dirty="0">
-                        <a:latin typeface="Calibri" charset="0"/>
-                        <a:ea typeface="Calibri" charset="0"/>
-                        <a:cs typeface="Calibri" charset="0"/>
-                      </a:endParaRPr>
-                    </a:p>
-                  </a:txBody>
-                  <a:tcPr marL="91440" marR="91440" marT="45720" marB="45720">
-                    <a:lnL w="6350" cap="flat" cmpd="sng" algn="ctr">
-                      <a:solidFill>
-                        <a:srgbClr val="2A2E3B"/>
-                      </a:solidFill>
-                      <a:prstDash val="solid"/>
-                      <a:round/>
-                      <a:headEnd type="none" w="med" len="med"/>
-                      <a:tailEnd type="none" w="med" len="med"/>
-                    </a:lnL>
-                    <a:lnR w="6350" cap="flat" cmpd="sng" algn="ctr">
-                      <a:solidFill>
-                        <a:srgbClr val="2A2E3B"/>
-                      </a:solidFill>
-                      <a:prstDash val="solid"/>
-                      <a:round/>
-                      <a:headEnd type="none" w="med" len="med"/>
-                      <a:tailEnd type="none" w="med" len="med"/>
-                    </a:lnR>
-                    <a:lnT w="6350" cap="flat" cmpd="sng" algn="ctr">
-                      <a:solidFill>
-                        <a:srgbClr val="2A2E3B"/>
-                      </a:solidFill>
-                      <a:prstDash val="solid"/>
-                      <a:round/>
-                      <a:headEnd type="none" w="med" len="med"/>
-                      <a:tailEnd type="none" w="med" len="med"/>
-                    </a:lnT>
-                    <a:lnB w="6350" cap="flat" cmpd="sng" algn="ctr">
-                      <a:solidFill>
-                        <a:srgbClr val="2A2E3B"/>
-                      </a:solidFill>
-                      <a:prstDash val="solid"/>
-                      <a:round/>
-                      <a:headEnd type="none" w="med" len="med"/>
-                      <a:tailEnd type="none" w="med" len="med"/>
-                    </a:lnB>
-                    <a:solidFill>
-                      <a:srgbClr val="1A1D27"/>
-                    </a:solidFill>
-                  </a:tcPr>
-                </a:tc>
-                <a:tc>
-                  <a:txBody>
-                    <a:bodyPr/>
-                    <a:lstStyle/>
-                    <a:p>
-                      <a:pPr algn="r" indent="0" marL="0">
-                        <a:buNone/>
-                      </a:pPr>
-                      <a:r>
-                        <a:rPr lang="en-US" sz="1200" dirty="0">
-                          <a:solidFill>
-                            <a:srgbClr val="E4E6ED"/>
-                          </a:solidFill>
-                          <a:latin typeface="Calibri" pitchFamily="34" charset="0"/>
-                          <a:ea typeface="Calibri" pitchFamily="34" charset="-122"/>
-                          <a:cs typeface="Calibri" pitchFamily="34" charset="-120"/>
-                        </a:rPr>
-                        <a:t>~40</a:t>
-                      </a:r>
-                      <a:endParaRPr lang="en-US" sz="1200" dirty="0">
-                        <a:latin typeface="Calibri" charset="0"/>
-                        <a:ea typeface="Calibri" charset="0"/>
-                        <a:cs typeface="Calibri" charset="0"/>
-                      </a:endParaRPr>
-                    </a:p>
-                  </a:txBody>
-                  <a:tcPr marL="91440" marR="91440" marT="45720" marB="45720">
-                    <a:lnL w="6350" cap="flat" cmpd="sng" algn="ctr">
-                      <a:solidFill>
-                        <a:srgbClr val="2A2E3B"/>
-                      </a:solidFill>
-                      <a:prstDash val="solid"/>
-                      <a:round/>
-                      <a:headEnd type="none" w="med" len="med"/>
-                      <a:tailEnd type="none" w="med" len="med"/>
-                    </a:lnL>
-                    <a:lnR w="6350" cap="flat" cmpd="sng" algn="ctr">
-                      <a:solidFill>
-                        <a:srgbClr val="2A2E3B"/>
-                      </a:solidFill>
-                      <a:prstDash val="solid"/>
-                      <a:round/>
-                      <a:headEnd type="none" w="med" len="med"/>
-                      <a:tailEnd type="none" w="med" len="med"/>
-                    </a:lnR>
-                    <a:lnT w="6350" cap="flat" cmpd="sng" algn="ctr">
-                      <a:solidFill>
-                        <a:srgbClr val="2A2E3B"/>
-                      </a:solidFill>
-                      <a:prstDash val="solid"/>
-                      <a:round/>
-                      <a:headEnd type="none" w="med" len="med"/>
-                      <a:tailEnd type="none" w="med" len="med"/>
-                    </a:lnT>
-                    <a:lnB w="6350" cap="flat" cmpd="sng" algn="ctr">
-                      <a:solidFill>
-                        <a:srgbClr val="2A2E3B"/>
-                      </a:solidFill>
-                      <a:prstDash val="solid"/>
-                      <a:round/>
-                      <a:headEnd type="none" w="med" len="med"/>
-                      <a:tailEnd type="none" w="med" len="med"/>
-                    </a:lnB>
-                    <a:solidFill>
-                      <a:srgbClr val="1A1D27"/>
-                    </a:solidFill>
-                  </a:tcPr>
-                </a:tc>
-                <a:tc>
-                  <a:txBody>
-                    <a:bodyPr/>
-                    <a:lstStyle/>
-                    <a:p>
-                      <a:pPr algn="r" indent="0" marL="0">
-                        <a:buNone/>
-                      </a:pPr>
-                      <a:r>
-                        <a:rPr lang="en-US" sz="1200" b="1" dirty="0">
-                          <a:solidFill>
-                            <a:srgbClr val="74B9FF"/>
-                          </a:solidFill>
-                          <a:latin typeface="Calibri" pitchFamily="34" charset="0"/>
-                          <a:ea typeface="Calibri" pitchFamily="34" charset="-122"/>
-                          <a:cs typeface="Calibri" pitchFamily="34" charset="-120"/>
-                        </a:rPr>
-                        <a:t>~10</a:t>
-                      </a:r>
-                      <a:endParaRPr lang="en-US" sz="1200" dirty="0">
-                        <a:latin typeface="Calibri" charset="0"/>
-                        <a:ea typeface="Calibri" charset="0"/>
-                        <a:cs typeface="Calibri" charset="0"/>
-                      </a:endParaRPr>
-                    </a:p>
-                  </a:txBody>
-                  <a:tcPr marL="91440" marR="91440" marT="45720" marB="45720">
-                    <a:lnL w="6350" cap="flat" cmpd="sng" algn="ctr">
-                      <a:solidFill>
-                        <a:srgbClr val="2A2E3B"/>
-                      </a:solidFill>
-                      <a:prstDash val="solid"/>
-                      <a:round/>
-                      <a:headEnd type="none" w="med" len="med"/>
-                      <a:tailEnd type="none" w="med" len="med"/>
-                    </a:lnL>
-                    <a:lnR w="6350" cap="flat" cmpd="sng" algn="ctr">
-                      <a:solidFill>
-                        <a:srgbClr val="2A2E3B"/>
-                      </a:solidFill>
-                      <a:prstDash val="solid"/>
-                      <a:round/>
-                      <a:headEnd type="none" w="med" len="med"/>
-                      <a:tailEnd type="none" w="med" len="med"/>
-                    </a:lnR>
-                    <a:lnT w="6350" cap="flat" cmpd="sng" algn="ctr">
-                      <a:solidFill>
-                        <a:srgbClr val="2A2E3B"/>
-                      </a:solidFill>
-                      <a:prstDash val="solid"/>
-                      <a:round/>
-                      <a:headEnd type="none" w="med" len="med"/>
-                      <a:tailEnd type="none" w="med" len="med"/>
-                    </a:lnT>
-                    <a:lnB w="6350" cap="flat" cmpd="sng" algn="ctr">
-                      <a:solidFill>
-                        <a:srgbClr val="2A2E3B"/>
-                      </a:solidFill>
-                      <a:prstDash val="solid"/>
-                      <a:round/>
-                      <a:headEnd type="none" w="med" len="med"/>
-                      <a:tailEnd type="none" w="med" len="med"/>
-                    </a:lnB>
-                    <a:solidFill>
-                      <a:srgbClr val="1A1D27"/>
-                    </a:solidFill>
-                  </a:tcPr>
-                </a:tc>
-                <a:tc>
-                  <a:txBody>
-                    <a:bodyPr/>
-                    <a:lstStyle/>
-                    <a:p>
-                      <a:pPr indent="0" marL="0">
-                        <a:buNone/>
-                      </a:pPr>
-                      <a:r>
-                        <a:rPr lang="en-US" sz="1000" dirty="0">
-                          <a:solidFill>
-                            <a:srgbClr val="8B8FA3"/>
-                          </a:solidFill>
-                          <a:latin typeface="Calibri" pitchFamily="34" charset="0"/>
-                          <a:ea typeface="Calibri" pitchFamily="34" charset="-122"/>
-                          <a:cs typeface="Calibri" pitchFamily="34" charset="-120"/>
-                        </a:rPr>
-                        <a:t>Retention + expansion conversations across the book</a:t>
-                      </a:r>
-                      <a:endParaRPr lang="en-US" sz="1000" dirty="0">
-                        <a:latin typeface="Calibri" charset="0"/>
-                        <a:ea typeface="Calibri" charset="0"/>
-                        <a:cs typeface="Calibri" charset="0"/>
-                      </a:endParaRPr>
-                    </a:p>
-                  </a:txBody>
-                  <a:tcPr marL="91440" marR="91440" marT="45720" marB="45720">
-                    <a:lnL w="6350" cap="flat" cmpd="sng" algn="ctr">
-                      <a:solidFill>
-                        <a:srgbClr val="2A2E3B"/>
-                      </a:solidFill>
-                      <a:prstDash val="solid"/>
-                      <a:round/>
-                      <a:headEnd type="none" w="med" len="med"/>
-                      <a:tailEnd type="none" w="med" len="med"/>
-                    </a:lnL>
-                    <a:lnR w="6350" cap="flat" cmpd="sng" algn="ctr">
-                      <a:solidFill>
-                        <a:srgbClr val="2A2E3B"/>
-                      </a:solidFill>
-                      <a:prstDash val="solid"/>
-                      <a:round/>
-                      <a:headEnd type="none" w="med" len="med"/>
-                      <a:tailEnd type="none" w="med" len="med"/>
-                    </a:lnR>
-                    <a:lnT w="6350" cap="flat" cmpd="sng" algn="ctr">
-                      <a:solidFill>
-                        <a:srgbClr val="2A2E3B"/>
-                      </a:solidFill>
-                      <a:prstDash val="solid"/>
-                      <a:round/>
-                      <a:headEnd type="none" w="med" len="med"/>
-                      <a:tailEnd type="none" w="med" len="med"/>
-                    </a:lnT>
-                    <a:lnB w="6350" cap="flat" cmpd="sng" algn="ctr">
-                      <a:solidFill>
-                        <a:srgbClr val="2A2E3B"/>
-                      </a:solidFill>
-                      <a:prstDash val="solid"/>
-                      <a:round/>
-                      <a:headEnd type="none" w="med" len="med"/>
-                      <a:tailEnd type="none" w="med" len="med"/>
-                    </a:lnB>
-                    <a:solidFill>
-                      <a:srgbClr val="1A1D27"/>
-                    </a:solidFill>
-                  </a:tcPr>
-                </a:tc>
-              </a:tr>
-              <a:tr h="457200">
-                <a:tc>
-                  <a:txBody>
-                    <a:bodyPr/>
-                    <a:lstStyle/>
-                    <a:p>
-                      <a:pPr indent="0" marL="0">
-                        <a:buNone/>
-                      </a:pPr>
-                      <a:r>
-                        <a:rPr lang="en-US" sz="1200" dirty="0">
-                          <a:solidFill>
-                            <a:srgbClr val="E4E6ED"/>
-                          </a:solidFill>
-                          <a:latin typeface="Calibri" pitchFamily="34" charset="0"/>
-                          <a:ea typeface="Calibri" pitchFamily="34" charset="-122"/>
-                          <a:cs typeface="Calibri" pitchFamily="34" charset="-120"/>
-                        </a:rPr>
-                        <a:t>Expansion / renewal ops surfaced</a:t>
-                      </a:r>
-                      <a:endParaRPr lang="en-US" sz="1200" dirty="0">
-                        <a:latin typeface="Calibri" charset="0"/>
-                        <a:ea typeface="Calibri" charset="0"/>
-                        <a:cs typeface="Calibri" charset="0"/>
-                      </a:endParaRPr>
-                    </a:p>
-                  </a:txBody>
-                  <a:tcPr marL="91440" marR="91440" marT="45720" marB="45720">
-                    <a:lnL w="6350" cap="flat" cmpd="sng" algn="ctr">
-                      <a:solidFill>
-                        <a:srgbClr val="2A2E3B"/>
-                      </a:solidFill>
-                      <a:prstDash val="solid"/>
-                      <a:round/>
-                      <a:headEnd type="none" w="med" len="med"/>
-                      <a:tailEnd type="none" w="med" len="med"/>
-                    </a:lnL>
-                    <a:lnR w="6350" cap="flat" cmpd="sng" algn="ctr">
-                      <a:solidFill>
-                        <a:srgbClr val="2A2E3B"/>
-                      </a:solidFill>
-                      <a:prstDash val="solid"/>
-                      <a:round/>
-                      <a:headEnd type="none" w="med" len="med"/>
-                      <a:tailEnd type="none" w="med" len="med"/>
-                    </a:lnR>
-                    <a:lnT w="6350" cap="flat" cmpd="sng" algn="ctr">
-                      <a:solidFill>
-                        <a:srgbClr val="2A2E3B"/>
-                      </a:solidFill>
-                      <a:prstDash val="solid"/>
-                      <a:round/>
-                      <a:headEnd type="none" w="med" len="med"/>
-                      <a:tailEnd type="none" w="med" len="med"/>
-                    </a:lnT>
-                    <a:lnB w="6350" cap="flat" cmpd="sng" algn="ctr">
-                      <a:solidFill>
-                        <a:srgbClr val="2A2E3B"/>
-                      </a:solidFill>
-                      <a:prstDash val="solid"/>
-                      <a:round/>
-                      <a:headEnd type="none" w="med" len="med"/>
-                      <a:tailEnd type="none" w="med" len="med"/>
-                    </a:lnB>
-                    <a:solidFill>
-                      <a:srgbClr val="1A1D27"/>
-                    </a:solidFill>
-                  </a:tcPr>
-                </a:tc>
-                <a:tc>
-                  <a:txBody>
-                    <a:bodyPr/>
-                    <a:lstStyle/>
-                    <a:p>
-                      <a:pPr algn="r" indent="0" marL="0">
-                        <a:buNone/>
-                      </a:pPr>
-                      <a:r>
-                        <a:rPr lang="en-US" sz="1200" dirty="0">
-                          <a:solidFill>
-                            <a:srgbClr val="E4E6ED"/>
-                          </a:solidFill>
-                          <a:latin typeface="Calibri" pitchFamily="34" charset="0"/>
-                          <a:ea typeface="Calibri" pitchFamily="34" charset="-122"/>
-                          <a:cs typeface="Calibri" pitchFamily="34" charset="-120"/>
-                        </a:rPr>
-                        <a:t>~10</a:t>
-                      </a:r>
-                      <a:endParaRPr lang="en-US" sz="1200" dirty="0">
-                        <a:latin typeface="Calibri" charset="0"/>
-                        <a:ea typeface="Calibri" charset="0"/>
-                        <a:cs typeface="Calibri" charset="0"/>
-                      </a:endParaRPr>
-                    </a:p>
-                  </a:txBody>
-                  <a:tcPr marL="91440" marR="91440" marT="45720" marB="45720">
-                    <a:lnL w="6350" cap="flat" cmpd="sng" algn="ctr">
-                      <a:solidFill>
-                        <a:srgbClr val="2A2E3B"/>
-                      </a:solidFill>
-                      <a:prstDash val="solid"/>
-                      <a:round/>
-                      <a:headEnd type="none" w="med" len="med"/>
-                      <a:tailEnd type="none" w="med" len="med"/>
-                    </a:lnL>
-                    <a:lnR w="6350" cap="flat" cmpd="sng" algn="ctr">
-                      <a:solidFill>
-                        <a:srgbClr val="2A2E3B"/>
-                      </a:solidFill>
-                      <a:prstDash val="solid"/>
-                      <a:round/>
-                      <a:headEnd type="none" w="med" len="med"/>
-                      <a:tailEnd type="none" w="med" len="med"/>
-                    </a:lnR>
-                    <a:lnT w="6350" cap="flat" cmpd="sng" algn="ctr">
-                      <a:solidFill>
-                        <a:srgbClr val="2A2E3B"/>
-                      </a:solidFill>
-                      <a:prstDash val="solid"/>
-                      <a:round/>
-                      <a:headEnd type="none" w="med" len="med"/>
-                      <a:tailEnd type="none" w="med" len="med"/>
-                    </a:lnT>
-                    <a:lnB w="6350" cap="flat" cmpd="sng" algn="ctr">
-                      <a:solidFill>
-                        <a:srgbClr val="2A2E3B"/>
-                      </a:solidFill>
-                      <a:prstDash val="solid"/>
-                      <a:round/>
-                      <a:headEnd type="none" w="med" len="med"/>
-                      <a:tailEnd type="none" w="med" len="med"/>
-                    </a:lnB>
-                    <a:solidFill>
-                      <a:srgbClr val="1A1D27"/>
-                    </a:solidFill>
-                  </a:tcPr>
-                </a:tc>
-                <a:tc>
-                  <a:txBody>
-                    <a:bodyPr/>
-                    <a:lstStyle/>
-                    <a:p>
-                      <a:pPr algn="r" indent="0" marL="0">
-                        <a:buNone/>
-                      </a:pPr>
-                      <a:r>
-                        <a:rPr lang="en-US" sz="1200" b="1" dirty="0">
-                          <a:solidFill>
-                            <a:srgbClr val="74B9FF"/>
-                          </a:solidFill>
-                          <a:latin typeface="Calibri" pitchFamily="34" charset="0"/>
-                          <a:ea typeface="Calibri" pitchFamily="34" charset="-122"/>
-                          <a:cs typeface="Calibri" pitchFamily="34" charset="-120"/>
-                        </a:rPr>
-                        <a:t>~2-3</a:t>
-                      </a:r>
-                      <a:endParaRPr lang="en-US" sz="1200" dirty="0">
-                        <a:latin typeface="Calibri" charset="0"/>
-                        <a:ea typeface="Calibri" charset="0"/>
-                        <a:cs typeface="Calibri" charset="0"/>
-                      </a:endParaRPr>
-                    </a:p>
-                  </a:txBody>
-                  <a:tcPr marL="91440" marR="91440" marT="45720" marB="45720">
-                    <a:lnL w="6350" cap="flat" cmpd="sng" algn="ctr">
-                      <a:solidFill>
-                        <a:srgbClr val="2A2E3B"/>
-                      </a:solidFill>
-                      <a:prstDash val="solid"/>
-                      <a:round/>
-                      <a:headEnd type="none" w="med" len="med"/>
-                      <a:tailEnd type="none" w="med" len="med"/>
-                    </a:lnL>
-                    <a:lnR w="6350" cap="flat" cmpd="sng" algn="ctr">
-                      <a:solidFill>
-                        <a:srgbClr val="2A2E3B"/>
-                      </a:solidFill>
-                      <a:prstDash val="solid"/>
-                      <a:round/>
-                      <a:headEnd type="none" w="med" len="med"/>
-                      <a:tailEnd type="none" w="med" len="med"/>
-                    </a:lnR>
-                    <a:lnT w="6350" cap="flat" cmpd="sng" algn="ctr">
-                      <a:solidFill>
-                        <a:srgbClr val="2A2E3B"/>
-                      </a:solidFill>
-                      <a:prstDash val="solid"/>
-                      <a:round/>
-                      <a:headEnd type="none" w="med" len="med"/>
-                      <a:tailEnd type="none" w="med" len="med"/>
-                    </a:lnT>
-                    <a:lnB w="6350" cap="flat" cmpd="sng" algn="ctr">
-                      <a:solidFill>
-                        <a:srgbClr val="2A2E3B"/>
-                      </a:solidFill>
-                      <a:prstDash val="solid"/>
-                      <a:round/>
-                      <a:headEnd type="none" w="med" len="med"/>
-                      <a:tailEnd type="none" w="med" len="med"/>
-                    </a:lnB>
-                    <a:solidFill>
-                      <a:srgbClr val="1A1D27"/>
-                    </a:solidFill>
-                  </a:tcPr>
-                </a:tc>
-                <a:tc>
-                  <a:txBody>
-                    <a:bodyPr/>
-                    <a:lstStyle/>
-                    <a:p>
-                      <a:pPr indent="0" marL="0">
-                        <a:buNone/>
-                      </a:pPr>
-                      <a:r>
-                        <a:rPr lang="en-US" sz="1000" dirty="0">
-                          <a:solidFill>
-                            <a:srgbClr val="8B8FA3"/>
-                          </a:solidFill>
-                          <a:latin typeface="Calibri" pitchFamily="34" charset="0"/>
-                          <a:ea typeface="Calibri" pitchFamily="34" charset="-122"/>
-                          <a:cs typeface="Calibri" pitchFamily="34" charset="-120"/>
-                        </a:rPr>
-                        <a:t>Whitespace + renewal timing (e.g. Hawaiian Airlines $20k)</a:t>
-                      </a:r>
-                      <a:endParaRPr lang="en-US" sz="1000" dirty="0">
-                        <a:latin typeface="Calibri" charset="0"/>
-                        <a:ea typeface="Calibri" charset="0"/>
-                        <a:cs typeface="Calibri" charset="0"/>
-                      </a:endParaRPr>
-                    </a:p>
-                  </a:txBody>
-                  <a:tcPr marL="91440" marR="91440" marT="45720" marB="45720">
-                    <a:lnL w="6350" cap="flat" cmpd="sng" algn="ctr">
-                      <a:solidFill>
-                        <a:srgbClr val="2A2E3B"/>
-                      </a:solidFill>
-                      <a:prstDash val="solid"/>
-                      <a:round/>
-                      <a:headEnd type="none" w="med" len="med"/>
-                      <a:tailEnd type="none" w="med" len="med"/>
-                    </a:lnL>
-                    <a:lnR w="6350" cap="flat" cmpd="sng" algn="ctr">
-                      <a:solidFill>
-                        <a:srgbClr val="2A2E3B"/>
-                      </a:solidFill>
-                      <a:prstDash val="solid"/>
-                      <a:round/>
-                      <a:headEnd type="none" w="med" len="med"/>
-                      <a:tailEnd type="none" w="med" len="med"/>
-                    </a:lnR>
-                    <a:lnT w="6350" cap="flat" cmpd="sng" algn="ctr">
-                      <a:solidFill>
-                        <a:srgbClr val="2A2E3B"/>
-                      </a:solidFill>
-                      <a:prstDash val="solid"/>
-                      <a:round/>
-                      <a:headEnd type="none" w="med" len="med"/>
-                      <a:tailEnd type="none" w="med" len="med"/>
-                    </a:lnT>
-                    <a:lnB w="6350" cap="flat" cmpd="sng" algn="ctr">
-                      <a:solidFill>
-                        <a:srgbClr val="2A2E3B"/>
-                      </a:solidFill>
-                      <a:prstDash val="solid"/>
-                      <a:round/>
-                      <a:headEnd type="none" w="med" len="med"/>
-                      <a:tailEnd type="none" w="med" len="med"/>
-                    </a:lnB>
-                    <a:solidFill>
-                      <a:srgbClr val="1A1D27"/>
-                    </a:solidFill>
-                  </a:tcPr>
-                </a:tc>
-              </a:tr>
-              <a:tr h="457200">
-                <a:tc>
-                  <a:txBody>
-                    <a:bodyPr/>
-                    <a:lstStyle/>
-                    <a:p>
-                      <a:pPr indent="0" marL="0">
-                        <a:buNone/>
-                      </a:pPr>
-                      <a:r>
-                        <a:rPr lang="en-US" sz="1200" dirty="0">
-                          <a:solidFill>
-                            <a:srgbClr val="E4E6ED"/>
-                          </a:solidFill>
-                          <a:latin typeface="Calibri" pitchFamily="34" charset="0"/>
-                          <a:ea typeface="Calibri" pitchFamily="34" charset="-122"/>
-                          <a:cs typeface="Calibri" pitchFamily="34" charset="-120"/>
-                        </a:rPr>
-                        <a:t>Open pipeline advanced</a:t>
-                      </a:r>
-                      <a:endParaRPr lang="en-US" sz="1200" dirty="0">
-                        <a:latin typeface="Calibri" charset="0"/>
-                        <a:ea typeface="Calibri" charset="0"/>
-                        <a:cs typeface="Calibri" charset="0"/>
-                      </a:endParaRPr>
-                    </a:p>
-                  </a:txBody>
-                  <a:tcPr marL="91440" marR="91440" marT="45720" marB="45720">
-                    <a:lnL w="6350" cap="flat" cmpd="sng" algn="ctr">
-                      <a:solidFill>
-                        <a:srgbClr val="2A2E3B"/>
-                      </a:solidFill>
-                      <a:prstDash val="solid"/>
-                      <a:round/>
-                      <a:headEnd type="none" w="med" len="med"/>
-                      <a:tailEnd type="none" w="med" len="med"/>
-                    </a:lnL>
-                    <a:lnR w="6350" cap="flat" cmpd="sng" algn="ctr">
-                      <a:solidFill>
-                        <a:srgbClr val="2A2E3B"/>
-                      </a:solidFill>
-                      <a:prstDash val="solid"/>
-                      <a:round/>
-                      <a:headEnd type="none" w="med" len="med"/>
-                      <a:tailEnd type="none" w="med" len="med"/>
-                    </a:lnR>
-                    <a:lnT w="6350" cap="flat" cmpd="sng" algn="ctr">
-                      <a:solidFill>
-                        <a:srgbClr val="2A2E3B"/>
-                      </a:solidFill>
-                      <a:prstDash val="solid"/>
-                      <a:round/>
-                      <a:headEnd type="none" w="med" len="med"/>
-                      <a:tailEnd type="none" w="med" len="med"/>
-                    </a:lnT>
-                    <a:lnB w="6350" cap="flat" cmpd="sng" algn="ctr">
-                      <a:solidFill>
-                        <a:srgbClr val="2A2E3B"/>
-                      </a:solidFill>
-                      <a:prstDash val="solid"/>
-                      <a:round/>
-                      <a:headEnd type="none" w="med" len="med"/>
-                      <a:tailEnd type="none" w="med" len="med"/>
-                    </a:lnB>
-                    <a:solidFill>
-                      <a:srgbClr val="1A1D27"/>
-                    </a:solidFill>
-                  </a:tcPr>
-                </a:tc>
-                <a:tc>
-                  <a:txBody>
-                    <a:bodyPr/>
-                    <a:lstStyle/>
-                    <a:p>
-                      <a:pPr algn="r" indent="0" marL="0">
-                        <a:buNone/>
-                      </a:pPr>
-                      <a:r>
-                        <a:rPr lang="en-US" sz="1200" dirty="0">
-                          <a:solidFill>
-                            <a:srgbClr val="E4E6ED"/>
-                          </a:solidFill>
-                          <a:latin typeface="Calibri" pitchFamily="34" charset="0"/>
-                          <a:ea typeface="Calibri" pitchFamily="34" charset="-122"/>
-                          <a:cs typeface="Calibri" pitchFamily="34" charset="-120"/>
-                        </a:rPr>
-                        <a:t>$106.9k</a:t>
-                      </a:r>
-                      <a:endParaRPr lang="en-US" sz="1200" dirty="0">
-                        <a:latin typeface="Calibri" charset="0"/>
-                        <a:ea typeface="Calibri" charset="0"/>
-                        <a:cs typeface="Calibri" charset="0"/>
-                      </a:endParaRPr>
-                    </a:p>
-                  </a:txBody>
-                  <a:tcPr marL="91440" marR="91440" marT="45720" marB="45720">
-                    <a:lnL w="6350" cap="flat" cmpd="sng" algn="ctr">
-                      <a:solidFill>
-                        <a:srgbClr val="2A2E3B"/>
-                      </a:solidFill>
-                      <a:prstDash val="solid"/>
-                      <a:round/>
-                      <a:headEnd type="none" w="med" len="med"/>
-                      <a:tailEnd type="none" w="med" len="med"/>
-                    </a:lnL>
-                    <a:lnR w="6350" cap="flat" cmpd="sng" algn="ctr">
-                      <a:solidFill>
-                        <a:srgbClr val="2A2E3B"/>
-                      </a:solidFill>
-                      <a:prstDash val="solid"/>
-                      <a:round/>
-                      <a:headEnd type="none" w="med" len="med"/>
-                      <a:tailEnd type="none" w="med" len="med"/>
-                    </a:lnR>
-                    <a:lnT w="6350" cap="flat" cmpd="sng" algn="ctr">
-                      <a:solidFill>
-                        <a:srgbClr val="2A2E3B"/>
-                      </a:solidFill>
-                      <a:prstDash val="solid"/>
-                      <a:round/>
-                      <a:headEnd type="none" w="med" len="med"/>
-                      <a:tailEnd type="none" w="med" len="med"/>
-                    </a:lnT>
-                    <a:lnB w="6350" cap="flat" cmpd="sng" algn="ctr">
-                      <a:solidFill>
-                        <a:srgbClr val="2A2E3B"/>
-                      </a:solidFill>
-                      <a:prstDash val="solid"/>
-                      <a:round/>
-                      <a:headEnd type="none" w="med" len="med"/>
-                      <a:tailEnd type="none" w="med" len="med"/>
-                    </a:lnB>
-                    <a:solidFill>
-                      <a:srgbClr val="1A1D27"/>
-                    </a:solidFill>
-                  </a:tcPr>
-                </a:tc>
-                <a:tc>
-                  <a:txBody>
-                    <a:bodyPr/>
-                    <a:lstStyle/>
-                    <a:p>
-                      <a:pPr algn="r" indent="0" marL="0">
-                        <a:buNone/>
-                      </a:pPr>
-                      <a:r>
-                        <a:rPr lang="en-US" sz="1200" b="1" dirty="0">
-                          <a:solidFill>
-                            <a:srgbClr val="74B9FF"/>
-                          </a:solidFill>
-                          <a:latin typeface="Calibri" pitchFamily="34" charset="0"/>
-                          <a:ea typeface="Calibri" pitchFamily="34" charset="-122"/>
-                          <a:cs typeface="Calibri" pitchFamily="34" charset="-120"/>
-                        </a:rPr>
-                        <a:t>weekly</a:t>
-                      </a:r>
-                      <a:endParaRPr lang="en-US" sz="1200" dirty="0">
-                        <a:latin typeface="Calibri" charset="0"/>
-                        <a:ea typeface="Calibri" charset="0"/>
-                        <a:cs typeface="Calibri" charset="0"/>
-                      </a:endParaRPr>
-                    </a:p>
-                  </a:txBody>
-                  <a:tcPr marL="91440" marR="91440" marT="45720" marB="45720">
-                    <a:lnL w="6350" cap="flat" cmpd="sng" algn="ctr">
-                      <a:solidFill>
-                        <a:srgbClr val="2A2E3B"/>
-                      </a:solidFill>
-                      <a:prstDash val="solid"/>
-                      <a:round/>
-                      <a:headEnd type="none" w="med" len="med"/>
-                      <a:tailEnd type="none" w="med" len="med"/>
-                    </a:lnL>
-                    <a:lnR w="6350" cap="flat" cmpd="sng" algn="ctr">
-                      <a:solidFill>
-                        <a:srgbClr val="2A2E3B"/>
-                      </a:solidFill>
-                      <a:prstDash val="solid"/>
-                      <a:round/>
-                      <a:headEnd type="none" w="med" len="med"/>
-                      <a:tailEnd type="none" w="med" len="med"/>
-                    </a:lnR>
-                    <a:lnT w="6350" cap="flat" cmpd="sng" algn="ctr">
-                      <a:solidFill>
-                        <a:srgbClr val="2A2E3B"/>
-                      </a:solidFill>
-                      <a:prstDash val="solid"/>
-                      <a:round/>
-                      <a:headEnd type="none" w="med" len="med"/>
-                      <a:tailEnd type="none" w="med" len="med"/>
-                    </a:lnT>
-                    <a:lnB w="6350" cap="flat" cmpd="sng" algn="ctr">
-                      <a:solidFill>
-                        <a:srgbClr val="2A2E3B"/>
-                      </a:solidFill>
-                      <a:prstDash val="solid"/>
-                      <a:round/>
-                      <a:headEnd type="none" w="med" len="med"/>
-                      <a:tailEnd type="none" w="med" len="med"/>
-                    </a:lnB>
-                    <a:solidFill>
-                      <a:srgbClr val="1A1D27"/>
-                    </a:solidFill>
-                  </a:tcPr>
-                </a:tc>
-                <a:tc>
-                  <a:txBody>
-                    <a:bodyPr/>
-                    <a:lstStyle/>
-                    <a:p>
-                      <a:pPr indent="0" marL="0">
-                        <a:buNone/>
-                      </a:pPr>
-                      <a:r>
-                        <a:rPr lang="en-US" sz="1000" dirty="0">
-                          <a:solidFill>
-                            <a:srgbClr val="8B8FA3"/>
-                          </a:solidFill>
-                          <a:latin typeface="Calibri" pitchFamily="34" charset="0"/>
-                          <a:ea typeface="Calibri" pitchFamily="34" charset="-122"/>
-                          <a:cs typeface="Calibri" pitchFamily="34" charset="-120"/>
-                        </a:rPr>
-                        <a:t>MEDDICC discipline on every $10k+ open deal</a:t>
-                      </a:r>
-                      <a:endParaRPr lang="en-US" sz="1000" dirty="0">
-                        <a:latin typeface="Calibri" charset="0"/>
-                        <a:ea typeface="Calibri" charset="0"/>
-                        <a:cs typeface="Calibri" charset="0"/>
-                      </a:endParaRPr>
-                    </a:p>
-                  </a:txBody>
-                  <a:tcPr marL="91440" marR="91440" marT="45720" marB="45720">
-                    <a:lnL w="6350" cap="flat" cmpd="sng" algn="ctr">
-                      <a:solidFill>
-                        <a:srgbClr val="2A2E3B"/>
-                      </a:solidFill>
-                      <a:prstDash val="solid"/>
-                      <a:round/>
-                      <a:headEnd type="none" w="med" len="med"/>
-                      <a:tailEnd type="none" w="med" len="med"/>
-                    </a:lnL>
-                    <a:lnR w="6350" cap="flat" cmpd="sng" algn="ctr">
-                      <a:solidFill>
-                        <a:srgbClr val="2A2E3B"/>
-                      </a:solidFill>
-                      <a:prstDash val="solid"/>
-                      <a:round/>
-                      <a:headEnd type="none" w="med" len="med"/>
-                      <a:tailEnd type="none" w="med" len="med"/>
-                    </a:lnR>
-                    <a:lnT w="6350" cap="flat" cmpd="sng" algn="ctr">
-                      <a:solidFill>
-                        <a:srgbClr val="2A2E3B"/>
-                      </a:solidFill>
-                      <a:prstDash val="solid"/>
-                      <a:round/>
-                      <a:headEnd type="none" w="med" len="med"/>
-                      <a:tailEnd type="none" w="med" len="med"/>
-                    </a:lnT>
-                    <a:lnB w="6350" cap="flat" cmpd="sng" algn="ctr">
-                      <a:solidFill>
-                        <a:srgbClr val="2A2E3B"/>
-                      </a:solidFill>
-                      <a:prstDash val="solid"/>
-                      <a:round/>
-                      <a:headEnd type="none" w="med" len="med"/>
-                      <a:tailEnd type="none" w="med" len="med"/>
-                    </a:lnB>
-                    <a:solidFill>
-                      <a:srgbClr val="1A1D27"/>
-                    </a:solidFill>
-                  </a:tcPr>
-                </a:tc>
-              </a:tr>
-              <a:tr h="457200">
-                <a:tc>
-                  <a:txBody>
-                    <a:bodyPr/>
-                    <a:lstStyle/>
-                    <a:p>
-                      <a:pPr indent="0" marL="0">
-                        <a:buNone/>
-                      </a:pPr>
-                      <a:r>
-                        <a:rPr lang="en-US" sz="1200" dirty="0">
-                          <a:solidFill>
-                            <a:srgbClr val="E4E6ED"/>
-                          </a:solidFill>
-                          <a:latin typeface="Calibri" pitchFamily="34" charset="0"/>
-                          <a:ea typeface="Calibri" pitchFamily="34" charset="-122"/>
-                          <a:cs typeface="Calibri" pitchFamily="34" charset="-120"/>
-                        </a:rPr>
-                        <a:t>Cold dials</a:t>
-                      </a:r>
-                      <a:endParaRPr lang="en-US" sz="1200" dirty="0">
-                        <a:latin typeface="Calibri" charset="0"/>
-                        <a:ea typeface="Calibri" charset="0"/>
-                        <a:cs typeface="Calibri" charset="0"/>
-                      </a:endParaRPr>
-                    </a:p>
-                  </a:txBody>
-                  <a:tcPr marL="91440" marR="91440" marT="45720" marB="45720">
-                    <a:lnL w="6350" cap="flat" cmpd="sng" algn="ctr">
-                      <a:solidFill>
-                        <a:srgbClr val="2A2E3B"/>
-                      </a:solidFill>
-                      <a:prstDash val="solid"/>
-                      <a:round/>
-                      <a:headEnd type="none" w="med" len="med"/>
-                      <a:tailEnd type="none" w="med" len="med"/>
-                    </a:lnL>
-                    <a:lnR w="6350" cap="flat" cmpd="sng" algn="ctr">
-                      <a:solidFill>
-                        <a:srgbClr val="2A2E3B"/>
-                      </a:solidFill>
-                      <a:prstDash val="solid"/>
-                      <a:round/>
-                      <a:headEnd type="none" w="med" len="med"/>
-                      <a:tailEnd type="none" w="med" len="med"/>
-                    </a:lnR>
-                    <a:lnT w="6350" cap="flat" cmpd="sng" algn="ctr">
-                      <a:solidFill>
-                        <a:srgbClr val="2A2E3B"/>
-                      </a:solidFill>
-                      <a:prstDash val="solid"/>
-                      <a:round/>
-                      <a:headEnd type="none" w="med" len="med"/>
-                      <a:tailEnd type="none" w="med" len="med"/>
-                    </a:lnT>
-                    <a:lnB w="6350" cap="flat" cmpd="sng" algn="ctr">
-                      <a:solidFill>
-                        <a:srgbClr val="2A2E3B"/>
-                      </a:solidFill>
-                      <a:prstDash val="solid"/>
-                      <a:round/>
-                      <a:headEnd type="none" w="med" len="med"/>
-                      <a:tailEnd type="none" w="med" len="med"/>
-                    </a:lnB>
-                    <a:solidFill>
-                      <a:srgbClr val="1A1D27"/>
-                    </a:solidFill>
-                  </a:tcPr>
-                </a:tc>
-                <a:tc>
-                  <a:txBody>
-                    <a:bodyPr/>
-                    <a:lstStyle/>
-                    <a:p>
-                      <a:pPr algn="r" indent="0" marL="0">
-                        <a:buNone/>
-                      </a:pPr>
-                      <a:r>
-                        <a:rPr lang="en-US" sz="1200" dirty="0">
-                          <a:solidFill>
-                            <a:srgbClr val="E4E6ED"/>
-                          </a:solidFill>
-                          <a:latin typeface="Calibri" pitchFamily="34" charset="0"/>
-                          <a:ea typeface="Calibri" pitchFamily="34" charset="-122"/>
-                          <a:cs typeface="Calibri" pitchFamily="34" charset="-120"/>
-                        </a:rPr>
-                        <a:t>0</a:t>
-                      </a:r>
-                      <a:endParaRPr lang="en-US" sz="1200" dirty="0">
-                        <a:latin typeface="Calibri" charset="0"/>
-                        <a:ea typeface="Calibri" charset="0"/>
-                        <a:cs typeface="Calibri" charset="0"/>
-                      </a:endParaRPr>
-                    </a:p>
-                  </a:txBody>
-                  <a:tcPr marL="91440" marR="91440" marT="45720" marB="45720">
-                    <a:lnL w="6350" cap="flat" cmpd="sng" algn="ctr">
-                      <a:solidFill>
-                        <a:srgbClr val="2A2E3B"/>
-                      </a:solidFill>
-                      <a:prstDash val="solid"/>
-                      <a:round/>
-                      <a:headEnd type="none" w="med" len="med"/>
-                      <a:tailEnd type="none" w="med" len="med"/>
-                    </a:lnL>
-                    <a:lnR w="6350" cap="flat" cmpd="sng" algn="ctr">
-                      <a:solidFill>
-                        <a:srgbClr val="2A2E3B"/>
-                      </a:solidFill>
-                      <a:prstDash val="solid"/>
-                      <a:round/>
-                      <a:headEnd type="none" w="med" len="med"/>
-                      <a:tailEnd type="none" w="med" len="med"/>
-                    </a:lnR>
-                    <a:lnT w="6350" cap="flat" cmpd="sng" algn="ctr">
-                      <a:solidFill>
-                        <a:srgbClr val="2A2E3B"/>
-                      </a:solidFill>
-                      <a:prstDash val="solid"/>
-                      <a:round/>
-                      <a:headEnd type="none" w="med" len="med"/>
-                      <a:tailEnd type="none" w="med" len="med"/>
-                    </a:lnT>
-                    <a:lnB w="6350" cap="flat" cmpd="sng" algn="ctr">
-                      <a:solidFill>
-                        <a:srgbClr val="2A2E3B"/>
-                      </a:solidFill>
-                      <a:prstDash val="solid"/>
-                      <a:round/>
-                      <a:headEnd type="none" w="med" len="med"/>
-                      <a:tailEnd type="none" w="med" len="med"/>
-                    </a:lnB>
-                    <a:solidFill>
-                      <a:srgbClr val="1A1D27"/>
-                    </a:solidFill>
-                  </a:tcPr>
-                </a:tc>
-                <a:tc>
-                  <a:txBody>
-                    <a:bodyPr/>
-                    <a:lstStyle/>
-                    <a:p>
-                      <a:pPr algn="r" indent="0" marL="0">
-                        <a:buNone/>
-                      </a:pPr>
-                      <a:r>
-                        <a:rPr lang="en-US" sz="1200" b="1" dirty="0">
-                          <a:solidFill>
-                            <a:srgbClr val="74B9FF"/>
-                          </a:solidFill>
-                          <a:latin typeface="Calibri" pitchFamily="34" charset="0"/>
-                          <a:ea typeface="Calibri" pitchFamily="34" charset="-122"/>
-                          <a:cs typeface="Calibri" pitchFamily="34" charset="-120"/>
-                        </a:rPr>
-                        <a:t>—</a:t>
-                      </a:r>
-                      <a:endParaRPr lang="en-US" sz="1200" dirty="0">
-                        <a:latin typeface="Calibri" charset="0"/>
-                        <a:ea typeface="Calibri" charset="0"/>
-                        <a:cs typeface="Calibri" charset="0"/>
-                      </a:endParaRPr>
-                    </a:p>
-                  </a:txBody>
-                  <a:tcPr marL="91440" marR="91440" marT="45720" marB="45720">
-                    <a:lnL w="6350" cap="flat" cmpd="sng" algn="ctr">
-                      <a:solidFill>
-                        <a:srgbClr val="2A2E3B"/>
-                      </a:solidFill>
-                      <a:prstDash val="solid"/>
-                      <a:round/>
-                      <a:headEnd type="none" w="med" len="med"/>
-                      <a:tailEnd type="none" w="med" len="med"/>
-                    </a:lnL>
-                    <a:lnR w="6350" cap="flat" cmpd="sng" algn="ctr">
-                      <a:solidFill>
-                        <a:srgbClr val="2A2E3B"/>
-                      </a:solidFill>
-                      <a:prstDash val="solid"/>
-                      <a:round/>
-                      <a:headEnd type="none" w="med" len="med"/>
-                      <a:tailEnd type="none" w="med" len="med"/>
-                    </a:lnR>
-                    <a:lnT w="6350" cap="flat" cmpd="sng" algn="ctr">
-                      <a:solidFill>
-                        <a:srgbClr val="2A2E3B"/>
-                      </a:solidFill>
-                      <a:prstDash val="solid"/>
-                      <a:round/>
-                      <a:headEnd type="none" w="med" len="med"/>
-                      <a:tailEnd type="none" w="med" len="med"/>
-                    </a:lnT>
-                    <a:lnB w="6350" cap="flat" cmpd="sng" algn="ctr">
-                      <a:solidFill>
-                        <a:srgbClr val="2A2E3B"/>
-                      </a:solidFill>
-                      <a:prstDash val="solid"/>
-                      <a:round/>
-                      <a:headEnd type="none" w="med" len="med"/>
-                      <a:tailEnd type="none" w="med" len="med"/>
-                    </a:lnB>
-                    <a:solidFill>
-                      <a:srgbClr val="1A1D27"/>
-                    </a:solidFill>
-                  </a:tcPr>
-                </a:tc>
-                <a:tc>
-                  <a:txBody>
-                    <a:bodyPr/>
-                    <a:lstStyle/>
-                    <a:p>
-                      <a:pPr indent="0" marL="0">
-                        <a:buNone/>
-                      </a:pPr>
-                      <a:r>
-                        <a:rPr lang="en-US" sz="1000" dirty="0">
-                          <a:solidFill>
-                            <a:srgbClr val="8B8FA3"/>
-                          </a:solidFill>
-                          <a:latin typeface="Calibri" pitchFamily="34" charset="0"/>
-                          <a:ea typeface="Calibri" pitchFamily="34" charset="-122"/>
-                          <a:cs typeface="Calibri" pitchFamily="34" charset="-120"/>
-                        </a:rPr>
-                        <a:t>Deprioritized in the KAM motion — not a July KPI</a:t>
-                      </a:r>
-                      <a:endParaRPr lang="en-US" sz="1000" dirty="0">
-                        <a:latin typeface="Calibri" charset="0"/>
-                        <a:ea typeface="Calibri" charset="0"/>
-                        <a:cs typeface="Calibri" charset="0"/>
-                      </a:endParaRPr>
-                    </a:p>
-                  </a:txBody>
-                  <a:tcPr marL="91440" marR="91440" marT="45720" marB="45720">
-                    <a:lnL w="6350" cap="flat" cmpd="sng" algn="ctr">
-                      <a:solidFill>
-                        <a:srgbClr val="2A2E3B"/>
-                      </a:solidFill>
-                      <a:prstDash val="solid"/>
-                      <a:round/>
-                      <a:headEnd type="none" w="med" len="med"/>
-                      <a:tailEnd type="none" w="med" len="med"/>
-                    </a:lnL>
-                    <a:lnR w="6350" cap="flat" cmpd="sng" algn="ctr">
-                      <a:solidFill>
-                        <a:srgbClr val="2A2E3B"/>
-                      </a:solidFill>
-                      <a:prstDash val="solid"/>
-                      <a:round/>
-                      <a:headEnd type="none" w="med" len="med"/>
-                      <a:tailEnd type="none" w="med" len="med"/>
-                    </a:lnR>
-                    <a:lnT w="6350" cap="flat" cmpd="sng" algn="ctr">
-                      <a:solidFill>
-                        <a:srgbClr val="2A2E3B"/>
-                      </a:solidFill>
-                      <a:prstDash val="solid"/>
-                      <a:round/>
-                      <a:headEnd type="none" w="med" len="med"/>
-                      <a:tailEnd type="none" w="med" len="med"/>
-                    </a:lnT>
-                    <a:lnB w="6350" cap="flat" cmpd="sng" algn="ctr">
-                      <a:solidFill>
-                        <a:srgbClr val="2A2E3B"/>
-                      </a:solidFill>
-                      <a:prstDash val="solid"/>
-                      <a:round/>
-                      <a:headEnd type="none" w="med" len="med"/>
-                      <a:tailEnd type="none" w="med" len="med"/>
-                    </a:lnB>
-                    <a:solidFill>
-                      <a:srgbClr val="1A1D27"/>
-                    </a:solidFill>
-                  </a:tcPr>
-                </a:tc>
-              </a:tr>
-            </a:tbl>
-          </a:graphicData>
-        </a:graphic>
-      </p:graphicFrame>
       <p:sp>
         <p:nvSpPr>
-          <p:cNvPr id="6" name="Shape 3"/>
+          <p:cNvPr id="5" name="Shape 3"/>
+          <p:cNvSpPr/>
+          <p:nvPr/>
+        </p:nvSpPr>
+        <p:spPr>
+          <a:xfrm>
+            <a:off x="365760" y="1600200"/>
+            <a:ext cx="5669280" cy="3703320"/>
+          </a:xfrm>
+          <a:prstGeom prst="rect">
+            <a:avLst/>
+          </a:prstGeom>
+          <a:solidFill>
+            <a:srgbClr val="222632"/>
+          </a:solidFill>
+          <a:ln w="6350">
+            <a:solidFill>
+              <a:srgbClr val="2A2E3B"/>
+            </a:solidFill>
+            <a:prstDash val="solid"/>
+          </a:ln>
+        </p:spPr>
+      </p:sp>
+      <p:sp>
+        <p:nvSpPr>
+          <p:cNvPr id="6" name="Shape 4"/>
+          <p:cNvSpPr/>
+          <p:nvPr/>
+        </p:nvSpPr>
+        <p:spPr>
+          <a:xfrm>
+            <a:off x="365760" y="1600200"/>
+            <a:ext cx="73152" cy="3703320"/>
+          </a:xfrm>
+          <a:prstGeom prst="rect">
+            <a:avLst/>
+          </a:prstGeom>
+          <a:solidFill>
+            <a:srgbClr val="74B9FF"/>
+          </a:solidFill>
+          <a:ln w="12700">
+            <a:solidFill>
+              <a:srgbClr val="333333"/>
+            </a:solidFill>
+            <a:prstDash val="solid"/>
+          </a:ln>
+        </p:spPr>
+      </p:sp>
+      <p:sp>
+        <p:nvSpPr>
+          <p:cNvPr id="7" name="Text 5"/>
+          <p:cNvSpPr/>
+          <p:nvPr/>
+        </p:nvSpPr>
+        <p:spPr>
+          <a:xfrm>
+            <a:off x="594360" y="1737360"/>
+            <a:ext cx="5303520" cy="228600"/>
+          </a:xfrm>
+          <a:prstGeom prst="rect">
+            <a:avLst/>
+          </a:prstGeom>
+          <a:noFill/>
+          <a:ln/>
+        </p:spPr>
+        <p:txBody>
+          <a:bodyPr wrap="square" rtlCol="0" anchor="ctr"/>
+          <a:lstStyle/>
+          <a:p>
+            <a:pPr indent="0" marL="0">
+              <a:buNone/>
+            </a:pPr>
+            <a:r>
+              <a:rPr lang="en-US" sz="1000" b="1" spc="200" kern="0" dirty="0">
+                <a:solidFill>
+                  <a:srgbClr val="8B8FA3"/>
+                </a:solidFill>
+                <a:latin typeface="Calibri" pitchFamily="34" charset="0"/>
+                <a:ea typeface="Calibri" pitchFamily="34" charset="-122"/>
+                <a:cs typeface="Calibri" pitchFamily="34" charset="-120"/>
+              </a:rPr>
+              <a:t>MONTH 1</a:t>
+            </a:r>
+            <a:endParaRPr lang="en-US" sz="1000" dirty="0"/>
+          </a:p>
+        </p:txBody>
+      </p:sp>
+      <p:sp>
+        <p:nvSpPr>
+          <p:cNvPr id="8" name="Text 6"/>
+          <p:cNvSpPr/>
+          <p:nvPr/>
+        </p:nvSpPr>
+        <p:spPr>
+          <a:xfrm>
+            <a:off x="594360" y="1965960"/>
+            <a:ext cx="5303520" cy="365760"/>
+          </a:xfrm>
+          <a:prstGeom prst="rect">
+            <a:avLst/>
+          </a:prstGeom>
+          <a:noFill/>
+          <a:ln/>
+        </p:spPr>
+        <p:txBody>
+          <a:bodyPr wrap="square" rtlCol="0" anchor="ctr"/>
+          <a:lstStyle/>
+          <a:p>
+            <a:pPr indent="0" marL="0">
+              <a:buNone/>
+            </a:pPr>
+            <a:r>
+              <a:rPr lang="en-US" sz="1600" b="1" dirty="0">
+                <a:solidFill>
+                  <a:srgbClr val="74B9FF"/>
+                </a:solidFill>
+                <a:latin typeface="Calibri" pitchFamily="34" charset="0"/>
+                <a:ea typeface="Calibri" pitchFamily="34" charset="-122"/>
+                <a:cs typeface="Calibri" pitchFamily="34" charset="-120"/>
+              </a:rPr>
+              <a:t>JULY — LEARN &amp; COVER</a:t>
+            </a:r>
+            <a:endParaRPr lang="en-US" sz="1600" dirty="0"/>
+          </a:p>
+        </p:txBody>
+      </p:sp>
+      <p:sp>
+        <p:nvSpPr>
+          <p:cNvPr id="9" name="Text 7"/>
+          <p:cNvSpPr/>
+          <p:nvPr/>
+        </p:nvSpPr>
+        <p:spPr>
+          <a:xfrm>
+            <a:off x="594360" y="2514600"/>
+            <a:ext cx="5212080" cy="2743200"/>
+          </a:xfrm>
+          <a:prstGeom prst="rect">
+            <a:avLst/>
+          </a:prstGeom>
+          <a:noFill/>
+          <a:ln/>
+        </p:spPr>
+        <p:txBody>
+          <a:bodyPr wrap="square" rtlCol="0" anchor="t"/>
+          <a:lstStyle/>
+          <a:p>
+            <a:pPr indent="0" marL="0">
+              <a:buNone/>
+            </a:pPr>
+            <a:r>
+              <a:rPr lang="en-US" sz="1300" b="1" dirty="0">
+                <a:solidFill>
+                  <a:srgbClr val="E4E6ED"/>
+                </a:solidFill>
+                <a:latin typeface="Calibri" pitchFamily="34" charset="0"/>
+                <a:ea typeface="Calibri" pitchFamily="34" charset="-122"/>
+                <a:cs typeface="Calibri" pitchFamily="34" charset="-120"/>
+              </a:rPr>
+              <a:t>• Tier all 75 Gold accounts</a:t>
+            </a:r>
+            <a:pPr indent="0" marL="0">
+              <a:buNone/>
+            </a:pPr>
+            <a:r>
+              <a:rPr lang="en-US" sz="1250" dirty="0">
+                <a:solidFill>
+                  <a:srgbClr val="8B8FA3"/>
+                </a:solidFill>
+                <a:latin typeface="Calibri" pitchFamily="34" charset="0"/>
+                <a:ea typeface="Calibri" pitchFamily="34" charset="-122"/>
+                <a:cs typeface="Calibri" pitchFamily="34" charset="-120"/>
+              </a:rPr>
+              <a:t> — health, spend, whitespace, renewal timing
+</a:t>
+            </a:r>
+            <a:pPr indent="0" marL="0">
+              <a:buNone/>
+            </a:pPr>
+            <a:r>
+              <a:rPr lang="en-US" sz="1300" b="1" dirty="0">
+                <a:solidFill>
+                  <a:srgbClr val="E4E6ED"/>
+                </a:solidFill>
+                <a:latin typeface="Calibri" pitchFamily="34" charset="0"/>
+                <a:ea typeface="Calibri" pitchFamily="34" charset="-122"/>
+                <a:cs typeface="Calibri" pitchFamily="34" charset="-120"/>
+              </a:rPr>
+              <a:t>• First-pass coverage touch</a:t>
+            </a:r>
+            <a:pPr indent="0" marL="0">
+              <a:buNone/>
+            </a:pPr>
+            <a:r>
+              <a:rPr lang="en-US" sz="1250" dirty="0">
+                <a:solidFill>
+                  <a:srgbClr val="8B8FA3"/>
+                </a:solidFill>
+                <a:latin typeface="Calibri" pitchFamily="34" charset="0"/>
+                <a:ea typeface="Calibri" pitchFamily="34" charset="-122"/>
+                <a:cs typeface="Calibri" pitchFamily="34" charset="-120"/>
+              </a:rPr>
+              <a:t> across the Gold base
+</a:t>
+            </a:r>
+            <a:pPr indent="0" marL="0">
+              <a:buNone/>
+            </a:pPr>
+            <a:r>
+              <a:rPr lang="en-US" sz="1300" b="1" dirty="0">
+                <a:solidFill>
+                  <a:srgbClr val="E4E6ED"/>
+                </a:solidFill>
+                <a:latin typeface="Calibri" pitchFamily="34" charset="0"/>
+                <a:ea typeface="Calibri" pitchFamily="34" charset="-122"/>
+                <a:cs typeface="Calibri" pitchFamily="34" charset="-120"/>
+              </a:rPr>
+              <a:t>• Triage every dated renewal</a:t>
+            </a:r>
+            <a:pPr indent="0" marL="0">
+              <a:buNone/>
+            </a:pPr>
+            <a:r>
+              <a:rPr lang="en-US" sz="1250" dirty="0">
+                <a:solidFill>
+                  <a:srgbClr val="8B8FA3"/>
+                </a:solidFill>
+                <a:latin typeface="Calibri" pitchFamily="34" charset="0"/>
+                <a:ea typeface="Calibri" pitchFamily="34" charset="-122"/>
+                <a:cs typeface="Calibri" pitchFamily="34" charset="-120"/>
+              </a:rPr>
+              <a:t> (Hawaiian $20k Q3'27, etc.) — no surprises
+</a:t>
+            </a:r>
+            <a:pPr indent="0" marL="0">
+              <a:buNone/>
+            </a:pPr>
+            <a:r>
+              <a:rPr lang="en-US" sz="1300" b="1" dirty="0">
+                <a:solidFill>
+                  <a:srgbClr val="E4E6ED"/>
+                </a:solidFill>
+                <a:latin typeface="Calibri" pitchFamily="34" charset="0"/>
+                <a:ea typeface="Calibri" pitchFamily="34" charset="-122"/>
+                <a:cs typeface="Calibri" pitchFamily="34" charset="-120"/>
+              </a:rPr>
+              <a:t>• Clean the book</a:t>
+            </a:r>
+            <a:pPr indent="0" marL="0">
+              <a:buNone/>
+            </a:pPr>
+            <a:r>
+              <a:rPr lang="en-US" sz="1250" dirty="0">
+                <a:solidFill>
+                  <a:srgbClr val="8B8FA3"/>
+                </a:solidFill>
+                <a:latin typeface="Calibri" pitchFamily="34" charset="0"/>
+                <a:ea typeface="Calibri" pitchFamily="34" charset="-122"/>
+                <a:cs typeface="Calibri" pitchFamily="34" charset="-120"/>
+              </a:rPr>
+              <a:t> — day-60 disqualification sweep on inherited pipe
+</a:t>
+            </a:r>
+            <a:pPr indent="0" marL="0">
+              <a:buNone/>
+            </a:pPr>
+            <a:r>
+              <a:rPr lang="en-US" sz="1300" b="1" dirty="0">
+                <a:solidFill>
+                  <a:srgbClr val="00B894"/>
+                </a:solidFill>
+                <a:latin typeface="Calibri" pitchFamily="34" charset="0"/>
+                <a:ea typeface="Calibri" pitchFamily="34" charset="-122"/>
+                <a:cs typeface="Calibri" pitchFamily="34" charset="-120"/>
+              </a:rPr>
+              <a:t>• Close the confirmed July FC</a:t>
+            </a:r>
+            <a:pPr indent="0" marL="0">
+              <a:buNone/>
+            </a:pPr>
+            <a:r>
+              <a:rPr lang="en-US" sz="1250" dirty="0">
+                <a:solidFill>
+                  <a:srgbClr val="8B8FA3"/>
+                </a:solidFill>
+                <a:latin typeface="Calibri" pitchFamily="34" charset="0"/>
+                <a:ea typeface="Calibri" pitchFamily="34" charset="-122"/>
+                <a:cs typeface="Calibri" pitchFamily="34" charset="-120"/>
+              </a:rPr>
+              <a:t> ($18.8k)</a:t>
+            </a:r>
+            <a:endParaRPr lang="en-US" sz="1300" dirty="0"/>
+          </a:p>
+        </p:txBody>
+      </p:sp>
+      <p:sp>
+        <p:nvSpPr>
+          <p:cNvPr id="10" name="Shape 8"/>
+          <p:cNvSpPr/>
+          <p:nvPr/>
+        </p:nvSpPr>
+        <p:spPr>
+          <a:xfrm>
+            <a:off x="6217920" y="1600200"/>
+            <a:ext cx="5669280" cy="3703320"/>
+          </a:xfrm>
+          <a:prstGeom prst="rect">
+            <a:avLst/>
+          </a:prstGeom>
+          <a:solidFill>
+            <a:srgbClr val="222632"/>
+          </a:solidFill>
+          <a:ln w="6350">
+            <a:solidFill>
+              <a:srgbClr val="2A2E3B"/>
+            </a:solidFill>
+            <a:prstDash val="solid"/>
+          </a:ln>
+        </p:spPr>
+      </p:sp>
+      <p:sp>
+        <p:nvSpPr>
+          <p:cNvPr id="11" name="Shape 9"/>
+          <p:cNvSpPr/>
+          <p:nvPr/>
+        </p:nvSpPr>
+        <p:spPr>
+          <a:xfrm>
+            <a:off x="6217920" y="1600200"/>
+            <a:ext cx="73152" cy="3703320"/>
+          </a:xfrm>
+          <a:prstGeom prst="rect">
+            <a:avLst/>
+          </a:prstGeom>
+          <a:solidFill>
+            <a:srgbClr val="6C5CE7"/>
+          </a:solidFill>
+          <a:ln w="12700">
+            <a:solidFill>
+              <a:srgbClr val="333333"/>
+            </a:solidFill>
+            <a:prstDash val="solid"/>
+          </a:ln>
+        </p:spPr>
+      </p:sp>
+      <p:sp>
+        <p:nvSpPr>
+          <p:cNvPr id="12" name="Text 10"/>
+          <p:cNvSpPr/>
+          <p:nvPr/>
+        </p:nvSpPr>
+        <p:spPr>
+          <a:xfrm>
+            <a:off x="6446520" y="1737360"/>
+            <a:ext cx="5303520" cy="228600"/>
+          </a:xfrm>
+          <a:prstGeom prst="rect">
+            <a:avLst/>
+          </a:prstGeom>
+          <a:noFill/>
+          <a:ln/>
+        </p:spPr>
+        <p:txBody>
+          <a:bodyPr wrap="square" rtlCol="0" anchor="ctr"/>
+          <a:lstStyle/>
+          <a:p>
+            <a:pPr indent="0" marL="0">
+              <a:buNone/>
+            </a:pPr>
+            <a:r>
+              <a:rPr lang="en-US" sz="1000" b="1" spc="200" kern="0" dirty="0">
+                <a:solidFill>
+                  <a:srgbClr val="8B8FA3"/>
+                </a:solidFill>
+                <a:latin typeface="Calibri" pitchFamily="34" charset="0"/>
+                <a:ea typeface="Calibri" pitchFamily="34" charset="-122"/>
+                <a:cs typeface="Calibri" pitchFamily="34" charset="-120"/>
+              </a:rPr>
+              <a:t>MONTH 2</a:t>
+            </a:r>
+            <a:endParaRPr lang="en-US" sz="1000" dirty="0"/>
+          </a:p>
+        </p:txBody>
+      </p:sp>
+      <p:sp>
+        <p:nvSpPr>
+          <p:cNvPr id="13" name="Text 11"/>
+          <p:cNvSpPr/>
+          <p:nvPr/>
+        </p:nvSpPr>
+        <p:spPr>
+          <a:xfrm>
+            <a:off x="6446520" y="1965960"/>
+            <a:ext cx="5303520" cy="365760"/>
+          </a:xfrm>
+          <a:prstGeom prst="rect">
+            <a:avLst/>
+          </a:prstGeom>
+          <a:noFill/>
+          <a:ln/>
+        </p:spPr>
+        <p:txBody>
+          <a:bodyPr wrap="square" rtlCol="0" anchor="ctr"/>
+          <a:lstStyle/>
+          <a:p>
+            <a:pPr indent="0" marL="0">
+              <a:buNone/>
+            </a:pPr>
+            <a:r>
+              <a:rPr lang="en-US" sz="1600" b="1" dirty="0">
+                <a:solidFill>
+                  <a:srgbClr val="6C5CE7"/>
+                </a:solidFill>
+                <a:latin typeface="Calibri" pitchFamily="34" charset="0"/>
+                <a:ea typeface="Calibri" pitchFamily="34" charset="-122"/>
+                <a:cs typeface="Calibri" pitchFamily="34" charset="-120"/>
+              </a:rPr>
+              <a:t>AUGUST — PLAN &amp; DRIVE</a:t>
+            </a:r>
+            <a:endParaRPr lang="en-US" sz="1600" dirty="0"/>
+          </a:p>
+        </p:txBody>
+      </p:sp>
+      <p:sp>
+        <p:nvSpPr>
+          <p:cNvPr id="14" name="Text 12"/>
+          <p:cNvSpPr/>
+          <p:nvPr/>
+        </p:nvSpPr>
+        <p:spPr>
+          <a:xfrm>
+            <a:off x="6446520" y="2514600"/>
+            <a:ext cx="5212080" cy="2743200"/>
+          </a:xfrm>
+          <a:prstGeom prst="rect">
+            <a:avLst/>
+          </a:prstGeom>
+          <a:noFill/>
+          <a:ln/>
+        </p:spPr>
+        <p:txBody>
+          <a:bodyPr wrap="square" rtlCol="0" anchor="t"/>
+          <a:lstStyle/>
+          <a:p>
+            <a:pPr indent="0" marL="0">
+              <a:buNone/>
+            </a:pPr>
+            <a:r>
+              <a:rPr lang="en-US" sz="1300" b="1" dirty="0">
+                <a:solidFill>
+                  <a:srgbClr val="E4E6ED"/>
+                </a:solidFill>
+                <a:latin typeface="Calibri" pitchFamily="34" charset="0"/>
+                <a:ea typeface="Calibri" pitchFamily="34" charset="-122"/>
+                <a:cs typeface="Calibri" pitchFamily="34" charset="-120"/>
+              </a:rPr>
+              <a:t>• Build account plans</a:t>
+            </a:r>
+            <a:pPr indent="0" marL="0">
+              <a:buNone/>
+            </a:pPr>
+            <a:r>
+              <a:rPr lang="en-US" sz="1250" dirty="0">
+                <a:solidFill>
+                  <a:srgbClr val="8B8FA3"/>
+                </a:solidFill>
+                <a:latin typeface="Calibri" pitchFamily="34" charset="0"/>
+                <a:ea typeface="Calibri" pitchFamily="34" charset="-122"/>
+                <a:cs typeface="Calibri" pitchFamily="34" charset="-120"/>
+              </a:rPr>
+              <a:t> for the top ~25 Gold accounts (ARR + renewals first)
+</a:t>
+            </a:r>
+            <a:pPr indent="0" marL="0">
+              <a:buNone/>
+            </a:pPr>
+            <a:r>
+              <a:rPr lang="en-US" sz="1300" b="1" dirty="0">
+                <a:solidFill>
+                  <a:srgbClr val="E4E6ED"/>
+                </a:solidFill>
+                <a:latin typeface="Calibri" pitchFamily="34" charset="0"/>
+                <a:ea typeface="Calibri" pitchFamily="34" charset="-122"/>
+                <a:cs typeface="Calibri" pitchFamily="34" charset="-120"/>
+              </a:rPr>
+              <a:t>• Run QBRs / value reviews</a:t>
+            </a:r>
+            <a:pPr indent="0" marL="0">
+              <a:buNone/>
+            </a:pPr>
+            <a:r>
+              <a:rPr lang="en-US" sz="1250" dirty="0">
+                <a:solidFill>
+                  <a:srgbClr val="8B8FA3"/>
+                </a:solidFill>
+                <a:latin typeface="Calibri" pitchFamily="34" charset="0"/>
+                <a:ea typeface="Calibri" pitchFamily="34" charset="-122"/>
+                <a:cs typeface="Calibri" pitchFamily="34" charset="-120"/>
+              </a:rPr>
+              <a:t> — quantify ROI delivered to date
+</a:t>
+            </a:r>
+            <a:pPr indent="0" marL="0">
+              <a:buNone/>
+            </a:pPr>
+            <a:r>
+              <a:rPr lang="en-US" sz="1300" b="1" dirty="0">
+                <a:solidFill>
+                  <a:srgbClr val="E4E6ED"/>
+                </a:solidFill>
+                <a:latin typeface="Calibri" pitchFamily="34" charset="0"/>
+                <a:ea typeface="Calibri" pitchFamily="34" charset="-122"/>
+                <a:cs typeface="Calibri" pitchFamily="34" charset="-120"/>
+              </a:rPr>
+              <a:t>• Drive expansion + renewal</a:t>
+            </a:r>
+            <a:pPr indent="0" marL="0">
+              <a:buNone/>
+            </a:pPr>
+            <a:r>
+              <a:rPr lang="en-US" sz="1250" dirty="0">
+                <a:solidFill>
+                  <a:srgbClr val="8B8FA3"/>
+                </a:solidFill>
+                <a:latin typeface="Calibri" pitchFamily="34" charset="0"/>
+                <a:ea typeface="Calibri" pitchFamily="34" charset="-122"/>
+                <a:cs typeface="Calibri" pitchFamily="34" charset="-120"/>
+              </a:rPr>
+              <a:t> ops surfaced in July
+</a:t>
+            </a:r>
+            <a:pPr indent="0" marL="0">
+              <a:buNone/>
+            </a:pPr>
+            <a:r>
+              <a:rPr lang="en-US" sz="1300" b="1" dirty="0">
+                <a:solidFill>
+                  <a:srgbClr val="E4E6ED"/>
+                </a:solidFill>
+                <a:latin typeface="Calibri" pitchFamily="34" charset="0"/>
+                <a:ea typeface="Calibri" pitchFamily="34" charset="-122"/>
+                <a:cs typeface="Calibri" pitchFamily="34" charset="-120"/>
+              </a:rPr>
+              <a:t>• Advance the open $106.9k</a:t>
+            </a:r>
+            <a:pPr indent="0" marL="0">
+              <a:buNone/>
+            </a:pPr>
+            <a:r>
+              <a:rPr lang="en-US" sz="1250" dirty="0">
+                <a:solidFill>
+                  <a:srgbClr val="8B8FA3"/>
+                </a:solidFill>
+                <a:latin typeface="Calibri" pitchFamily="34" charset="0"/>
+                <a:ea typeface="Calibri" pitchFamily="34" charset="-122"/>
+                <a:cs typeface="Calibri" pitchFamily="34" charset="-120"/>
+              </a:rPr>
+              <a:t> — MEDDICC on every $10k+
+</a:t>
+            </a:r>
+            <a:pPr indent="0" marL="0">
+              <a:buNone/>
+            </a:pPr>
+            <a:r>
+              <a:rPr lang="en-US" sz="1300" b="1" dirty="0">
+                <a:solidFill>
+                  <a:srgbClr val="00B894"/>
+                </a:solidFill>
+                <a:latin typeface="Calibri" pitchFamily="34" charset="0"/>
+                <a:ea typeface="Calibri" pitchFamily="34" charset="-122"/>
+                <a:cs typeface="Calibri" pitchFamily="34" charset="-120"/>
+              </a:rPr>
+              <a:t>• Lock the named path to H2 quota</a:t>
+            </a:r>
+            <a:endParaRPr lang="en-US" sz="1300" dirty="0"/>
+          </a:p>
+        </p:txBody>
+      </p:sp>
+      <p:sp>
+        <p:nvSpPr>
+          <p:cNvPr id="15" name="Shape 13"/>
           <p:cNvSpPr/>
           <p:nvPr/>
         </p:nvSpPr>
@@ -4536,7 +2988,7 @@
       </p:sp>
       <p:sp>
         <p:nvSpPr>
-          <p:cNvPr id="7" name="Text 4"/>
+          <p:cNvPr id="16" name="Text 14"/>
           <p:cNvSpPr/>
           <p:nvPr/>
         </p:nvSpPr>
@@ -4559,7 +3011,7 @@
               <a:buNone/>
             </a:pPr>
             <a:r>
-              <a:rPr lang="en-US" sz="1200" b="1" dirty="0">
+              <a:rPr lang="en-US" sz="1250" b="1" dirty="0">
                 <a:solidFill>
                   <a:srgbClr val="00B894"/>
                 </a:solidFill>
@@ -4567,13 +3019,13 @@
                 <a:ea typeface="Calibri" pitchFamily="34" charset="-122"/>
                 <a:cs typeface="Calibri" pitchFamily="34" charset="-120"/>
               </a:rPr>
-              <a:t>The month-end bar: </a:t>
-            </a:r>
-            <a:pPr indent="0" marL="0">
-              <a:buNone/>
-            </a:pPr>
-            <a:r>
-              <a:rPr lang="en-US" sz="1200" dirty="0">
+              <a:t>The 2-month bar: </a:t>
+            </a:r>
+            <a:pPr indent="0" marL="0">
+              <a:buNone/>
+            </a:pPr>
+            <a:r>
+              <a:rPr lang="en-US" sz="1250" dirty="0">
                 <a:solidFill>
                   <a:srgbClr val="E4E6ED"/>
                 </a:solidFill>
@@ -4581,13 +3033,13 @@
                 <a:ea typeface="Calibri" pitchFamily="34" charset="-122"/>
                 <a:cs typeface="Calibri" pitchFamily="34" charset="-120"/>
               </a:rPr>
-              <a:t>every Gold account touched and tiered, the top accounts with a written plan, and a named path to H2 quota. </a:t>
-            </a:r>
-            <a:pPr indent="0" marL="0">
-              <a:buNone/>
-            </a:pPr>
-            <a:r>
-              <a:rPr lang="en-US" sz="1200" b="1" dirty="0">
+              <a:t>by end of August — every Gold account tiered with a plan, renewals triaged, expansion in motion, and a named path to H2 quota. </a:t>
+            </a:r>
+            <a:pPr indent="0" marL="0">
+              <a:buNone/>
+            </a:pPr>
+            <a:r>
+              <a:rPr lang="en-US" sz="1250" b="1" dirty="0">
                 <a:solidFill>
                   <a:srgbClr val="E4E6ED"/>
                 </a:solidFill>
@@ -4595,9 +3047,9 @@
                 <a:ea typeface="Calibri" pitchFamily="34" charset="-122"/>
                 <a:cs typeface="Calibri" pitchFamily="34" charset="-120"/>
               </a:rPr>
-              <a:t>Book coverage is the metric — not calls.</a:t>
-            </a:r>
-            <a:endParaRPr lang="en-US" sz="1200" dirty="0"/>
+              <a:t>Book coverage is the metric — not dials.</a:t>
+            </a:r>
+            <a:endParaRPr lang="en-US" sz="1250" dirty="0"/>
           </a:p>
         </p:txBody>
       </p:sp>
@@ -10116,1702 +8568,6 @@
                 <a:cs typeface="Calibri" pitchFamily="34" charset="-120"/>
               </a:rPr>
               <a:t>SLIDE 13</a:t>
-            </a:r>
-            <a:endParaRPr lang="en-US" sz="900" dirty="0"/>
-          </a:p>
-        </p:txBody>
-      </p:sp>
-      <p:sp>
-        <p:nvSpPr>
-          <p:cNvPr id="3" name="Text 1"/>
-          <p:cNvSpPr/>
-          <p:nvPr/>
-        </p:nvSpPr>
-        <p:spPr>
-          <a:xfrm>
-            <a:off x="365760" y="502920"/>
-            <a:ext cx="11430000" cy="640080"/>
-          </a:xfrm>
-          <a:prstGeom prst="rect">
-            <a:avLst/>
-          </a:prstGeom>
-          <a:noFill/>
-          <a:ln/>
-        </p:spPr>
-        <p:txBody>
-          <a:bodyPr wrap="square" rtlCol="0" anchor="ctr"/>
-          <a:lstStyle/>
-          <a:p>
-            <a:pPr indent="0" marL="0">
-              <a:buNone/>
-            </a:pPr>
-            <a:r>
-              <a:rPr lang="en-US" sz="2800" b="1" dirty="0">
-                <a:solidFill>
-                  <a:srgbClr val="FFFFFF"/>
-                </a:solidFill>
-                <a:latin typeface="Calibri" pitchFamily="34" charset="0"/>
-                <a:ea typeface="Calibri" pitchFamily="34" charset="-122"/>
-                <a:cs typeface="Calibri" pitchFamily="34" charset="-120"/>
-              </a:rPr>
-              <a:t>Closing / Account Plan — Hawaiian Airlines (Gold)</a:t>
-            </a:r>
-            <a:endParaRPr lang="en-US" sz="2800" dirty="0"/>
-          </a:p>
-        </p:txBody>
-      </p:sp>
-      <p:sp>
-        <p:nvSpPr>
-          <p:cNvPr id="4" name="Text 2"/>
-          <p:cNvSpPr/>
-          <p:nvPr/>
-        </p:nvSpPr>
-        <p:spPr>
-          <a:xfrm>
-            <a:off x="365760" y="1188720"/>
-            <a:ext cx="11521440" cy="274320"/>
-          </a:xfrm>
-          <a:prstGeom prst="rect">
-            <a:avLst/>
-          </a:prstGeom>
-          <a:noFill/>
-          <a:ln/>
-        </p:spPr>
-        <p:txBody>
-          <a:bodyPr wrap="square" rtlCol="0" anchor="ctr"/>
-          <a:lstStyle/>
-          <a:p>
-            <a:pPr indent="0" marL="0">
-              <a:buNone/>
-            </a:pPr>
-            <a:r>
-              <a:rPr lang="en-US" sz="1100" dirty="0">
-                <a:solidFill>
-                  <a:srgbClr val="8B8FA3"/>
-                </a:solidFill>
-                <a:latin typeface="Calibri" pitchFamily="34" charset="0"/>
-                <a:ea typeface="Calibri" pitchFamily="34" charset="-122"/>
-                <a:cs typeface="Calibri" pitchFamily="34" charset="-120"/>
-              </a:rPr>
-              <a:t>The marquee Gold-account plan. The other open ops are smaller (Growth/MCP $2–5k) and run on the standard cadence — no standalone plan needed.</a:t>
-            </a:r>
-            <a:endParaRPr lang="en-US" sz="1100" dirty="0"/>
-          </a:p>
-        </p:txBody>
-      </p:sp>
-      <p:sp>
-        <p:nvSpPr>
-          <p:cNvPr id="5" name="Shape 3"/>
-          <p:cNvSpPr/>
-          <p:nvPr/>
-        </p:nvSpPr>
-        <p:spPr>
-          <a:xfrm>
-            <a:off x="365760" y="1600200"/>
-            <a:ext cx="3703320" cy="4023360"/>
-          </a:xfrm>
-          <a:prstGeom prst="rect">
-            <a:avLst/>
-          </a:prstGeom>
-          <a:solidFill>
-            <a:srgbClr val="222632"/>
-          </a:solidFill>
-          <a:ln w="6350">
-            <a:solidFill>
-              <a:srgbClr val="2A2E3B"/>
-            </a:solidFill>
-            <a:prstDash val="solid"/>
-          </a:ln>
-        </p:spPr>
-      </p:sp>
-      <p:sp>
-        <p:nvSpPr>
-          <p:cNvPr id="6" name="Shape 4"/>
-          <p:cNvSpPr/>
-          <p:nvPr/>
-        </p:nvSpPr>
-        <p:spPr>
-          <a:xfrm>
-            <a:off x="365760" y="1600200"/>
-            <a:ext cx="45720" cy="4023360"/>
-          </a:xfrm>
-          <a:prstGeom prst="rect">
-            <a:avLst/>
-          </a:prstGeom>
-          <a:solidFill>
-            <a:srgbClr val="FDCB6E"/>
-          </a:solidFill>
-          <a:ln w="12700">
-            <a:solidFill>
-              <a:srgbClr val="333333"/>
-            </a:solidFill>
-            <a:prstDash val="solid"/>
-          </a:ln>
-        </p:spPr>
-      </p:sp>
-      <p:sp>
-        <p:nvSpPr>
-          <p:cNvPr id="7" name="Text 5"/>
-          <p:cNvSpPr/>
-          <p:nvPr/>
-        </p:nvSpPr>
-        <p:spPr>
-          <a:xfrm>
-            <a:off x="502920" y="1709928"/>
-            <a:ext cx="3474720" cy="274320"/>
-          </a:xfrm>
-          <a:prstGeom prst="rect">
-            <a:avLst/>
-          </a:prstGeom>
-          <a:noFill/>
-          <a:ln/>
-        </p:spPr>
-        <p:txBody>
-          <a:bodyPr wrap="square" rtlCol="0" anchor="ctr"/>
-          <a:lstStyle/>
-          <a:p>
-            <a:pPr indent="0" marL="0">
-              <a:buNone/>
-            </a:pPr>
-            <a:r>
-              <a:rPr lang="en-US" sz="1000" b="1" spc="100" kern="0" dirty="0">
-                <a:solidFill>
-                  <a:srgbClr val="FDCB6E"/>
-                </a:solidFill>
-                <a:latin typeface="Calibri" pitchFamily="34" charset="0"/>
-                <a:ea typeface="Calibri" pitchFamily="34" charset="-122"/>
-                <a:cs typeface="Calibri" pitchFamily="34" charset="-120"/>
-              </a:rPr>
-              <a:t>ACCOUNT SNAPSHOT</a:t>
-            </a:r>
-            <a:endParaRPr lang="en-US" sz="1000" dirty="0"/>
-          </a:p>
-        </p:txBody>
-      </p:sp>
-      <p:sp>
-        <p:nvSpPr>
-          <p:cNvPr id="8" name="Text 6"/>
-          <p:cNvSpPr/>
-          <p:nvPr/>
-        </p:nvSpPr>
-        <p:spPr>
-          <a:xfrm>
-            <a:off x="502920" y="2057400"/>
-            <a:ext cx="3474720" cy="3474720"/>
-          </a:xfrm>
-          <a:prstGeom prst="rect">
-            <a:avLst/>
-          </a:prstGeom>
-          <a:noFill/>
-          <a:ln/>
-        </p:spPr>
-        <p:txBody>
-          <a:bodyPr wrap="square" rtlCol="0" anchor="t"/>
-          <a:lstStyle/>
-          <a:p>
-            <a:pPr indent="0" marL="0">
-              <a:buNone/>
-            </a:pPr>
-            <a:r>
-              <a:rPr lang="en-US" sz="1100" b="1" dirty="0">
-                <a:solidFill>
-                  <a:srgbClr val="E4E6ED"/>
-                </a:solidFill>
-                <a:latin typeface="Calibri" pitchFamily="34" charset="0"/>
-                <a:ea typeface="Calibri" pitchFamily="34" charset="-122"/>
-                <a:cs typeface="Calibri" pitchFamily="34" charset="-120"/>
-              </a:rPr>
-              <a:t>Tier: </a:t>
-            </a:r>
-            <a:pPr indent="0" marL="0">
-              <a:buNone/>
-            </a:pPr>
-            <a:r>
-              <a:rPr lang="en-US" sz="1000" dirty="0">
-                <a:solidFill>
-                  <a:srgbClr val="8B8FA3"/>
-                </a:solidFill>
-                <a:latin typeface="Calibri" pitchFamily="34" charset="0"/>
-                <a:ea typeface="Calibri" pitchFamily="34" charset="-122"/>
-                <a:cs typeface="Calibri" pitchFamily="34" charset="-120"/>
-              </a:rPr>
-              <a:t>Gold · established, expanding customer
-</a:t>
-            </a:r>
-            <a:pPr indent="0" marL="0">
-              <a:buNone/>
-            </a:pPr>
-            <a:r>
-              <a:rPr lang="en-US" sz="1100" b="1" dirty="0">
-                <a:solidFill>
-                  <a:srgbClr val="E4E6ED"/>
-                </a:solidFill>
-                <a:latin typeface="Calibri" pitchFamily="34" charset="0"/>
-                <a:ea typeface="Calibri" pitchFamily="34" charset="-122"/>
-                <a:cs typeface="Calibri" pitchFamily="34" charset="-120"/>
-              </a:rPr>
-              <a:t>Products: </a:t>
-            </a:r>
-            <a:pPr indent="0" marL="0">
-              <a:buNone/>
-            </a:pPr>
-            <a:r>
-              <a:rPr lang="en-US" sz="1000" dirty="0">
-                <a:solidFill>
-                  <a:srgbClr val="8B8FA3"/>
-                </a:solidFill>
-                <a:latin typeface="Calibri" pitchFamily="34" charset="0"/>
-                <a:ea typeface="Calibri" pitchFamily="34" charset="-122"/>
-                <a:cs typeface="Calibri" pitchFamily="34" charset="-120"/>
-              </a:rPr>
-              <a:t>MIC + DWH (managed ingestion + data warehouse)
-</a:t>
-            </a:r>
-            <a:pPr indent="0" marL="0">
-              <a:buNone/>
-            </a:pPr>
-            <a:r>
-              <a:rPr lang="en-US" sz="1100" b="1" dirty="0">
-                <a:solidFill>
-                  <a:srgbClr val="E4E6ED"/>
-                </a:solidFill>
-                <a:latin typeface="Calibri" pitchFamily="34" charset="0"/>
-                <a:ea typeface="Calibri" pitchFamily="34" charset="-122"/>
-                <a:cs typeface="Calibri" pitchFamily="34" charset="-120"/>
-              </a:rPr>
-              <a:t>Installed base: </a:t>
-            </a:r>
-            <a:pPr indent="0" marL="0">
-              <a:buNone/>
-            </a:pPr>
-            <a:r>
-              <a:rPr lang="en-US" sz="1000" dirty="0">
-                <a:solidFill>
-                  <a:srgbClr val="8B8FA3"/>
-                </a:solidFill>
-                <a:latin typeface="Calibri" pitchFamily="34" charset="0"/>
-                <a:ea typeface="Calibri" pitchFamily="34" charset="-122"/>
-                <a:cs typeface="Calibri" pitchFamily="34" charset="-120"/>
-              </a:rPr>
-              <a:t>$40k SNO (2023) + $20k MIC+DWH (won 2025) — proven, renewing account
-</a:t>
-            </a:r>
-            <a:pPr indent="0" marL="0">
-              <a:buNone/>
-            </a:pPr>
-            <a:r>
-              <a:rPr lang="en-US" sz="1100" b="1" dirty="0">
-                <a:solidFill>
-                  <a:srgbClr val="00B894"/>
-                </a:solidFill>
-                <a:latin typeface="Calibri" pitchFamily="34" charset="0"/>
-                <a:ea typeface="Calibri" pitchFamily="34" charset="-122"/>
-                <a:cs typeface="Calibri" pitchFamily="34" charset="-120"/>
-              </a:rPr>
-              <a:t>Open op: </a:t>
-            </a:r>
-            <a:pPr indent="0" marL="0">
-              <a:buNone/>
-            </a:pPr>
-            <a:r>
-              <a:rPr lang="en-US" sz="1000" dirty="0">
-                <a:solidFill>
-                  <a:srgbClr val="8B8FA3"/>
-                </a:solidFill>
-                <a:latin typeface="Calibri" pitchFamily="34" charset="0"/>
-                <a:ea typeface="Calibri" pitchFamily="34" charset="-122"/>
-                <a:cs typeface="Calibri" pitchFamily="34" charset="-120"/>
-              </a:rPr>
-              <a:t>$20k MIC+DWH renewal · Q3 2027 · 40% · created 9/2025</a:t>
-            </a:r>
-            <a:endParaRPr lang="en-US" sz="1100" dirty="0"/>
-          </a:p>
-        </p:txBody>
-      </p:sp>
-      <p:sp>
-        <p:nvSpPr>
-          <p:cNvPr id="9" name="Shape 7"/>
-          <p:cNvSpPr/>
-          <p:nvPr/>
-        </p:nvSpPr>
-        <p:spPr>
-          <a:xfrm>
-            <a:off x="4251960" y="1600200"/>
-            <a:ext cx="3703320" cy="4023360"/>
-          </a:xfrm>
-          <a:prstGeom prst="rect">
-            <a:avLst/>
-          </a:prstGeom>
-          <a:solidFill>
-            <a:srgbClr val="222632"/>
-          </a:solidFill>
-          <a:ln w="6350">
-            <a:solidFill>
-              <a:srgbClr val="2A2E3B"/>
-            </a:solidFill>
-            <a:prstDash val="solid"/>
-          </a:ln>
-        </p:spPr>
-      </p:sp>
-      <p:sp>
-        <p:nvSpPr>
-          <p:cNvPr id="10" name="Shape 8"/>
-          <p:cNvSpPr/>
-          <p:nvPr/>
-        </p:nvSpPr>
-        <p:spPr>
-          <a:xfrm>
-            <a:off x="4251960" y="1600200"/>
-            <a:ext cx="45720" cy="4023360"/>
-          </a:xfrm>
-          <a:prstGeom prst="rect">
-            <a:avLst/>
-          </a:prstGeom>
-          <a:solidFill>
-            <a:srgbClr val="00B894"/>
-          </a:solidFill>
-          <a:ln w="12700">
-            <a:solidFill>
-              <a:srgbClr val="333333"/>
-            </a:solidFill>
-            <a:prstDash val="solid"/>
-          </a:ln>
-        </p:spPr>
-      </p:sp>
-      <p:sp>
-        <p:nvSpPr>
-          <p:cNvPr id="11" name="Text 9"/>
-          <p:cNvSpPr/>
-          <p:nvPr/>
-        </p:nvSpPr>
-        <p:spPr>
-          <a:xfrm>
-            <a:off x="4389120" y="1709928"/>
-            <a:ext cx="3474720" cy="274320"/>
-          </a:xfrm>
-          <a:prstGeom prst="rect">
-            <a:avLst/>
-          </a:prstGeom>
-          <a:noFill/>
-          <a:ln/>
-        </p:spPr>
-        <p:txBody>
-          <a:bodyPr wrap="square" rtlCol="0" anchor="ctr"/>
-          <a:lstStyle/>
-          <a:p>
-            <a:pPr indent="0" marL="0">
-              <a:buNone/>
-            </a:pPr>
-            <a:r>
-              <a:rPr lang="en-US" sz="1000" b="1" spc="100" kern="0" dirty="0">
-                <a:solidFill>
-                  <a:srgbClr val="00B894"/>
-                </a:solidFill>
-                <a:latin typeface="Calibri" pitchFamily="34" charset="0"/>
-                <a:ea typeface="Calibri" pitchFamily="34" charset="-122"/>
-                <a:cs typeface="Calibri" pitchFamily="34" charset="-120"/>
-              </a:rPr>
-              <a:t>THE PLAN — RETAIN + EXPAND</a:t>
-            </a:r>
-            <a:endParaRPr lang="en-US" sz="1000" dirty="0"/>
-          </a:p>
-        </p:txBody>
-      </p:sp>
-      <p:sp>
-        <p:nvSpPr>
-          <p:cNvPr id="12" name="Text 10"/>
-          <p:cNvSpPr/>
-          <p:nvPr/>
-        </p:nvSpPr>
-        <p:spPr>
-          <a:xfrm>
-            <a:off x="4389120" y="2057400"/>
-            <a:ext cx="3474720" cy="3474720"/>
-          </a:xfrm>
-          <a:prstGeom prst="rect">
-            <a:avLst/>
-          </a:prstGeom>
-          <a:noFill/>
-          <a:ln/>
-        </p:spPr>
-        <p:txBody>
-          <a:bodyPr wrap="square" rtlCol="0" anchor="t"/>
-          <a:lstStyle/>
-          <a:p>
-            <a:pPr indent="0" marL="0">
-              <a:buNone/>
-            </a:pPr>
-            <a:r>
-              <a:rPr lang="en-US" sz="1100" b="1" dirty="0">
-                <a:solidFill>
-                  <a:srgbClr val="E4E6ED"/>
-                </a:solidFill>
-                <a:latin typeface="Calibri" pitchFamily="34" charset="0"/>
-                <a:ea typeface="Calibri" pitchFamily="34" charset="-122"/>
-                <a:cs typeface="Calibri" pitchFamily="34" charset="-120"/>
-              </a:rPr>
-              <a:t>•  Retain: </a:t>
-            </a:r>
-            <a:pPr indent="0" marL="0">
-              <a:buNone/>
-            </a:pPr>
-            <a:r>
-              <a:rPr lang="en-US" sz="1000" dirty="0">
-                <a:solidFill>
-                  <a:srgbClr val="8B8FA3"/>
-                </a:solidFill>
-                <a:latin typeface="Calibri" pitchFamily="34" charset="0"/>
-                <a:ea typeface="Calibri" pitchFamily="34" charset="-122"/>
-                <a:cs typeface="Calibri" pitchFamily="34" charset="-120"/>
-              </a:rPr>
-              <a:t>lock the $20k Q3-2027 renewal early — map decision process + value realized before it hits the danger zone
-</a:t>
-            </a:r>
-            <a:pPr indent="0" marL="0">
-              <a:buNone/>
-            </a:pPr>
-            <a:r>
-              <a:rPr lang="en-US" sz="1100" b="1" dirty="0">
-                <a:solidFill>
-                  <a:srgbClr val="E4E6ED"/>
-                </a:solidFill>
-                <a:latin typeface="Calibri" pitchFamily="34" charset="0"/>
-                <a:ea typeface="Calibri" pitchFamily="34" charset="-122"/>
-                <a:cs typeface="Calibri" pitchFamily="34" charset="-120"/>
-              </a:rPr>
-              <a:t>•  Expand: </a:t>
-            </a:r>
-            <a:pPr indent="0" marL="0">
-              <a:buNone/>
-            </a:pPr>
-            <a:r>
-              <a:rPr lang="en-US" sz="1000" dirty="0">
-                <a:solidFill>
-                  <a:srgbClr val="8B8FA3"/>
-                </a:solidFill>
-                <a:latin typeface="Calibri" pitchFamily="34" charset="0"/>
-                <a:ea typeface="Calibri" pitchFamily="34" charset="-122"/>
-                <a:cs typeface="Calibri" pitchFamily="34" charset="-120"/>
-              </a:rPr>
-              <a:t>DWH growth, added sources / seats — the June expansion template (BRP, Tracer) applied here
-</a:t>
-            </a:r>
-            <a:pPr indent="0" marL="0">
-              <a:buNone/>
-            </a:pPr>
-            <a:r>
-              <a:rPr lang="en-US" sz="1100" b="1" dirty="0">
-                <a:solidFill>
-                  <a:srgbClr val="E4E6ED"/>
-                </a:solidFill>
-                <a:latin typeface="Calibri" pitchFamily="34" charset="0"/>
-                <a:ea typeface="Calibri" pitchFamily="34" charset="-122"/>
-                <a:cs typeface="Calibri" pitchFamily="34" charset="-120"/>
-              </a:rPr>
-              <a:t>•  Multi-thread: </a:t>
-            </a:r>
-            <a:pPr indent="0" marL="0">
-              <a:buNone/>
-            </a:pPr>
-            <a:r>
-              <a:rPr lang="en-US" sz="1000" dirty="0">
-                <a:solidFill>
-                  <a:srgbClr val="8B8FA3"/>
-                </a:solidFill>
-                <a:latin typeface="Calibri" pitchFamily="34" charset="0"/>
-                <a:ea typeface="Calibri" pitchFamily="34" charset="-122"/>
-                <a:cs typeface="Calibri" pitchFamily="34" charset="-120"/>
-              </a:rPr>
-              <a:t>EB + technical / data-eng stakeholders, not one champion
-</a:t>
-            </a:r>
-            <a:pPr indent="0" marL="0">
-              <a:buNone/>
-            </a:pPr>
-            <a:r>
-              <a:rPr lang="en-US" sz="1100" b="1" dirty="0">
-                <a:solidFill>
-                  <a:srgbClr val="E4E6ED"/>
-                </a:solidFill>
-                <a:latin typeface="Calibri" pitchFamily="34" charset="0"/>
-                <a:ea typeface="Calibri" pitchFamily="34" charset="-122"/>
-                <a:cs typeface="Calibri" pitchFamily="34" charset="-120"/>
-              </a:rPr>
-              <a:t>•  QBR: </a:t>
-            </a:r>
-            <a:pPr indent="0" marL="0">
-              <a:buNone/>
-            </a:pPr>
-            <a:r>
-              <a:rPr lang="en-US" sz="1000" dirty="0">
-                <a:solidFill>
-                  <a:srgbClr val="8B8FA3"/>
-                </a:solidFill>
-                <a:latin typeface="Calibri" pitchFamily="34" charset="0"/>
-                <a:ea typeface="Calibri" pitchFamily="34" charset="-122"/>
-                <a:cs typeface="Calibri" pitchFamily="34" charset="-120"/>
-              </a:rPr>
-              <a:t>value review — quantify ingestion / warehouse ROI delivered to date</a:t>
-            </a:r>
-            <a:endParaRPr lang="en-US" sz="1100" dirty="0"/>
-          </a:p>
-        </p:txBody>
-      </p:sp>
-      <p:sp>
-        <p:nvSpPr>
-          <p:cNvPr id="13" name="Shape 11"/>
-          <p:cNvSpPr/>
-          <p:nvPr/>
-        </p:nvSpPr>
-        <p:spPr>
-          <a:xfrm>
-            <a:off x="8138160" y="1600200"/>
-            <a:ext cx="3703320" cy="4023360"/>
-          </a:xfrm>
-          <a:prstGeom prst="rect">
-            <a:avLst/>
-          </a:prstGeom>
-          <a:solidFill>
-            <a:srgbClr val="222632"/>
-          </a:solidFill>
-          <a:ln w="6350">
-            <a:solidFill>
-              <a:srgbClr val="2A2E3B"/>
-            </a:solidFill>
-            <a:prstDash val="solid"/>
-          </a:ln>
-        </p:spPr>
-      </p:sp>
-      <p:sp>
-        <p:nvSpPr>
-          <p:cNvPr id="14" name="Shape 12"/>
-          <p:cNvSpPr/>
-          <p:nvPr/>
-        </p:nvSpPr>
-        <p:spPr>
-          <a:xfrm>
-            <a:off x="8138160" y="1600200"/>
-            <a:ext cx="45720" cy="4023360"/>
-          </a:xfrm>
-          <a:prstGeom prst="rect">
-            <a:avLst/>
-          </a:prstGeom>
-          <a:solidFill>
-            <a:srgbClr val="6C5CE7"/>
-          </a:solidFill>
-          <a:ln w="12700">
-            <a:solidFill>
-              <a:srgbClr val="333333"/>
-            </a:solidFill>
-            <a:prstDash val="solid"/>
-          </a:ln>
-        </p:spPr>
-      </p:sp>
-      <p:sp>
-        <p:nvSpPr>
-          <p:cNvPr id="15" name="Text 13"/>
-          <p:cNvSpPr/>
-          <p:nvPr/>
-        </p:nvSpPr>
-        <p:spPr>
-          <a:xfrm>
-            <a:off x="8275320" y="1709928"/>
-            <a:ext cx="3474720" cy="274320"/>
-          </a:xfrm>
-          <a:prstGeom prst="rect">
-            <a:avLst/>
-          </a:prstGeom>
-          <a:noFill/>
-          <a:ln/>
-        </p:spPr>
-        <p:txBody>
-          <a:bodyPr wrap="square" rtlCol="0" anchor="ctr"/>
-          <a:lstStyle/>
-          <a:p>
-            <a:pPr indent="0" marL="0">
-              <a:buNone/>
-            </a:pPr>
-            <a:r>
-              <a:rPr lang="en-US" sz="1000" b="1" spc="100" kern="0" dirty="0">
-                <a:solidFill>
-                  <a:srgbClr val="6C5CE7"/>
-                </a:solidFill>
-                <a:latin typeface="Calibri" pitchFamily="34" charset="0"/>
-                <a:ea typeface="Calibri" pitchFamily="34" charset="-122"/>
-                <a:cs typeface="Calibri" pitchFamily="34" charset="-120"/>
-              </a:rPr>
-              <a:t>MEDDICC + NEXT STEPS</a:t>
-            </a:r>
-            <a:endParaRPr lang="en-US" sz="1000" dirty="0"/>
-          </a:p>
-        </p:txBody>
-      </p:sp>
-      <p:sp>
-        <p:nvSpPr>
-          <p:cNvPr id="16" name="Text 14"/>
-          <p:cNvSpPr/>
-          <p:nvPr/>
-        </p:nvSpPr>
-        <p:spPr>
-          <a:xfrm>
-            <a:off x="8275320" y="2057400"/>
-            <a:ext cx="3474720" cy="3474720"/>
-          </a:xfrm>
-          <a:prstGeom prst="rect">
-            <a:avLst/>
-          </a:prstGeom>
-          <a:noFill/>
-          <a:ln/>
-        </p:spPr>
-        <p:txBody>
-          <a:bodyPr wrap="square" rtlCol="0" anchor="t"/>
-          <a:lstStyle/>
-          <a:p>
-            <a:pPr indent="0" marL="0">
-              <a:buNone/>
-            </a:pPr>
-            <a:r>
-              <a:rPr lang="en-US" sz="1100" b="1" dirty="0">
-                <a:solidFill>
-                  <a:srgbClr val="6C5CE7"/>
-                </a:solidFill>
-                <a:latin typeface="Calibri" pitchFamily="34" charset="0"/>
-                <a:ea typeface="Calibri" pitchFamily="34" charset="-122"/>
-                <a:cs typeface="Calibri" pitchFamily="34" charset="-120"/>
-              </a:rPr>
-              <a:t>E</a:t>
-            </a:r>
-            <a:pPr indent="0" marL="0">
-              <a:buNone/>
-            </a:pPr>
-            <a:r>
-              <a:rPr lang="en-US" sz="1000" dirty="0">
-                <a:solidFill>
-                  <a:srgbClr val="8B8FA3"/>
-                </a:solidFill>
-                <a:latin typeface="Calibri" pitchFamily="34" charset="0"/>
-                <a:ea typeface="Calibri" pitchFamily="34" charset="-122"/>
-                <a:cs typeface="Calibri" pitchFamily="34" charset="-120"/>
-              </a:rPr>
-              <a:t>B — confirm the economic buyer for the 2027 renewal
-</a:t>
-            </a:r>
-            <a:pPr indent="0" marL="0">
-              <a:buNone/>
-            </a:pPr>
-            <a:r>
-              <a:rPr lang="en-US" sz="1100" b="1" dirty="0">
-                <a:solidFill>
-                  <a:srgbClr val="6C5CE7"/>
-                </a:solidFill>
-                <a:latin typeface="Calibri" pitchFamily="34" charset="0"/>
-                <a:ea typeface="Calibri" pitchFamily="34" charset="-122"/>
-                <a:cs typeface="Calibri" pitchFamily="34" charset="-120"/>
-              </a:rPr>
-              <a:t>M</a:t>
-            </a:r>
-            <a:pPr indent="0" marL="0">
-              <a:buNone/>
-            </a:pPr>
-            <a:r>
-              <a:rPr lang="en-US" sz="1000" dirty="0">
-                <a:solidFill>
-                  <a:srgbClr val="8B8FA3"/>
-                </a:solidFill>
-                <a:latin typeface="Calibri" pitchFamily="34" charset="0"/>
-                <a:ea typeface="Calibri" pitchFamily="34" charset="-122"/>
-                <a:cs typeface="Calibri" pitchFamily="34" charset="-120"/>
-              </a:rPr>
-              <a:t>etrics — quantify data value delivered (usage, time saved)
-</a:t>
-            </a:r>
-            <a:pPr indent="0" marL="0">
-              <a:buNone/>
-            </a:pPr>
-            <a:r>
-              <a:rPr lang="en-US" sz="1100" b="1" dirty="0">
-                <a:solidFill>
-                  <a:srgbClr val="6C5CE7"/>
-                </a:solidFill>
-                <a:latin typeface="Calibri" pitchFamily="34" charset="0"/>
-                <a:ea typeface="Calibri" pitchFamily="34" charset="-122"/>
-                <a:cs typeface="Calibri" pitchFamily="34" charset="-120"/>
-              </a:rPr>
-              <a:t>D</a:t>
-            </a:r>
-            <a:pPr indent="0" marL="0">
-              <a:buNone/>
-            </a:pPr>
-            <a:r>
-              <a:rPr lang="en-US" sz="1000" dirty="0">
-                <a:solidFill>
-                  <a:srgbClr val="8B8FA3"/>
-                </a:solidFill>
-                <a:latin typeface="Calibri" pitchFamily="34" charset="0"/>
-                <a:ea typeface="Calibri" pitchFamily="34" charset="-122"/>
-                <a:cs typeface="Calibri" pitchFamily="34" charset="-120"/>
-              </a:rPr>
-              <a:t>ecision Process — map the renewal approval path
-</a:t>
-            </a:r>
-            <a:pPr indent="0" marL="0">
-              <a:buNone/>
-            </a:pPr>
-            <a:r>
-              <a:rPr lang="en-US" sz="1100" b="1" dirty="0">
-                <a:solidFill>
-                  <a:srgbClr val="6C5CE7"/>
-                </a:solidFill>
-                <a:latin typeface="Calibri" pitchFamily="34" charset="0"/>
-                <a:ea typeface="Calibri" pitchFamily="34" charset="-122"/>
-                <a:cs typeface="Calibri" pitchFamily="34" charset="-120"/>
-              </a:rPr>
-              <a:t>C</a:t>
-            </a:r>
-            <a:pPr indent="0" marL="0">
-              <a:buNone/>
-            </a:pPr>
-            <a:r>
-              <a:rPr lang="en-US" sz="1000" dirty="0">
-                <a:solidFill>
-                  <a:srgbClr val="8B8FA3"/>
-                </a:solidFill>
-                <a:latin typeface="Calibri" pitchFamily="34" charset="0"/>
-                <a:ea typeface="Calibri" pitchFamily="34" charset="-122"/>
-                <a:cs typeface="Calibri" pitchFamily="34" charset="-120"/>
-              </a:rPr>
-              <a:t>hampion — confirm + coach the internal advocate
-</a:t>
-            </a:r>
-            <a:pPr indent="0" marL="0">
-              <a:buNone/>
-            </a:pPr>
-            <a:r>
-              <a:rPr lang="en-US" sz="1100" b="1" dirty="0">
-                <a:solidFill>
-                  <a:srgbClr val="00B894"/>
-                </a:solidFill>
-                <a:latin typeface="Calibri" pitchFamily="34" charset="0"/>
-                <a:ea typeface="Calibri" pitchFamily="34" charset="-122"/>
-                <a:cs typeface="Calibri" pitchFamily="34" charset="-120"/>
-              </a:rPr>
-              <a:t>Next steps: </a:t>
-            </a:r>
-            <a:pPr indent="0" marL="0">
-              <a:buNone/>
-            </a:pPr>
-            <a:r>
-              <a:rPr lang="en-US" sz="1000" dirty="0">
-                <a:solidFill>
-                  <a:srgbClr val="8B8FA3"/>
-                </a:solidFill>
-                <a:latin typeface="Calibri" pitchFamily="34" charset="0"/>
-                <a:ea typeface="Calibri" pitchFamily="34" charset="-122"/>
-                <a:cs typeface="Calibri" pitchFamily="34" charset="-120"/>
-              </a:rPr>
-              <a:t>book QBR (Jul) · account plan doc (Jul) · renewal strategy locked by Q1 2027</a:t>
-            </a:r>
-            <a:endParaRPr lang="en-US" sz="1100" dirty="0"/>
-          </a:p>
-        </p:txBody>
-      </p:sp>
-      <p:sp>
-        <p:nvSpPr>
-          <p:cNvPr id="17" name="Shape 15"/>
-          <p:cNvSpPr/>
-          <p:nvPr/>
-        </p:nvSpPr>
-        <p:spPr>
-          <a:xfrm>
-            <a:off x="365760" y="5806440"/>
-            <a:ext cx="11475720" cy="594360"/>
-          </a:xfrm>
-          <a:prstGeom prst="roundRect">
-            <a:avLst>
-              <a:gd name="adj" fmla="val 15385"/>
-            </a:avLst>
-          </a:prstGeom>
-          <a:solidFill>
-            <a:srgbClr val="13392D"/>
-          </a:solidFill>
-          <a:ln w="12700">
-            <a:solidFill>
-              <a:srgbClr val="00B894"/>
-            </a:solidFill>
-            <a:prstDash val="solid"/>
-          </a:ln>
-        </p:spPr>
-      </p:sp>
-      <p:sp>
-        <p:nvSpPr>
-          <p:cNvPr id="18" name="Text 16"/>
-          <p:cNvSpPr/>
-          <p:nvPr/>
-        </p:nvSpPr>
-        <p:spPr>
-          <a:xfrm>
-            <a:off x="548640" y="5870448"/>
-            <a:ext cx="11155680" cy="457200"/>
-          </a:xfrm>
-          <a:prstGeom prst="rect">
-            <a:avLst/>
-          </a:prstGeom>
-          <a:noFill/>
-          <a:ln/>
-        </p:spPr>
-        <p:txBody>
-          <a:bodyPr wrap="square" rtlCol="0" anchor="ctr"/>
-          <a:lstStyle/>
-          <a:p>
-            <a:pPr indent="0" marL="0">
-              <a:buNone/>
-            </a:pPr>
-            <a:r>
-              <a:rPr lang="en-US" sz="1200" b="1" dirty="0">
-                <a:solidFill>
-                  <a:srgbClr val="00B894"/>
-                </a:solidFill>
-                <a:latin typeface="Calibri" pitchFamily="34" charset="0"/>
-                <a:ea typeface="Calibri" pitchFamily="34" charset="-122"/>
-                <a:cs typeface="Calibri" pitchFamily="34" charset="-120"/>
-              </a:rPr>
-              <a:t>The KAM template: </a:t>
-            </a:r>
-            <a:pPr indent="0" marL="0">
-              <a:buNone/>
-            </a:pPr>
-            <a:r>
-              <a:rPr lang="en-US" sz="1200" dirty="0">
-                <a:solidFill>
-                  <a:srgbClr val="E4E6ED"/>
-                </a:solidFill>
-                <a:latin typeface="Calibri" pitchFamily="34" charset="0"/>
-                <a:ea typeface="Calibri" pitchFamily="34" charset="-122"/>
-                <a:cs typeface="Calibri" pitchFamily="34" charset="-120"/>
-              </a:rPr>
-              <a:t>retain the renewal, expand the base, multi-thread the account. Hawaiian is the model — the rest of the Gold book gets the same treatment through July.</a:t>
-            </a:r>
-            <a:endParaRPr lang="en-US" sz="1200" dirty="0"/>
-          </a:p>
-        </p:txBody>
-      </p:sp>
-    </p:spTree>
-  </p:cSld>
-  <p:clrMapOvr>
-    <a:masterClrMapping/>
-  </p:clrMapOvr>
-</p:sld>
-</file>
-
-<file path=ppt/slides/slide14.xml><?xml version="1.0" encoding="utf-8"?>
-<p:sld xmlns:a="http://schemas.openxmlformats.org/drawingml/2006/main" xmlns:r="http://schemas.openxmlformats.org/officeDocument/2006/relationships" xmlns:p="http://schemas.openxmlformats.org/presentationml/2006/main">
-  <p:cSld name="Slide 14">
-    <p:spTree>
-      <p:nvGrpSpPr>
-        <p:cNvPr id="1" name=""/>
-        <p:cNvGrpSpPr/>
-        <p:nvPr/>
-      </p:nvGrpSpPr>
-      <p:grpSpPr>
-        <a:xfrm>
-          <a:off x="0" y="0"/>
-          <a:ext cx="0" cy="0"/>
-          <a:chOff x="0" y="0"/>
-          <a:chExt cx="0" cy="0"/>
-        </a:xfrm>
-      </p:grpSpPr>
-      <p:sp>
-        <p:nvSpPr>
-          <p:cNvPr id="2" name="Text 0"/>
-          <p:cNvSpPr/>
-          <p:nvPr/>
-        </p:nvSpPr>
-        <p:spPr>
-          <a:xfrm>
-            <a:off x="365760" y="274320"/>
-            <a:ext cx="5486400" cy="274320"/>
-          </a:xfrm>
-          <a:prstGeom prst="rect">
-            <a:avLst/>
-          </a:prstGeom>
-          <a:noFill/>
-          <a:ln/>
-        </p:spPr>
-        <p:txBody>
-          <a:bodyPr wrap="square" rtlCol="0" anchor="ctr"/>
-          <a:lstStyle/>
-          <a:p>
-            <a:pPr indent="0" marL="0">
-              <a:buNone/>
-            </a:pPr>
-            <a:r>
-              <a:rPr lang="en-US" sz="900" b="1" spc="400" kern="0" dirty="0">
-                <a:solidFill>
-                  <a:srgbClr val="8B8FA3"/>
-                </a:solidFill>
-                <a:latin typeface="Calibri" pitchFamily="34" charset="0"/>
-                <a:ea typeface="Calibri" pitchFamily="34" charset="-122"/>
-                <a:cs typeface="Calibri" pitchFamily="34" charset="-120"/>
-              </a:rPr>
-              <a:t>SLIDE 13b</a:t>
-            </a:r>
-            <a:endParaRPr lang="en-US" sz="900" dirty="0"/>
-          </a:p>
-        </p:txBody>
-      </p:sp>
-      <p:sp>
-        <p:nvSpPr>
-          <p:cNvPr id="3" name="Text 1"/>
-          <p:cNvSpPr/>
-          <p:nvPr/>
-        </p:nvSpPr>
-        <p:spPr>
-          <a:xfrm>
-            <a:off x="365760" y="502920"/>
-            <a:ext cx="11430000" cy="640080"/>
-          </a:xfrm>
-          <a:prstGeom prst="rect">
-            <a:avLst/>
-          </a:prstGeom>
-          <a:noFill/>
-          <a:ln/>
-        </p:spPr>
-        <p:txBody>
-          <a:bodyPr wrap="square" rtlCol="0" anchor="ctr"/>
-          <a:lstStyle/>
-          <a:p>
-            <a:pPr indent="0" marL="0">
-              <a:buNone/>
-            </a:pPr>
-            <a:r>
-              <a:rPr lang="en-US" sz="2800" b="1" dirty="0">
-                <a:solidFill>
-                  <a:srgbClr val="FFFFFF"/>
-                </a:solidFill>
-                <a:latin typeface="Calibri" pitchFamily="34" charset="0"/>
-                <a:ea typeface="Calibri" pitchFamily="34" charset="-122"/>
-                <a:cs typeface="Calibri" pitchFamily="34" charset="-120"/>
-              </a:rPr>
-              <a:t>Appendix / Leave-Behind — MEDDICC Proven on Scotiabank</a:t>
-            </a:r>
-            <a:endParaRPr lang="en-US" sz="2800" dirty="0"/>
-          </a:p>
-        </p:txBody>
-      </p:sp>
-      <p:sp>
-        <p:nvSpPr>
-          <p:cNvPr id="4" name="Shape 2"/>
-          <p:cNvSpPr/>
-          <p:nvPr/>
-        </p:nvSpPr>
-        <p:spPr>
-          <a:xfrm>
-            <a:off x="365760" y="1188720"/>
-            <a:ext cx="11475720" cy="777240"/>
-          </a:xfrm>
-          <a:prstGeom prst="roundRect">
-            <a:avLst>
-              <a:gd name="adj" fmla="val 11765"/>
-            </a:avLst>
-          </a:prstGeom>
-          <a:solidFill>
-            <a:srgbClr val="143A2E"/>
-          </a:solidFill>
-          <a:ln w="12700">
-            <a:solidFill>
-              <a:srgbClr val="00B894"/>
-            </a:solidFill>
-            <a:prstDash val="solid"/>
-          </a:ln>
-        </p:spPr>
-      </p:sp>
-      <p:sp>
-        <p:nvSpPr>
-          <p:cNvPr id="5" name="Text 3"/>
-          <p:cNvSpPr/>
-          <p:nvPr/>
-        </p:nvSpPr>
-        <p:spPr>
-          <a:xfrm>
-            <a:off x="548640" y="1261872"/>
-            <a:ext cx="11155680" cy="640080"/>
-          </a:xfrm>
-          <a:prstGeom prst="rect">
-            <a:avLst/>
-          </a:prstGeom>
-          <a:noFill/>
-          <a:ln/>
-        </p:spPr>
-        <p:txBody>
-          <a:bodyPr wrap="square" rtlCol="0" anchor="ctr"/>
-          <a:lstStyle/>
-          <a:p>
-            <a:pPr indent="0" marL="0">
-              <a:buNone/>
-            </a:pPr>
-            <a:r>
-              <a:rPr lang="en-US" sz="1200" b="1" dirty="0">
-                <a:solidFill>
-                  <a:srgbClr val="00B894"/>
-                </a:solidFill>
-                <a:latin typeface="Calibri" pitchFamily="34" charset="0"/>
-                <a:ea typeface="Calibri" pitchFamily="34" charset="-122"/>
-                <a:cs typeface="Calibri" pitchFamily="34" charset="-120"/>
-              </a:rPr>
-              <a:t>Scotiabank proved MEDDICC converts flagship deals. June forgot it — </a:t>
-            </a:r>
-            <a:pPr indent="0" marL="0">
-              <a:buNone/>
-            </a:pPr>
-            <a:r>
-              <a:rPr lang="en-US" sz="1200" dirty="0">
-                <a:solidFill>
-                  <a:srgbClr val="E4E6ED"/>
-                </a:solidFill>
-                <a:latin typeface="Calibri" pitchFamily="34" charset="0"/>
-                <a:ea typeface="Calibri" pitchFamily="34" charset="-122"/>
-                <a:cs typeface="Calibri" pitchFamily="34" charset="-120"/>
-              </a:rPr>
-              <a:t>every $10k+ deal died stale, unqualified, or without an EB. The July job is breadth: run the exact Scotiabank motion on every $10k+ deal, not just whatever inbound sends.</a:t>
-            </a:r>
-            <a:endParaRPr lang="en-US" sz="1200" dirty="0"/>
-          </a:p>
-        </p:txBody>
-      </p:sp>
-      <p:sp>
-        <p:nvSpPr>
-          <p:cNvPr id="6" name="Shape 4"/>
-          <p:cNvSpPr/>
-          <p:nvPr/>
-        </p:nvSpPr>
-        <p:spPr>
-          <a:xfrm>
-            <a:off x="365760" y="2103120"/>
-            <a:ext cx="3703320" cy="3657600"/>
-          </a:xfrm>
-          <a:prstGeom prst="rect">
-            <a:avLst/>
-          </a:prstGeom>
-          <a:solidFill>
-            <a:srgbClr val="222632"/>
-          </a:solidFill>
-          <a:ln w="6350">
-            <a:solidFill>
-              <a:srgbClr val="2A2E3B"/>
-            </a:solidFill>
-            <a:prstDash val="solid"/>
-          </a:ln>
-        </p:spPr>
-      </p:sp>
-      <p:sp>
-        <p:nvSpPr>
-          <p:cNvPr id="7" name="Shape 5"/>
-          <p:cNvSpPr/>
-          <p:nvPr/>
-        </p:nvSpPr>
-        <p:spPr>
-          <a:xfrm>
-            <a:off x="365760" y="2103120"/>
-            <a:ext cx="45720" cy="3657600"/>
-          </a:xfrm>
-          <a:prstGeom prst="rect">
-            <a:avLst/>
-          </a:prstGeom>
-          <a:solidFill>
-            <a:srgbClr val="00B894"/>
-          </a:solidFill>
-          <a:ln w="12700">
-            <a:solidFill>
-              <a:srgbClr val="333333"/>
-            </a:solidFill>
-            <a:prstDash val="solid"/>
-          </a:ln>
-        </p:spPr>
-      </p:sp>
-      <p:sp>
-        <p:nvSpPr>
-          <p:cNvPr id="8" name="Text 6"/>
-          <p:cNvSpPr/>
-          <p:nvPr/>
-        </p:nvSpPr>
-        <p:spPr>
-          <a:xfrm>
-            <a:off x="502920" y="2240280"/>
-            <a:ext cx="3474720" cy="274320"/>
-          </a:xfrm>
-          <a:prstGeom prst="rect">
-            <a:avLst/>
-          </a:prstGeom>
-          <a:noFill/>
-          <a:ln/>
-        </p:spPr>
-        <p:txBody>
-          <a:bodyPr wrap="square" rtlCol="0" anchor="ctr"/>
-          <a:lstStyle/>
-          <a:p>
-            <a:pPr indent="0" marL="0">
-              <a:buNone/>
-            </a:pPr>
-            <a:r>
-              <a:rPr lang="en-US" sz="1200" b="1" spc="100" kern="0" dirty="0">
-                <a:solidFill>
-                  <a:srgbClr val="00B894"/>
-                </a:solidFill>
-                <a:latin typeface="Calibri" pitchFamily="34" charset="0"/>
-                <a:ea typeface="Calibri" pitchFamily="34" charset="-122"/>
-                <a:cs typeface="Calibri" pitchFamily="34" charset="-120"/>
-              </a:rPr>
-              <a:t>WHAT WON SCOTIABANK</a:t>
-            </a:r>
-            <a:endParaRPr lang="en-US" sz="1200" dirty="0"/>
-          </a:p>
-        </p:txBody>
-      </p:sp>
-      <p:sp>
-        <p:nvSpPr>
-          <p:cNvPr id="9" name="Text 7"/>
-          <p:cNvSpPr/>
-          <p:nvPr/>
-        </p:nvSpPr>
-        <p:spPr>
-          <a:xfrm>
-            <a:off x="502920" y="2651760"/>
-            <a:ext cx="3474720" cy="3017520"/>
-          </a:xfrm>
-          <a:prstGeom prst="rect">
-            <a:avLst/>
-          </a:prstGeom>
-          <a:noFill/>
-          <a:ln/>
-        </p:spPr>
-        <p:txBody>
-          <a:bodyPr wrap="square" rtlCol="0" anchor="t"/>
-          <a:lstStyle/>
-          <a:p>
-            <a:pPr indent="0" marL="0">
-              <a:buNone/>
-            </a:pPr>
-            <a:r>
-              <a:rPr lang="en-US" sz="1300" b="1" dirty="0">
-                <a:solidFill>
-                  <a:srgbClr val="00B894"/>
-                </a:solidFill>
-                <a:latin typeface="Calibri" pitchFamily="34" charset="0"/>
-                <a:ea typeface="Calibri" pitchFamily="34" charset="-122"/>
-                <a:cs typeface="Calibri" pitchFamily="34" charset="-120"/>
-              </a:rPr>
-              <a:t>E</a:t>
-            </a:r>
-            <a:pPr indent="0" marL="0">
-              <a:buNone/>
-            </a:pPr>
-            <a:r>
-              <a:rPr lang="en-US" sz="1250" dirty="0">
-                <a:solidFill>
-                  <a:srgbClr val="E4E6ED"/>
-                </a:solidFill>
-                <a:latin typeface="Calibri" pitchFamily="34" charset="0"/>
-                <a:ea typeface="Calibri" pitchFamily="34" charset="-122"/>
-                <a:cs typeface="Calibri" pitchFamily="34" charset="-120"/>
-              </a:rPr>
-              <a:t>conomic Buyer — engaged + decision path live through signature
-</a:t>
-            </a:r>
-            <a:pPr indent="0" marL="0">
-              <a:buNone/>
-            </a:pPr>
-            <a:r>
-              <a:rPr lang="en-US" sz="1300" b="1" dirty="0">
-                <a:solidFill>
-                  <a:srgbClr val="E4E6ED"/>
-                </a:solidFill>
-                <a:latin typeface="Calibri" pitchFamily="34" charset="0"/>
-                <a:ea typeface="Calibri" pitchFamily="34" charset="-122"/>
-                <a:cs typeface="Calibri" pitchFamily="34" charset="-120"/>
-              </a:rPr>
-              <a:t>Technical multi-thread</a:t>
-            </a:r>
-            <a:pPr indent="0" marL="0">
-              <a:buNone/>
-            </a:pPr>
-            <a:r>
-              <a:rPr lang="en-US" sz="1250" dirty="0">
-                <a:solidFill>
-                  <a:srgbClr val="8B8FA3"/>
-                </a:solidFill>
-                <a:latin typeface="Calibri" pitchFamily="34" charset="0"/>
-                <a:ea typeface="Calibri" pitchFamily="34" charset="-122"/>
-                <a:cs typeface="Calibri" pitchFamily="34" charset="-120"/>
-              </a:rPr>
-              <a:t> — engineering org, not just champion
-</a:t>
-            </a:r>
-            <a:pPr indent="0" marL="0">
-              <a:buNone/>
-            </a:pPr>
-            <a:r>
-              <a:rPr lang="en-US" sz="1300" b="1" dirty="0">
-                <a:solidFill>
-                  <a:srgbClr val="00B894"/>
-                </a:solidFill>
-                <a:latin typeface="Calibri" pitchFamily="34" charset="0"/>
-                <a:ea typeface="Calibri" pitchFamily="34" charset="-122"/>
-                <a:cs typeface="Calibri" pitchFamily="34" charset="-120"/>
-              </a:rPr>
-              <a:t>P</a:t>
-            </a:r>
-            <a:pPr indent="0" marL="0">
-              <a:buNone/>
-            </a:pPr>
-            <a:r>
-              <a:rPr lang="en-US" sz="1250" dirty="0">
-                <a:solidFill>
-                  <a:srgbClr val="E4E6ED"/>
-                </a:solidFill>
-                <a:latin typeface="Calibri" pitchFamily="34" charset="0"/>
-                <a:ea typeface="Calibri" pitchFamily="34" charset="-122"/>
-                <a:cs typeface="Calibri" pitchFamily="34" charset="-120"/>
-              </a:rPr>
-              <a:t>aper Process — security/DR docs early, confirmed received
-</a:t>
-            </a:r>
-            <a:pPr indent="0" marL="0">
-              <a:buNone/>
-            </a:pPr>
-            <a:r>
-              <a:rPr lang="en-US" sz="1300" b="1" dirty="0">
-                <a:solidFill>
-                  <a:srgbClr val="E4E6ED"/>
-                </a:solidFill>
-                <a:latin typeface="Calibri" pitchFamily="34" charset="0"/>
-                <a:ea typeface="Calibri" pitchFamily="34" charset="-122"/>
-                <a:cs typeface="Calibri" pitchFamily="34" charset="-120"/>
-              </a:rPr>
-              <a:t>Prep brief</a:t>
-            </a:r>
-            <a:pPr indent="0" marL="0">
-              <a:buNone/>
-            </a:pPr>
-            <a:r>
-              <a:rPr lang="en-US" sz="1250" dirty="0">
-                <a:solidFill>
-                  <a:srgbClr val="8B8FA3"/>
-                </a:solidFill>
-                <a:latin typeface="Calibri" pitchFamily="34" charset="0"/>
-                <a:ea typeface="Calibri" pitchFamily="34" charset="-122"/>
-                <a:cs typeface="Calibri" pitchFamily="34" charset="-120"/>
-              </a:rPr>
-              <a:t> before the technical call — objections anticipated</a:t>
-            </a:r>
-            <a:endParaRPr lang="en-US" sz="1300" dirty="0"/>
-          </a:p>
-        </p:txBody>
-      </p:sp>
-      <p:sp>
-        <p:nvSpPr>
-          <p:cNvPr id="10" name="Shape 8"/>
-          <p:cNvSpPr/>
-          <p:nvPr/>
-        </p:nvSpPr>
-        <p:spPr>
-          <a:xfrm>
-            <a:off x="4251960" y="2103120"/>
-            <a:ext cx="3703320" cy="3657600"/>
-          </a:xfrm>
-          <a:prstGeom prst="rect">
-            <a:avLst/>
-          </a:prstGeom>
-          <a:solidFill>
-            <a:srgbClr val="222632"/>
-          </a:solidFill>
-          <a:ln w="6350">
-            <a:solidFill>
-              <a:srgbClr val="2A2E3B"/>
-            </a:solidFill>
-            <a:prstDash val="solid"/>
-          </a:ln>
-        </p:spPr>
-      </p:sp>
-      <p:sp>
-        <p:nvSpPr>
-          <p:cNvPr id="11" name="Shape 9"/>
-          <p:cNvSpPr/>
-          <p:nvPr/>
-        </p:nvSpPr>
-        <p:spPr>
-          <a:xfrm>
-            <a:off x="4251960" y="2103120"/>
-            <a:ext cx="45720" cy="3657600"/>
-          </a:xfrm>
-          <a:prstGeom prst="rect">
-            <a:avLst/>
-          </a:prstGeom>
-          <a:solidFill>
-            <a:srgbClr val="E17055"/>
-          </a:solidFill>
-          <a:ln w="12700">
-            <a:solidFill>
-              <a:srgbClr val="333333"/>
-            </a:solidFill>
-            <a:prstDash val="solid"/>
-          </a:ln>
-        </p:spPr>
-      </p:sp>
-      <p:sp>
-        <p:nvSpPr>
-          <p:cNvPr id="12" name="Text 10"/>
-          <p:cNvSpPr/>
-          <p:nvPr/>
-        </p:nvSpPr>
-        <p:spPr>
-          <a:xfrm>
-            <a:off x="4389120" y="2240280"/>
-            <a:ext cx="3474720" cy="274320"/>
-          </a:xfrm>
-          <a:prstGeom prst="rect">
-            <a:avLst/>
-          </a:prstGeom>
-          <a:noFill/>
-          <a:ln/>
-        </p:spPr>
-        <p:txBody>
-          <a:bodyPr wrap="square" rtlCol="0" anchor="ctr"/>
-          <a:lstStyle/>
-          <a:p>
-            <a:pPr indent="0" marL="0">
-              <a:buNone/>
-            </a:pPr>
-            <a:r>
-              <a:rPr lang="en-US" sz="1200" b="1" spc="100" kern="0" dirty="0">
-                <a:solidFill>
-                  <a:srgbClr val="E17055"/>
-                </a:solidFill>
-                <a:latin typeface="Calibri" pitchFamily="34" charset="0"/>
-                <a:ea typeface="Calibri" pitchFamily="34" charset="-122"/>
-                <a:cs typeface="Calibri" pitchFamily="34" charset="-120"/>
-              </a:rPr>
-              <a:t>WHAT LOST JUNE'S $10k+ DEALS</a:t>
-            </a:r>
-            <a:endParaRPr lang="en-US" sz="1200" dirty="0"/>
-          </a:p>
-        </p:txBody>
-      </p:sp>
-      <p:sp>
-        <p:nvSpPr>
-          <p:cNvPr id="13" name="Text 11"/>
-          <p:cNvSpPr/>
-          <p:nvPr/>
-        </p:nvSpPr>
-        <p:spPr>
-          <a:xfrm>
-            <a:off x="4389120" y="2651760"/>
-            <a:ext cx="3474720" cy="3017520"/>
-          </a:xfrm>
-          <a:prstGeom prst="rect">
-            <a:avLst/>
-          </a:prstGeom>
-          <a:noFill/>
-          <a:ln/>
-        </p:spPr>
-        <p:txBody>
-          <a:bodyPr wrap="square" rtlCol="0" anchor="t"/>
-          <a:lstStyle/>
-          <a:p>
-            <a:pPr indent="0" marL="0">
-              <a:buNone/>
-            </a:pPr>
-            <a:r>
-              <a:rPr lang="en-US" sz="1250" b="1" dirty="0">
-                <a:solidFill>
-                  <a:srgbClr val="E17055"/>
-                </a:solidFill>
-                <a:latin typeface="Calibri" pitchFamily="34" charset="0"/>
-                <a:ea typeface="Calibri" pitchFamily="34" charset="-122"/>
-                <a:cs typeface="Calibri" pitchFamily="34" charset="-120"/>
-              </a:rPr>
-              <a:t>✗  No EB motion ran (AMN — sat live for months)
-</a:t>
-            </a:r>
-            <a:pPr indent="0" marL="0">
-              <a:buNone/>
-            </a:pPr>
-            <a:r>
-              <a:rPr lang="en-US" sz="1250" b="1" dirty="0">
-                <a:solidFill>
-                  <a:srgbClr val="E17055"/>
-                </a:solidFill>
-                <a:latin typeface="Calibri" pitchFamily="34" charset="0"/>
-                <a:ea typeface="Calibri" pitchFamily="34" charset="-122"/>
-                <a:cs typeface="Calibri" pitchFamily="34" charset="-120"/>
-              </a:rPr>
-              <a:t>✗  ~10–12 month stale deaths, no next step (Unilever, AdRoll)
-</a:t>
-            </a:r>
-            <a:pPr indent="0" marL="0">
-              <a:buNone/>
-            </a:pPr>
-            <a:r>
-              <a:rPr lang="en-US" sz="1250" b="1" dirty="0">
-                <a:solidFill>
-                  <a:srgbClr val="E17055"/>
-                </a:solidFill>
-                <a:latin typeface="Calibri" pitchFamily="34" charset="0"/>
-                <a:ea typeface="Calibri" pitchFamily="34" charset="-122"/>
-                <a:cs typeface="Calibri" pitchFamily="34" charset="-120"/>
-              </a:rPr>
-              <a:t>✗  Died unqualified in ~10 days (Celebrands)
-</a:t>
-            </a:r>
-            <a:pPr indent="0" marL="0">
-              <a:buNone/>
-            </a:pPr>
-            <a:r>
-              <a:rPr lang="en-US" sz="1250" b="1" dirty="0">
-                <a:solidFill>
-                  <a:srgbClr val="E17055"/>
-                </a:solidFill>
-                <a:latin typeface="Calibri" pitchFamily="34" charset="0"/>
-                <a:ea typeface="Calibri" pitchFamily="34" charset="-122"/>
-                <a:cs typeface="Calibri" pitchFamily="34" charset="-120"/>
-              </a:rPr>
-              <a:t>✗  Day-60 disqualification rule not enforced</a:t>
-            </a:r>
-            <a:endParaRPr lang="en-US" sz="1250" dirty="0"/>
-          </a:p>
-        </p:txBody>
-      </p:sp>
-      <p:sp>
-        <p:nvSpPr>
-          <p:cNvPr id="14" name="Shape 12"/>
-          <p:cNvSpPr/>
-          <p:nvPr/>
-        </p:nvSpPr>
-        <p:spPr>
-          <a:xfrm>
-            <a:off x="8138160" y="2103120"/>
-            <a:ext cx="3703320" cy="3657600"/>
-          </a:xfrm>
-          <a:prstGeom prst="rect">
-            <a:avLst/>
-          </a:prstGeom>
-          <a:solidFill>
-            <a:srgbClr val="222632"/>
-          </a:solidFill>
-          <a:ln w="6350">
-            <a:solidFill>
-              <a:srgbClr val="2A2E3B"/>
-            </a:solidFill>
-            <a:prstDash val="solid"/>
-          </a:ln>
-        </p:spPr>
-      </p:sp>
-      <p:sp>
-        <p:nvSpPr>
-          <p:cNvPr id="15" name="Shape 13"/>
-          <p:cNvSpPr/>
-          <p:nvPr/>
-        </p:nvSpPr>
-        <p:spPr>
-          <a:xfrm>
-            <a:off x="8138160" y="2103120"/>
-            <a:ext cx="45720" cy="3657600"/>
-          </a:xfrm>
-          <a:prstGeom prst="rect">
-            <a:avLst/>
-          </a:prstGeom>
-          <a:solidFill>
-            <a:srgbClr val="74B9FF"/>
-          </a:solidFill>
-          <a:ln w="12700">
-            <a:solidFill>
-              <a:srgbClr val="333333"/>
-            </a:solidFill>
-            <a:prstDash val="solid"/>
-          </a:ln>
-        </p:spPr>
-      </p:sp>
-      <p:sp>
-        <p:nvSpPr>
-          <p:cNvPr id="16" name="Text 14"/>
-          <p:cNvSpPr/>
-          <p:nvPr/>
-        </p:nvSpPr>
-        <p:spPr>
-          <a:xfrm>
-            <a:off x="8275320" y="2240280"/>
-            <a:ext cx="3474720" cy="274320"/>
-          </a:xfrm>
-          <a:prstGeom prst="rect">
-            <a:avLst/>
-          </a:prstGeom>
-          <a:noFill/>
-          <a:ln/>
-        </p:spPr>
-        <p:txBody>
-          <a:bodyPr wrap="square" rtlCol="0" anchor="ctr"/>
-          <a:lstStyle/>
-          <a:p>
-            <a:pPr indent="0" marL="0">
-              <a:buNone/>
-            </a:pPr>
-            <a:r>
-              <a:rPr lang="en-US" sz="1200" b="1" spc="100" kern="0" dirty="0">
-                <a:solidFill>
-                  <a:srgbClr val="74B9FF"/>
-                </a:solidFill>
-                <a:latin typeface="Calibri" pitchFamily="34" charset="0"/>
-                <a:ea typeface="Calibri" pitchFamily="34" charset="-122"/>
-                <a:cs typeface="Calibri" pitchFamily="34" charset="-120"/>
-              </a:rPr>
-              <a:t>THE MEDDICC OPERATING RHYTHM</a:t>
-            </a:r>
-            <a:endParaRPr lang="en-US" sz="1200" dirty="0"/>
-          </a:p>
-        </p:txBody>
-      </p:sp>
-      <p:sp>
-        <p:nvSpPr>
-          <p:cNvPr id="17" name="Text 15"/>
-          <p:cNvSpPr/>
-          <p:nvPr/>
-        </p:nvSpPr>
-        <p:spPr>
-          <a:xfrm>
-            <a:off x="8275320" y="2651760"/>
-            <a:ext cx="3474720" cy="3017520"/>
-          </a:xfrm>
-          <a:prstGeom prst="rect">
-            <a:avLst/>
-          </a:prstGeom>
-          <a:noFill/>
-          <a:ln/>
-        </p:spPr>
-        <p:txBody>
-          <a:bodyPr wrap="square" rtlCol="0" anchor="t"/>
-          <a:lstStyle/>
-          <a:p>
-            <a:pPr indent="0" marL="0">
-              <a:buNone/>
-            </a:pPr>
-            <a:r>
-              <a:rPr lang="en-US" sz="1250" dirty="0">
-                <a:solidFill>
-                  <a:srgbClr val="E4E6ED"/>
-                </a:solidFill>
-                <a:latin typeface="Calibri" pitchFamily="34" charset="0"/>
-                <a:ea typeface="Calibri" pitchFamily="34" charset="-122"/>
-                <a:cs typeface="Calibri" pitchFamily="34" charset="-120"/>
-              </a:rPr>
-              <a:t>• Day 1: open MEDDICC card, rate R/Y/G
-</a:t>
-            </a:r>
-            <a:pPr indent="0" marL="0">
-              <a:buNone/>
-            </a:pPr>
-            <a:r>
-              <a:rPr lang="en-US" sz="1250" dirty="0">
-                <a:solidFill>
-                  <a:srgbClr val="E4E6ED"/>
-                </a:solidFill>
-                <a:latin typeface="Calibri" pitchFamily="34" charset="0"/>
-                <a:ea typeface="Calibri" pitchFamily="34" charset="-122"/>
-                <a:cs typeface="Calibri" pitchFamily="34" charset="-120"/>
-              </a:rPr>
-              <a:t>• Every $10k+ deal: EB booked before pricing
-</a:t>
-            </a:r>
-            <a:pPr indent="0" marL="0">
-              <a:buNone/>
-            </a:pPr>
-            <a:r>
-              <a:rPr lang="en-US" sz="1250" dirty="0">
-                <a:solidFill>
-                  <a:srgbClr val="E4E6ED"/>
-                </a:solidFill>
-                <a:latin typeface="Calibri" pitchFamily="34" charset="0"/>
-                <a:ea typeface="Calibri" pitchFamily="34" charset="-122"/>
-                <a:cs typeface="Calibri" pitchFamily="34" charset="-120"/>
-              </a:rPr>
-              <a:t>• Every technical call: written prep brief
-</a:t>
-            </a:r>
-            <a:pPr indent="0" marL="0">
-              <a:buNone/>
-            </a:pPr>
-            <a:r>
-              <a:rPr lang="en-US" sz="1250" dirty="0">
-                <a:solidFill>
-                  <a:srgbClr val="E4E6ED"/>
-                </a:solidFill>
-                <a:latin typeface="Calibri" pitchFamily="34" charset="0"/>
-                <a:ea typeface="Calibri" pitchFamily="34" charset="-122"/>
-                <a:cs typeface="Calibri" pitchFamily="34" charset="-120"/>
-              </a:rPr>
-              <a:t>• Friday: disqualify anything 60d+ with no next step</a:t>
-            </a:r>
-            <a:endParaRPr lang="en-US" sz="1250" dirty="0"/>
-          </a:p>
-        </p:txBody>
-      </p:sp>
-    </p:spTree>
-  </p:cSld>
-  <p:clrMapOvr>
-    <a:masterClrMapping/>
-  </p:clrMapOvr>
-</p:sld>
-</file>
-
-<file path=ppt/slides/slide15.xml><?xml version="1.0" encoding="utf-8"?>
-<p:sld xmlns:a="http://schemas.openxmlformats.org/drawingml/2006/main" xmlns:r="http://schemas.openxmlformats.org/officeDocument/2006/relationships" xmlns:p="http://schemas.openxmlformats.org/presentationml/2006/main">
-  <p:cSld name="Slide 15">
-    <p:spTree>
-      <p:nvGrpSpPr>
-        <p:cNvPr id="1" name=""/>
-        <p:cNvGrpSpPr/>
-        <p:nvPr/>
-      </p:nvGrpSpPr>
-      <p:grpSpPr>
-        <a:xfrm>
-          <a:off x="0" y="0"/>
-          <a:ext cx="0" cy="0"/>
-          <a:chOff x="0" y="0"/>
-          <a:chExt cx="0" cy="0"/>
-        </a:xfrm>
-      </p:grpSpPr>
-      <p:sp>
-        <p:nvSpPr>
-          <p:cNvPr id="2" name="Text 0"/>
-          <p:cNvSpPr/>
-          <p:nvPr/>
-        </p:nvSpPr>
-        <p:spPr>
-          <a:xfrm>
-            <a:off x="365760" y="274320"/>
-            <a:ext cx="5486400" cy="274320"/>
-          </a:xfrm>
-          <a:prstGeom prst="rect">
-            <a:avLst/>
-          </a:prstGeom>
-          <a:noFill/>
-          <a:ln/>
-        </p:spPr>
-        <p:txBody>
-          <a:bodyPr wrap="square" rtlCol="0" anchor="ctr"/>
-          <a:lstStyle/>
-          <a:p>
-            <a:pPr indent="0" marL="0">
-              <a:buNone/>
-            </a:pPr>
-            <a:r>
-              <a:rPr lang="en-US" sz="900" b="1" spc="400" kern="0" dirty="0">
-                <a:solidFill>
-                  <a:srgbClr val="8B8FA3"/>
-                </a:solidFill>
-                <a:latin typeface="Calibri" pitchFamily="34" charset="0"/>
-                <a:ea typeface="Calibri" pitchFamily="34" charset="-122"/>
-                <a:cs typeface="Calibri" pitchFamily="34" charset="-120"/>
-              </a:rPr>
-              <a:t>SLIDE 15</a:t>
             </a:r>
             <a:endParaRPr lang="en-US" sz="900" dirty="0"/>
           </a:p>
@@ -20948,7 +17704,7 @@
                           <a:ea typeface="Calibri" pitchFamily="34" charset="-122"/>
                           <a:cs typeface="Calibri" pitchFamily="34" charset="-120"/>
                         </a:rPr>
-                        <a:t>~$40k</a:t>
+                        <a:t>~$42k</a:t>
                       </a:r>
                       <a:endParaRPr lang="en-US" sz="1150" dirty="0">
                         <a:latin typeface="Calibri" charset="0"/>
@@ -21016,7 +17772,7 @@
                           <a:ea typeface="Calibri" pitchFamily="34" charset="-122"/>
                           <a:cs typeface="Calibri" pitchFamily="34" charset="-120"/>
                         </a:rPr>
-                        <a:t>~86%</a:t>
+                        <a:t>~90%</a:t>
                       </a:r>
                       <a:endParaRPr lang="en-US" sz="1150" dirty="0">
                         <a:latin typeface="Calibri" charset="0"/>
@@ -21222,7 +17978,7 @@
                           <a:ea typeface="Calibri" pitchFamily="34" charset="-122"/>
                           <a:cs typeface="Calibri" pitchFamily="34" charset="-120"/>
                         </a:rPr>
-                        <a:t>~$40k+</a:t>
+                        <a:t>~$58k</a:t>
                       </a:r>
                       <a:endParaRPr lang="en-US" sz="1150" dirty="0">
                         <a:latin typeface="Calibri" charset="0"/>
@@ -21284,13 +18040,13 @@
                       <a:r>
                         <a:rPr lang="en-US" sz="1150" b="1" dirty="0">
                           <a:solidFill>
-                            <a:srgbClr val="FDCB6E"/>
+                            <a:srgbClr val="00B894"/>
                           </a:solidFill>
                           <a:latin typeface="Calibri" pitchFamily="34" charset="0"/>
                           <a:ea typeface="Calibri" pitchFamily="34" charset="-122"/>
                           <a:cs typeface="Calibri" pitchFamily="34" charset="-120"/>
                         </a:rPr>
-                        <a:t>~86%+</a:t>
+                        <a:t>~124%</a:t>
                       </a:r>
                       <a:endParaRPr lang="en-US" sz="1150" dirty="0">
                         <a:latin typeface="Calibri" charset="0"/>
@@ -21496,7 +18252,7 @@
                           <a:ea typeface="Calibri" pitchFamily="34" charset="-122"/>
                           <a:cs typeface="Calibri" pitchFamily="34" charset="-120"/>
                         </a:rPr>
-                        <a:t>~$40k+</a:t>
+                        <a:t>~$62k</a:t>
                       </a:r>
                       <a:endParaRPr lang="en-US" sz="1150" dirty="0">
                         <a:latin typeface="Calibri" charset="0"/>
@@ -21558,13 +18314,13 @@
                       <a:r>
                         <a:rPr lang="en-US" sz="1150" b="1" dirty="0">
                           <a:solidFill>
-                            <a:srgbClr val="FDCB6E"/>
+                            <a:srgbClr val="00B894"/>
                           </a:solidFill>
                           <a:latin typeface="Calibri" pitchFamily="34" charset="0"/>
                           <a:ea typeface="Calibri" pitchFamily="34" charset="-122"/>
                           <a:cs typeface="Calibri" pitchFamily="34" charset="-120"/>
                         </a:rPr>
-                        <a:t>~86%+</a:t>
+                        <a:t>~133%</a:t>
                       </a:r>
                       <a:endParaRPr lang="en-US" sz="1150" dirty="0">
                         <a:latin typeface="Calibri" charset="0"/>
@@ -21653,7 +18409,7 @@
                 <a:ea typeface="Calibri" pitchFamily="34" charset="-122"/>
                 <a:cs typeface="Calibri" pitchFamily="34" charset="-120"/>
               </a:rPr>
-              <a:t>Jul = confirmed FC ($18.8k, 81%) with weighted upside to $46.1k (197%). Aug–Oct pace ~85% at the current ~$43k/mo pipe × 29% yield — the KAM book's expansion + renewals must close the ~15% gap (Sep–Oct carry seasonal upside; both strong in 2025).</a:t>
+              <a:t>Jul = confirmed FC ($18.8k, 81%) + weighted upside to $46.1k. Aug–Oct = H1 run-rate (~$40k) with 2025 seasonality applied — Sep/Oct are historically the strongest months (both ~$63k in 2025); Aug a summer lull. H2 paces above quota if the KAM book's renewals + expansion convert.</a:t>
             </a:r>
             <a:endParaRPr lang="en-US" sz="950" dirty="0"/>
           </a:p>

</xml_diff>

<commit_message>
Add new op Hawk ($12.5k, 69%) to July forecast + reconcile pipeline totals
Hawk | MCP | $12.5k confirmed in HubSpot (created 7/8, closes 7/30); command
center sets it at 69% -> $8.6k weighted.

- S12: added Hawk to the deal table; bumped Kraken 70%->85% ($2.9k); refreshed
  totals to the command center — Weighted FC $62.0k (265%), Open Pipeline
  $141.9k (607%), 25 July-close deals. Read box calls out Hawk as a 2nd $10k+
  swing alongside RLE.
- S6: July weighted-upside note $46.1k -> $62.0k.
- S9/S10: open-pipe figures $106.9k -> $141.9k, 457% -> 607%, $46.1k/197% ->
  $62.0k/265%; Hawk added to the $10k+ MEDDICC ops.
- S13: Hawk added to the open $10k+ ops list.

Co-Authored-By: Claude Opus 4.8 <noreply@anthropic.com>
</commit_message>
<xml_diff>
--- a/June_2026_NAM_MBR.pptx
+++ b/June_2026_NAM_MBR.pptx
@@ -2924,7 +2924,7 @@
                 <a:ea typeface="Calibri" pitchFamily="34" charset="-122"/>
                 <a:cs typeface="Calibri" pitchFamily="34" charset="-120"/>
               </a:rPr>
-              <a:t>• Advance the open $106.9k</a:t>
+              <a:t>• Advance the open $141.9k</a:t>
             </a:r>
             <a:pPr indent="0" marL="0">
               <a:buNone/>
@@ -3710,7 +3710,7 @@
                 <a:ea typeface="Calibri" pitchFamily="34" charset="-122"/>
                 <a:cs typeface="Calibri" pitchFamily="34" charset="-120"/>
               </a:rPr>
-              <a:t>MEDDICC on every $10k+ open op (RLE, Upwork, HA) — EB, next step, drive it forward.</a:t>
+              <a:t>MEDDICC on every $10k+ open op (RLE, Hawk, Upwork, HA) — EB, next step, drive it forward.</a:t>
             </a:r>
             <a:endParaRPr lang="en-US" sz="1000" dirty="0"/>
           </a:p>
@@ -4440,7 +4440,7 @@
                 <a:ea typeface="Calibri" pitchFamily="34" charset="-122"/>
                 <a:cs typeface="Calibri" pitchFamily="34" charset="-120"/>
               </a:rPr>
-              <a:t>$46.1k</a:t>
+              <a:t>$62.0k</a:t>
             </a:r>
             <a:endParaRPr lang="en-US" sz="2200" dirty="0"/>
           </a:p>
@@ -4479,7 +4479,7 @@
                 <a:ea typeface="Calibri" pitchFamily="34" charset="-122"/>
                 <a:cs typeface="Calibri" pitchFamily="34" charset="-120"/>
               </a:rPr>
-              <a:t>197% of quota</a:t>
+              <a:t>265% of quota</a:t>
             </a:r>
             <a:endParaRPr lang="en-US" sz="800" dirty="0"/>
           </a:p>
@@ -4582,7 +4582,7 @@
                 <a:ea typeface="Calibri" pitchFamily="34" charset="-122"/>
                 <a:cs typeface="Calibri" pitchFamily="34" charset="-120"/>
               </a:rPr>
-              <a:t>$106.9k</a:t>
+              <a:t>$141.9k</a:t>
             </a:r>
             <a:endParaRPr lang="en-US" sz="2200" dirty="0"/>
           </a:p>
@@ -4621,7 +4621,7 @@
                 <a:ea typeface="Calibri" pitchFamily="34" charset="-122"/>
                 <a:cs typeface="Calibri" pitchFamily="34" charset="-120"/>
               </a:rPr>
-              <a:t>457% · 22 July-close</a:t>
+              <a:t>607% · 25 July-close</a:t>
             </a:r>
             <a:endParaRPr lang="en-US" sz="800" dirty="0"/>
           </a:p>
@@ -4657,7 +4657,7 @@
                 <a:gridCol w="1188720"/>
                 <a:gridCol w="2743200"/>
               </a:tblGrid>
-              <a:tr h="310896">
+              <a:tr h="274320">
                 <a:tc>
                   <a:txBody>
                     <a:bodyPr/>
@@ -5067,7 +5067,7 @@
                   </a:tcPr>
                 </a:tc>
               </a:tr>
-              <a:tr h="310896">
+              <a:tr h="274320">
                 <a:tc>
                   <a:txBody>
                     <a:bodyPr/>
@@ -5477,7 +5477,7 @@
                   </a:tcPr>
                 </a:tc>
               </a:tr>
-              <a:tr h="310896">
+              <a:tr h="274320">
                 <a:tc>
                   <a:txBody>
                     <a:bodyPr/>
@@ -5887,7 +5887,417 @@
                   </a:tcPr>
                 </a:tc>
               </a:tr>
-              <a:tr h="310896">
+              <a:tr h="274320">
+                <a:tc>
+                  <a:txBody>
+                    <a:bodyPr/>
+                    <a:lstStyle/>
+                    <a:p>
+                      <a:pPr indent="0" marL="0">
+                        <a:buNone/>
+                      </a:pPr>
+                      <a:r>
+                        <a:rPr lang="en-US" sz="1100" b="1" dirty="0">
+                          <a:solidFill>
+                            <a:srgbClr val="E4E6ED"/>
+                          </a:solidFill>
+                          <a:latin typeface="Calibri" pitchFamily="34" charset="0"/>
+                          <a:ea typeface="Calibri" pitchFamily="34" charset="-122"/>
+                          <a:cs typeface="Calibri" pitchFamily="34" charset="-120"/>
+                        </a:rPr>
+                        <a:t>Kraken</a:t>
+                      </a:r>
+                      <a:endParaRPr lang="en-US" sz="1100" dirty="0">
+                        <a:latin typeface="Calibri" charset="0"/>
+                        <a:ea typeface="Calibri" charset="0"/>
+                        <a:cs typeface="Calibri" charset="0"/>
+                      </a:endParaRPr>
+                    </a:p>
+                  </a:txBody>
+                  <a:tcPr marL="91440" marR="91440" marT="45720" marB="45720">
+                    <a:lnL w="6350" cap="flat" cmpd="sng" algn="ctr">
+                      <a:solidFill>
+                        <a:srgbClr val="2A2E3B"/>
+                      </a:solidFill>
+                      <a:prstDash val="solid"/>
+                      <a:round/>
+                      <a:headEnd type="none" w="med" len="med"/>
+                      <a:tailEnd type="none" w="med" len="med"/>
+                    </a:lnL>
+                    <a:lnR w="6350" cap="flat" cmpd="sng" algn="ctr">
+                      <a:solidFill>
+                        <a:srgbClr val="2A2E3B"/>
+                      </a:solidFill>
+                      <a:prstDash val="solid"/>
+                      <a:round/>
+                      <a:headEnd type="none" w="med" len="med"/>
+                      <a:tailEnd type="none" w="med" len="med"/>
+                    </a:lnR>
+                    <a:lnT w="6350" cap="flat" cmpd="sng" algn="ctr">
+                      <a:solidFill>
+                        <a:srgbClr val="2A2E3B"/>
+                      </a:solidFill>
+                      <a:prstDash val="solid"/>
+                      <a:round/>
+                      <a:headEnd type="none" w="med" len="med"/>
+                      <a:tailEnd type="none" w="med" len="med"/>
+                    </a:lnT>
+                    <a:lnB w="6350" cap="flat" cmpd="sng" algn="ctr">
+                      <a:solidFill>
+                        <a:srgbClr val="2A2E3B"/>
+                      </a:solidFill>
+                      <a:prstDash val="solid"/>
+                      <a:round/>
+                      <a:headEnd type="none" w="med" len="med"/>
+                      <a:tailEnd type="none" w="med" len="med"/>
+                    </a:lnB>
+                    <a:solidFill>
+                      <a:srgbClr val="1A1D27"/>
+                    </a:solidFill>
+                  </a:tcPr>
+                </a:tc>
+                <a:tc>
+                  <a:txBody>
+                    <a:bodyPr/>
+                    <a:lstStyle/>
+                    <a:p>
+                      <a:pPr indent="0" marL="0">
+                        <a:buNone/>
+                      </a:pPr>
+                      <a:r>
+                        <a:rPr lang="en-US" sz="1100" dirty="0">
+                          <a:solidFill>
+                            <a:srgbClr val="E4E6ED"/>
+                          </a:solidFill>
+                          <a:latin typeface="Calibri" pitchFamily="34" charset="0"/>
+                          <a:ea typeface="Calibri" pitchFamily="34" charset="-122"/>
+                          <a:cs typeface="Calibri" pitchFamily="34" charset="-120"/>
+                        </a:rPr>
+                        <a:t>MCP | $3.5k</a:t>
+                      </a:r>
+                      <a:endParaRPr lang="en-US" sz="1100" dirty="0">
+                        <a:latin typeface="Calibri" charset="0"/>
+                        <a:ea typeface="Calibri" charset="0"/>
+                        <a:cs typeface="Calibri" charset="0"/>
+                      </a:endParaRPr>
+                    </a:p>
+                  </a:txBody>
+                  <a:tcPr marL="91440" marR="91440" marT="45720" marB="45720">
+                    <a:lnL w="6350" cap="flat" cmpd="sng" algn="ctr">
+                      <a:solidFill>
+                        <a:srgbClr val="2A2E3B"/>
+                      </a:solidFill>
+                      <a:prstDash val="solid"/>
+                      <a:round/>
+                      <a:headEnd type="none" w="med" len="med"/>
+                      <a:tailEnd type="none" w="med" len="med"/>
+                    </a:lnL>
+                    <a:lnR w="6350" cap="flat" cmpd="sng" algn="ctr">
+                      <a:solidFill>
+                        <a:srgbClr val="2A2E3B"/>
+                      </a:solidFill>
+                      <a:prstDash val="solid"/>
+                      <a:round/>
+                      <a:headEnd type="none" w="med" len="med"/>
+                      <a:tailEnd type="none" w="med" len="med"/>
+                    </a:lnR>
+                    <a:lnT w="6350" cap="flat" cmpd="sng" algn="ctr">
+                      <a:solidFill>
+                        <a:srgbClr val="2A2E3B"/>
+                      </a:solidFill>
+                      <a:prstDash val="solid"/>
+                      <a:round/>
+                      <a:headEnd type="none" w="med" len="med"/>
+                      <a:tailEnd type="none" w="med" len="med"/>
+                    </a:lnT>
+                    <a:lnB w="6350" cap="flat" cmpd="sng" algn="ctr">
+                      <a:solidFill>
+                        <a:srgbClr val="2A2E3B"/>
+                      </a:solidFill>
+                      <a:prstDash val="solid"/>
+                      <a:round/>
+                      <a:headEnd type="none" w="med" len="med"/>
+                      <a:tailEnd type="none" w="med" len="med"/>
+                    </a:lnB>
+                    <a:solidFill>
+                      <a:srgbClr val="1A1D27"/>
+                    </a:solidFill>
+                  </a:tcPr>
+                </a:tc>
+                <a:tc>
+                  <a:txBody>
+                    <a:bodyPr/>
+                    <a:lstStyle/>
+                    <a:p>
+                      <a:pPr algn="r" indent="0" marL="0">
+                        <a:buNone/>
+                      </a:pPr>
+                      <a:r>
+                        <a:rPr lang="en-US" sz="1100" dirty="0">
+                          <a:solidFill>
+                            <a:srgbClr val="E4E6ED"/>
+                          </a:solidFill>
+                          <a:latin typeface="Calibri" pitchFamily="34" charset="0"/>
+                          <a:ea typeface="Calibri" pitchFamily="34" charset="-122"/>
+                          <a:cs typeface="Calibri" pitchFamily="34" charset="-120"/>
+                        </a:rPr>
+                        <a:t>$3,468</a:t>
+                      </a:r>
+                      <a:endParaRPr lang="en-US" sz="1100" dirty="0">
+                        <a:latin typeface="Calibri" charset="0"/>
+                        <a:ea typeface="Calibri" charset="0"/>
+                        <a:cs typeface="Calibri" charset="0"/>
+                      </a:endParaRPr>
+                    </a:p>
+                  </a:txBody>
+                  <a:tcPr marL="91440" marR="91440" marT="45720" marB="45720">
+                    <a:lnL w="6350" cap="flat" cmpd="sng" algn="ctr">
+                      <a:solidFill>
+                        <a:srgbClr val="2A2E3B"/>
+                      </a:solidFill>
+                      <a:prstDash val="solid"/>
+                      <a:round/>
+                      <a:headEnd type="none" w="med" len="med"/>
+                      <a:tailEnd type="none" w="med" len="med"/>
+                    </a:lnL>
+                    <a:lnR w="6350" cap="flat" cmpd="sng" algn="ctr">
+                      <a:solidFill>
+                        <a:srgbClr val="2A2E3B"/>
+                      </a:solidFill>
+                      <a:prstDash val="solid"/>
+                      <a:round/>
+                      <a:headEnd type="none" w="med" len="med"/>
+                      <a:tailEnd type="none" w="med" len="med"/>
+                    </a:lnR>
+                    <a:lnT w="6350" cap="flat" cmpd="sng" algn="ctr">
+                      <a:solidFill>
+                        <a:srgbClr val="2A2E3B"/>
+                      </a:solidFill>
+                      <a:prstDash val="solid"/>
+                      <a:round/>
+                      <a:headEnd type="none" w="med" len="med"/>
+                      <a:tailEnd type="none" w="med" len="med"/>
+                    </a:lnT>
+                    <a:lnB w="6350" cap="flat" cmpd="sng" algn="ctr">
+                      <a:solidFill>
+                        <a:srgbClr val="2A2E3B"/>
+                      </a:solidFill>
+                      <a:prstDash val="solid"/>
+                      <a:round/>
+                      <a:headEnd type="none" w="med" len="med"/>
+                      <a:tailEnd type="none" w="med" len="med"/>
+                    </a:lnB>
+                    <a:solidFill>
+                      <a:srgbClr val="1A1D27"/>
+                    </a:solidFill>
+                  </a:tcPr>
+                </a:tc>
+                <a:tc>
+                  <a:txBody>
+                    <a:bodyPr/>
+                    <a:lstStyle/>
+                    <a:p>
+                      <a:pPr indent="0" marL="0">
+                        <a:buNone/>
+                      </a:pPr>
+                      <a:r>
+                        <a:rPr lang="en-US" sz="1000" b="1" dirty="0">
+                          <a:solidFill>
+                            <a:srgbClr val="00B894"/>
+                          </a:solidFill>
+                          <a:latin typeface="Calibri" pitchFamily="34" charset="0"/>
+                          <a:ea typeface="Calibri" pitchFamily="34" charset="-122"/>
+                          <a:cs typeface="Calibri" pitchFamily="34" charset="-120"/>
+                        </a:rPr>
+                        <a:t>Committed</a:t>
+                      </a:r>
+                      <a:endParaRPr lang="en-US" sz="1000" dirty="0">
+                        <a:latin typeface="Calibri" charset="0"/>
+                        <a:ea typeface="Calibri" charset="0"/>
+                        <a:cs typeface="Calibri" charset="0"/>
+                      </a:endParaRPr>
+                    </a:p>
+                  </a:txBody>
+                  <a:tcPr marL="91440" marR="91440" marT="45720" marB="45720">
+                    <a:lnL w="6350" cap="flat" cmpd="sng" algn="ctr">
+                      <a:solidFill>
+                        <a:srgbClr val="2A2E3B"/>
+                      </a:solidFill>
+                      <a:prstDash val="solid"/>
+                      <a:round/>
+                      <a:headEnd type="none" w="med" len="med"/>
+                      <a:tailEnd type="none" w="med" len="med"/>
+                    </a:lnL>
+                    <a:lnR w="6350" cap="flat" cmpd="sng" algn="ctr">
+                      <a:solidFill>
+                        <a:srgbClr val="2A2E3B"/>
+                      </a:solidFill>
+                      <a:prstDash val="solid"/>
+                      <a:round/>
+                      <a:headEnd type="none" w="med" len="med"/>
+                      <a:tailEnd type="none" w="med" len="med"/>
+                    </a:lnR>
+                    <a:lnT w="6350" cap="flat" cmpd="sng" algn="ctr">
+                      <a:solidFill>
+                        <a:srgbClr val="2A2E3B"/>
+                      </a:solidFill>
+                      <a:prstDash val="solid"/>
+                      <a:round/>
+                      <a:headEnd type="none" w="med" len="med"/>
+                      <a:tailEnd type="none" w="med" len="med"/>
+                    </a:lnT>
+                    <a:lnB w="6350" cap="flat" cmpd="sng" algn="ctr">
+                      <a:solidFill>
+                        <a:srgbClr val="2A2E3B"/>
+                      </a:solidFill>
+                      <a:prstDash val="solid"/>
+                      <a:round/>
+                      <a:headEnd type="none" w="med" len="med"/>
+                      <a:tailEnd type="none" w="med" len="med"/>
+                    </a:lnB>
+                    <a:solidFill>
+                      <a:srgbClr val="1A1D27"/>
+                    </a:solidFill>
+                  </a:tcPr>
+                </a:tc>
+                <a:tc>
+                  <a:txBody>
+                    <a:bodyPr/>
+                    <a:lstStyle/>
+                    <a:p>
+                      <a:pPr algn="r" indent="0" marL="0">
+                        <a:buNone/>
+                      </a:pPr>
+                      <a:r>
+                        <a:rPr lang="en-US" sz="1100" dirty="0">
+                          <a:solidFill>
+                            <a:srgbClr val="E4E6ED"/>
+                          </a:solidFill>
+                          <a:latin typeface="Calibri" pitchFamily="34" charset="0"/>
+                          <a:ea typeface="Calibri" pitchFamily="34" charset="-122"/>
+                          <a:cs typeface="Calibri" pitchFamily="34" charset="-120"/>
+                        </a:rPr>
+                        <a:t>85%</a:t>
+                      </a:r>
+                      <a:endParaRPr lang="en-US" sz="1100" dirty="0">
+                        <a:latin typeface="Calibri" charset="0"/>
+                        <a:ea typeface="Calibri" charset="0"/>
+                        <a:cs typeface="Calibri" charset="0"/>
+                      </a:endParaRPr>
+                    </a:p>
+                  </a:txBody>
+                  <a:tcPr marL="91440" marR="91440" marT="45720" marB="45720">
+                    <a:lnL w="6350" cap="flat" cmpd="sng" algn="ctr">
+                      <a:solidFill>
+                        <a:srgbClr val="2A2E3B"/>
+                      </a:solidFill>
+                      <a:prstDash val="solid"/>
+                      <a:round/>
+                      <a:headEnd type="none" w="med" len="med"/>
+                      <a:tailEnd type="none" w="med" len="med"/>
+                    </a:lnL>
+                    <a:lnR w="6350" cap="flat" cmpd="sng" algn="ctr">
+                      <a:solidFill>
+                        <a:srgbClr val="2A2E3B"/>
+                      </a:solidFill>
+                      <a:prstDash val="solid"/>
+                      <a:round/>
+                      <a:headEnd type="none" w="med" len="med"/>
+                      <a:tailEnd type="none" w="med" len="med"/>
+                    </a:lnR>
+                    <a:lnT w="6350" cap="flat" cmpd="sng" algn="ctr">
+                      <a:solidFill>
+                        <a:srgbClr val="2A2E3B"/>
+                      </a:solidFill>
+                      <a:prstDash val="solid"/>
+                      <a:round/>
+                      <a:headEnd type="none" w="med" len="med"/>
+                      <a:tailEnd type="none" w="med" len="med"/>
+                    </a:lnT>
+                    <a:lnB w="6350" cap="flat" cmpd="sng" algn="ctr">
+                      <a:solidFill>
+                        <a:srgbClr val="2A2E3B"/>
+                      </a:solidFill>
+                      <a:prstDash val="solid"/>
+                      <a:round/>
+                      <a:headEnd type="none" w="med" len="med"/>
+                      <a:tailEnd type="none" w="med" len="med"/>
+                    </a:lnB>
+                    <a:solidFill>
+                      <a:srgbClr val="1A1D27"/>
+                    </a:solidFill>
+                  </a:tcPr>
+                </a:tc>
+                <a:tc>
+                  <a:txBody>
+                    <a:bodyPr/>
+                    <a:lstStyle/>
+                    <a:p>
+                      <a:pPr algn="r" indent="0" marL="0">
+                        <a:buNone/>
+                      </a:pPr>
+                      <a:r>
+                        <a:rPr lang="en-US" sz="1100" b="1" dirty="0">
+                          <a:solidFill>
+                            <a:srgbClr val="E4E6ED"/>
+                          </a:solidFill>
+                          <a:latin typeface="Calibri" pitchFamily="34" charset="0"/>
+                          <a:ea typeface="Calibri" pitchFamily="34" charset="-122"/>
+                          <a:cs typeface="Calibri" pitchFamily="34" charset="-120"/>
+                        </a:rPr>
+                        <a:t>$2,900</a:t>
+                      </a:r>
+                      <a:endParaRPr lang="en-US" sz="1100" dirty="0">
+                        <a:latin typeface="Calibri" charset="0"/>
+                        <a:ea typeface="Calibri" charset="0"/>
+                        <a:cs typeface="Calibri" charset="0"/>
+                      </a:endParaRPr>
+                    </a:p>
+                  </a:txBody>
+                  <a:tcPr marL="91440" marR="91440" marT="45720" marB="45720">
+                    <a:lnL w="6350" cap="flat" cmpd="sng" algn="ctr">
+                      <a:solidFill>
+                        <a:srgbClr val="2A2E3B"/>
+                      </a:solidFill>
+                      <a:prstDash val="solid"/>
+                      <a:round/>
+                      <a:headEnd type="none" w="med" len="med"/>
+                      <a:tailEnd type="none" w="med" len="med"/>
+                    </a:lnL>
+                    <a:lnR w="6350" cap="flat" cmpd="sng" algn="ctr">
+                      <a:solidFill>
+                        <a:srgbClr val="2A2E3B"/>
+                      </a:solidFill>
+                      <a:prstDash val="solid"/>
+                      <a:round/>
+                      <a:headEnd type="none" w="med" len="med"/>
+                      <a:tailEnd type="none" w="med" len="med"/>
+                    </a:lnR>
+                    <a:lnT w="6350" cap="flat" cmpd="sng" algn="ctr">
+                      <a:solidFill>
+                        <a:srgbClr val="2A2E3B"/>
+                      </a:solidFill>
+                      <a:prstDash val="solid"/>
+                      <a:round/>
+                      <a:headEnd type="none" w="med" len="med"/>
+                      <a:tailEnd type="none" w="med" len="med"/>
+                    </a:lnT>
+                    <a:lnB w="6350" cap="flat" cmpd="sng" algn="ctr">
+                      <a:solidFill>
+                        <a:srgbClr val="2A2E3B"/>
+                      </a:solidFill>
+                      <a:prstDash val="solid"/>
+                      <a:round/>
+                      <a:headEnd type="none" w="med" len="med"/>
+                      <a:tailEnd type="none" w="med" len="med"/>
+                    </a:lnB>
+                    <a:solidFill>
+                      <a:srgbClr val="1A1D27"/>
+                    </a:solidFill>
+                  </a:tcPr>
+                </a:tc>
+              </a:tr>
+              <a:tr h="274320">
                 <a:tc>
                   <a:txBody>
                     <a:bodyPr/>
@@ -6177,7 +6587,7 @@
                           <a:ea typeface="Calibri" pitchFamily="34" charset="-122"/>
                           <a:cs typeface="Calibri" pitchFamily="34" charset="-120"/>
                         </a:rPr>
-                        <a:t>75%</a:t>
+                        <a:t>76%</a:t>
                       </a:r>
                       <a:endParaRPr lang="en-US" sz="1100" dirty="0">
                         <a:latin typeface="Calibri" charset="0"/>
@@ -6297,7 +6707,7 @@
                   </a:tcPr>
                 </a:tc>
               </a:tr>
-              <a:tr h="310896">
+              <a:tr h="274320">
                 <a:tc>
                   <a:txBody>
                     <a:bodyPr/>
@@ -6307,7 +6717,7 @@
                         <a:buNone/>
                       </a:pPr>
                       <a:r>
-                        <a:rPr lang="en-US" sz="1100" b="1" dirty="0">
+                        <a:rPr lang="en-US" sz="1100" dirty="0">
                           <a:solidFill>
                             <a:srgbClr val="E4E6ED"/>
                           </a:solidFill>
@@ -6315,7 +6725,7 @@
                           <a:ea typeface="Calibri" pitchFamily="34" charset="-122"/>
                           <a:cs typeface="Calibri" pitchFamily="34" charset="-120"/>
                         </a:rPr>
-                        <a:t>Kraken</a:t>
+                        <a:t>Hawk</a:t>
                       </a:r>
                       <a:endParaRPr lang="en-US" sz="1100" dirty="0">
                         <a:latin typeface="Calibri" charset="0"/>
@@ -6383,7 +6793,7 @@
                           <a:ea typeface="Calibri" pitchFamily="34" charset="-122"/>
                           <a:cs typeface="Calibri" pitchFamily="34" charset="-120"/>
                         </a:rPr>
-                        <a:t>MCP | $3.5k</a:t>
+                        <a:t>MCP | $12.5k</a:t>
                       </a:r>
                       <a:endParaRPr lang="en-US" sz="1100" dirty="0">
                         <a:latin typeface="Calibri" charset="0"/>
@@ -6451,7 +6861,7 @@
                           <a:ea typeface="Calibri" pitchFamily="34" charset="-122"/>
                           <a:cs typeface="Calibri" pitchFamily="34" charset="-120"/>
                         </a:rPr>
-                        <a:t>$3,468</a:t>
+                        <a:t>$12,500</a:t>
                       </a:r>
                       <a:endParaRPr lang="en-US" sz="1100" dirty="0">
                         <a:latin typeface="Calibri" charset="0"/>
@@ -6513,13 +6923,13 @@
                       <a:r>
                         <a:rPr lang="en-US" sz="1000" b="1" dirty="0">
                           <a:solidFill>
-                            <a:srgbClr val="00B894"/>
+                            <a:srgbClr val="74B9FF"/>
                           </a:solidFill>
                           <a:latin typeface="Calibri" pitchFamily="34" charset="0"/>
                           <a:ea typeface="Calibri" pitchFamily="34" charset="-122"/>
                           <a:cs typeface="Calibri" pitchFamily="34" charset="-120"/>
                         </a:rPr>
-                        <a:t>Committed</a:t>
+                        <a:t>Qualification · new</a:t>
                       </a:r>
                       <a:endParaRPr lang="en-US" sz="1000" dirty="0">
                         <a:latin typeface="Calibri" charset="0"/>
@@ -6587,7 +6997,7 @@
                           <a:ea typeface="Calibri" pitchFamily="34" charset="-122"/>
                           <a:cs typeface="Calibri" pitchFamily="34" charset="-120"/>
                         </a:rPr>
-                        <a:t>70%</a:t>
+                        <a:t>69%</a:t>
                       </a:r>
                       <a:endParaRPr lang="en-US" sz="1100" dirty="0">
                         <a:latin typeface="Calibri" charset="0"/>
@@ -6647,7 +7057,7 @@
                         <a:buNone/>
                       </a:pPr>
                       <a:r>
-                        <a:rPr lang="en-US" sz="1100" b="1" dirty="0">
+                        <a:rPr lang="en-US" sz="1100" dirty="0">
                           <a:solidFill>
                             <a:srgbClr val="E4E6ED"/>
                           </a:solidFill>
@@ -6655,7 +7065,7 @@
                           <a:ea typeface="Calibri" pitchFamily="34" charset="-122"/>
                           <a:cs typeface="Calibri" pitchFamily="34" charset="-120"/>
                         </a:rPr>
-                        <a:t>$2,400</a:t>
+                        <a:t>$8,600</a:t>
                       </a:r>
                       <a:endParaRPr lang="en-US" sz="1100" dirty="0">
                         <a:latin typeface="Calibri" charset="0"/>
@@ -6707,7 +7117,7 @@
                   </a:tcPr>
                 </a:tc>
               </a:tr>
-              <a:tr h="310896">
+              <a:tr h="274320">
                 <a:tc>
                   <a:txBody>
                     <a:bodyPr/>
@@ -7117,7 +7527,7 @@
                   </a:tcPr>
                 </a:tc>
               </a:tr>
-              <a:tr h="310896">
+              <a:tr h="274320">
                 <a:tc>
                   <a:txBody>
                     <a:bodyPr/>
@@ -7527,7 +7937,7 @@
                   </a:tcPr>
                 </a:tc>
               </a:tr>
-              <a:tr h="310896">
+              <a:tr h="274320">
                 <a:tc>
                   <a:txBody>
                     <a:bodyPr/>
@@ -7545,7 +7955,7 @@
                           <a:ea typeface="Calibri" pitchFamily="34" charset="-122"/>
                           <a:cs typeface="Calibri" pitchFamily="34" charset="-120"/>
                         </a:rPr>
-                        <a:t>Other (~16)</a:t>
+                        <a:t>Other (~18)</a:t>
                       </a:r>
                       <a:endParaRPr lang="en-US" sz="1100" dirty="0">
                         <a:latin typeface="Calibri" charset="0"/>
@@ -7681,7 +8091,7 @@
                           <a:ea typeface="Calibri" pitchFamily="34" charset="-122"/>
                           <a:cs typeface="Calibri" pitchFamily="34" charset="-120"/>
                         </a:rPr>
-                        <a:t>~$60,500</a:t>
+                        <a:t>~$83,000</a:t>
                       </a:r>
                       <a:endParaRPr lang="en-US" sz="1100" dirty="0">
                         <a:latin typeface="Calibri" charset="0"/>
@@ -7817,7 +8227,7 @@
                           <a:ea typeface="Calibri" pitchFamily="34" charset="-122"/>
                           <a:cs typeface="Calibri" pitchFamily="34" charset="-120"/>
                         </a:rPr>
-                        <a:t>~26%</a:t>
+                        <a:t>~27%</a:t>
                       </a:r>
                       <a:endParaRPr lang="en-US" sz="1100" dirty="0">
                         <a:latin typeface="Calibri" charset="0"/>
@@ -7885,7 +8295,7 @@
                           <a:ea typeface="Calibri" pitchFamily="34" charset="-122"/>
                           <a:cs typeface="Calibri" pitchFamily="34" charset="-120"/>
                         </a:rPr>
-                        <a:t>~$15,800</a:t>
+                        <a:t>~$22,600</a:t>
                       </a:r>
                       <a:endParaRPr lang="en-US" sz="1100" dirty="0">
                         <a:latin typeface="Calibri" charset="0"/>
@@ -7937,7 +8347,7 @@
                   </a:tcPr>
                 </a:tc>
               </a:tr>
-              <a:tr h="310896">
+              <a:tr h="274320">
                 <a:tc>
                   <a:txBody>
                     <a:bodyPr/>
@@ -8023,7 +8433,7 @@
                           <a:ea typeface="Calibri" pitchFamily="34" charset="-122"/>
                           <a:cs typeface="Calibri" pitchFamily="34" charset="-120"/>
                         </a:rPr>
-                        <a:t>22 July-close deals</a:t>
+                        <a:t>25 July-close deals</a:t>
                       </a:r>
                       <a:endParaRPr lang="en-US" sz="1100" dirty="0">
                         <a:latin typeface="Calibri" charset="0"/>
@@ -8091,7 +8501,7 @@
                           <a:ea typeface="Calibri" pitchFamily="34" charset="-122"/>
                           <a:cs typeface="Calibri" pitchFamily="34" charset="-120"/>
                         </a:rPr>
-                        <a:t>$106,900</a:t>
+                        <a:t>$141,900</a:t>
                       </a:r>
                       <a:endParaRPr lang="en-US" sz="1100" dirty="0">
                         <a:latin typeface="Calibri" charset="0"/>
@@ -8227,7 +8637,7 @@
                           <a:ea typeface="Calibri" pitchFamily="34" charset="-122"/>
                           <a:cs typeface="Calibri" pitchFamily="34" charset="-120"/>
                         </a:rPr>
-                        <a:t>43%</a:t>
+                        <a:t>44%</a:t>
                       </a:r>
                       <a:endParaRPr lang="en-US" sz="1100" dirty="0">
                         <a:latin typeface="Calibri" charset="0"/>
@@ -8295,7 +8705,7 @@
                           <a:ea typeface="Calibri" pitchFamily="34" charset="-122"/>
                           <a:cs typeface="Calibri" pitchFamily="34" charset="-120"/>
                         </a:rPr>
-                        <a:t>$46,100</a:t>
+                        <a:t>$62,000</a:t>
                       </a:r>
                       <a:endParaRPr lang="en-US" sz="1100" dirty="0">
                         <a:latin typeface="Calibri" charset="0"/>
@@ -8409,7 +8819,7 @@
                 <a:ea typeface="Calibri" pitchFamily="34" charset="-122"/>
                 <a:cs typeface="Calibri" pitchFamily="34" charset="-120"/>
               </a:rPr>
-              <a:t>Swing / overdue (not in the $106.9k July-close): </a:t>
+              <a:t>Swing / overdue (not in the $141.9k July-close): </a:t>
             </a:r>
             <a:pPr indent="0" marL="0">
               <a:buNone/>
@@ -8503,7 +8913,7 @@
                 <a:ea typeface="Calibri" pitchFamily="34" charset="-122"/>
                 <a:cs typeface="Calibri" pitchFamily="34" charset="-120"/>
               </a:rPr>
-              <a:t>July opens 197% weighted-covered with $18.8k already committed (81%) on the reduced $23.4k quota — coverage is not the risk. A no-anchor portfolio (largest weighted RLE $10k) converts on MEDDICC breadth; Upwork (85%, legal/DPA) is the strongest signal. HubSpot|MCP moved to Aug.</a:t>
+              <a:t>July opens 265% weighted-covered ($62.0k) with $18.8k committed (81%) on the reduced $23.4k quota. New op Hawk ($12.5k, 69%, $8.6k weighted) adds a second $10k+ swing alongside RLE ($10k). Upwork (85%, legal/DPA) is the strongest signal; MEDDICC breadth on RLE, Hawk, HA is the play.</a:t>
             </a:r>
             <a:endParaRPr lang="en-US" sz="1050" dirty="0"/>
           </a:p>
@@ -8922,7 +9332,7 @@
                 <a:ea typeface="Calibri" pitchFamily="34" charset="-122"/>
                 <a:cs typeface="Calibri" pitchFamily="34" charset="-120"/>
               </a:rPr>
-              <a:t>• MEDDICC discipline on the open $10k+ ops (RLE, Upwork, HA)</a:t>
+              <a:t>• MEDDICC discipline on the open $10k+ ops (RLE, Hawk, Upwork, HA)</a:t>
             </a:r>
             <a:endParaRPr lang="en-US" sz="1300" dirty="0"/>
           </a:p>
@@ -18409,7 +18819,7 @@
                 <a:ea typeface="Calibri" pitchFamily="34" charset="-122"/>
                 <a:cs typeface="Calibri" pitchFamily="34" charset="-120"/>
               </a:rPr>
-              <a:t>Jul = confirmed FC ($18.8k, 81%) + weighted upside to $46.1k. Aug–Oct = H1 run-rate (~$40k) with 2025 seasonality applied — Sep/Oct are historically the strongest months (both ~$63k in 2025); Aug a summer lull. H2 paces above quota if the KAM book's renewals + expansion convert.</a:t>
+              <a:t>Jul = confirmed FC ($18.8k, 81%) + weighted upside to $62.0k. Aug–Oct = H1 run-rate (~$40k) with 2025 seasonality applied — Sep/Oct are historically the strongest months (both ~$63k in 2025); Aug a summer lull. H2 paces above quota if the KAM book's renewals + expansion convert.</a:t>
             </a:r>
             <a:endParaRPr lang="en-US" sz="950" dirty="0"/>
           </a:p>
@@ -21233,7 +21643,7 @@
                 <a:ea typeface="Calibri" pitchFamily="34" charset="-122"/>
                 <a:cs typeface="Calibri" pitchFamily="34" charset="-120"/>
               </a:rPr>
-              <a:t>$106.9k</a:t>
+              <a:t>$141.9k</a:t>
             </a:r>
             <a:pPr indent="0" marL="0">
               <a:buNone/>
@@ -21247,7 +21657,7 @@
                 <a:ea typeface="Calibri" pitchFamily="34" charset="-122"/>
                 <a:cs typeface="Calibri" pitchFamily="34" charset="-120"/>
               </a:rPr>
-              <a:t> · 457% coverage · $46.1k weighted (197%)
+              <a:t> · 607% coverage · $62.0k weighted (265%)
 </a:t>
             </a:r>
             <a:pPr indent="0" marL="0">
@@ -21398,7 +21808,7 @@
                 <a:ea typeface="Calibri" pitchFamily="34" charset="-122"/>
                 <a:cs typeface="Calibri" pitchFamily="34" charset="-120"/>
               </a:rPr>
-              <a:t>• Convert the $106.9k open with MEDDICC discipline on every $10k+</a:t>
+              <a:t>• Convert the $141.9k open with MEDDICC discipline on every $10k+</a:t>
             </a:r>
             <a:endParaRPr lang="en-US" sz="1300" dirty="0"/>
           </a:p>
@@ -22684,7 +23094,7 @@
                 <a:ea typeface="Calibri" pitchFamily="34" charset="-122"/>
                 <a:cs typeface="Calibri" pitchFamily="34" charset="-120"/>
               </a:rPr>
-              <a:t> — 75 Gold accounts mapped and planned, expansion/renewal surfaced, the $106.9k open converted.</a:t>
+              <a:t> — 75 Gold accounts mapped and planned, expansion/renewal surfaced, the $141.9k open converted.</a:t>
             </a:r>
             <a:endParaRPr lang="en-US" sz="1200" dirty="0"/>
           </a:p>

</xml_diff>

<commit_message>
S12: Hawk stage -> Proposal
Co-Authored-By: Claude Opus 4.8 <noreply@anthropic.com>
</commit_message>
<xml_diff>
--- a/June_2026_NAM_MBR.pptx
+++ b/June_2026_NAM_MBR.pptx
@@ -6923,13 +6923,13 @@
                       <a:r>
                         <a:rPr lang="en-US" sz="1000" b="1" dirty="0">
                           <a:solidFill>
-                            <a:srgbClr val="74B9FF"/>
+                            <a:srgbClr val="6C5CE7"/>
                           </a:solidFill>
                           <a:latin typeface="Calibri" pitchFamily="34" charset="0"/>
                           <a:ea typeface="Calibri" pitchFamily="34" charset="-122"/>
                           <a:cs typeface="Calibri" pitchFamily="34" charset="-120"/>
                         </a:rPr>
-                        <a:t>Qualification · new</a:t>
+                        <a:t>Proposal · new</a:t>
                       </a:r>
                       <a:endParaRPr lang="en-US" sz="1000" dirty="0">
                         <a:latin typeface="Calibri" charset="0"/>

</xml_diff>

<commit_message>
S9: June activity from command-center email CMS (not HubSpot)
Replaced the HubSpot activity table with the Sales Command Center outreach
numbers: Emails Sent 3,093 (155%), Contacts Enrolled 90 (23%), Contacts
Reached 427 (21%), Accounts Touched 32 (40%); reply rate 0.6% / 2 replies;
tier split Gold 3 (498) / Bronze 17 (1,115) / Prospect 12 (975). Read reframed:
volume hot but low-yield and skewed to Bronze/Prospect — reinforces the KAM
pivot to the Gold base.

Co-Authored-By: Claude Opus 4.8 <noreply@anthropic.com>
</commit_message>
<xml_diff>
--- a/June_2026_NAM_MBR.pptx
+++ b/June_2026_NAM_MBR.pptx
@@ -21872,7 +21872,7 @@
                 <a:ea typeface="Calibri" pitchFamily="34" charset="-122"/>
                 <a:cs typeface="Calibri" pitchFamily="34" charset="-120"/>
               </a:rPr>
-              <a:t>JUNE ACTIVITY BASELINE (HubSpot / Command Center)</a:t>
+              <a:t>JUNE OUTREACH — COMMAND CENTER (email CMS)</a:t>
             </a:r>
             <a:endParaRPr lang="en-US" sz="1200" dirty="0"/>
           </a:p>
@@ -21901,11 +21901,11 @@
             <a:tbl>
               <a:tblPr/>
               <a:tblGrid>
+                <a:gridCol w="2377440"/>
+                <a:gridCol w="1371600"/>
                 <a:gridCol w="1554480"/>
-                <a:gridCol w="731520"/>
-                <a:gridCol w="3017520"/>
               </a:tblGrid>
-              <a:tr h="438912">
+              <a:tr h="384048">
                 <a:tc>
                   <a:txBody>
                     <a:bodyPr/>
@@ -21923,7 +21923,7 @@
                           <a:ea typeface="Calibri" pitchFamily="34" charset="-122"/>
                           <a:cs typeface="Calibri" pitchFamily="34" charset="-120"/>
                         </a:rPr>
-                        <a:t>Activity</a:t>
+                        <a:t>Metric</a:t>
                       </a:r>
                       <a:endParaRPr lang="en-US" sz="1200" dirty="0">
                         <a:latin typeface="Calibri" charset="0"/>
@@ -22047,7 +22047,7 @@
                     <a:bodyPr/>
                     <a:lstStyle/>
                     <a:p>
-                      <a:pPr indent="0" marL="0">
+                      <a:pPr algn="r" indent="0" marL="0">
                         <a:buNone/>
                       </a:pPr>
                       <a:r>
@@ -22059,7 +22059,7 @@
                           <a:ea typeface="Calibri" pitchFamily="34" charset="-122"/>
                           <a:cs typeface="Calibri" pitchFamily="34" charset="-120"/>
                         </a:rPr>
-                        <a:t>Read</a:t>
+                        <a:t>% Goal</a:t>
                       </a:r>
                       <a:endParaRPr lang="en-US" sz="1200" dirty="0">
                         <a:latin typeface="Calibri" charset="0"/>
@@ -22111,7 +22111,7 @@
                   </a:tcPr>
                 </a:tc>
               </a:tr>
-              <a:tr h="438912">
+              <a:tr h="384048">
                 <a:tc>
                   <a:txBody>
                     <a:bodyPr/>
@@ -22129,7 +22129,75 @@
                           <a:ea typeface="Calibri" pitchFamily="34" charset="-122"/>
                           <a:cs typeface="Calibri" pitchFamily="34" charset="-120"/>
                         </a:rPr>
-                        <a:t>Meetings</a:t>
+                        <a:t>Emails Sent</a:t>
+                      </a:r>
+                      <a:endParaRPr lang="en-US" sz="1250" dirty="0">
+                        <a:latin typeface="Calibri" charset="0"/>
+                        <a:ea typeface="Calibri" charset="0"/>
+                        <a:cs typeface="Calibri" charset="0"/>
+                      </a:endParaRPr>
+                    </a:p>
+                  </a:txBody>
+                  <a:tcPr marL="91440" marR="91440" marT="45720" marB="45720">
+                    <a:lnL w="6350" cap="flat" cmpd="sng" algn="ctr">
+                      <a:solidFill>
+                        <a:srgbClr val="2A2E3B"/>
+                      </a:solidFill>
+                      <a:prstDash val="solid"/>
+                      <a:round/>
+                      <a:headEnd type="none" w="med" len="med"/>
+                      <a:tailEnd type="none" w="med" len="med"/>
+                    </a:lnL>
+                    <a:lnR w="6350" cap="flat" cmpd="sng" algn="ctr">
+                      <a:solidFill>
+                        <a:srgbClr val="2A2E3B"/>
+                      </a:solidFill>
+                      <a:prstDash val="solid"/>
+                      <a:round/>
+                      <a:headEnd type="none" w="med" len="med"/>
+                      <a:tailEnd type="none" w="med" len="med"/>
+                    </a:lnR>
+                    <a:lnT w="6350" cap="flat" cmpd="sng" algn="ctr">
+                      <a:solidFill>
+                        <a:srgbClr val="2A2E3B"/>
+                      </a:solidFill>
+                      <a:prstDash val="solid"/>
+                      <a:round/>
+                      <a:headEnd type="none" w="med" len="med"/>
+                      <a:tailEnd type="none" w="med" len="med"/>
+                    </a:lnT>
+                    <a:lnB w="6350" cap="flat" cmpd="sng" algn="ctr">
+                      <a:solidFill>
+                        <a:srgbClr val="2A2E3B"/>
+                      </a:solidFill>
+                      <a:prstDash val="solid"/>
+                      <a:round/>
+                      <a:headEnd type="none" w="med" len="med"/>
+                      <a:tailEnd type="none" w="med" len="med"/>
+                    </a:lnB>
+                    <a:solidFill>
+                      <a:srgbClr val="222632"/>
+                    </a:solidFill>
+                  </a:tcPr>
+                </a:tc>
+                <a:tc>
+                  <a:txBody>
+                    <a:bodyPr/>
+                    <a:lstStyle/>
+                    <a:p>
+                      <a:pPr algn="r" indent="0" marL="0">
+                        <a:buNone/>
+                      </a:pPr>
+                      <a:r>
+                        <a:rPr lang="en-US" sz="1250" b="1" dirty="0">
+                          <a:solidFill>
+                            <a:srgbClr val="E4E6ED"/>
+                          </a:solidFill>
+                          <a:latin typeface="Calibri" pitchFamily="34" charset="0"/>
+                          <a:ea typeface="Calibri" pitchFamily="34" charset="-122"/>
+                          <a:cs typeface="Calibri" pitchFamily="34" charset="-120"/>
+                        </a:rPr>
+                        <a:t>3,093</a:t>
                       </a:r>
                       <a:endParaRPr lang="en-US" sz="1250" dirty="0">
                         <a:latin typeface="Calibri" charset="0"/>
@@ -22197,7 +22265,7 @@
                           <a:ea typeface="Calibri" pitchFamily="34" charset="-122"/>
                           <a:cs typeface="Calibri" pitchFamily="34" charset="-120"/>
                         </a:rPr>
-                        <a:t>62</a:t>
+                        <a:t>155%</a:t>
                       </a:r>
                       <a:endParaRPr lang="en-US" sz="1250" dirty="0">
                         <a:latin typeface="Calibri" charset="0"/>
@@ -22248,76 +22316,8 @@
                     </a:solidFill>
                   </a:tcPr>
                 </a:tc>
-                <a:tc>
-                  <a:txBody>
-                    <a:bodyPr/>
-                    <a:lstStyle/>
-                    <a:p>
-                      <a:pPr indent="0" marL="0">
-                        <a:buNone/>
-                      </a:pPr>
-                      <a:r>
-                        <a:rPr lang="en-US" sz="1150" dirty="0">
-                          <a:solidFill>
-                            <a:srgbClr val="8B8FA3"/>
-                          </a:solidFill>
-                          <a:latin typeface="Calibri" pitchFamily="34" charset="0"/>
-                          <a:ea typeface="Calibri" pitchFamily="34" charset="-122"/>
-                          <a:cs typeface="Calibri" pitchFamily="34" charset="-120"/>
-                        </a:rPr>
-                        <a:t>Healthy inbound + customer load (~2.8/day)</a:t>
-                      </a:r>
-                      <a:endParaRPr lang="en-US" sz="1150" dirty="0">
-                        <a:latin typeface="Calibri" charset="0"/>
-                        <a:ea typeface="Calibri" charset="0"/>
-                        <a:cs typeface="Calibri" charset="0"/>
-                      </a:endParaRPr>
-                    </a:p>
-                  </a:txBody>
-                  <a:tcPr marL="91440" marR="91440" marT="45720" marB="45720">
-                    <a:lnL w="6350" cap="flat" cmpd="sng" algn="ctr">
-                      <a:solidFill>
-                        <a:srgbClr val="2A2E3B"/>
-                      </a:solidFill>
-                      <a:prstDash val="solid"/>
-                      <a:round/>
-                      <a:headEnd type="none" w="med" len="med"/>
-                      <a:tailEnd type="none" w="med" len="med"/>
-                    </a:lnL>
-                    <a:lnR w="6350" cap="flat" cmpd="sng" algn="ctr">
-                      <a:solidFill>
-                        <a:srgbClr val="2A2E3B"/>
-                      </a:solidFill>
-                      <a:prstDash val="solid"/>
-                      <a:round/>
-                      <a:headEnd type="none" w="med" len="med"/>
-                      <a:tailEnd type="none" w="med" len="med"/>
-                    </a:lnR>
-                    <a:lnT w="6350" cap="flat" cmpd="sng" algn="ctr">
-                      <a:solidFill>
-                        <a:srgbClr val="2A2E3B"/>
-                      </a:solidFill>
-                      <a:prstDash val="solid"/>
-                      <a:round/>
-                      <a:headEnd type="none" w="med" len="med"/>
-                      <a:tailEnd type="none" w="med" len="med"/>
-                    </a:lnT>
-                    <a:lnB w="6350" cap="flat" cmpd="sng" algn="ctr">
-                      <a:solidFill>
-                        <a:srgbClr val="2A2E3B"/>
-                      </a:solidFill>
-                      <a:prstDash val="solid"/>
-                      <a:round/>
-                      <a:headEnd type="none" w="med" len="med"/>
-                      <a:tailEnd type="none" w="med" len="med"/>
-                    </a:lnB>
-                    <a:solidFill>
-                      <a:srgbClr val="222632"/>
-                    </a:solidFill>
-                  </a:tcPr>
-                </a:tc>
               </a:tr>
-              <a:tr h="438912">
+              <a:tr h="384048">
                 <a:tc>
                   <a:txBody>
                     <a:bodyPr/>
@@ -22335,213 +22335,7 @@
                           <a:ea typeface="Calibri" pitchFamily="34" charset="-122"/>
                           <a:cs typeface="Calibri" pitchFamily="34" charset="-120"/>
                         </a:rPr>
-                        <a:t>Emails logged</a:t>
-                      </a:r>
-                      <a:endParaRPr lang="en-US" sz="1250" dirty="0">
-                        <a:latin typeface="Calibri" charset="0"/>
-                        <a:ea typeface="Calibri" charset="0"/>
-                        <a:cs typeface="Calibri" charset="0"/>
-                      </a:endParaRPr>
-                    </a:p>
-                  </a:txBody>
-                  <a:tcPr marL="91440" marR="91440" marT="45720" marB="45720">
-                    <a:lnL w="6350" cap="flat" cmpd="sng" algn="ctr">
-                      <a:solidFill>
-                        <a:srgbClr val="2A2E3B"/>
-                      </a:solidFill>
-                      <a:prstDash val="solid"/>
-                      <a:round/>
-                      <a:headEnd type="none" w="med" len="med"/>
-                      <a:tailEnd type="none" w="med" len="med"/>
-                    </a:lnL>
-                    <a:lnR w="6350" cap="flat" cmpd="sng" algn="ctr">
-                      <a:solidFill>
-                        <a:srgbClr val="2A2E3B"/>
-                      </a:solidFill>
-                      <a:prstDash val="solid"/>
-                      <a:round/>
-                      <a:headEnd type="none" w="med" len="med"/>
-                      <a:tailEnd type="none" w="med" len="med"/>
-                    </a:lnR>
-                    <a:lnT w="6350" cap="flat" cmpd="sng" algn="ctr">
-                      <a:solidFill>
-                        <a:srgbClr val="2A2E3B"/>
-                      </a:solidFill>
-                      <a:prstDash val="solid"/>
-                      <a:round/>
-                      <a:headEnd type="none" w="med" len="med"/>
-                      <a:tailEnd type="none" w="med" len="med"/>
-                    </a:lnT>
-                    <a:lnB w="6350" cap="flat" cmpd="sng" algn="ctr">
-                      <a:solidFill>
-                        <a:srgbClr val="2A2E3B"/>
-                      </a:solidFill>
-                      <a:prstDash val="solid"/>
-                      <a:round/>
-                      <a:headEnd type="none" w="med" len="med"/>
-                      <a:tailEnd type="none" w="med" len="med"/>
-                    </a:lnB>
-                    <a:solidFill>
-                      <a:srgbClr val="222632"/>
-                    </a:solidFill>
-                  </a:tcPr>
-                </a:tc>
-                <a:tc>
-                  <a:txBody>
-                    <a:bodyPr/>
-                    <a:lstStyle/>
-                    <a:p>
-                      <a:pPr algn="r" indent="0" marL="0">
-                        <a:buNone/>
-                      </a:pPr>
-                      <a:r>
-                        <a:rPr lang="en-US" sz="1250" b="1" dirty="0">
-                          <a:solidFill>
-                            <a:srgbClr val="E4E6ED"/>
-                          </a:solidFill>
-                          <a:latin typeface="Calibri" pitchFamily="34" charset="0"/>
-                          <a:ea typeface="Calibri" pitchFamily="34" charset="-122"/>
-                          <a:cs typeface="Calibri" pitchFamily="34" charset="-120"/>
-                        </a:rPr>
-                        <a:t>394</a:t>
-                      </a:r>
-                      <a:endParaRPr lang="en-US" sz="1250" dirty="0">
-                        <a:latin typeface="Calibri" charset="0"/>
-                        <a:ea typeface="Calibri" charset="0"/>
-                        <a:cs typeface="Calibri" charset="0"/>
-                      </a:endParaRPr>
-                    </a:p>
-                  </a:txBody>
-                  <a:tcPr marL="91440" marR="91440" marT="45720" marB="45720">
-                    <a:lnL w="6350" cap="flat" cmpd="sng" algn="ctr">
-                      <a:solidFill>
-                        <a:srgbClr val="2A2E3B"/>
-                      </a:solidFill>
-                      <a:prstDash val="solid"/>
-                      <a:round/>
-                      <a:headEnd type="none" w="med" len="med"/>
-                      <a:tailEnd type="none" w="med" len="med"/>
-                    </a:lnL>
-                    <a:lnR w="6350" cap="flat" cmpd="sng" algn="ctr">
-                      <a:solidFill>
-                        <a:srgbClr val="2A2E3B"/>
-                      </a:solidFill>
-                      <a:prstDash val="solid"/>
-                      <a:round/>
-                      <a:headEnd type="none" w="med" len="med"/>
-                      <a:tailEnd type="none" w="med" len="med"/>
-                    </a:lnR>
-                    <a:lnT w="6350" cap="flat" cmpd="sng" algn="ctr">
-                      <a:solidFill>
-                        <a:srgbClr val="2A2E3B"/>
-                      </a:solidFill>
-                      <a:prstDash val="solid"/>
-                      <a:round/>
-                      <a:headEnd type="none" w="med" len="med"/>
-                      <a:tailEnd type="none" w="med" len="med"/>
-                    </a:lnT>
-                    <a:lnB w="6350" cap="flat" cmpd="sng" algn="ctr">
-                      <a:solidFill>
-                        <a:srgbClr val="2A2E3B"/>
-                      </a:solidFill>
-                      <a:prstDash val="solid"/>
-                      <a:round/>
-                      <a:headEnd type="none" w="med" len="med"/>
-                      <a:tailEnd type="none" w="med" len="med"/>
-                    </a:lnB>
-                    <a:solidFill>
-                      <a:srgbClr val="222632"/>
-                    </a:solidFill>
-                  </a:tcPr>
-                </a:tc>
-                <a:tc>
-                  <a:txBody>
-                    <a:bodyPr/>
-                    <a:lstStyle/>
-                    <a:p>
-                      <a:pPr indent="0" marL="0">
-                        <a:buNone/>
-                      </a:pPr>
-                      <a:r>
-                        <a:rPr lang="en-US" sz="1150" dirty="0">
-                          <a:solidFill>
-                            <a:srgbClr val="8B8FA3"/>
-                          </a:solidFill>
-                          <a:latin typeface="Calibri" pitchFamily="34" charset="0"/>
-                          <a:ea typeface="Calibri" pitchFamily="34" charset="-122"/>
-                          <a:cs typeface="Calibri" pitchFamily="34" charset="-120"/>
-                        </a:rPr>
-                        <a:t>Down, still the primary written channel</a:t>
-                      </a:r>
-                      <a:endParaRPr lang="en-US" sz="1150" dirty="0">
-                        <a:latin typeface="Calibri" charset="0"/>
-                        <a:ea typeface="Calibri" charset="0"/>
-                        <a:cs typeface="Calibri" charset="0"/>
-                      </a:endParaRPr>
-                    </a:p>
-                  </a:txBody>
-                  <a:tcPr marL="91440" marR="91440" marT="45720" marB="45720">
-                    <a:lnL w="6350" cap="flat" cmpd="sng" algn="ctr">
-                      <a:solidFill>
-                        <a:srgbClr val="2A2E3B"/>
-                      </a:solidFill>
-                      <a:prstDash val="solid"/>
-                      <a:round/>
-                      <a:headEnd type="none" w="med" len="med"/>
-                      <a:tailEnd type="none" w="med" len="med"/>
-                    </a:lnL>
-                    <a:lnR w="6350" cap="flat" cmpd="sng" algn="ctr">
-                      <a:solidFill>
-                        <a:srgbClr val="2A2E3B"/>
-                      </a:solidFill>
-                      <a:prstDash val="solid"/>
-                      <a:round/>
-                      <a:headEnd type="none" w="med" len="med"/>
-                      <a:tailEnd type="none" w="med" len="med"/>
-                    </a:lnR>
-                    <a:lnT w="6350" cap="flat" cmpd="sng" algn="ctr">
-                      <a:solidFill>
-                        <a:srgbClr val="2A2E3B"/>
-                      </a:solidFill>
-                      <a:prstDash val="solid"/>
-                      <a:round/>
-                      <a:headEnd type="none" w="med" len="med"/>
-                      <a:tailEnd type="none" w="med" len="med"/>
-                    </a:lnT>
-                    <a:lnB w="6350" cap="flat" cmpd="sng" algn="ctr">
-                      <a:solidFill>
-                        <a:srgbClr val="2A2E3B"/>
-                      </a:solidFill>
-                      <a:prstDash val="solid"/>
-                      <a:round/>
-                      <a:headEnd type="none" w="med" len="med"/>
-                      <a:tailEnd type="none" w="med" len="med"/>
-                    </a:lnB>
-                    <a:solidFill>
-                      <a:srgbClr val="222632"/>
-                    </a:solidFill>
-                  </a:tcPr>
-                </a:tc>
-              </a:tr>
-              <a:tr h="438912">
-                <a:tc>
-                  <a:txBody>
-                    <a:bodyPr/>
-                    <a:lstStyle/>
-                    <a:p>
-                      <a:pPr indent="0" marL="0">
-                        <a:buNone/>
-                      </a:pPr>
-                      <a:r>
-                        <a:rPr lang="en-US" sz="1250" dirty="0">
-                          <a:solidFill>
-                            <a:srgbClr val="E4E6ED"/>
-                          </a:solidFill>
-                          <a:latin typeface="Calibri" pitchFamily="34" charset="0"/>
-                          <a:ea typeface="Calibri" pitchFamily="34" charset="-122"/>
-                          <a:cs typeface="Calibri" pitchFamily="34" charset="-120"/>
-                        </a:rPr>
-                        <a:t>New contacts</a:t>
+                        <a:t>Contacts Enrolled</a:t>
                       </a:r>
                       <a:endParaRPr lang="en-US" sz="1250" dirty="0">
                         <a:latin typeface="Calibri" charset="0"/>
@@ -22665,21 +22459,21 @@
                     <a:bodyPr/>
                     <a:lstStyle/>
                     <a:p>
-                      <a:pPr indent="0" marL="0">
+                      <a:pPr algn="r" indent="0" marL="0">
                         <a:buNone/>
                       </a:pPr>
                       <a:r>
-                        <a:rPr lang="en-US" sz="1150" dirty="0">
+                        <a:rPr lang="en-US" sz="1250" b="1" dirty="0">
                           <a:solidFill>
-                            <a:srgbClr val="8B8FA3"/>
+                            <a:srgbClr val="FDCB6E"/>
                           </a:solidFill>
                           <a:latin typeface="Calibri" pitchFamily="34" charset="0"/>
                           <a:ea typeface="Calibri" pitchFamily="34" charset="-122"/>
                           <a:cs typeface="Calibri" pitchFamily="34" charset="-120"/>
                         </a:rPr>
-                        <a:t>Lighter — top-of-list enrollment slowed</a:t>
+                        <a:t>23%</a:t>
                       </a:r>
-                      <a:endParaRPr lang="en-US" sz="1150" dirty="0">
+                      <a:endParaRPr lang="en-US" sz="1250" dirty="0">
                         <a:latin typeface="Calibri" charset="0"/>
                         <a:ea typeface="Calibri" charset="0"/>
                         <a:cs typeface="Calibri" charset="0"/>
@@ -22729,7 +22523,7 @@
                   </a:tcPr>
                 </a:tc>
               </a:tr>
-              <a:tr h="438912">
+              <a:tr h="384048">
                 <a:tc>
                   <a:txBody>
                     <a:bodyPr/>
@@ -22747,7 +22541,281 @@
                           <a:ea typeface="Calibri" pitchFamily="34" charset="-122"/>
                           <a:cs typeface="Calibri" pitchFamily="34" charset="-120"/>
                         </a:rPr>
-                        <a:t>Calls / dials</a:t>
+                        <a:t>Contacts Reached</a:t>
+                      </a:r>
+                      <a:endParaRPr lang="en-US" sz="1250" dirty="0">
+                        <a:latin typeface="Calibri" charset="0"/>
+                        <a:ea typeface="Calibri" charset="0"/>
+                        <a:cs typeface="Calibri" charset="0"/>
+                      </a:endParaRPr>
+                    </a:p>
+                  </a:txBody>
+                  <a:tcPr marL="91440" marR="91440" marT="45720" marB="45720">
+                    <a:lnL w="6350" cap="flat" cmpd="sng" algn="ctr">
+                      <a:solidFill>
+                        <a:srgbClr val="2A2E3B"/>
+                      </a:solidFill>
+                      <a:prstDash val="solid"/>
+                      <a:round/>
+                      <a:headEnd type="none" w="med" len="med"/>
+                      <a:tailEnd type="none" w="med" len="med"/>
+                    </a:lnL>
+                    <a:lnR w="6350" cap="flat" cmpd="sng" algn="ctr">
+                      <a:solidFill>
+                        <a:srgbClr val="2A2E3B"/>
+                      </a:solidFill>
+                      <a:prstDash val="solid"/>
+                      <a:round/>
+                      <a:headEnd type="none" w="med" len="med"/>
+                      <a:tailEnd type="none" w="med" len="med"/>
+                    </a:lnR>
+                    <a:lnT w="6350" cap="flat" cmpd="sng" algn="ctr">
+                      <a:solidFill>
+                        <a:srgbClr val="2A2E3B"/>
+                      </a:solidFill>
+                      <a:prstDash val="solid"/>
+                      <a:round/>
+                      <a:headEnd type="none" w="med" len="med"/>
+                      <a:tailEnd type="none" w="med" len="med"/>
+                    </a:lnT>
+                    <a:lnB w="6350" cap="flat" cmpd="sng" algn="ctr">
+                      <a:solidFill>
+                        <a:srgbClr val="2A2E3B"/>
+                      </a:solidFill>
+                      <a:prstDash val="solid"/>
+                      <a:round/>
+                      <a:headEnd type="none" w="med" len="med"/>
+                      <a:tailEnd type="none" w="med" len="med"/>
+                    </a:lnB>
+                    <a:solidFill>
+                      <a:srgbClr val="222632"/>
+                    </a:solidFill>
+                  </a:tcPr>
+                </a:tc>
+                <a:tc>
+                  <a:txBody>
+                    <a:bodyPr/>
+                    <a:lstStyle/>
+                    <a:p>
+                      <a:pPr algn="r" indent="0" marL="0">
+                        <a:buNone/>
+                      </a:pPr>
+                      <a:r>
+                        <a:rPr lang="en-US" sz="1250" b="1" dirty="0">
+                          <a:solidFill>
+                            <a:srgbClr val="E4E6ED"/>
+                          </a:solidFill>
+                          <a:latin typeface="Calibri" pitchFamily="34" charset="0"/>
+                          <a:ea typeface="Calibri" pitchFamily="34" charset="-122"/>
+                          <a:cs typeface="Calibri" pitchFamily="34" charset="-120"/>
+                        </a:rPr>
+                        <a:t>427</a:t>
+                      </a:r>
+                      <a:endParaRPr lang="en-US" sz="1250" dirty="0">
+                        <a:latin typeface="Calibri" charset="0"/>
+                        <a:ea typeface="Calibri" charset="0"/>
+                        <a:cs typeface="Calibri" charset="0"/>
+                      </a:endParaRPr>
+                    </a:p>
+                  </a:txBody>
+                  <a:tcPr marL="91440" marR="91440" marT="45720" marB="45720">
+                    <a:lnL w="6350" cap="flat" cmpd="sng" algn="ctr">
+                      <a:solidFill>
+                        <a:srgbClr val="2A2E3B"/>
+                      </a:solidFill>
+                      <a:prstDash val="solid"/>
+                      <a:round/>
+                      <a:headEnd type="none" w="med" len="med"/>
+                      <a:tailEnd type="none" w="med" len="med"/>
+                    </a:lnL>
+                    <a:lnR w="6350" cap="flat" cmpd="sng" algn="ctr">
+                      <a:solidFill>
+                        <a:srgbClr val="2A2E3B"/>
+                      </a:solidFill>
+                      <a:prstDash val="solid"/>
+                      <a:round/>
+                      <a:headEnd type="none" w="med" len="med"/>
+                      <a:tailEnd type="none" w="med" len="med"/>
+                    </a:lnR>
+                    <a:lnT w="6350" cap="flat" cmpd="sng" algn="ctr">
+                      <a:solidFill>
+                        <a:srgbClr val="2A2E3B"/>
+                      </a:solidFill>
+                      <a:prstDash val="solid"/>
+                      <a:round/>
+                      <a:headEnd type="none" w="med" len="med"/>
+                      <a:tailEnd type="none" w="med" len="med"/>
+                    </a:lnT>
+                    <a:lnB w="6350" cap="flat" cmpd="sng" algn="ctr">
+                      <a:solidFill>
+                        <a:srgbClr val="2A2E3B"/>
+                      </a:solidFill>
+                      <a:prstDash val="solid"/>
+                      <a:round/>
+                      <a:headEnd type="none" w="med" len="med"/>
+                      <a:tailEnd type="none" w="med" len="med"/>
+                    </a:lnB>
+                    <a:solidFill>
+                      <a:srgbClr val="222632"/>
+                    </a:solidFill>
+                  </a:tcPr>
+                </a:tc>
+                <a:tc>
+                  <a:txBody>
+                    <a:bodyPr/>
+                    <a:lstStyle/>
+                    <a:p>
+                      <a:pPr algn="r" indent="0" marL="0">
+                        <a:buNone/>
+                      </a:pPr>
+                      <a:r>
+                        <a:rPr lang="en-US" sz="1250" b="1" dirty="0">
+                          <a:solidFill>
+                            <a:srgbClr val="E17055"/>
+                          </a:solidFill>
+                          <a:latin typeface="Calibri" pitchFamily="34" charset="0"/>
+                          <a:ea typeface="Calibri" pitchFamily="34" charset="-122"/>
+                          <a:cs typeface="Calibri" pitchFamily="34" charset="-120"/>
+                        </a:rPr>
+                        <a:t>21%</a:t>
+                      </a:r>
+                      <a:endParaRPr lang="en-US" sz="1250" dirty="0">
+                        <a:latin typeface="Calibri" charset="0"/>
+                        <a:ea typeface="Calibri" charset="0"/>
+                        <a:cs typeface="Calibri" charset="0"/>
+                      </a:endParaRPr>
+                    </a:p>
+                  </a:txBody>
+                  <a:tcPr marL="91440" marR="91440" marT="45720" marB="45720">
+                    <a:lnL w="6350" cap="flat" cmpd="sng" algn="ctr">
+                      <a:solidFill>
+                        <a:srgbClr val="2A2E3B"/>
+                      </a:solidFill>
+                      <a:prstDash val="solid"/>
+                      <a:round/>
+                      <a:headEnd type="none" w="med" len="med"/>
+                      <a:tailEnd type="none" w="med" len="med"/>
+                    </a:lnL>
+                    <a:lnR w="6350" cap="flat" cmpd="sng" algn="ctr">
+                      <a:solidFill>
+                        <a:srgbClr val="2A2E3B"/>
+                      </a:solidFill>
+                      <a:prstDash val="solid"/>
+                      <a:round/>
+                      <a:headEnd type="none" w="med" len="med"/>
+                      <a:tailEnd type="none" w="med" len="med"/>
+                    </a:lnR>
+                    <a:lnT w="6350" cap="flat" cmpd="sng" algn="ctr">
+                      <a:solidFill>
+                        <a:srgbClr val="2A2E3B"/>
+                      </a:solidFill>
+                      <a:prstDash val="solid"/>
+                      <a:round/>
+                      <a:headEnd type="none" w="med" len="med"/>
+                      <a:tailEnd type="none" w="med" len="med"/>
+                    </a:lnT>
+                    <a:lnB w="6350" cap="flat" cmpd="sng" algn="ctr">
+                      <a:solidFill>
+                        <a:srgbClr val="2A2E3B"/>
+                      </a:solidFill>
+                      <a:prstDash val="solid"/>
+                      <a:round/>
+                      <a:headEnd type="none" w="med" len="med"/>
+                      <a:tailEnd type="none" w="med" len="med"/>
+                    </a:lnB>
+                    <a:solidFill>
+                      <a:srgbClr val="222632"/>
+                    </a:solidFill>
+                  </a:tcPr>
+                </a:tc>
+              </a:tr>
+              <a:tr h="384048">
+                <a:tc>
+                  <a:txBody>
+                    <a:bodyPr/>
+                    <a:lstStyle/>
+                    <a:p>
+                      <a:pPr indent="0" marL="0">
+                        <a:buNone/>
+                      </a:pPr>
+                      <a:r>
+                        <a:rPr lang="en-US" sz="1250" dirty="0">
+                          <a:solidFill>
+                            <a:srgbClr val="E4E6ED"/>
+                          </a:solidFill>
+                          <a:latin typeface="Calibri" pitchFamily="34" charset="0"/>
+                          <a:ea typeface="Calibri" pitchFamily="34" charset="-122"/>
+                          <a:cs typeface="Calibri" pitchFamily="34" charset="-120"/>
+                        </a:rPr>
+                        <a:t>Accounts Touched</a:t>
+                      </a:r>
+                      <a:endParaRPr lang="en-US" sz="1250" dirty="0">
+                        <a:latin typeface="Calibri" charset="0"/>
+                        <a:ea typeface="Calibri" charset="0"/>
+                        <a:cs typeface="Calibri" charset="0"/>
+                      </a:endParaRPr>
+                    </a:p>
+                  </a:txBody>
+                  <a:tcPr marL="91440" marR="91440" marT="45720" marB="45720">
+                    <a:lnL w="6350" cap="flat" cmpd="sng" algn="ctr">
+                      <a:solidFill>
+                        <a:srgbClr val="2A2E3B"/>
+                      </a:solidFill>
+                      <a:prstDash val="solid"/>
+                      <a:round/>
+                      <a:headEnd type="none" w="med" len="med"/>
+                      <a:tailEnd type="none" w="med" len="med"/>
+                    </a:lnL>
+                    <a:lnR w="6350" cap="flat" cmpd="sng" algn="ctr">
+                      <a:solidFill>
+                        <a:srgbClr val="2A2E3B"/>
+                      </a:solidFill>
+                      <a:prstDash val="solid"/>
+                      <a:round/>
+                      <a:headEnd type="none" w="med" len="med"/>
+                      <a:tailEnd type="none" w="med" len="med"/>
+                    </a:lnR>
+                    <a:lnT w="6350" cap="flat" cmpd="sng" algn="ctr">
+                      <a:solidFill>
+                        <a:srgbClr val="2A2E3B"/>
+                      </a:solidFill>
+                      <a:prstDash val="solid"/>
+                      <a:round/>
+                      <a:headEnd type="none" w="med" len="med"/>
+                      <a:tailEnd type="none" w="med" len="med"/>
+                    </a:lnT>
+                    <a:lnB w="6350" cap="flat" cmpd="sng" algn="ctr">
+                      <a:solidFill>
+                        <a:srgbClr val="2A2E3B"/>
+                      </a:solidFill>
+                      <a:prstDash val="solid"/>
+                      <a:round/>
+                      <a:headEnd type="none" w="med" len="med"/>
+                      <a:tailEnd type="none" w="med" len="med"/>
+                    </a:lnB>
+                    <a:solidFill>
+                      <a:srgbClr val="222632"/>
+                    </a:solidFill>
+                  </a:tcPr>
+                </a:tc>
+                <a:tc>
+                  <a:txBody>
+                    <a:bodyPr/>
+                    <a:lstStyle/>
+                    <a:p>
+                      <a:pPr algn="r" indent="0" marL="0">
+                        <a:buNone/>
+                      </a:pPr>
+                      <a:r>
+                        <a:rPr lang="en-US" sz="1250" b="1" dirty="0">
+                          <a:solidFill>
+                            <a:srgbClr val="E4E6ED"/>
+                          </a:solidFill>
+                          <a:latin typeface="Calibri" pitchFamily="34" charset="0"/>
+                          <a:ea typeface="Calibri" pitchFamily="34" charset="-122"/>
+                          <a:cs typeface="Calibri" pitchFamily="34" charset="-120"/>
+                        </a:rPr>
+                        <a:t>32</a:t>
                       </a:r>
                       <a:endParaRPr lang="en-US" sz="1250" dirty="0">
                         <a:latin typeface="Calibri" charset="0"/>
@@ -22815,77 +22883,9 @@
                           <a:ea typeface="Calibri" pitchFamily="34" charset="-122"/>
                           <a:cs typeface="Calibri" pitchFamily="34" charset="-120"/>
                         </a:rPr>
-                        <a:t>0</a:t>
+                        <a:t>40%</a:t>
                       </a:r>
                       <a:endParaRPr lang="en-US" sz="1250" dirty="0">
-                        <a:latin typeface="Calibri" charset="0"/>
-                        <a:ea typeface="Calibri" charset="0"/>
-                        <a:cs typeface="Calibri" charset="0"/>
-                      </a:endParaRPr>
-                    </a:p>
-                  </a:txBody>
-                  <a:tcPr marL="91440" marR="91440" marT="45720" marB="45720">
-                    <a:lnL w="6350" cap="flat" cmpd="sng" algn="ctr">
-                      <a:solidFill>
-                        <a:srgbClr val="2A2E3B"/>
-                      </a:solidFill>
-                      <a:prstDash val="solid"/>
-                      <a:round/>
-                      <a:headEnd type="none" w="med" len="med"/>
-                      <a:tailEnd type="none" w="med" len="med"/>
-                    </a:lnL>
-                    <a:lnR w="6350" cap="flat" cmpd="sng" algn="ctr">
-                      <a:solidFill>
-                        <a:srgbClr val="2A2E3B"/>
-                      </a:solidFill>
-                      <a:prstDash val="solid"/>
-                      <a:round/>
-                      <a:headEnd type="none" w="med" len="med"/>
-                      <a:tailEnd type="none" w="med" len="med"/>
-                    </a:lnR>
-                    <a:lnT w="6350" cap="flat" cmpd="sng" algn="ctr">
-                      <a:solidFill>
-                        <a:srgbClr val="2A2E3B"/>
-                      </a:solidFill>
-                      <a:prstDash val="solid"/>
-                      <a:round/>
-                      <a:headEnd type="none" w="med" len="med"/>
-                      <a:tailEnd type="none" w="med" len="med"/>
-                    </a:lnT>
-                    <a:lnB w="6350" cap="flat" cmpd="sng" algn="ctr">
-                      <a:solidFill>
-                        <a:srgbClr val="2A2E3B"/>
-                      </a:solidFill>
-                      <a:prstDash val="solid"/>
-                      <a:round/>
-                      <a:headEnd type="none" w="med" len="med"/>
-                      <a:tailEnd type="none" w="med" len="med"/>
-                    </a:lnB>
-                    <a:solidFill>
-                      <a:srgbClr val="222632"/>
-                    </a:solidFill>
-                  </a:tcPr>
-                </a:tc>
-                <a:tc>
-                  <a:txBody>
-                    <a:bodyPr/>
-                    <a:lstStyle/>
-                    <a:p>
-                      <a:pPr indent="0" marL="0">
-                        <a:buNone/>
-                      </a:pPr>
-                      <a:r>
-                        <a:rPr lang="en-US" sz="1150" dirty="0">
-                          <a:solidFill>
-                            <a:srgbClr val="8B8FA3"/>
-                          </a:solidFill>
-                          <a:latin typeface="Calibri" pitchFamily="34" charset="0"/>
-                          <a:ea typeface="Calibri" pitchFamily="34" charset="-122"/>
-                          <a:cs typeface="Calibri" pitchFamily="34" charset="-120"/>
-                        </a:rPr>
-                        <a:t>Cold dials deprioritized — intentional</a:t>
-                      </a:r>
-                      <a:endParaRPr lang="en-US" sz="1150" dirty="0">
                         <a:latin typeface="Calibri" charset="0"/>
                         <a:ea typeface="Calibri" charset="0"/>
                         <a:cs typeface="Calibri" charset="0"/>
@@ -22947,8 +22947,61 @@
         </p:nvSpPr>
         <p:spPr>
           <a:xfrm>
-            <a:off x="6400800" y="4160520"/>
-            <a:ext cx="5303520" cy="1600200"/>
+            <a:off x="6400800" y="3840480"/>
+            <a:ext cx="5303520" cy="320040"/>
+          </a:xfrm>
+          <a:prstGeom prst="rect">
+            <a:avLst/>
+          </a:prstGeom>
+          <a:noFill/>
+          <a:ln/>
+        </p:spPr>
+        <p:txBody>
+          <a:bodyPr wrap="square" rtlCol="0" anchor="ctr"/>
+          <a:lstStyle/>
+          <a:p>
+            <a:pPr indent="0" marL="0">
+              <a:buNone/>
+            </a:pPr>
+            <a:r>
+              <a:rPr lang="en-US" sz="1150" b="1" dirty="0">
+                <a:solidFill>
+                  <a:srgbClr val="E4E6ED"/>
+                </a:solidFill>
+                <a:latin typeface="Calibri" pitchFamily="34" charset="0"/>
+                <a:ea typeface="Calibri" pitchFamily="34" charset="-122"/>
+                <a:cs typeface="Calibri" pitchFamily="34" charset="-120"/>
+              </a:rPr>
+              <a:t>Reply rate 0.6% · 2 replies</a:t>
+            </a:r>
+            <a:pPr indent="0" marL="0">
+              <a:buNone/>
+            </a:pPr>
+            <a:r>
+              <a:rPr lang="en-US" sz="1050" dirty="0">
+                <a:solidFill>
+                  <a:srgbClr val="8B8FA3"/>
+                </a:solidFill>
+                <a:latin typeface="Calibri" pitchFamily="34" charset="0"/>
+                <a:ea typeface="Calibri" pitchFamily="34" charset="-122"/>
+                <a:cs typeface="Calibri" pitchFamily="34" charset="-120"/>
+              </a:rPr>
+              <a:t>   ·   Gold 3 (498 sent) · Bronze 17 (1,115) · Prospect 12 (975)</a:t>
+            </a:r>
+            <a:endParaRPr lang="en-US" sz="1150" dirty="0"/>
+          </a:p>
+        </p:txBody>
+      </p:sp>
+      <p:sp>
+        <p:nvSpPr>
+          <p:cNvPr id="13" name="Text 10"/>
+          <p:cNvSpPr/>
+          <p:nvPr/>
+        </p:nvSpPr>
+        <p:spPr>
+          <a:xfrm>
+            <a:off x="6400800" y="4251960"/>
+            <a:ext cx="5303520" cy="1143000"/>
           </a:xfrm>
           <a:prstGeom prst="rect">
             <a:avLst/>
@@ -22964,7 +23017,7 @@
               <a:buNone/>
             </a:pPr>
             <a:r>
-              <a:rPr lang="en-US" sz="1300" b="1" dirty="0">
+              <a:rPr lang="en-US" sz="1250" b="1" dirty="0">
                 <a:solidFill>
                   <a:srgbClr val="74B9FF"/>
                 </a:solidFill>
@@ -22978,7 +23031,7 @@
               <a:buNone/>
             </a:pPr>
             <a:r>
-              <a:rPr lang="en-US" sz="1300" dirty="0">
+              <a:rPr lang="en-US" sz="1250" dirty="0">
                 <a:solidFill>
                   <a:srgbClr val="E4E6ED"/>
                 </a:solidFill>
@@ -22986,15 +23039,15 @@
                 <a:ea typeface="Calibri" pitchFamily="34" charset="-122"/>
                 <a:cs typeface="Calibri" pitchFamily="34" charset="-120"/>
               </a:rPr>
-              <a:t>June ran on inbound demand + expansion — meetings healthy, cold outbound at zero by design. In the KAM motion that is the point: the KPI shifts from dials to account coverage, retention, and expansion pipeline.</a:t>
-            </a:r>
-            <a:endParaRPr lang="en-US" sz="1300" dirty="0"/>
+              <a:t>volume ran hot (155%) but low-yield — 21% reached, 0.6% reply, 2 replies — and skewed to Bronze/Prospect (Gold just 3 accounts). Calls were 0. The cadence ran on autopilot; the KAM pivot redirects effort to the Gold base.</a:t>
+            </a:r>
+            <a:endParaRPr lang="en-US" sz="1250" dirty="0"/>
           </a:p>
         </p:txBody>
       </p:sp>
       <p:sp>
         <p:nvSpPr>
-          <p:cNvPr id="13" name="Shape 10"/>
+          <p:cNvPr id="14" name="Shape 11"/>
           <p:cNvSpPr/>
           <p:nvPr/>
         </p:nvSpPr>
@@ -23021,7 +23074,7 @@
       </p:sp>
       <p:sp>
         <p:nvSpPr>
-          <p:cNvPr id="14" name="Text 11"/>
+          <p:cNvPr id="15" name="Text 12"/>
           <p:cNvSpPr/>
           <p:nvPr/>
         </p:nvSpPr>

</xml_diff>

<commit_message>
S9: compile HubSpot + Command Center outreach into a combined total
Combined outreach table with HubSpot | Cmd Ctr | Total columns:
Emails 394 + 3,093 = 3,487; Enrolled 90; Reached 427; Accounts Touched 32;
Replies 2. Reply rate 0.6%. HubSpot also 62 meetings / 0 calls; tier split
Gold 3 (498) / Bronze 17 (1,115) / Prospect 12 (975). HubSpot June email
count verified at 394.

Co-Authored-By: Claude Opus 4.8 <noreply@anthropic.com>
</commit_message>
<xml_diff>
--- a/June_2026_NAM_MBR.pptx
+++ b/June_2026_NAM_MBR.pptx
@@ -21872,7 +21872,7 @@
                 <a:ea typeface="Calibri" pitchFamily="34" charset="-122"/>
                 <a:cs typeface="Calibri" pitchFamily="34" charset="-120"/>
               </a:rPr>
-              <a:t>JUNE OUTREACH — COMMAND CENTER (email CMS)</a:t>
+              <a:t>JUNE OUTREACH — HubSpot + Command Center</a:t>
             </a:r>
             <a:endParaRPr lang="en-US" sz="1200" dirty="0"/>
           </a:p>
@@ -21893,7 +21893,7 @@
           </p:nvPr>
         </p:nvGraphicFramePr>
         <p:xfrm>
-          <a:off x="6400800" y="1783080"/>
+          <a:off x="6400800" y="1737360"/>
           <a:ext cx="5303520" cy="914400"/>
         </p:xfrm>
         <a:graphic>
@@ -21901,11 +21901,12 @@
             <a:tbl>
               <a:tblPr/>
               <a:tblGrid>
-                <a:gridCol w="2377440"/>
-                <a:gridCol w="1371600"/>
-                <a:gridCol w="1554480"/>
+                <a:gridCol w="1828800"/>
+                <a:gridCol w="1097280"/>
+                <a:gridCol w="1188720"/>
+                <a:gridCol w="1188720"/>
               </a:tblGrid>
-              <a:tr h="384048">
+              <a:tr h="310896">
                 <a:tc>
                   <a:txBody>
                     <a:bodyPr/>
@@ -21915,7 +21916,7 @@
                         <a:buNone/>
                       </a:pPr>
                       <a:r>
-                        <a:rPr lang="en-US" sz="1200" b="1" dirty="0">
+                        <a:rPr lang="en-US" sz="1100" b="1" dirty="0">
                           <a:solidFill>
                             <a:srgbClr val="8B8FA3"/>
                           </a:solidFill>
@@ -21925,7 +21926,7 @@
                         </a:rPr>
                         <a:t>Metric</a:t>
                       </a:r>
-                      <a:endParaRPr lang="en-US" sz="1200" dirty="0">
+                      <a:endParaRPr lang="en-US" sz="1100" dirty="0">
                         <a:latin typeface="Calibri" charset="0"/>
                         <a:ea typeface="Calibri" charset="0"/>
                         <a:cs typeface="Calibri" charset="0"/>
@@ -21983,7 +21984,7 @@
                         <a:buNone/>
                       </a:pPr>
                       <a:r>
-                        <a:rPr lang="en-US" sz="1200" b="1" dirty="0">
+                        <a:rPr lang="en-US" sz="1100" b="1" dirty="0">
                           <a:solidFill>
                             <a:srgbClr val="8B8FA3"/>
                           </a:solidFill>
@@ -21991,9 +21992,9 @@
                           <a:ea typeface="Calibri" pitchFamily="34" charset="-122"/>
                           <a:cs typeface="Calibri" pitchFamily="34" charset="-120"/>
                         </a:rPr>
-                        <a:t>June</a:t>
+                        <a:t>HubSpot</a:t>
                       </a:r>
-                      <a:endParaRPr lang="en-US" sz="1200" dirty="0">
+                      <a:endParaRPr lang="en-US" sz="1100" dirty="0">
                         <a:latin typeface="Calibri" charset="0"/>
                         <a:ea typeface="Calibri" charset="0"/>
                         <a:cs typeface="Calibri" charset="0"/>
@@ -22051,7 +22052,7 @@
                         <a:buNone/>
                       </a:pPr>
                       <a:r>
-                        <a:rPr lang="en-US" sz="1200" b="1" dirty="0">
+                        <a:rPr lang="en-US" sz="1100" b="1" dirty="0">
                           <a:solidFill>
                             <a:srgbClr val="8B8FA3"/>
                           </a:solidFill>
@@ -22059,9 +22060,9 @@
                           <a:ea typeface="Calibri" pitchFamily="34" charset="-122"/>
                           <a:cs typeface="Calibri" pitchFamily="34" charset="-120"/>
                         </a:rPr>
-                        <a:t>% Goal</a:t>
+                        <a:t>Cmd Ctr</a:t>
                       </a:r>
-                      <a:endParaRPr lang="en-US" sz="1200" dirty="0">
+                      <a:endParaRPr lang="en-US" sz="1100" dirty="0">
                         <a:latin typeface="Calibri" charset="0"/>
                         <a:ea typeface="Calibri" charset="0"/>
                         <a:cs typeface="Calibri" charset="0"/>
@@ -22110,8 +22111,76 @@
                     </a:solidFill>
                   </a:tcPr>
                 </a:tc>
+                <a:tc>
+                  <a:txBody>
+                    <a:bodyPr/>
+                    <a:lstStyle/>
+                    <a:p>
+                      <a:pPr algn="r" indent="0" marL="0">
+                        <a:buNone/>
+                      </a:pPr>
+                      <a:r>
+                        <a:rPr lang="en-US" sz="1100" b="1" dirty="0">
+                          <a:solidFill>
+                            <a:srgbClr val="8B8FA3"/>
+                          </a:solidFill>
+                          <a:latin typeface="Calibri" pitchFamily="34" charset="0"/>
+                          <a:ea typeface="Calibri" pitchFamily="34" charset="-122"/>
+                          <a:cs typeface="Calibri" pitchFamily="34" charset="-120"/>
+                        </a:rPr>
+                        <a:t>Total</a:t>
+                      </a:r>
+                      <a:endParaRPr lang="en-US" sz="1100" dirty="0">
+                        <a:latin typeface="Calibri" charset="0"/>
+                        <a:ea typeface="Calibri" charset="0"/>
+                        <a:cs typeface="Calibri" charset="0"/>
+                      </a:endParaRPr>
+                    </a:p>
+                  </a:txBody>
+                  <a:tcPr marL="91440" marR="91440" marT="45720" marB="45720">
+                    <a:lnL w="6350" cap="flat" cmpd="sng" algn="ctr">
+                      <a:solidFill>
+                        <a:srgbClr val="2A2E3B"/>
+                      </a:solidFill>
+                      <a:prstDash val="solid"/>
+                      <a:round/>
+                      <a:headEnd type="none" w="med" len="med"/>
+                      <a:tailEnd type="none" w="med" len="med"/>
+                    </a:lnL>
+                    <a:lnR w="6350" cap="flat" cmpd="sng" algn="ctr">
+                      <a:solidFill>
+                        <a:srgbClr val="2A2E3B"/>
+                      </a:solidFill>
+                      <a:prstDash val="solid"/>
+                      <a:round/>
+                      <a:headEnd type="none" w="med" len="med"/>
+                      <a:tailEnd type="none" w="med" len="med"/>
+                    </a:lnR>
+                    <a:lnT w="6350" cap="flat" cmpd="sng" algn="ctr">
+                      <a:solidFill>
+                        <a:srgbClr val="2A2E3B"/>
+                      </a:solidFill>
+                      <a:prstDash val="solid"/>
+                      <a:round/>
+                      <a:headEnd type="none" w="med" len="med"/>
+                      <a:tailEnd type="none" w="med" len="med"/>
+                    </a:lnT>
+                    <a:lnB w="6350" cap="flat" cmpd="sng" algn="ctr">
+                      <a:solidFill>
+                        <a:srgbClr val="2A2E3B"/>
+                      </a:solidFill>
+                      <a:prstDash val="solid"/>
+                      <a:round/>
+                      <a:headEnd type="none" w="med" len="med"/>
+                      <a:tailEnd type="none" w="med" len="med"/>
+                    </a:lnB>
+                    <a:solidFill>
+                      <a:srgbClr val="1A1D27"/>
+                    </a:solidFill>
+                  </a:tcPr>
+                </a:tc>
               </a:tr>
-              <a:tr h="384048">
+              <a:tr h="310896">
                 <a:tc>
                   <a:txBody>
                     <a:bodyPr/>
@@ -22121,7 +22190,7 @@
                         <a:buNone/>
                       </a:pPr>
                       <a:r>
-                        <a:rPr lang="en-US" sz="1250" dirty="0">
+                        <a:rPr lang="en-US" sz="1150" dirty="0">
                           <a:solidFill>
                             <a:srgbClr val="E4E6ED"/>
                           </a:solidFill>
@@ -22131,7 +22200,7 @@
                         </a:rPr>
                         <a:t>Emails Sent</a:t>
                       </a:r>
-                      <a:endParaRPr lang="en-US" sz="1250" dirty="0">
+                      <a:endParaRPr lang="en-US" sz="1150" dirty="0">
                         <a:latin typeface="Calibri" charset="0"/>
                         <a:ea typeface="Calibri" charset="0"/>
                         <a:cs typeface="Calibri" charset="0"/>
@@ -22189,17 +22258,17 @@
                         <a:buNone/>
                       </a:pPr>
                       <a:r>
-                        <a:rPr lang="en-US" sz="1250" b="1" dirty="0">
+                        <a:rPr lang="en-US" sz="1150" dirty="0">
                           <a:solidFill>
-                            <a:srgbClr val="E4E6ED"/>
+                            <a:srgbClr val="8B8FA3"/>
                           </a:solidFill>
                           <a:latin typeface="Calibri" pitchFamily="34" charset="0"/>
                           <a:ea typeface="Calibri" pitchFamily="34" charset="-122"/>
                           <a:cs typeface="Calibri" pitchFamily="34" charset="-120"/>
                         </a:rPr>
-                        <a:t>3,093</a:t>
+                        <a:t>394</a:t>
                       </a:r>
-                      <a:endParaRPr lang="en-US" sz="1250" dirty="0">
+                      <a:endParaRPr lang="en-US" sz="1150" dirty="0">
                         <a:latin typeface="Calibri" charset="0"/>
                         <a:ea typeface="Calibri" charset="0"/>
                         <a:cs typeface="Calibri" charset="0"/>
@@ -22257,87 +22326,17 @@
                         <a:buNone/>
                       </a:pPr>
                       <a:r>
-                        <a:rPr lang="en-US" sz="1250" b="1" dirty="0">
+                        <a:rPr lang="en-US" sz="1150" dirty="0">
                           <a:solidFill>
-                            <a:srgbClr val="00B894"/>
+                            <a:srgbClr val="8B8FA3"/>
                           </a:solidFill>
                           <a:latin typeface="Calibri" pitchFamily="34" charset="0"/>
                           <a:ea typeface="Calibri" pitchFamily="34" charset="-122"/>
                           <a:cs typeface="Calibri" pitchFamily="34" charset="-120"/>
                         </a:rPr>
-                        <a:t>155%</a:t>
+                        <a:t>3,093</a:t>
                       </a:r>
-                      <a:endParaRPr lang="en-US" sz="1250" dirty="0">
-                        <a:latin typeface="Calibri" charset="0"/>
-                        <a:ea typeface="Calibri" charset="0"/>
-                        <a:cs typeface="Calibri" charset="0"/>
-                      </a:endParaRPr>
-                    </a:p>
-                  </a:txBody>
-                  <a:tcPr marL="91440" marR="91440" marT="45720" marB="45720">
-                    <a:lnL w="6350" cap="flat" cmpd="sng" algn="ctr">
-                      <a:solidFill>
-                        <a:srgbClr val="2A2E3B"/>
-                      </a:solidFill>
-                      <a:prstDash val="solid"/>
-                      <a:round/>
-                      <a:headEnd type="none" w="med" len="med"/>
-                      <a:tailEnd type="none" w="med" len="med"/>
-                    </a:lnL>
-                    <a:lnR w="6350" cap="flat" cmpd="sng" algn="ctr">
-                      <a:solidFill>
-                        <a:srgbClr val="2A2E3B"/>
-                      </a:solidFill>
-                      <a:prstDash val="solid"/>
-                      <a:round/>
-                      <a:headEnd type="none" w="med" len="med"/>
-                      <a:tailEnd type="none" w="med" len="med"/>
-                    </a:lnR>
-                    <a:lnT w="6350" cap="flat" cmpd="sng" algn="ctr">
-                      <a:solidFill>
-                        <a:srgbClr val="2A2E3B"/>
-                      </a:solidFill>
-                      <a:prstDash val="solid"/>
-                      <a:round/>
-                      <a:headEnd type="none" w="med" len="med"/>
-                      <a:tailEnd type="none" w="med" len="med"/>
-                    </a:lnT>
-                    <a:lnB w="6350" cap="flat" cmpd="sng" algn="ctr">
-                      <a:solidFill>
-                        <a:srgbClr val="2A2E3B"/>
-                      </a:solidFill>
-                      <a:prstDash val="solid"/>
-                      <a:round/>
-                      <a:headEnd type="none" w="med" len="med"/>
-                      <a:tailEnd type="none" w="med" len="med"/>
-                    </a:lnB>
-                    <a:solidFill>
-                      <a:srgbClr val="222632"/>
-                    </a:solidFill>
-                  </a:tcPr>
-                </a:tc>
-              </a:tr>
-              <a:tr h="384048">
-                <a:tc>
-                  <a:txBody>
-                    <a:bodyPr/>
-                    <a:lstStyle/>
-                    <a:p>
-                      <a:pPr indent="0" marL="0">
-                        <a:buNone/>
-                      </a:pPr>
-                      <a:r>
-                        <a:rPr lang="en-US" sz="1250" dirty="0">
-                          <a:solidFill>
-                            <a:srgbClr val="E4E6ED"/>
-                          </a:solidFill>
-                          <a:latin typeface="Calibri" pitchFamily="34" charset="0"/>
-                          <a:ea typeface="Calibri" pitchFamily="34" charset="-122"/>
-                          <a:cs typeface="Calibri" pitchFamily="34" charset="-120"/>
-                        </a:rPr>
-                        <a:t>Contacts Enrolled</a:t>
-                      </a:r>
-                      <a:endParaRPr lang="en-US" sz="1250" dirty="0">
+                      <a:endParaRPr lang="en-US" sz="1150" dirty="0">
                         <a:latin typeface="Calibri" charset="0"/>
                         <a:ea typeface="Calibri" charset="0"/>
                         <a:cs typeface="Calibri" charset="0"/>
@@ -22395,7 +22394,77 @@
                         <a:buNone/>
                       </a:pPr>
                       <a:r>
-                        <a:rPr lang="en-US" sz="1250" b="1" dirty="0">
+                        <a:rPr lang="en-US" sz="1150" b="1" dirty="0">
+                          <a:solidFill>
+                            <a:srgbClr val="00B894"/>
+                          </a:solidFill>
+                          <a:latin typeface="Calibri" pitchFamily="34" charset="0"/>
+                          <a:ea typeface="Calibri" pitchFamily="34" charset="-122"/>
+                          <a:cs typeface="Calibri" pitchFamily="34" charset="-120"/>
+                        </a:rPr>
+                        <a:t>3,487</a:t>
+                      </a:r>
+                      <a:endParaRPr lang="en-US" sz="1150" dirty="0">
+                        <a:latin typeface="Calibri" charset="0"/>
+                        <a:ea typeface="Calibri" charset="0"/>
+                        <a:cs typeface="Calibri" charset="0"/>
+                      </a:endParaRPr>
+                    </a:p>
+                  </a:txBody>
+                  <a:tcPr marL="91440" marR="91440" marT="45720" marB="45720">
+                    <a:lnL w="6350" cap="flat" cmpd="sng" algn="ctr">
+                      <a:solidFill>
+                        <a:srgbClr val="2A2E3B"/>
+                      </a:solidFill>
+                      <a:prstDash val="solid"/>
+                      <a:round/>
+                      <a:headEnd type="none" w="med" len="med"/>
+                      <a:tailEnd type="none" w="med" len="med"/>
+                    </a:lnL>
+                    <a:lnR w="6350" cap="flat" cmpd="sng" algn="ctr">
+                      <a:solidFill>
+                        <a:srgbClr val="2A2E3B"/>
+                      </a:solidFill>
+                      <a:prstDash val="solid"/>
+                      <a:round/>
+                      <a:headEnd type="none" w="med" len="med"/>
+                      <a:tailEnd type="none" w="med" len="med"/>
+                    </a:lnR>
+                    <a:lnT w="6350" cap="flat" cmpd="sng" algn="ctr">
+                      <a:solidFill>
+                        <a:srgbClr val="2A2E3B"/>
+                      </a:solidFill>
+                      <a:prstDash val="solid"/>
+                      <a:round/>
+                      <a:headEnd type="none" w="med" len="med"/>
+                      <a:tailEnd type="none" w="med" len="med"/>
+                    </a:lnT>
+                    <a:lnB w="6350" cap="flat" cmpd="sng" algn="ctr">
+                      <a:solidFill>
+                        <a:srgbClr val="2A2E3B"/>
+                      </a:solidFill>
+                      <a:prstDash val="solid"/>
+                      <a:round/>
+                      <a:headEnd type="none" w="med" len="med"/>
+                      <a:tailEnd type="none" w="med" len="med"/>
+                    </a:lnB>
+                    <a:solidFill>
+                      <a:srgbClr val="222632"/>
+                    </a:solidFill>
+                  </a:tcPr>
+                </a:tc>
+              </a:tr>
+              <a:tr h="310896">
+                <a:tc>
+                  <a:txBody>
+                    <a:bodyPr/>
+                    <a:lstStyle/>
+                    <a:p>
+                      <a:pPr indent="0" marL="0">
+                        <a:buNone/>
+                      </a:pPr>
+                      <a:r>
+                        <a:rPr lang="en-US" sz="1150" dirty="0">
                           <a:solidFill>
                             <a:srgbClr val="E4E6ED"/>
                           </a:solidFill>
@@ -22403,9 +22472,9 @@
                           <a:ea typeface="Calibri" pitchFamily="34" charset="-122"/>
                           <a:cs typeface="Calibri" pitchFamily="34" charset="-120"/>
                         </a:rPr>
-                        <a:t>90</a:t>
+                        <a:t>Contacts Enrolled</a:t>
                       </a:r>
-                      <a:endParaRPr lang="en-US" sz="1250" dirty="0">
+                      <a:endParaRPr lang="en-US" sz="1150" dirty="0">
                         <a:latin typeface="Calibri" charset="0"/>
                         <a:ea typeface="Calibri" charset="0"/>
                         <a:cs typeface="Calibri" charset="0"/>
@@ -22463,87 +22532,17 @@
                         <a:buNone/>
                       </a:pPr>
                       <a:r>
-                        <a:rPr lang="en-US" sz="1250" b="1" dirty="0">
+                        <a:rPr lang="en-US" sz="1150" dirty="0">
                           <a:solidFill>
-                            <a:srgbClr val="FDCB6E"/>
+                            <a:srgbClr val="8B8FA3"/>
                           </a:solidFill>
                           <a:latin typeface="Calibri" pitchFamily="34" charset="0"/>
                           <a:ea typeface="Calibri" pitchFamily="34" charset="-122"/>
                           <a:cs typeface="Calibri" pitchFamily="34" charset="-120"/>
                         </a:rPr>
-                        <a:t>23%</a:t>
+                        <a:t>—</a:t>
                       </a:r>
-                      <a:endParaRPr lang="en-US" sz="1250" dirty="0">
-                        <a:latin typeface="Calibri" charset="0"/>
-                        <a:ea typeface="Calibri" charset="0"/>
-                        <a:cs typeface="Calibri" charset="0"/>
-                      </a:endParaRPr>
-                    </a:p>
-                  </a:txBody>
-                  <a:tcPr marL="91440" marR="91440" marT="45720" marB="45720">
-                    <a:lnL w="6350" cap="flat" cmpd="sng" algn="ctr">
-                      <a:solidFill>
-                        <a:srgbClr val="2A2E3B"/>
-                      </a:solidFill>
-                      <a:prstDash val="solid"/>
-                      <a:round/>
-                      <a:headEnd type="none" w="med" len="med"/>
-                      <a:tailEnd type="none" w="med" len="med"/>
-                    </a:lnL>
-                    <a:lnR w="6350" cap="flat" cmpd="sng" algn="ctr">
-                      <a:solidFill>
-                        <a:srgbClr val="2A2E3B"/>
-                      </a:solidFill>
-                      <a:prstDash val="solid"/>
-                      <a:round/>
-                      <a:headEnd type="none" w="med" len="med"/>
-                      <a:tailEnd type="none" w="med" len="med"/>
-                    </a:lnR>
-                    <a:lnT w="6350" cap="flat" cmpd="sng" algn="ctr">
-                      <a:solidFill>
-                        <a:srgbClr val="2A2E3B"/>
-                      </a:solidFill>
-                      <a:prstDash val="solid"/>
-                      <a:round/>
-                      <a:headEnd type="none" w="med" len="med"/>
-                      <a:tailEnd type="none" w="med" len="med"/>
-                    </a:lnT>
-                    <a:lnB w="6350" cap="flat" cmpd="sng" algn="ctr">
-                      <a:solidFill>
-                        <a:srgbClr val="2A2E3B"/>
-                      </a:solidFill>
-                      <a:prstDash val="solid"/>
-                      <a:round/>
-                      <a:headEnd type="none" w="med" len="med"/>
-                      <a:tailEnd type="none" w="med" len="med"/>
-                    </a:lnB>
-                    <a:solidFill>
-                      <a:srgbClr val="222632"/>
-                    </a:solidFill>
-                  </a:tcPr>
-                </a:tc>
-              </a:tr>
-              <a:tr h="384048">
-                <a:tc>
-                  <a:txBody>
-                    <a:bodyPr/>
-                    <a:lstStyle/>
-                    <a:p>
-                      <a:pPr indent="0" marL="0">
-                        <a:buNone/>
-                      </a:pPr>
-                      <a:r>
-                        <a:rPr lang="en-US" sz="1250" dirty="0">
-                          <a:solidFill>
-                            <a:srgbClr val="E4E6ED"/>
-                          </a:solidFill>
-                          <a:latin typeface="Calibri" pitchFamily="34" charset="0"/>
-                          <a:ea typeface="Calibri" pitchFamily="34" charset="-122"/>
-                          <a:cs typeface="Calibri" pitchFamily="34" charset="-120"/>
-                        </a:rPr>
-                        <a:t>Contacts Reached</a:t>
-                      </a:r>
-                      <a:endParaRPr lang="en-US" sz="1250" dirty="0">
+                      <a:endParaRPr lang="en-US" sz="1150" dirty="0">
                         <a:latin typeface="Calibri" charset="0"/>
                         <a:ea typeface="Calibri" charset="0"/>
                         <a:cs typeface="Calibri" charset="0"/>
@@ -22601,17 +22600,17 @@
                         <a:buNone/>
                       </a:pPr>
                       <a:r>
-                        <a:rPr lang="en-US" sz="1250" b="1" dirty="0">
+                        <a:rPr lang="en-US" sz="1150" dirty="0">
                           <a:solidFill>
-                            <a:srgbClr val="E4E6ED"/>
+                            <a:srgbClr val="8B8FA3"/>
                           </a:solidFill>
                           <a:latin typeface="Calibri" pitchFamily="34" charset="0"/>
                           <a:ea typeface="Calibri" pitchFamily="34" charset="-122"/>
                           <a:cs typeface="Calibri" pitchFamily="34" charset="-120"/>
                         </a:rPr>
-                        <a:t>427</a:t>
+                        <a:t>90</a:t>
                       </a:r>
-                      <a:endParaRPr lang="en-US" sz="1250" dirty="0">
+                      <a:endParaRPr lang="en-US" sz="1150" dirty="0">
                         <a:latin typeface="Calibri" charset="0"/>
                         <a:ea typeface="Calibri" charset="0"/>
                         <a:cs typeface="Calibri" charset="0"/>
@@ -22669,17 +22668,17 @@
                         <a:buNone/>
                       </a:pPr>
                       <a:r>
-                        <a:rPr lang="en-US" sz="1250" b="1" dirty="0">
+                        <a:rPr lang="en-US" sz="1150" b="1" dirty="0">
                           <a:solidFill>
-                            <a:srgbClr val="E17055"/>
+                            <a:srgbClr val="E4E6ED"/>
                           </a:solidFill>
                           <a:latin typeface="Calibri" pitchFamily="34" charset="0"/>
                           <a:ea typeface="Calibri" pitchFamily="34" charset="-122"/>
                           <a:cs typeface="Calibri" pitchFamily="34" charset="-120"/>
                         </a:rPr>
-                        <a:t>21%</a:t>
+                        <a:t>90</a:t>
                       </a:r>
-                      <a:endParaRPr lang="en-US" sz="1250" dirty="0">
+                      <a:endParaRPr lang="en-US" sz="1150" dirty="0">
                         <a:latin typeface="Calibri" charset="0"/>
                         <a:ea typeface="Calibri" charset="0"/>
                         <a:cs typeface="Calibri" charset="0"/>
@@ -22729,7 +22728,7 @@
                   </a:tcPr>
                 </a:tc>
               </a:tr>
-              <a:tr h="384048">
+              <a:tr h="310896">
                 <a:tc>
                   <a:txBody>
                     <a:bodyPr/>
@@ -22739,7 +22738,7 @@
                         <a:buNone/>
                       </a:pPr>
                       <a:r>
-                        <a:rPr lang="en-US" sz="1250" dirty="0">
+                        <a:rPr lang="en-US" sz="1150" dirty="0">
                           <a:solidFill>
                             <a:srgbClr val="E4E6ED"/>
                           </a:solidFill>
@@ -22747,9 +22746,9 @@
                           <a:ea typeface="Calibri" pitchFamily="34" charset="-122"/>
                           <a:cs typeface="Calibri" pitchFamily="34" charset="-120"/>
                         </a:rPr>
-                        <a:t>Accounts Touched</a:t>
+                        <a:t>Contacts Reached</a:t>
                       </a:r>
-                      <a:endParaRPr lang="en-US" sz="1250" dirty="0">
+                      <a:endParaRPr lang="en-US" sz="1150" dirty="0">
                         <a:latin typeface="Calibri" charset="0"/>
                         <a:ea typeface="Calibri" charset="0"/>
                         <a:cs typeface="Calibri" charset="0"/>
@@ -22807,17 +22806,17 @@
                         <a:buNone/>
                       </a:pPr>
                       <a:r>
-                        <a:rPr lang="en-US" sz="1250" b="1" dirty="0">
+                        <a:rPr lang="en-US" sz="1150" dirty="0">
                           <a:solidFill>
-                            <a:srgbClr val="E4E6ED"/>
+                            <a:srgbClr val="8B8FA3"/>
                           </a:solidFill>
                           <a:latin typeface="Calibri" pitchFamily="34" charset="0"/>
                           <a:ea typeface="Calibri" pitchFamily="34" charset="-122"/>
                           <a:cs typeface="Calibri" pitchFamily="34" charset="-120"/>
                         </a:rPr>
-                        <a:t>32</a:t>
+                        <a:t>—</a:t>
                       </a:r>
-                      <a:endParaRPr lang="en-US" sz="1250" dirty="0">
+                      <a:endParaRPr lang="en-US" sz="1150" dirty="0">
                         <a:latin typeface="Calibri" charset="0"/>
                         <a:ea typeface="Calibri" charset="0"/>
                         <a:cs typeface="Calibri" charset="0"/>
@@ -22875,17 +22874,633 @@
                         <a:buNone/>
                       </a:pPr>
                       <a:r>
-                        <a:rPr lang="en-US" sz="1250" b="1" dirty="0">
+                        <a:rPr lang="en-US" sz="1150" dirty="0">
                           <a:solidFill>
-                            <a:srgbClr val="FDCB6E"/>
+                            <a:srgbClr val="8B8FA3"/>
                           </a:solidFill>
                           <a:latin typeface="Calibri" pitchFamily="34" charset="0"/>
                           <a:ea typeface="Calibri" pitchFamily="34" charset="-122"/>
                           <a:cs typeface="Calibri" pitchFamily="34" charset="-120"/>
                         </a:rPr>
-                        <a:t>40%</a:t>
+                        <a:t>427</a:t>
                       </a:r>
-                      <a:endParaRPr lang="en-US" sz="1250" dirty="0">
+                      <a:endParaRPr lang="en-US" sz="1150" dirty="0">
+                        <a:latin typeface="Calibri" charset="0"/>
+                        <a:ea typeface="Calibri" charset="0"/>
+                        <a:cs typeface="Calibri" charset="0"/>
+                      </a:endParaRPr>
+                    </a:p>
+                  </a:txBody>
+                  <a:tcPr marL="91440" marR="91440" marT="45720" marB="45720">
+                    <a:lnL w="6350" cap="flat" cmpd="sng" algn="ctr">
+                      <a:solidFill>
+                        <a:srgbClr val="2A2E3B"/>
+                      </a:solidFill>
+                      <a:prstDash val="solid"/>
+                      <a:round/>
+                      <a:headEnd type="none" w="med" len="med"/>
+                      <a:tailEnd type="none" w="med" len="med"/>
+                    </a:lnL>
+                    <a:lnR w="6350" cap="flat" cmpd="sng" algn="ctr">
+                      <a:solidFill>
+                        <a:srgbClr val="2A2E3B"/>
+                      </a:solidFill>
+                      <a:prstDash val="solid"/>
+                      <a:round/>
+                      <a:headEnd type="none" w="med" len="med"/>
+                      <a:tailEnd type="none" w="med" len="med"/>
+                    </a:lnR>
+                    <a:lnT w="6350" cap="flat" cmpd="sng" algn="ctr">
+                      <a:solidFill>
+                        <a:srgbClr val="2A2E3B"/>
+                      </a:solidFill>
+                      <a:prstDash val="solid"/>
+                      <a:round/>
+                      <a:headEnd type="none" w="med" len="med"/>
+                      <a:tailEnd type="none" w="med" len="med"/>
+                    </a:lnT>
+                    <a:lnB w="6350" cap="flat" cmpd="sng" algn="ctr">
+                      <a:solidFill>
+                        <a:srgbClr val="2A2E3B"/>
+                      </a:solidFill>
+                      <a:prstDash val="solid"/>
+                      <a:round/>
+                      <a:headEnd type="none" w="med" len="med"/>
+                      <a:tailEnd type="none" w="med" len="med"/>
+                    </a:lnB>
+                    <a:solidFill>
+                      <a:srgbClr val="222632"/>
+                    </a:solidFill>
+                  </a:tcPr>
+                </a:tc>
+                <a:tc>
+                  <a:txBody>
+                    <a:bodyPr/>
+                    <a:lstStyle/>
+                    <a:p>
+                      <a:pPr algn="r" indent="0" marL="0">
+                        <a:buNone/>
+                      </a:pPr>
+                      <a:r>
+                        <a:rPr lang="en-US" sz="1150" b="1" dirty="0">
+                          <a:solidFill>
+                            <a:srgbClr val="E4E6ED"/>
+                          </a:solidFill>
+                          <a:latin typeface="Calibri" pitchFamily="34" charset="0"/>
+                          <a:ea typeface="Calibri" pitchFamily="34" charset="-122"/>
+                          <a:cs typeface="Calibri" pitchFamily="34" charset="-120"/>
+                        </a:rPr>
+                        <a:t>427</a:t>
+                      </a:r>
+                      <a:endParaRPr lang="en-US" sz="1150" dirty="0">
+                        <a:latin typeface="Calibri" charset="0"/>
+                        <a:ea typeface="Calibri" charset="0"/>
+                        <a:cs typeface="Calibri" charset="0"/>
+                      </a:endParaRPr>
+                    </a:p>
+                  </a:txBody>
+                  <a:tcPr marL="91440" marR="91440" marT="45720" marB="45720">
+                    <a:lnL w="6350" cap="flat" cmpd="sng" algn="ctr">
+                      <a:solidFill>
+                        <a:srgbClr val="2A2E3B"/>
+                      </a:solidFill>
+                      <a:prstDash val="solid"/>
+                      <a:round/>
+                      <a:headEnd type="none" w="med" len="med"/>
+                      <a:tailEnd type="none" w="med" len="med"/>
+                    </a:lnL>
+                    <a:lnR w="6350" cap="flat" cmpd="sng" algn="ctr">
+                      <a:solidFill>
+                        <a:srgbClr val="2A2E3B"/>
+                      </a:solidFill>
+                      <a:prstDash val="solid"/>
+                      <a:round/>
+                      <a:headEnd type="none" w="med" len="med"/>
+                      <a:tailEnd type="none" w="med" len="med"/>
+                    </a:lnR>
+                    <a:lnT w="6350" cap="flat" cmpd="sng" algn="ctr">
+                      <a:solidFill>
+                        <a:srgbClr val="2A2E3B"/>
+                      </a:solidFill>
+                      <a:prstDash val="solid"/>
+                      <a:round/>
+                      <a:headEnd type="none" w="med" len="med"/>
+                      <a:tailEnd type="none" w="med" len="med"/>
+                    </a:lnT>
+                    <a:lnB w="6350" cap="flat" cmpd="sng" algn="ctr">
+                      <a:solidFill>
+                        <a:srgbClr val="2A2E3B"/>
+                      </a:solidFill>
+                      <a:prstDash val="solid"/>
+                      <a:round/>
+                      <a:headEnd type="none" w="med" len="med"/>
+                      <a:tailEnd type="none" w="med" len="med"/>
+                    </a:lnB>
+                    <a:solidFill>
+                      <a:srgbClr val="222632"/>
+                    </a:solidFill>
+                  </a:tcPr>
+                </a:tc>
+              </a:tr>
+              <a:tr h="310896">
+                <a:tc>
+                  <a:txBody>
+                    <a:bodyPr/>
+                    <a:lstStyle/>
+                    <a:p>
+                      <a:pPr indent="0" marL="0">
+                        <a:buNone/>
+                      </a:pPr>
+                      <a:r>
+                        <a:rPr lang="en-US" sz="1150" dirty="0">
+                          <a:solidFill>
+                            <a:srgbClr val="E4E6ED"/>
+                          </a:solidFill>
+                          <a:latin typeface="Calibri" pitchFamily="34" charset="0"/>
+                          <a:ea typeface="Calibri" pitchFamily="34" charset="-122"/>
+                          <a:cs typeface="Calibri" pitchFamily="34" charset="-120"/>
+                        </a:rPr>
+                        <a:t>Accounts Touched</a:t>
+                      </a:r>
+                      <a:endParaRPr lang="en-US" sz="1150" dirty="0">
+                        <a:latin typeface="Calibri" charset="0"/>
+                        <a:ea typeface="Calibri" charset="0"/>
+                        <a:cs typeface="Calibri" charset="0"/>
+                      </a:endParaRPr>
+                    </a:p>
+                  </a:txBody>
+                  <a:tcPr marL="91440" marR="91440" marT="45720" marB="45720">
+                    <a:lnL w="6350" cap="flat" cmpd="sng" algn="ctr">
+                      <a:solidFill>
+                        <a:srgbClr val="2A2E3B"/>
+                      </a:solidFill>
+                      <a:prstDash val="solid"/>
+                      <a:round/>
+                      <a:headEnd type="none" w="med" len="med"/>
+                      <a:tailEnd type="none" w="med" len="med"/>
+                    </a:lnL>
+                    <a:lnR w="6350" cap="flat" cmpd="sng" algn="ctr">
+                      <a:solidFill>
+                        <a:srgbClr val="2A2E3B"/>
+                      </a:solidFill>
+                      <a:prstDash val="solid"/>
+                      <a:round/>
+                      <a:headEnd type="none" w="med" len="med"/>
+                      <a:tailEnd type="none" w="med" len="med"/>
+                    </a:lnR>
+                    <a:lnT w="6350" cap="flat" cmpd="sng" algn="ctr">
+                      <a:solidFill>
+                        <a:srgbClr val="2A2E3B"/>
+                      </a:solidFill>
+                      <a:prstDash val="solid"/>
+                      <a:round/>
+                      <a:headEnd type="none" w="med" len="med"/>
+                      <a:tailEnd type="none" w="med" len="med"/>
+                    </a:lnT>
+                    <a:lnB w="6350" cap="flat" cmpd="sng" algn="ctr">
+                      <a:solidFill>
+                        <a:srgbClr val="2A2E3B"/>
+                      </a:solidFill>
+                      <a:prstDash val="solid"/>
+                      <a:round/>
+                      <a:headEnd type="none" w="med" len="med"/>
+                      <a:tailEnd type="none" w="med" len="med"/>
+                    </a:lnB>
+                    <a:solidFill>
+                      <a:srgbClr val="222632"/>
+                    </a:solidFill>
+                  </a:tcPr>
+                </a:tc>
+                <a:tc>
+                  <a:txBody>
+                    <a:bodyPr/>
+                    <a:lstStyle/>
+                    <a:p>
+                      <a:pPr algn="r" indent="0" marL="0">
+                        <a:buNone/>
+                      </a:pPr>
+                      <a:r>
+                        <a:rPr lang="en-US" sz="1150" dirty="0">
+                          <a:solidFill>
+                            <a:srgbClr val="8B8FA3"/>
+                          </a:solidFill>
+                          <a:latin typeface="Calibri" pitchFamily="34" charset="0"/>
+                          <a:ea typeface="Calibri" pitchFamily="34" charset="-122"/>
+                          <a:cs typeface="Calibri" pitchFamily="34" charset="-120"/>
+                        </a:rPr>
+                        <a:t>—</a:t>
+                      </a:r>
+                      <a:endParaRPr lang="en-US" sz="1150" dirty="0">
+                        <a:latin typeface="Calibri" charset="0"/>
+                        <a:ea typeface="Calibri" charset="0"/>
+                        <a:cs typeface="Calibri" charset="0"/>
+                      </a:endParaRPr>
+                    </a:p>
+                  </a:txBody>
+                  <a:tcPr marL="91440" marR="91440" marT="45720" marB="45720">
+                    <a:lnL w="6350" cap="flat" cmpd="sng" algn="ctr">
+                      <a:solidFill>
+                        <a:srgbClr val="2A2E3B"/>
+                      </a:solidFill>
+                      <a:prstDash val="solid"/>
+                      <a:round/>
+                      <a:headEnd type="none" w="med" len="med"/>
+                      <a:tailEnd type="none" w="med" len="med"/>
+                    </a:lnL>
+                    <a:lnR w="6350" cap="flat" cmpd="sng" algn="ctr">
+                      <a:solidFill>
+                        <a:srgbClr val="2A2E3B"/>
+                      </a:solidFill>
+                      <a:prstDash val="solid"/>
+                      <a:round/>
+                      <a:headEnd type="none" w="med" len="med"/>
+                      <a:tailEnd type="none" w="med" len="med"/>
+                    </a:lnR>
+                    <a:lnT w="6350" cap="flat" cmpd="sng" algn="ctr">
+                      <a:solidFill>
+                        <a:srgbClr val="2A2E3B"/>
+                      </a:solidFill>
+                      <a:prstDash val="solid"/>
+                      <a:round/>
+                      <a:headEnd type="none" w="med" len="med"/>
+                      <a:tailEnd type="none" w="med" len="med"/>
+                    </a:lnT>
+                    <a:lnB w="6350" cap="flat" cmpd="sng" algn="ctr">
+                      <a:solidFill>
+                        <a:srgbClr val="2A2E3B"/>
+                      </a:solidFill>
+                      <a:prstDash val="solid"/>
+                      <a:round/>
+                      <a:headEnd type="none" w="med" len="med"/>
+                      <a:tailEnd type="none" w="med" len="med"/>
+                    </a:lnB>
+                    <a:solidFill>
+                      <a:srgbClr val="222632"/>
+                    </a:solidFill>
+                  </a:tcPr>
+                </a:tc>
+                <a:tc>
+                  <a:txBody>
+                    <a:bodyPr/>
+                    <a:lstStyle/>
+                    <a:p>
+                      <a:pPr algn="r" indent="0" marL="0">
+                        <a:buNone/>
+                      </a:pPr>
+                      <a:r>
+                        <a:rPr lang="en-US" sz="1150" dirty="0">
+                          <a:solidFill>
+                            <a:srgbClr val="8B8FA3"/>
+                          </a:solidFill>
+                          <a:latin typeface="Calibri" pitchFamily="34" charset="0"/>
+                          <a:ea typeface="Calibri" pitchFamily="34" charset="-122"/>
+                          <a:cs typeface="Calibri" pitchFamily="34" charset="-120"/>
+                        </a:rPr>
+                        <a:t>32</a:t>
+                      </a:r>
+                      <a:endParaRPr lang="en-US" sz="1150" dirty="0">
+                        <a:latin typeface="Calibri" charset="0"/>
+                        <a:ea typeface="Calibri" charset="0"/>
+                        <a:cs typeface="Calibri" charset="0"/>
+                      </a:endParaRPr>
+                    </a:p>
+                  </a:txBody>
+                  <a:tcPr marL="91440" marR="91440" marT="45720" marB="45720">
+                    <a:lnL w="6350" cap="flat" cmpd="sng" algn="ctr">
+                      <a:solidFill>
+                        <a:srgbClr val="2A2E3B"/>
+                      </a:solidFill>
+                      <a:prstDash val="solid"/>
+                      <a:round/>
+                      <a:headEnd type="none" w="med" len="med"/>
+                      <a:tailEnd type="none" w="med" len="med"/>
+                    </a:lnL>
+                    <a:lnR w="6350" cap="flat" cmpd="sng" algn="ctr">
+                      <a:solidFill>
+                        <a:srgbClr val="2A2E3B"/>
+                      </a:solidFill>
+                      <a:prstDash val="solid"/>
+                      <a:round/>
+                      <a:headEnd type="none" w="med" len="med"/>
+                      <a:tailEnd type="none" w="med" len="med"/>
+                    </a:lnR>
+                    <a:lnT w="6350" cap="flat" cmpd="sng" algn="ctr">
+                      <a:solidFill>
+                        <a:srgbClr val="2A2E3B"/>
+                      </a:solidFill>
+                      <a:prstDash val="solid"/>
+                      <a:round/>
+                      <a:headEnd type="none" w="med" len="med"/>
+                      <a:tailEnd type="none" w="med" len="med"/>
+                    </a:lnT>
+                    <a:lnB w="6350" cap="flat" cmpd="sng" algn="ctr">
+                      <a:solidFill>
+                        <a:srgbClr val="2A2E3B"/>
+                      </a:solidFill>
+                      <a:prstDash val="solid"/>
+                      <a:round/>
+                      <a:headEnd type="none" w="med" len="med"/>
+                      <a:tailEnd type="none" w="med" len="med"/>
+                    </a:lnB>
+                    <a:solidFill>
+                      <a:srgbClr val="222632"/>
+                    </a:solidFill>
+                  </a:tcPr>
+                </a:tc>
+                <a:tc>
+                  <a:txBody>
+                    <a:bodyPr/>
+                    <a:lstStyle/>
+                    <a:p>
+                      <a:pPr algn="r" indent="0" marL="0">
+                        <a:buNone/>
+                      </a:pPr>
+                      <a:r>
+                        <a:rPr lang="en-US" sz="1150" b="1" dirty="0">
+                          <a:solidFill>
+                            <a:srgbClr val="E4E6ED"/>
+                          </a:solidFill>
+                          <a:latin typeface="Calibri" pitchFamily="34" charset="0"/>
+                          <a:ea typeface="Calibri" pitchFamily="34" charset="-122"/>
+                          <a:cs typeface="Calibri" pitchFamily="34" charset="-120"/>
+                        </a:rPr>
+                        <a:t>32</a:t>
+                      </a:r>
+                      <a:endParaRPr lang="en-US" sz="1150" dirty="0">
+                        <a:latin typeface="Calibri" charset="0"/>
+                        <a:ea typeface="Calibri" charset="0"/>
+                        <a:cs typeface="Calibri" charset="0"/>
+                      </a:endParaRPr>
+                    </a:p>
+                  </a:txBody>
+                  <a:tcPr marL="91440" marR="91440" marT="45720" marB="45720">
+                    <a:lnL w="6350" cap="flat" cmpd="sng" algn="ctr">
+                      <a:solidFill>
+                        <a:srgbClr val="2A2E3B"/>
+                      </a:solidFill>
+                      <a:prstDash val="solid"/>
+                      <a:round/>
+                      <a:headEnd type="none" w="med" len="med"/>
+                      <a:tailEnd type="none" w="med" len="med"/>
+                    </a:lnL>
+                    <a:lnR w="6350" cap="flat" cmpd="sng" algn="ctr">
+                      <a:solidFill>
+                        <a:srgbClr val="2A2E3B"/>
+                      </a:solidFill>
+                      <a:prstDash val="solid"/>
+                      <a:round/>
+                      <a:headEnd type="none" w="med" len="med"/>
+                      <a:tailEnd type="none" w="med" len="med"/>
+                    </a:lnR>
+                    <a:lnT w="6350" cap="flat" cmpd="sng" algn="ctr">
+                      <a:solidFill>
+                        <a:srgbClr val="2A2E3B"/>
+                      </a:solidFill>
+                      <a:prstDash val="solid"/>
+                      <a:round/>
+                      <a:headEnd type="none" w="med" len="med"/>
+                      <a:tailEnd type="none" w="med" len="med"/>
+                    </a:lnT>
+                    <a:lnB w="6350" cap="flat" cmpd="sng" algn="ctr">
+                      <a:solidFill>
+                        <a:srgbClr val="2A2E3B"/>
+                      </a:solidFill>
+                      <a:prstDash val="solid"/>
+                      <a:round/>
+                      <a:headEnd type="none" w="med" len="med"/>
+                      <a:tailEnd type="none" w="med" len="med"/>
+                    </a:lnB>
+                    <a:solidFill>
+                      <a:srgbClr val="222632"/>
+                    </a:solidFill>
+                  </a:tcPr>
+                </a:tc>
+              </a:tr>
+              <a:tr h="310896">
+                <a:tc>
+                  <a:txBody>
+                    <a:bodyPr/>
+                    <a:lstStyle/>
+                    <a:p>
+                      <a:pPr indent="0" marL="0">
+                        <a:buNone/>
+                      </a:pPr>
+                      <a:r>
+                        <a:rPr lang="en-US" sz="1150" dirty="0">
+                          <a:solidFill>
+                            <a:srgbClr val="E4E6ED"/>
+                          </a:solidFill>
+                          <a:latin typeface="Calibri" pitchFamily="34" charset="0"/>
+                          <a:ea typeface="Calibri" pitchFamily="34" charset="-122"/>
+                          <a:cs typeface="Calibri" pitchFamily="34" charset="-120"/>
+                        </a:rPr>
+                        <a:t>Replies</a:t>
+                      </a:r>
+                      <a:endParaRPr lang="en-US" sz="1150" dirty="0">
+                        <a:latin typeface="Calibri" charset="0"/>
+                        <a:ea typeface="Calibri" charset="0"/>
+                        <a:cs typeface="Calibri" charset="0"/>
+                      </a:endParaRPr>
+                    </a:p>
+                  </a:txBody>
+                  <a:tcPr marL="91440" marR="91440" marT="45720" marB="45720">
+                    <a:lnL w="6350" cap="flat" cmpd="sng" algn="ctr">
+                      <a:solidFill>
+                        <a:srgbClr val="2A2E3B"/>
+                      </a:solidFill>
+                      <a:prstDash val="solid"/>
+                      <a:round/>
+                      <a:headEnd type="none" w="med" len="med"/>
+                      <a:tailEnd type="none" w="med" len="med"/>
+                    </a:lnL>
+                    <a:lnR w="6350" cap="flat" cmpd="sng" algn="ctr">
+                      <a:solidFill>
+                        <a:srgbClr val="2A2E3B"/>
+                      </a:solidFill>
+                      <a:prstDash val="solid"/>
+                      <a:round/>
+                      <a:headEnd type="none" w="med" len="med"/>
+                      <a:tailEnd type="none" w="med" len="med"/>
+                    </a:lnR>
+                    <a:lnT w="6350" cap="flat" cmpd="sng" algn="ctr">
+                      <a:solidFill>
+                        <a:srgbClr val="2A2E3B"/>
+                      </a:solidFill>
+                      <a:prstDash val="solid"/>
+                      <a:round/>
+                      <a:headEnd type="none" w="med" len="med"/>
+                      <a:tailEnd type="none" w="med" len="med"/>
+                    </a:lnT>
+                    <a:lnB w="6350" cap="flat" cmpd="sng" algn="ctr">
+                      <a:solidFill>
+                        <a:srgbClr val="2A2E3B"/>
+                      </a:solidFill>
+                      <a:prstDash val="solid"/>
+                      <a:round/>
+                      <a:headEnd type="none" w="med" len="med"/>
+                      <a:tailEnd type="none" w="med" len="med"/>
+                    </a:lnB>
+                    <a:solidFill>
+                      <a:srgbClr val="222632"/>
+                    </a:solidFill>
+                  </a:tcPr>
+                </a:tc>
+                <a:tc>
+                  <a:txBody>
+                    <a:bodyPr/>
+                    <a:lstStyle/>
+                    <a:p>
+                      <a:pPr algn="r" indent="0" marL="0">
+                        <a:buNone/>
+                      </a:pPr>
+                      <a:r>
+                        <a:rPr lang="en-US" sz="1150" dirty="0">
+                          <a:solidFill>
+                            <a:srgbClr val="8B8FA3"/>
+                          </a:solidFill>
+                          <a:latin typeface="Calibri" pitchFamily="34" charset="0"/>
+                          <a:ea typeface="Calibri" pitchFamily="34" charset="-122"/>
+                          <a:cs typeface="Calibri" pitchFamily="34" charset="-120"/>
+                        </a:rPr>
+                        <a:t>—</a:t>
+                      </a:r>
+                      <a:endParaRPr lang="en-US" sz="1150" dirty="0">
+                        <a:latin typeface="Calibri" charset="0"/>
+                        <a:ea typeface="Calibri" charset="0"/>
+                        <a:cs typeface="Calibri" charset="0"/>
+                      </a:endParaRPr>
+                    </a:p>
+                  </a:txBody>
+                  <a:tcPr marL="91440" marR="91440" marT="45720" marB="45720">
+                    <a:lnL w="6350" cap="flat" cmpd="sng" algn="ctr">
+                      <a:solidFill>
+                        <a:srgbClr val="2A2E3B"/>
+                      </a:solidFill>
+                      <a:prstDash val="solid"/>
+                      <a:round/>
+                      <a:headEnd type="none" w="med" len="med"/>
+                      <a:tailEnd type="none" w="med" len="med"/>
+                    </a:lnL>
+                    <a:lnR w="6350" cap="flat" cmpd="sng" algn="ctr">
+                      <a:solidFill>
+                        <a:srgbClr val="2A2E3B"/>
+                      </a:solidFill>
+                      <a:prstDash val="solid"/>
+                      <a:round/>
+                      <a:headEnd type="none" w="med" len="med"/>
+                      <a:tailEnd type="none" w="med" len="med"/>
+                    </a:lnR>
+                    <a:lnT w="6350" cap="flat" cmpd="sng" algn="ctr">
+                      <a:solidFill>
+                        <a:srgbClr val="2A2E3B"/>
+                      </a:solidFill>
+                      <a:prstDash val="solid"/>
+                      <a:round/>
+                      <a:headEnd type="none" w="med" len="med"/>
+                      <a:tailEnd type="none" w="med" len="med"/>
+                    </a:lnT>
+                    <a:lnB w="6350" cap="flat" cmpd="sng" algn="ctr">
+                      <a:solidFill>
+                        <a:srgbClr val="2A2E3B"/>
+                      </a:solidFill>
+                      <a:prstDash val="solid"/>
+                      <a:round/>
+                      <a:headEnd type="none" w="med" len="med"/>
+                      <a:tailEnd type="none" w="med" len="med"/>
+                    </a:lnB>
+                    <a:solidFill>
+                      <a:srgbClr val="222632"/>
+                    </a:solidFill>
+                  </a:tcPr>
+                </a:tc>
+                <a:tc>
+                  <a:txBody>
+                    <a:bodyPr/>
+                    <a:lstStyle/>
+                    <a:p>
+                      <a:pPr algn="r" indent="0" marL="0">
+                        <a:buNone/>
+                      </a:pPr>
+                      <a:r>
+                        <a:rPr lang="en-US" sz="1150" dirty="0">
+                          <a:solidFill>
+                            <a:srgbClr val="8B8FA3"/>
+                          </a:solidFill>
+                          <a:latin typeface="Calibri" pitchFamily="34" charset="0"/>
+                          <a:ea typeface="Calibri" pitchFamily="34" charset="-122"/>
+                          <a:cs typeface="Calibri" pitchFamily="34" charset="-120"/>
+                        </a:rPr>
+                        <a:t>2</a:t>
+                      </a:r>
+                      <a:endParaRPr lang="en-US" sz="1150" dirty="0">
+                        <a:latin typeface="Calibri" charset="0"/>
+                        <a:ea typeface="Calibri" charset="0"/>
+                        <a:cs typeface="Calibri" charset="0"/>
+                      </a:endParaRPr>
+                    </a:p>
+                  </a:txBody>
+                  <a:tcPr marL="91440" marR="91440" marT="45720" marB="45720">
+                    <a:lnL w="6350" cap="flat" cmpd="sng" algn="ctr">
+                      <a:solidFill>
+                        <a:srgbClr val="2A2E3B"/>
+                      </a:solidFill>
+                      <a:prstDash val="solid"/>
+                      <a:round/>
+                      <a:headEnd type="none" w="med" len="med"/>
+                      <a:tailEnd type="none" w="med" len="med"/>
+                    </a:lnL>
+                    <a:lnR w="6350" cap="flat" cmpd="sng" algn="ctr">
+                      <a:solidFill>
+                        <a:srgbClr val="2A2E3B"/>
+                      </a:solidFill>
+                      <a:prstDash val="solid"/>
+                      <a:round/>
+                      <a:headEnd type="none" w="med" len="med"/>
+                      <a:tailEnd type="none" w="med" len="med"/>
+                    </a:lnR>
+                    <a:lnT w="6350" cap="flat" cmpd="sng" algn="ctr">
+                      <a:solidFill>
+                        <a:srgbClr val="2A2E3B"/>
+                      </a:solidFill>
+                      <a:prstDash val="solid"/>
+                      <a:round/>
+                      <a:headEnd type="none" w="med" len="med"/>
+                      <a:tailEnd type="none" w="med" len="med"/>
+                    </a:lnT>
+                    <a:lnB w="6350" cap="flat" cmpd="sng" algn="ctr">
+                      <a:solidFill>
+                        <a:srgbClr val="2A2E3B"/>
+                      </a:solidFill>
+                      <a:prstDash val="solid"/>
+                      <a:round/>
+                      <a:headEnd type="none" w="med" len="med"/>
+                      <a:tailEnd type="none" w="med" len="med"/>
+                    </a:lnB>
+                    <a:solidFill>
+                      <a:srgbClr val="222632"/>
+                    </a:solidFill>
+                  </a:tcPr>
+                </a:tc>
+                <a:tc>
+                  <a:txBody>
+                    <a:bodyPr/>
+                    <a:lstStyle/>
+                    <a:p>
+                      <a:pPr algn="r" indent="0" marL="0">
+                        <a:buNone/>
+                      </a:pPr>
+                      <a:r>
+                        <a:rPr lang="en-US" sz="1150" b="1" dirty="0">
+                          <a:solidFill>
+                            <a:srgbClr val="E4E6ED"/>
+                          </a:solidFill>
+                          <a:latin typeface="Calibri" pitchFamily="34" charset="0"/>
+                          <a:ea typeface="Calibri" pitchFamily="34" charset="-122"/>
+                          <a:cs typeface="Calibri" pitchFamily="34" charset="-120"/>
+                        </a:rPr>
+                        <a:t>2</a:t>
+                      </a:r>
+                      <a:endParaRPr lang="en-US" sz="1150" dirty="0">
                         <a:latin typeface="Calibri" charset="0"/>
                         <a:ea typeface="Calibri" charset="0"/>
                         <a:cs typeface="Calibri" charset="0"/>
@@ -22947,8 +23562,8 @@
         </p:nvSpPr>
         <p:spPr>
           <a:xfrm>
-            <a:off x="6400800" y="3840480"/>
-            <a:ext cx="5303520" cy="320040"/>
+            <a:off x="6400800" y="3675888"/>
+            <a:ext cx="5303520" cy="457200"/>
           </a:xfrm>
           <a:prstGeom prst="rect">
             <a:avLst/>
@@ -22964,7 +23579,7 @@
               <a:buNone/>
             </a:pPr>
             <a:r>
-              <a:rPr lang="en-US" sz="1150" b="1" dirty="0">
+              <a:rPr lang="en-US" sz="1100" b="1" dirty="0">
                 <a:solidFill>
                   <a:srgbClr val="E4E6ED"/>
                 </a:solidFill>
@@ -22972,13 +23587,13 @@
                 <a:ea typeface="Calibri" pitchFamily="34" charset="-122"/>
                 <a:cs typeface="Calibri" pitchFamily="34" charset="-120"/>
               </a:rPr>
-              <a:t>Reply rate 0.6% · 2 replies</a:t>
-            </a:r>
-            <a:pPr indent="0" marL="0">
-              <a:buNone/>
-            </a:pPr>
-            <a:r>
-              <a:rPr lang="en-US" sz="1050" dirty="0">
+              <a:t>Reply rate 0.6%</a:t>
+            </a:r>
+            <a:pPr indent="0" marL="0">
+              <a:buNone/>
+            </a:pPr>
+            <a:r>
+              <a:rPr lang="en-US" sz="1000" dirty="0">
                 <a:solidFill>
                   <a:srgbClr val="8B8FA3"/>
                 </a:solidFill>
@@ -22986,9 +23601,9 @@
                 <a:ea typeface="Calibri" pitchFamily="34" charset="-122"/>
                 <a:cs typeface="Calibri" pitchFamily="34" charset="-120"/>
               </a:rPr>
-              <a:t>   ·   Gold 3 (498 sent) · Bronze 17 (1,115) · Prospect 12 (975)</a:t>
-            </a:r>
-            <a:endParaRPr lang="en-US" sz="1150" dirty="0"/>
+              <a:t>  ·  HubSpot also: 62 meetings, 0 calls  ·  Tiers: Gold 3 (498) · Bronze 17 (1,115) · Prospect 12 (975)</a:t>
+            </a:r>
+            <a:endParaRPr lang="en-US" sz="1100" dirty="0"/>
           </a:p>
         </p:txBody>
       </p:sp>
@@ -23000,7 +23615,7 @@
         </p:nvSpPr>
         <p:spPr>
           <a:xfrm>
-            <a:off x="6400800" y="4251960"/>
+            <a:off x="6400800" y="4224528"/>
             <a:ext cx="5303520" cy="1143000"/>
           </a:xfrm>
           <a:prstGeom prst="rect">
@@ -23017,7 +23632,7 @@
               <a:buNone/>
             </a:pPr>
             <a:r>
-              <a:rPr lang="en-US" sz="1250" b="1" dirty="0">
+              <a:rPr lang="en-US" sz="1200" b="1" dirty="0">
                 <a:solidFill>
                   <a:srgbClr val="74B9FF"/>
                 </a:solidFill>
@@ -23031,7 +23646,7 @@
               <a:buNone/>
             </a:pPr>
             <a:r>
-              <a:rPr lang="en-US" sz="1250" dirty="0">
+              <a:rPr lang="en-US" sz="1200" dirty="0">
                 <a:solidFill>
                   <a:srgbClr val="E4E6ED"/>
                 </a:solidFill>
@@ -23039,9 +23654,9 @@
                 <a:ea typeface="Calibri" pitchFamily="34" charset="-122"/>
                 <a:cs typeface="Calibri" pitchFamily="34" charset="-120"/>
               </a:rPr>
-              <a:t>volume ran hot (155%) but low-yield — 21% reached, 0.6% reply, 2 replies — and skewed to Bronze/Prospect (Gold just 3 accounts). Calls were 0. The cadence ran on autopilot; the KAM pivot redirects effort to the Gold base.</a:t>
-            </a:r>
-            <a:endParaRPr lang="en-US" sz="1250" dirty="0"/>
+              <a:t>3,487 total emails but low-yield — 427 reached, 0.6% reply, 2 replies — skewed to Bronze/Prospect (Gold just 3 accts). Cadence on autopilot; the KAM pivot redirects effort to the Gold base.</a:t>
+            </a:r>
+            <a:endParaRPr lang="en-US" sz="1200" dirty="0"/>
           </a:p>
         </p:txBody>
       </p:sp>

</xml_diff>

<commit_message>
S9: add warm (HubSpot 1:1) vs cold (CMS) reply-rate split
HubSpot June email direction = 313 outgoing / 93 incoming -> warm 1:1 reply
rate ~30%, vs cold cadence 0.6% (2 replies). ~50x gap, reinforcing the KAM
pivot to warm Gold relationships. Cold sends shown by tier (Gold 3 / Bronze 17
/ Prospect 12). Combined email total still 3,487 (394 HubSpot + 3,093 CMS).

Co-Authored-By: Claude Opus 4.8 <noreply@anthropic.com>
</commit_message>
<xml_diff>
--- a/June_2026_NAM_MBR.pptx
+++ b/June_2026_NAM_MBR.pptx
@@ -21906,7 +21906,7 @@
                 <a:gridCol w="1188720"/>
                 <a:gridCol w="1188720"/>
               </a:tblGrid>
-              <a:tr h="310896">
+              <a:tr h="292608">
                 <a:tc>
                   <a:txBody>
                     <a:bodyPr/>
@@ -22180,7 +22180,7 @@
                   </a:tcPr>
                 </a:tc>
               </a:tr>
-              <a:tr h="310896">
+              <a:tr h="292608">
                 <a:tc>
                   <a:txBody>
                     <a:bodyPr/>
@@ -22454,7 +22454,7 @@
                   </a:tcPr>
                 </a:tc>
               </a:tr>
-              <a:tr h="310896">
+              <a:tr h="292608">
                 <a:tc>
                   <a:txBody>
                     <a:bodyPr/>
@@ -22472,7 +22472,7 @@
                           <a:ea typeface="Calibri" pitchFamily="34" charset="-122"/>
                           <a:cs typeface="Calibri" pitchFamily="34" charset="-120"/>
                         </a:rPr>
-                        <a:t>Contacts Enrolled</a:t>
+                        <a:t>Contacts Reached</a:t>
                       </a:r>
                       <a:endParaRPr lang="en-US" sz="1150" dirty="0">
                         <a:latin typeface="Calibri" charset="0"/>
@@ -22608,6 +22608,554 @@
                           <a:ea typeface="Calibri" pitchFamily="34" charset="-122"/>
                           <a:cs typeface="Calibri" pitchFamily="34" charset="-120"/>
                         </a:rPr>
+                        <a:t>427</a:t>
+                      </a:r>
+                      <a:endParaRPr lang="en-US" sz="1150" dirty="0">
+                        <a:latin typeface="Calibri" charset="0"/>
+                        <a:ea typeface="Calibri" charset="0"/>
+                        <a:cs typeface="Calibri" charset="0"/>
+                      </a:endParaRPr>
+                    </a:p>
+                  </a:txBody>
+                  <a:tcPr marL="91440" marR="91440" marT="45720" marB="45720">
+                    <a:lnL w="6350" cap="flat" cmpd="sng" algn="ctr">
+                      <a:solidFill>
+                        <a:srgbClr val="2A2E3B"/>
+                      </a:solidFill>
+                      <a:prstDash val="solid"/>
+                      <a:round/>
+                      <a:headEnd type="none" w="med" len="med"/>
+                      <a:tailEnd type="none" w="med" len="med"/>
+                    </a:lnL>
+                    <a:lnR w="6350" cap="flat" cmpd="sng" algn="ctr">
+                      <a:solidFill>
+                        <a:srgbClr val="2A2E3B"/>
+                      </a:solidFill>
+                      <a:prstDash val="solid"/>
+                      <a:round/>
+                      <a:headEnd type="none" w="med" len="med"/>
+                      <a:tailEnd type="none" w="med" len="med"/>
+                    </a:lnR>
+                    <a:lnT w="6350" cap="flat" cmpd="sng" algn="ctr">
+                      <a:solidFill>
+                        <a:srgbClr val="2A2E3B"/>
+                      </a:solidFill>
+                      <a:prstDash val="solid"/>
+                      <a:round/>
+                      <a:headEnd type="none" w="med" len="med"/>
+                      <a:tailEnd type="none" w="med" len="med"/>
+                    </a:lnT>
+                    <a:lnB w="6350" cap="flat" cmpd="sng" algn="ctr">
+                      <a:solidFill>
+                        <a:srgbClr val="2A2E3B"/>
+                      </a:solidFill>
+                      <a:prstDash val="solid"/>
+                      <a:round/>
+                      <a:headEnd type="none" w="med" len="med"/>
+                      <a:tailEnd type="none" w="med" len="med"/>
+                    </a:lnB>
+                    <a:solidFill>
+                      <a:srgbClr val="222632"/>
+                    </a:solidFill>
+                  </a:tcPr>
+                </a:tc>
+                <a:tc>
+                  <a:txBody>
+                    <a:bodyPr/>
+                    <a:lstStyle/>
+                    <a:p>
+                      <a:pPr algn="r" indent="0" marL="0">
+                        <a:buNone/>
+                      </a:pPr>
+                      <a:r>
+                        <a:rPr lang="en-US" sz="1150" b="1" dirty="0">
+                          <a:solidFill>
+                            <a:srgbClr val="E4E6ED"/>
+                          </a:solidFill>
+                          <a:latin typeface="Calibri" pitchFamily="34" charset="0"/>
+                          <a:ea typeface="Calibri" pitchFamily="34" charset="-122"/>
+                          <a:cs typeface="Calibri" pitchFamily="34" charset="-120"/>
+                        </a:rPr>
+                        <a:t>427</a:t>
+                      </a:r>
+                      <a:endParaRPr lang="en-US" sz="1150" dirty="0">
+                        <a:latin typeface="Calibri" charset="0"/>
+                        <a:ea typeface="Calibri" charset="0"/>
+                        <a:cs typeface="Calibri" charset="0"/>
+                      </a:endParaRPr>
+                    </a:p>
+                  </a:txBody>
+                  <a:tcPr marL="91440" marR="91440" marT="45720" marB="45720">
+                    <a:lnL w="6350" cap="flat" cmpd="sng" algn="ctr">
+                      <a:solidFill>
+                        <a:srgbClr val="2A2E3B"/>
+                      </a:solidFill>
+                      <a:prstDash val="solid"/>
+                      <a:round/>
+                      <a:headEnd type="none" w="med" len="med"/>
+                      <a:tailEnd type="none" w="med" len="med"/>
+                    </a:lnL>
+                    <a:lnR w="6350" cap="flat" cmpd="sng" algn="ctr">
+                      <a:solidFill>
+                        <a:srgbClr val="2A2E3B"/>
+                      </a:solidFill>
+                      <a:prstDash val="solid"/>
+                      <a:round/>
+                      <a:headEnd type="none" w="med" len="med"/>
+                      <a:tailEnd type="none" w="med" len="med"/>
+                    </a:lnR>
+                    <a:lnT w="6350" cap="flat" cmpd="sng" algn="ctr">
+                      <a:solidFill>
+                        <a:srgbClr val="2A2E3B"/>
+                      </a:solidFill>
+                      <a:prstDash val="solid"/>
+                      <a:round/>
+                      <a:headEnd type="none" w="med" len="med"/>
+                      <a:tailEnd type="none" w="med" len="med"/>
+                    </a:lnT>
+                    <a:lnB w="6350" cap="flat" cmpd="sng" algn="ctr">
+                      <a:solidFill>
+                        <a:srgbClr val="2A2E3B"/>
+                      </a:solidFill>
+                      <a:prstDash val="solid"/>
+                      <a:round/>
+                      <a:headEnd type="none" w="med" len="med"/>
+                      <a:tailEnd type="none" w="med" len="med"/>
+                    </a:lnB>
+                    <a:solidFill>
+                      <a:srgbClr val="222632"/>
+                    </a:solidFill>
+                  </a:tcPr>
+                </a:tc>
+              </a:tr>
+              <a:tr h="292608">
+                <a:tc>
+                  <a:txBody>
+                    <a:bodyPr/>
+                    <a:lstStyle/>
+                    <a:p>
+                      <a:pPr indent="0" marL="0">
+                        <a:buNone/>
+                      </a:pPr>
+                      <a:r>
+                        <a:rPr lang="en-US" sz="1150" dirty="0">
+                          <a:solidFill>
+                            <a:srgbClr val="E4E6ED"/>
+                          </a:solidFill>
+                          <a:latin typeface="Calibri" pitchFamily="34" charset="0"/>
+                          <a:ea typeface="Calibri" pitchFamily="34" charset="-122"/>
+                          <a:cs typeface="Calibri" pitchFamily="34" charset="-120"/>
+                        </a:rPr>
+                        <a:t>Accounts Touched</a:t>
+                      </a:r>
+                      <a:endParaRPr lang="en-US" sz="1150" dirty="0">
+                        <a:latin typeface="Calibri" charset="0"/>
+                        <a:ea typeface="Calibri" charset="0"/>
+                        <a:cs typeface="Calibri" charset="0"/>
+                      </a:endParaRPr>
+                    </a:p>
+                  </a:txBody>
+                  <a:tcPr marL="91440" marR="91440" marT="45720" marB="45720">
+                    <a:lnL w="6350" cap="flat" cmpd="sng" algn="ctr">
+                      <a:solidFill>
+                        <a:srgbClr val="2A2E3B"/>
+                      </a:solidFill>
+                      <a:prstDash val="solid"/>
+                      <a:round/>
+                      <a:headEnd type="none" w="med" len="med"/>
+                      <a:tailEnd type="none" w="med" len="med"/>
+                    </a:lnL>
+                    <a:lnR w="6350" cap="flat" cmpd="sng" algn="ctr">
+                      <a:solidFill>
+                        <a:srgbClr val="2A2E3B"/>
+                      </a:solidFill>
+                      <a:prstDash val="solid"/>
+                      <a:round/>
+                      <a:headEnd type="none" w="med" len="med"/>
+                      <a:tailEnd type="none" w="med" len="med"/>
+                    </a:lnR>
+                    <a:lnT w="6350" cap="flat" cmpd="sng" algn="ctr">
+                      <a:solidFill>
+                        <a:srgbClr val="2A2E3B"/>
+                      </a:solidFill>
+                      <a:prstDash val="solid"/>
+                      <a:round/>
+                      <a:headEnd type="none" w="med" len="med"/>
+                      <a:tailEnd type="none" w="med" len="med"/>
+                    </a:lnT>
+                    <a:lnB w="6350" cap="flat" cmpd="sng" algn="ctr">
+                      <a:solidFill>
+                        <a:srgbClr val="2A2E3B"/>
+                      </a:solidFill>
+                      <a:prstDash val="solid"/>
+                      <a:round/>
+                      <a:headEnd type="none" w="med" len="med"/>
+                      <a:tailEnd type="none" w="med" len="med"/>
+                    </a:lnB>
+                    <a:solidFill>
+                      <a:srgbClr val="222632"/>
+                    </a:solidFill>
+                  </a:tcPr>
+                </a:tc>
+                <a:tc>
+                  <a:txBody>
+                    <a:bodyPr/>
+                    <a:lstStyle/>
+                    <a:p>
+                      <a:pPr algn="r" indent="0" marL="0">
+                        <a:buNone/>
+                      </a:pPr>
+                      <a:r>
+                        <a:rPr lang="en-US" sz="1150" dirty="0">
+                          <a:solidFill>
+                            <a:srgbClr val="8B8FA3"/>
+                          </a:solidFill>
+                          <a:latin typeface="Calibri" pitchFamily="34" charset="0"/>
+                          <a:ea typeface="Calibri" pitchFamily="34" charset="-122"/>
+                          <a:cs typeface="Calibri" pitchFamily="34" charset="-120"/>
+                        </a:rPr>
+                        <a:t>—</a:t>
+                      </a:r>
+                      <a:endParaRPr lang="en-US" sz="1150" dirty="0">
+                        <a:latin typeface="Calibri" charset="0"/>
+                        <a:ea typeface="Calibri" charset="0"/>
+                        <a:cs typeface="Calibri" charset="0"/>
+                      </a:endParaRPr>
+                    </a:p>
+                  </a:txBody>
+                  <a:tcPr marL="91440" marR="91440" marT="45720" marB="45720">
+                    <a:lnL w="6350" cap="flat" cmpd="sng" algn="ctr">
+                      <a:solidFill>
+                        <a:srgbClr val="2A2E3B"/>
+                      </a:solidFill>
+                      <a:prstDash val="solid"/>
+                      <a:round/>
+                      <a:headEnd type="none" w="med" len="med"/>
+                      <a:tailEnd type="none" w="med" len="med"/>
+                    </a:lnL>
+                    <a:lnR w="6350" cap="flat" cmpd="sng" algn="ctr">
+                      <a:solidFill>
+                        <a:srgbClr val="2A2E3B"/>
+                      </a:solidFill>
+                      <a:prstDash val="solid"/>
+                      <a:round/>
+                      <a:headEnd type="none" w="med" len="med"/>
+                      <a:tailEnd type="none" w="med" len="med"/>
+                    </a:lnR>
+                    <a:lnT w="6350" cap="flat" cmpd="sng" algn="ctr">
+                      <a:solidFill>
+                        <a:srgbClr val="2A2E3B"/>
+                      </a:solidFill>
+                      <a:prstDash val="solid"/>
+                      <a:round/>
+                      <a:headEnd type="none" w="med" len="med"/>
+                      <a:tailEnd type="none" w="med" len="med"/>
+                    </a:lnT>
+                    <a:lnB w="6350" cap="flat" cmpd="sng" algn="ctr">
+                      <a:solidFill>
+                        <a:srgbClr val="2A2E3B"/>
+                      </a:solidFill>
+                      <a:prstDash val="solid"/>
+                      <a:round/>
+                      <a:headEnd type="none" w="med" len="med"/>
+                      <a:tailEnd type="none" w="med" len="med"/>
+                    </a:lnB>
+                    <a:solidFill>
+                      <a:srgbClr val="222632"/>
+                    </a:solidFill>
+                  </a:tcPr>
+                </a:tc>
+                <a:tc>
+                  <a:txBody>
+                    <a:bodyPr/>
+                    <a:lstStyle/>
+                    <a:p>
+                      <a:pPr algn="r" indent="0" marL="0">
+                        <a:buNone/>
+                      </a:pPr>
+                      <a:r>
+                        <a:rPr lang="en-US" sz="1150" dirty="0">
+                          <a:solidFill>
+                            <a:srgbClr val="8B8FA3"/>
+                          </a:solidFill>
+                          <a:latin typeface="Calibri" pitchFamily="34" charset="0"/>
+                          <a:ea typeface="Calibri" pitchFamily="34" charset="-122"/>
+                          <a:cs typeface="Calibri" pitchFamily="34" charset="-120"/>
+                        </a:rPr>
+                        <a:t>32</a:t>
+                      </a:r>
+                      <a:endParaRPr lang="en-US" sz="1150" dirty="0">
+                        <a:latin typeface="Calibri" charset="0"/>
+                        <a:ea typeface="Calibri" charset="0"/>
+                        <a:cs typeface="Calibri" charset="0"/>
+                      </a:endParaRPr>
+                    </a:p>
+                  </a:txBody>
+                  <a:tcPr marL="91440" marR="91440" marT="45720" marB="45720">
+                    <a:lnL w="6350" cap="flat" cmpd="sng" algn="ctr">
+                      <a:solidFill>
+                        <a:srgbClr val="2A2E3B"/>
+                      </a:solidFill>
+                      <a:prstDash val="solid"/>
+                      <a:round/>
+                      <a:headEnd type="none" w="med" len="med"/>
+                      <a:tailEnd type="none" w="med" len="med"/>
+                    </a:lnL>
+                    <a:lnR w="6350" cap="flat" cmpd="sng" algn="ctr">
+                      <a:solidFill>
+                        <a:srgbClr val="2A2E3B"/>
+                      </a:solidFill>
+                      <a:prstDash val="solid"/>
+                      <a:round/>
+                      <a:headEnd type="none" w="med" len="med"/>
+                      <a:tailEnd type="none" w="med" len="med"/>
+                    </a:lnR>
+                    <a:lnT w="6350" cap="flat" cmpd="sng" algn="ctr">
+                      <a:solidFill>
+                        <a:srgbClr val="2A2E3B"/>
+                      </a:solidFill>
+                      <a:prstDash val="solid"/>
+                      <a:round/>
+                      <a:headEnd type="none" w="med" len="med"/>
+                      <a:tailEnd type="none" w="med" len="med"/>
+                    </a:lnT>
+                    <a:lnB w="6350" cap="flat" cmpd="sng" algn="ctr">
+                      <a:solidFill>
+                        <a:srgbClr val="2A2E3B"/>
+                      </a:solidFill>
+                      <a:prstDash val="solid"/>
+                      <a:round/>
+                      <a:headEnd type="none" w="med" len="med"/>
+                      <a:tailEnd type="none" w="med" len="med"/>
+                    </a:lnB>
+                    <a:solidFill>
+                      <a:srgbClr val="222632"/>
+                    </a:solidFill>
+                  </a:tcPr>
+                </a:tc>
+                <a:tc>
+                  <a:txBody>
+                    <a:bodyPr/>
+                    <a:lstStyle/>
+                    <a:p>
+                      <a:pPr algn="r" indent="0" marL="0">
+                        <a:buNone/>
+                      </a:pPr>
+                      <a:r>
+                        <a:rPr lang="en-US" sz="1150" b="1" dirty="0">
+                          <a:solidFill>
+                            <a:srgbClr val="E4E6ED"/>
+                          </a:solidFill>
+                          <a:latin typeface="Calibri" pitchFamily="34" charset="0"/>
+                          <a:ea typeface="Calibri" pitchFamily="34" charset="-122"/>
+                          <a:cs typeface="Calibri" pitchFamily="34" charset="-120"/>
+                        </a:rPr>
+                        <a:t>32</a:t>
+                      </a:r>
+                      <a:endParaRPr lang="en-US" sz="1150" dirty="0">
+                        <a:latin typeface="Calibri" charset="0"/>
+                        <a:ea typeface="Calibri" charset="0"/>
+                        <a:cs typeface="Calibri" charset="0"/>
+                      </a:endParaRPr>
+                    </a:p>
+                  </a:txBody>
+                  <a:tcPr marL="91440" marR="91440" marT="45720" marB="45720">
+                    <a:lnL w="6350" cap="flat" cmpd="sng" algn="ctr">
+                      <a:solidFill>
+                        <a:srgbClr val="2A2E3B"/>
+                      </a:solidFill>
+                      <a:prstDash val="solid"/>
+                      <a:round/>
+                      <a:headEnd type="none" w="med" len="med"/>
+                      <a:tailEnd type="none" w="med" len="med"/>
+                    </a:lnL>
+                    <a:lnR w="6350" cap="flat" cmpd="sng" algn="ctr">
+                      <a:solidFill>
+                        <a:srgbClr val="2A2E3B"/>
+                      </a:solidFill>
+                      <a:prstDash val="solid"/>
+                      <a:round/>
+                      <a:headEnd type="none" w="med" len="med"/>
+                      <a:tailEnd type="none" w="med" len="med"/>
+                    </a:lnR>
+                    <a:lnT w="6350" cap="flat" cmpd="sng" algn="ctr">
+                      <a:solidFill>
+                        <a:srgbClr val="2A2E3B"/>
+                      </a:solidFill>
+                      <a:prstDash val="solid"/>
+                      <a:round/>
+                      <a:headEnd type="none" w="med" len="med"/>
+                      <a:tailEnd type="none" w="med" len="med"/>
+                    </a:lnT>
+                    <a:lnB w="6350" cap="flat" cmpd="sng" algn="ctr">
+                      <a:solidFill>
+                        <a:srgbClr val="2A2E3B"/>
+                      </a:solidFill>
+                      <a:prstDash val="solid"/>
+                      <a:round/>
+                      <a:headEnd type="none" w="med" len="med"/>
+                      <a:tailEnd type="none" w="med" len="med"/>
+                    </a:lnB>
+                    <a:solidFill>
+                      <a:srgbClr val="222632"/>
+                    </a:solidFill>
+                  </a:tcPr>
+                </a:tc>
+              </a:tr>
+              <a:tr h="292608">
+                <a:tc>
+                  <a:txBody>
+                    <a:bodyPr/>
+                    <a:lstStyle/>
+                    <a:p>
+                      <a:pPr indent="0" marL="0">
+                        <a:buNone/>
+                      </a:pPr>
+                      <a:r>
+                        <a:rPr lang="en-US" sz="1150" dirty="0">
+                          <a:solidFill>
+                            <a:srgbClr val="E4E6ED"/>
+                          </a:solidFill>
+                          <a:latin typeface="Calibri" pitchFamily="34" charset="0"/>
+                          <a:ea typeface="Calibri" pitchFamily="34" charset="-122"/>
+                          <a:cs typeface="Calibri" pitchFamily="34" charset="-120"/>
+                        </a:rPr>
+                        <a:t>Contacts Enrolled</a:t>
+                      </a:r>
+                      <a:endParaRPr lang="en-US" sz="1150" dirty="0">
+                        <a:latin typeface="Calibri" charset="0"/>
+                        <a:ea typeface="Calibri" charset="0"/>
+                        <a:cs typeface="Calibri" charset="0"/>
+                      </a:endParaRPr>
+                    </a:p>
+                  </a:txBody>
+                  <a:tcPr marL="91440" marR="91440" marT="45720" marB="45720">
+                    <a:lnL w="6350" cap="flat" cmpd="sng" algn="ctr">
+                      <a:solidFill>
+                        <a:srgbClr val="2A2E3B"/>
+                      </a:solidFill>
+                      <a:prstDash val="solid"/>
+                      <a:round/>
+                      <a:headEnd type="none" w="med" len="med"/>
+                      <a:tailEnd type="none" w="med" len="med"/>
+                    </a:lnL>
+                    <a:lnR w="6350" cap="flat" cmpd="sng" algn="ctr">
+                      <a:solidFill>
+                        <a:srgbClr val="2A2E3B"/>
+                      </a:solidFill>
+                      <a:prstDash val="solid"/>
+                      <a:round/>
+                      <a:headEnd type="none" w="med" len="med"/>
+                      <a:tailEnd type="none" w="med" len="med"/>
+                    </a:lnR>
+                    <a:lnT w="6350" cap="flat" cmpd="sng" algn="ctr">
+                      <a:solidFill>
+                        <a:srgbClr val="2A2E3B"/>
+                      </a:solidFill>
+                      <a:prstDash val="solid"/>
+                      <a:round/>
+                      <a:headEnd type="none" w="med" len="med"/>
+                      <a:tailEnd type="none" w="med" len="med"/>
+                    </a:lnT>
+                    <a:lnB w="6350" cap="flat" cmpd="sng" algn="ctr">
+                      <a:solidFill>
+                        <a:srgbClr val="2A2E3B"/>
+                      </a:solidFill>
+                      <a:prstDash val="solid"/>
+                      <a:round/>
+                      <a:headEnd type="none" w="med" len="med"/>
+                      <a:tailEnd type="none" w="med" len="med"/>
+                    </a:lnB>
+                    <a:solidFill>
+                      <a:srgbClr val="222632"/>
+                    </a:solidFill>
+                  </a:tcPr>
+                </a:tc>
+                <a:tc>
+                  <a:txBody>
+                    <a:bodyPr/>
+                    <a:lstStyle/>
+                    <a:p>
+                      <a:pPr algn="r" indent="0" marL="0">
+                        <a:buNone/>
+                      </a:pPr>
+                      <a:r>
+                        <a:rPr lang="en-US" sz="1150" dirty="0">
+                          <a:solidFill>
+                            <a:srgbClr val="8B8FA3"/>
+                          </a:solidFill>
+                          <a:latin typeface="Calibri" pitchFamily="34" charset="0"/>
+                          <a:ea typeface="Calibri" pitchFamily="34" charset="-122"/>
+                          <a:cs typeface="Calibri" pitchFamily="34" charset="-120"/>
+                        </a:rPr>
+                        <a:t>—</a:t>
+                      </a:r>
+                      <a:endParaRPr lang="en-US" sz="1150" dirty="0">
+                        <a:latin typeface="Calibri" charset="0"/>
+                        <a:ea typeface="Calibri" charset="0"/>
+                        <a:cs typeface="Calibri" charset="0"/>
+                      </a:endParaRPr>
+                    </a:p>
+                  </a:txBody>
+                  <a:tcPr marL="91440" marR="91440" marT="45720" marB="45720">
+                    <a:lnL w="6350" cap="flat" cmpd="sng" algn="ctr">
+                      <a:solidFill>
+                        <a:srgbClr val="2A2E3B"/>
+                      </a:solidFill>
+                      <a:prstDash val="solid"/>
+                      <a:round/>
+                      <a:headEnd type="none" w="med" len="med"/>
+                      <a:tailEnd type="none" w="med" len="med"/>
+                    </a:lnL>
+                    <a:lnR w="6350" cap="flat" cmpd="sng" algn="ctr">
+                      <a:solidFill>
+                        <a:srgbClr val="2A2E3B"/>
+                      </a:solidFill>
+                      <a:prstDash val="solid"/>
+                      <a:round/>
+                      <a:headEnd type="none" w="med" len="med"/>
+                      <a:tailEnd type="none" w="med" len="med"/>
+                    </a:lnR>
+                    <a:lnT w="6350" cap="flat" cmpd="sng" algn="ctr">
+                      <a:solidFill>
+                        <a:srgbClr val="2A2E3B"/>
+                      </a:solidFill>
+                      <a:prstDash val="solid"/>
+                      <a:round/>
+                      <a:headEnd type="none" w="med" len="med"/>
+                      <a:tailEnd type="none" w="med" len="med"/>
+                    </a:lnT>
+                    <a:lnB w="6350" cap="flat" cmpd="sng" algn="ctr">
+                      <a:solidFill>
+                        <a:srgbClr val="2A2E3B"/>
+                      </a:solidFill>
+                      <a:prstDash val="solid"/>
+                      <a:round/>
+                      <a:headEnd type="none" w="med" len="med"/>
+                      <a:tailEnd type="none" w="med" len="med"/>
+                    </a:lnB>
+                    <a:solidFill>
+                      <a:srgbClr val="222632"/>
+                    </a:solidFill>
+                  </a:tcPr>
+                </a:tc>
+                <a:tc>
+                  <a:txBody>
+                    <a:bodyPr/>
+                    <a:lstStyle/>
+                    <a:p>
+                      <a:pPr algn="r" indent="0" marL="0">
+                        <a:buNone/>
+                      </a:pPr>
+                      <a:r>
+                        <a:rPr lang="en-US" sz="1150" dirty="0">
+                          <a:solidFill>
+                            <a:srgbClr val="8B8FA3"/>
+                          </a:solidFill>
+                          <a:latin typeface="Calibri" pitchFamily="34" charset="0"/>
+                          <a:ea typeface="Calibri" pitchFamily="34" charset="-122"/>
+                          <a:cs typeface="Calibri" pitchFamily="34" charset="-120"/>
+                        </a:rPr>
                         <a:t>90</a:t>
                       </a:r>
                       <a:endParaRPr lang="en-US" sz="1150" dirty="0">
@@ -22728,828 +23276,6 @@
                   </a:tcPr>
                 </a:tc>
               </a:tr>
-              <a:tr h="310896">
-                <a:tc>
-                  <a:txBody>
-                    <a:bodyPr/>
-                    <a:lstStyle/>
-                    <a:p>
-                      <a:pPr indent="0" marL="0">
-                        <a:buNone/>
-                      </a:pPr>
-                      <a:r>
-                        <a:rPr lang="en-US" sz="1150" dirty="0">
-                          <a:solidFill>
-                            <a:srgbClr val="E4E6ED"/>
-                          </a:solidFill>
-                          <a:latin typeface="Calibri" pitchFamily="34" charset="0"/>
-                          <a:ea typeface="Calibri" pitchFamily="34" charset="-122"/>
-                          <a:cs typeface="Calibri" pitchFamily="34" charset="-120"/>
-                        </a:rPr>
-                        <a:t>Contacts Reached</a:t>
-                      </a:r>
-                      <a:endParaRPr lang="en-US" sz="1150" dirty="0">
-                        <a:latin typeface="Calibri" charset="0"/>
-                        <a:ea typeface="Calibri" charset="0"/>
-                        <a:cs typeface="Calibri" charset="0"/>
-                      </a:endParaRPr>
-                    </a:p>
-                  </a:txBody>
-                  <a:tcPr marL="91440" marR="91440" marT="45720" marB="45720">
-                    <a:lnL w="6350" cap="flat" cmpd="sng" algn="ctr">
-                      <a:solidFill>
-                        <a:srgbClr val="2A2E3B"/>
-                      </a:solidFill>
-                      <a:prstDash val="solid"/>
-                      <a:round/>
-                      <a:headEnd type="none" w="med" len="med"/>
-                      <a:tailEnd type="none" w="med" len="med"/>
-                    </a:lnL>
-                    <a:lnR w="6350" cap="flat" cmpd="sng" algn="ctr">
-                      <a:solidFill>
-                        <a:srgbClr val="2A2E3B"/>
-                      </a:solidFill>
-                      <a:prstDash val="solid"/>
-                      <a:round/>
-                      <a:headEnd type="none" w="med" len="med"/>
-                      <a:tailEnd type="none" w="med" len="med"/>
-                    </a:lnR>
-                    <a:lnT w="6350" cap="flat" cmpd="sng" algn="ctr">
-                      <a:solidFill>
-                        <a:srgbClr val="2A2E3B"/>
-                      </a:solidFill>
-                      <a:prstDash val="solid"/>
-                      <a:round/>
-                      <a:headEnd type="none" w="med" len="med"/>
-                      <a:tailEnd type="none" w="med" len="med"/>
-                    </a:lnT>
-                    <a:lnB w="6350" cap="flat" cmpd="sng" algn="ctr">
-                      <a:solidFill>
-                        <a:srgbClr val="2A2E3B"/>
-                      </a:solidFill>
-                      <a:prstDash val="solid"/>
-                      <a:round/>
-                      <a:headEnd type="none" w="med" len="med"/>
-                      <a:tailEnd type="none" w="med" len="med"/>
-                    </a:lnB>
-                    <a:solidFill>
-                      <a:srgbClr val="222632"/>
-                    </a:solidFill>
-                  </a:tcPr>
-                </a:tc>
-                <a:tc>
-                  <a:txBody>
-                    <a:bodyPr/>
-                    <a:lstStyle/>
-                    <a:p>
-                      <a:pPr algn="r" indent="0" marL="0">
-                        <a:buNone/>
-                      </a:pPr>
-                      <a:r>
-                        <a:rPr lang="en-US" sz="1150" dirty="0">
-                          <a:solidFill>
-                            <a:srgbClr val="8B8FA3"/>
-                          </a:solidFill>
-                          <a:latin typeface="Calibri" pitchFamily="34" charset="0"/>
-                          <a:ea typeface="Calibri" pitchFamily="34" charset="-122"/>
-                          <a:cs typeface="Calibri" pitchFamily="34" charset="-120"/>
-                        </a:rPr>
-                        <a:t>—</a:t>
-                      </a:r>
-                      <a:endParaRPr lang="en-US" sz="1150" dirty="0">
-                        <a:latin typeface="Calibri" charset="0"/>
-                        <a:ea typeface="Calibri" charset="0"/>
-                        <a:cs typeface="Calibri" charset="0"/>
-                      </a:endParaRPr>
-                    </a:p>
-                  </a:txBody>
-                  <a:tcPr marL="91440" marR="91440" marT="45720" marB="45720">
-                    <a:lnL w="6350" cap="flat" cmpd="sng" algn="ctr">
-                      <a:solidFill>
-                        <a:srgbClr val="2A2E3B"/>
-                      </a:solidFill>
-                      <a:prstDash val="solid"/>
-                      <a:round/>
-                      <a:headEnd type="none" w="med" len="med"/>
-                      <a:tailEnd type="none" w="med" len="med"/>
-                    </a:lnL>
-                    <a:lnR w="6350" cap="flat" cmpd="sng" algn="ctr">
-                      <a:solidFill>
-                        <a:srgbClr val="2A2E3B"/>
-                      </a:solidFill>
-                      <a:prstDash val="solid"/>
-                      <a:round/>
-                      <a:headEnd type="none" w="med" len="med"/>
-                      <a:tailEnd type="none" w="med" len="med"/>
-                    </a:lnR>
-                    <a:lnT w="6350" cap="flat" cmpd="sng" algn="ctr">
-                      <a:solidFill>
-                        <a:srgbClr val="2A2E3B"/>
-                      </a:solidFill>
-                      <a:prstDash val="solid"/>
-                      <a:round/>
-                      <a:headEnd type="none" w="med" len="med"/>
-                      <a:tailEnd type="none" w="med" len="med"/>
-                    </a:lnT>
-                    <a:lnB w="6350" cap="flat" cmpd="sng" algn="ctr">
-                      <a:solidFill>
-                        <a:srgbClr val="2A2E3B"/>
-                      </a:solidFill>
-                      <a:prstDash val="solid"/>
-                      <a:round/>
-                      <a:headEnd type="none" w="med" len="med"/>
-                      <a:tailEnd type="none" w="med" len="med"/>
-                    </a:lnB>
-                    <a:solidFill>
-                      <a:srgbClr val="222632"/>
-                    </a:solidFill>
-                  </a:tcPr>
-                </a:tc>
-                <a:tc>
-                  <a:txBody>
-                    <a:bodyPr/>
-                    <a:lstStyle/>
-                    <a:p>
-                      <a:pPr algn="r" indent="0" marL="0">
-                        <a:buNone/>
-                      </a:pPr>
-                      <a:r>
-                        <a:rPr lang="en-US" sz="1150" dirty="0">
-                          <a:solidFill>
-                            <a:srgbClr val="8B8FA3"/>
-                          </a:solidFill>
-                          <a:latin typeface="Calibri" pitchFamily="34" charset="0"/>
-                          <a:ea typeface="Calibri" pitchFamily="34" charset="-122"/>
-                          <a:cs typeface="Calibri" pitchFamily="34" charset="-120"/>
-                        </a:rPr>
-                        <a:t>427</a:t>
-                      </a:r>
-                      <a:endParaRPr lang="en-US" sz="1150" dirty="0">
-                        <a:latin typeface="Calibri" charset="0"/>
-                        <a:ea typeface="Calibri" charset="0"/>
-                        <a:cs typeface="Calibri" charset="0"/>
-                      </a:endParaRPr>
-                    </a:p>
-                  </a:txBody>
-                  <a:tcPr marL="91440" marR="91440" marT="45720" marB="45720">
-                    <a:lnL w="6350" cap="flat" cmpd="sng" algn="ctr">
-                      <a:solidFill>
-                        <a:srgbClr val="2A2E3B"/>
-                      </a:solidFill>
-                      <a:prstDash val="solid"/>
-                      <a:round/>
-                      <a:headEnd type="none" w="med" len="med"/>
-                      <a:tailEnd type="none" w="med" len="med"/>
-                    </a:lnL>
-                    <a:lnR w="6350" cap="flat" cmpd="sng" algn="ctr">
-                      <a:solidFill>
-                        <a:srgbClr val="2A2E3B"/>
-                      </a:solidFill>
-                      <a:prstDash val="solid"/>
-                      <a:round/>
-                      <a:headEnd type="none" w="med" len="med"/>
-                      <a:tailEnd type="none" w="med" len="med"/>
-                    </a:lnR>
-                    <a:lnT w="6350" cap="flat" cmpd="sng" algn="ctr">
-                      <a:solidFill>
-                        <a:srgbClr val="2A2E3B"/>
-                      </a:solidFill>
-                      <a:prstDash val="solid"/>
-                      <a:round/>
-                      <a:headEnd type="none" w="med" len="med"/>
-                      <a:tailEnd type="none" w="med" len="med"/>
-                    </a:lnT>
-                    <a:lnB w="6350" cap="flat" cmpd="sng" algn="ctr">
-                      <a:solidFill>
-                        <a:srgbClr val="2A2E3B"/>
-                      </a:solidFill>
-                      <a:prstDash val="solid"/>
-                      <a:round/>
-                      <a:headEnd type="none" w="med" len="med"/>
-                      <a:tailEnd type="none" w="med" len="med"/>
-                    </a:lnB>
-                    <a:solidFill>
-                      <a:srgbClr val="222632"/>
-                    </a:solidFill>
-                  </a:tcPr>
-                </a:tc>
-                <a:tc>
-                  <a:txBody>
-                    <a:bodyPr/>
-                    <a:lstStyle/>
-                    <a:p>
-                      <a:pPr algn="r" indent="0" marL="0">
-                        <a:buNone/>
-                      </a:pPr>
-                      <a:r>
-                        <a:rPr lang="en-US" sz="1150" b="1" dirty="0">
-                          <a:solidFill>
-                            <a:srgbClr val="E4E6ED"/>
-                          </a:solidFill>
-                          <a:latin typeface="Calibri" pitchFamily="34" charset="0"/>
-                          <a:ea typeface="Calibri" pitchFamily="34" charset="-122"/>
-                          <a:cs typeface="Calibri" pitchFamily="34" charset="-120"/>
-                        </a:rPr>
-                        <a:t>427</a:t>
-                      </a:r>
-                      <a:endParaRPr lang="en-US" sz="1150" dirty="0">
-                        <a:latin typeface="Calibri" charset="0"/>
-                        <a:ea typeface="Calibri" charset="0"/>
-                        <a:cs typeface="Calibri" charset="0"/>
-                      </a:endParaRPr>
-                    </a:p>
-                  </a:txBody>
-                  <a:tcPr marL="91440" marR="91440" marT="45720" marB="45720">
-                    <a:lnL w="6350" cap="flat" cmpd="sng" algn="ctr">
-                      <a:solidFill>
-                        <a:srgbClr val="2A2E3B"/>
-                      </a:solidFill>
-                      <a:prstDash val="solid"/>
-                      <a:round/>
-                      <a:headEnd type="none" w="med" len="med"/>
-                      <a:tailEnd type="none" w="med" len="med"/>
-                    </a:lnL>
-                    <a:lnR w="6350" cap="flat" cmpd="sng" algn="ctr">
-                      <a:solidFill>
-                        <a:srgbClr val="2A2E3B"/>
-                      </a:solidFill>
-                      <a:prstDash val="solid"/>
-                      <a:round/>
-                      <a:headEnd type="none" w="med" len="med"/>
-                      <a:tailEnd type="none" w="med" len="med"/>
-                    </a:lnR>
-                    <a:lnT w="6350" cap="flat" cmpd="sng" algn="ctr">
-                      <a:solidFill>
-                        <a:srgbClr val="2A2E3B"/>
-                      </a:solidFill>
-                      <a:prstDash val="solid"/>
-                      <a:round/>
-                      <a:headEnd type="none" w="med" len="med"/>
-                      <a:tailEnd type="none" w="med" len="med"/>
-                    </a:lnT>
-                    <a:lnB w="6350" cap="flat" cmpd="sng" algn="ctr">
-                      <a:solidFill>
-                        <a:srgbClr val="2A2E3B"/>
-                      </a:solidFill>
-                      <a:prstDash val="solid"/>
-                      <a:round/>
-                      <a:headEnd type="none" w="med" len="med"/>
-                      <a:tailEnd type="none" w="med" len="med"/>
-                    </a:lnB>
-                    <a:solidFill>
-                      <a:srgbClr val="222632"/>
-                    </a:solidFill>
-                  </a:tcPr>
-                </a:tc>
-              </a:tr>
-              <a:tr h="310896">
-                <a:tc>
-                  <a:txBody>
-                    <a:bodyPr/>
-                    <a:lstStyle/>
-                    <a:p>
-                      <a:pPr indent="0" marL="0">
-                        <a:buNone/>
-                      </a:pPr>
-                      <a:r>
-                        <a:rPr lang="en-US" sz="1150" dirty="0">
-                          <a:solidFill>
-                            <a:srgbClr val="E4E6ED"/>
-                          </a:solidFill>
-                          <a:latin typeface="Calibri" pitchFamily="34" charset="0"/>
-                          <a:ea typeface="Calibri" pitchFamily="34" charset="-122"/>
-                          <a:cs typeface="Calibri" pitchFamily="34" charset="-120"/>
-                        </a:rPr>
-                        <a:t>Accounts Touched</a:t>
-                      </a:r>
-                      <a:endParaRPr lang="en-US" sz="1150" dirty="0">
-                        <a:latin typeface="Calibri" charset="0"/>
-                        <a:ea typeface="Calibri" charset="0"/>
-                        <a:cs typeface="Calibri" charset="0"/>
-                      </a:endParaRPr>
-                    </a:p>
-                  </a:txBody>
-                  <a:tcPr marL="91440" marR="91440" marT="45720" marB="45720">
-                    <a:lnL w="6350" cap="flat" cmpd="sng" algn="ctr">
-                      <a:solidFill>
-                        <a:srgbClr val="2A2E3B"/>
-                      </a:solidFill>
-                      <a:prstDash val="solid"/>
-                      <a:round/>
-                      <a:headEnd type="none" w="med" len="med"/>
-                      <a:tailEnd type="none" w="med" len="med"/>
-                    </a:lnL>
-                    <a:lnR w="6350" cap="flat" cmpd="sng" algn="ctr">
-                      <a:solidFill>
-                        <a:srgbClr val="2A2E3B"/>
-                      </a:solidFill>
-                      <a:prstDash val="solid"/>
-                      <a:round/>
-                      <a:headEnd type="none" w="med" len="med"/>
-                      <a:tailEnd type="none" w="med" len="med"/>
-                    </a:lnR>
-                    <a:lnT w="6350" cap="flat" cmpd="sng" algn="ctr">
-                      <a:solidFill>
-                        <a:srgbClr val="2A2E3B"/>
-                      </a:solidFill>
-                      <a:prstDash val="solid"/>
-                      <a:round/>
-                      <a:headEnd type="none" w="med" len="med"/>
-                      <a:tailEnd type="none" w="med" len="med"/>
-                    </a:lnT>
-                    <a:lnB w="6350" cap="flat" cmpd="sng" algn="ctr">
-                      <a:solidFill>
-                        <a:srgbClr val="2A2E3B"/>
-                      </a:solidFill>
-                      <a:prstDash val="solid"/>
-                      <a:round/>
-                      <a:headEnd type="none" w="med" len="med"/>
-                      <a:tailEnd type="none" w="med" len="med"/>
-                    </a:lnB>
-                    <a:solidFill>
-                      <a:srgbClr val="222632"/>
-                    </a:solidFill>
-                  </a:tcPr>
-                </a:tc>
-                <a:tc>
-                  <a:txBody>
-                    <a:bodyPr/>
-                    <a:lstStyle/>
-                    <a:p>
-                      <a:pPr algn="r" indent="0" marL="0">
-                        <a:buNone/>
-                      </a:pPr>
-                      <a:r>
-                        <a:rPr lang="en-US" sz="1150" dirty="0">
-                          <a:solidFill>
-                            <a:srgbClr val="8B8FA3"/>
-                          </a:solidFill>
-                          <a:latin typeface="Calibri" pitchFamily="34" charset="0"/>
-                          <a:ea typeface="Calibri" pitchFamily="34" charset="-122"/>
-                          <a:cs typeface="Calibri" pitchFamily="34" charset="-120"/>
-                        </a:rPr>
-                        <a:t>—</a:t>
-                      </a:r>
-                      <a:endParaRPr lang="en-US" sz="1150" dirty="0">
-                        <a:latin typeface="Calibri" charset="0"/>
-                        <a:ea typeface="Calibri" charset="0"/>
-                        <a:cs typeface="Calibri" charset="0"/>
-                      </a:endParaRPr>
-                    </a:p>
-                  </a:txBody>
-                  <a:tcPr marL="91440" marR="91440" marT="45720" marB="45720">
-                    <a:lnL w="6350" cap="flat" cmpd="sng" algn="ctr">
-                      <a:solidFill>
-                        <a:srgbClr val="2A2E3B"/>
-                      </a:solidFill>
-                      <a:prstDash val="solid"/>
-                      <a:round/>
-                      <a:headEnd type="none" w="med" len="med"/>
-                      <a:tailEnd type="none" w="med" len="med"/>
-                    </a:lnL>
-                    <a:lnR w="6350" cap="flat" cmpd="sng" algn="ctr">
-                      <a:solidFill>
-                        <a:srgbClr val="2A2E3B"/>
-                      </a:solidFill>
-                      <a:prstDash val="solid"/>
-                      <a:round/>
-                      <a:headEnd type="none" w="med" len="med"/>
-                      <a:tailEnd type="none" w="med" len="med"/>
-                    </a:lnR>
-                    <a:lnT w="6350" cap="flat" cmpd="sng" algn="ctr">
-                      <a:solidFill>
-                        <a:srgbClr val="2A2E3B"/>
-                      </a:solidFill>
-                      <a:prstDash val="solid"/>
-                      <a:round/>
-                      <a:headEnd type="none" w="med" len="med"/>
-                      <a:tailEnd type="none" w="med" len="med"/>
-                    </a:lnT>
-                    <a:lnB w="6350" cap="flat" cmpd="sng" algn="ctr">
-                      <a:solidFill>
-                        <a:srgbClr val="2A2E3B"/>
-                      </a:solidFill>
-                      <a:prstDash val="solid"/>
-                      <a:round/>
-                      <a:headEnd type="none" w="med" len="med"/>
-                      <a:tailEnd type="none" w="med" len="med"/>
-                    </a:lnB>
-                    <a:solidFill>
-                      <a:srgbClr val="222632"/>
-                    </a:solidFill>
-                  </a:tcPr>
-                </a:tc>
-                <a:tc>
-                  <a:txBody>
-                    <a:bodyPr/>
-                    <a:lstStyle/>
-                    <a:p>
-                      <a:pPr algn="r" indent="0" marL="0">
-                        <a:buNone/>
-                      </a:pPr>
-                      <a:r>
-                        <a:rPr lang="en-US" sz="1150" dirty="0">
-                          <a:solidFill>
-                            <a:srgbClr val="8B8FA3"/>
-                          </a:solidFill>
-                          <a:latin typeface="Calibri" pitchFamily="34" charset="0"/>
-                          <a:ea typeface="Calibri" pitchFamily="34" charset="-122"/>
-                          <a:cs typeface="Calibri" pitchFamily="34" charset="-120"/>
-                        </a:rPr>
-                        <a:t>32</a:t>
-                      </a:r>
-                      <a:endParaRPr lang="en-US" sz="1150" dirty="0">
-                        <a:latin typeface="Calibri" charset="0"/>
-                        <a:ea typeface="Calibri" charset="0"/>
-                        <a:cs typeface="Calibri" charset="0"/>
-                      </a:endParaRPr>
-                    </a:p>
-                  </a:txBody>
-                  <a:tcPr marL="91440" marR="91440" marT="45720" marB="45720">
-                    <a:lnL w="6350" cap="flat" cmpd="sng" algn="ctr">
-                      <a:solidFill>
-                        <a:srgbClr val="2A2E3B"/>
-                      </a:solidFill>
-                      <a:prstDash val="solid"/>
-                      <a:round/>
-                      <a:headEnd type="none" w="med" len="med"/>
-                      <a:tailEnd type="none" w="med" len="med"/>
-                    </a:lnL>
-                    <a:lnR w="6350" cap="flat" cmpd="sng" algn="ctr">
-                      <a:solidFill>
-                        <a:srgbClr val="2A2E3B"/>
-                      </a:solidFill>
-                      <a:prstDash val="solid"/>
-                      <a:round/>
-                      <a:headEnd type="none" w="med" len="med"/>
-                      <a:tailEnd type="none" w="med" len="med"/>
-                    </a:lnR>
-                    <a:lnT w="6350" cap="flat" cmpd="sng" algn="ctr">
-                      <a:solidFill>
-                        <a:srgbClr val="2A2E3B"/>
-                      </a:solidFill>
-                      <a:prstDash val="solid"/>
-                      <a:round/>
-                      <a:headEnd type="none" w="med" len="med"/>
-                      <a:tailEnd type="none" w="med" len="med"/>
-                    </a:lnT>
-                    <a:lnB w="6350" cap="flat" cmpd="sng" algn="ctr">
-                      <a:solidFill>
-                        <a:srgbClr val="2A2E3B"/>
-                      </a:solidFill>
-                      <a:prstDash val="solid"/>
-                      <a:round/>
-                      <a:headEnd type="none" w="med" len="med"/>
-                      <a:tailEnd type="none" w="med" len="med"/>
-                    </a:lnB>
-                    <a:solidFill>
-                      <a:srgbClr val="222632"/>
-                    </a:solidFill>
-                  </a:tcPr>
-                </a:tc>
-                <a:tc>
-                  <a:txBody>
-                    <a:bodyPr/>
-                    <a:lstStyle/>
-                    <a:p>
-                      <a:pPr algn="r" indent="0" marL="0">
-                        <a:buNone/>
-                      </a:pPr>
-                      <a:r>
-                        <a:rPr lang="en-US" sz="1150" b="1" dirty="0">
-                          <a:solidFill>
-                            <a:srgbClr val="E4E6ED"/>
-                          </a:solidFill>
-                          <a:latin typeface="Calibri" pitchFamily="34" charset="0"/>
-                          <a:ea typeface="Calibri" pitchFamily="34" charset="-122"/>
-                          <a:cs typeface="Calibri" pitchFamily="34" charset="-120"/>
-                        </a:rPr>
-                        <a:t>32</a:t>
-                      </a:r>
-                      <a:endParaRPr lang="en-US" sz="1150" dirty="0">
-                        <a:latin typeface="Calibri" charset="0"/>
-                        <a:ea typeface="Calibri" charset="0"/>
-                        <a:cs typeface="Calibri" charset="0"/>
-                      </a:endParaRPr>
-                    </a:p>
-                  </a:txBody>
-                  <a:tcPr marL="91440" marR="91440" marT="45720" marB="45720">
-                    <a:lnL w="6350" cap="flat" cmpd="sng" algn="ctr">
-                      <a:solidFill>
-                        <a:srgbClr val="2A2E3B"/>
-                      </a:solidFill>
-                      <a:prstDash val="solid"/>
-                      <a:round/>
-                      <a:headEnd type="none" w="med" len="med"/>
-                      <a:tailEnd type="none" w="med" len="med"/>
-                    </a:lnL>
-                    <a:lnR w="6350" cap="flat" cmpd="sng" algn="ctr">
-                      <a:solidFill>
-                        <a:srgbClr val="2A2E3B"/>
-                      </a:solidFill>
-                      <a:prstDash val="solid"/>
-                      <a:round/>
-                      <a:headEnd type="none" w="med" len="med"/>
-                      <a:tailEnd type="none" w="med" len="med"/>
-                    </a:lnR>
-                    <a:lnT w="6350" cap="flat" cmpd="sng" algn="ctr">
-                      <a:solidFill>
-                        <a:srgbClr val="2A2E3B"/>
-                      </a:solidFill>
-                      <a:prstDash val="solid"/>
-                      <a:round/>
-                      <a:headEnd type="none" w="med" len="med"/>
-                      <a:tailEnd type="none" w="med" len="med"/>
-                    </a:lnT>
-                    <a:lnB w="6350" cap="flat" cmpd="sng" algn="ctr">
-                      <a:solidFill>
-                        <a:srgbClr val="2A2E3B"/>
-                      </a:solidFill>
-                      <a:prstDash val="solid"/>
-                      <a:round/>
-                      <a:headEnd type="none" w="med" len="med"/>
-                      <a:tailEnd type="none" w="med" len="med"/>
-                    </a:lnB>
-                    <a:solidFill>
-                      <a:srgbClr val="222632"/>
-                    </a:solidFill>
-                  </a:tcPr>
-                </a:tc>
-              </a:tr>
-              <a:tr h="310896">
-                <a:tc>
-                  <a:txBody>
-                    <a:bodyPr/>
-                    <a:lstStyle/>
-                    <a:p>
-                      <a:pPr indent="0" marL="0">
-                        <a:buNone/>
-                      </a:pPr>
-                      <a:r>
-                        <a:rPr lang="en-US" sz="1150" dirty="0">
-                          <a:solidFill>
-                            <a:srgbClr val="E4E6ED"/>
-                          </a:solidFill>
-                          <a:latin typeface="Calibri" pitchFamily="34" charset="0"/>
-                          <a:ea typeface="Calibri" pitchFamily="34" charset="-122"/>
-                          <a:cs typeface="Calibri" pitchFamily="34" charset="-120"/>
-                        </a:rPr>
-                        <a:t>Replies</a:t>
-                      </a:r>
-                      <a:endParaRPr lang="en-US" sz="1150" dirty="0">
-                        <a:latin typeface="Calibri" charset="0"/>
-                        <a:ea typeface="Calibri" charset="0"/>
-                        <a:cs typeface="Calibri" charset="0"/>
-                      </a:endParaRPr>
-                    </a:p>
-                  </a:txBody>
-                  <a:tcPr marL="91440" marR="91440" marT="45720" marB="45720">
-                    <a:lnL w="6350" cap="flat" cmpd="sng" algn="ctr">
-                      <a:solidFill>
-                        <a:srgbClr val="2A2E3B"/>
-                      </a:solidFill>
-                      <a:prstDash val="solid"/>
-                      <a:round/>
-                      <a:headEnd type="none" w="med" len="med"/>
-                      <a:tailEnd type="none" w="med" len="med"/>
-                    </a:lnL>
-                    <a:lnR w="6350" cap="flat" cmpd="sng" algn="ctr">
-                      <a:solidFill>
-                        <a:srgbClr val="2A2E3B"/>
-                      </a:solidFill>
-                      <a:prstDash val="solid"/>
-                      <a:round/>
-                      <a:headEnd type="none" w="med" len="med"/>
-                      <a:tailEnd type="none" w="med" len="med"/>
-                    </a:lnR>
-                    <a:lnT w="6350" cap="flat" cmpd="sng" algn="ctr">
-                      <a:solidFill>
-                        <a:srgbClr val="2A2E3B"/>
-                      </a:solidFill>
-                      <a:prstDash val="solid"/>
-                      <a:round/>
-                      <a:headEnd type="none" w="med" len="med"/>
-                      <a:tailEnd type="none" w="med" len="med"/>
-                    </a:lnT>
-                    <a:lnB w="6350" cap="flat" cmpd="sng" algn="ctr">
-                      <a:solidFill>
-                        <a:srgbClr val="2A2E3B"/>
-                      </a:solidFill>
-                      <a:prstDash val="solid"/>
-                      <a:round/>
-                      <a:headEnd type="none" w="med" len="med"/>
-                      <a:tailEnd type="none" w="med" len="med"/>
-                    </a:lnB>
-                    <a:solidFill>
-                      <a:srgbClr val="222632"/>
-                    </a:solidFill>
-                  </a:tcPr>
-                </a:tc>
-                <a:tc>
-                  <a:txBody>
-                    <a:bodyPr/>
-                    <a:lstStyle/>
-                    <a:p>
-                      <a:pPr algn="r" indent="0" marL="0">
-                        <a:buNone/>
-                      </a:pPr>
-                      <a:r>
-                        <a:rPr lang="en-US" sz="1150" dirty="0">
-                          <a:solidFill>
-                            <a:srgbClr val="8B8FA3"/>
-                          </a:solidFill>
-                          <a:latin typeface="Calibri" pitchFamily="34" charset="0"/>
-                          <a:ea typeface="Calibri" pitchFamily="34" charset="-122"/>
-                          <a:cs typeface="Calibri" pitchFamily="34" charset="-120"/>
-                        </a:rPr>
-                        <a:t>—</a:t>
-                      </a:r>
-                      <a:endParaRPr lang="en-US" sz="1150" dirty="0">
-                        <a:latin typeface="Calibri" charset="0"/>
-                        <a:ea typeface="Calibri" charset="0"/>
-                        <a:cs typeface="Calibri" charset="0"/>
-                      </a:endParaRPr>
-                    </a:p>
-                  </a:txBody>
-                  <a:tcPr marL="91440" marR="91440" marT="45720" marB="45720">
-                    <a:lnL w="6350" cap="flat" cmpd="sng" algn="ctr">
-                      <a:solidFill>
-                        <a:srgbClr val="2A2E3B"/>
-                      </a:solidFill>
-                      <a:prstDash val="solid"/>
-                      <a:round/>
-                      <a:headEnd type="none" w="med" len="med"/>
-                      <a:tailEnd type="none" w="med" len="med"/>
-                    </a:lnL>
-                    <a:lnR w="6350" cap="flat" cmpd="sng" algn="ctr">
-                      <a:solidFill>
-                        <a:srgbClr val="2A2E3B"/>
-                      </a:solidFill>
-                      <a:prstDash val="solid"/>
-                      <a:round/>
-                      <a:headEnd type="none" w="med" len="med"/>
-                      <a:tailEnd type="none" w="med" len="med"/>
-                    </a:lnR>
-                    <a:lnT w="6350" cap="flat" cmpd="sng" algn="ctr">
-                      <a:solidFill>
-                        <a:srgbClr val="2A2E3B"/>
-                      </a:solidFill>
-                      <a:prstDash val="solid"/>
-                      <a:round/>
-                      <a:headEnd type="none" w="med" len="med"/>
-                      <a:tailEnd type="none" w="med" len="med"/>
-                    </a:lnT>
-                    <a:lnB w="6350" cap="flat" cmpd="sng" algn="ctr">
-                      <a:solidFill>
-                        <a:srgbClr val="2A2E3B"/>
-                      </a:solidFill>
-                      <a:prstDash val="solid"/>
-                      <a:round/>
-                      <a:headEnd type="none" w="med" len="med"/>
-                      <a:tailEnd type="none" w="med" len="med"/>
-                    </a:lnB>
-                    <a:solidFill>
-                      <a:srgbClr val="222632"/>
-                    </a:solidFill>
-                  </a:tcPr>
-                </a:tc>
-                <a:tc>
-                  <a:txBody>
-                    <a:bodyPr/>
-                    <a:lstStyle/>
-                    <a:p>
-                      <a:pPr algn="r" indent="0" marL="0">
-                        <a:buNone/>
-                      </a:pPr>
-                      <a:r>
-                        <a:rPr lang="en-US" sz="1150" dirty="0">
-                          <a:solidFill>
-                            <a:srgbClr val="8B8FA3"/>
-                          </a:solidFill>
-                          <a:latin typeface="Calibri" pitchFamily="34" charset="0"/>
-                          <a:ea typeface="Calibri" pitchFamily="34" charset="-122"/>
-                          <a:cs typeface="Calibri" pitchFamily="34" charset="-120"/>
-                        </a:rPr>
-                        <a:t>2</a:t>
-                      </a:r>
-                      <a:endParaRPr lang="en-US" sz="1150" dirty="0">
-                        <a:latin typeface="Calibri" charset="0"/>
-                        <a:ea typeface="Calibri" charset="0"/>
-                        <a:cs typeface="Calibri" charset="0"/>
-                      </a:endParaRPr>
-                    </a:p>
-                  </a:txBody>
-                  <a:tcPr marL="91440" marR="91440" marT="45720" marB="45720">
-                    <a:lnL w="6350" cap="flat" cmpd="sng" algn="ctr">
-                      <a:solidFill>
-                        <a:srgbClr val="2A2E3B"/>
-                      </a:solidFill>
-                      <a:prstDash val="solid"/>
-                      <a:round/>
-                      <a:headEnd type="none" w="med" len="med"/>
-                      <a:tailEnd type="none" w="med" len="med"/>
-                    </a:lnL>
-                    <a:lnR w="6350" cap="flat" cmpd="sng" algn="ctr">
-                      <a:solidFill>
-                        <a:srgbClr val="2A2E3B"/>
-                      </a:solidFill>
-                      <a:prstDash val="solid"/>
-                      <a:round/>
-                      <a:headEnd type="none" w="med" len="med"/>
-                      <a:tailEnd type="none" w="med" len="med"/>
-                    </a:lnR>
-                    <a:lnT w="6350" cap="flat" cmpd="sng" algn="ctr">
-                      <a:solidFill>
-                        <a:srgbClr val="2A2E3B"/>
-                      </a:solidFill>
-                      <a:prstDash val="solid"/>
-                      <a:round/>
-                      <a:headEnd type="none" w="med" len="med"/>
-                      <a:tailEnd type="none" w="med" len="med"/>
-                    </a:lnT>
-                    <a:lnB w="6350" cap="flat" cmpd="sng" algn="ctr">
-                      <a:solidFill>
-                        <a:srgbClr val="2A2E3B"/>
-                      </a:solidFill>
-                      <a:prstDash val="solid"/>
-                      <a:round/>
-                      <a:headEnd type="none" w="med" len="med"/>
-                      <a:tailEnd type="none" w="med" len="med"/>
-                    </a:lnB>
-                    <a:solidFill>
-                      <a:srgbClr val="222632"/>
-                    </a:solidFill>
-                  </a:tcPr>
-                </a:tc>
-                <a:tc>
-                  <a:txBody>
-                    <a:bodyPr/>
-                    <a:lstStyle/>
-                    <a:p>
-                      <a:pPr algn="r" indent="0" marL="0">
-                        <a:buNone/>
-                      </a:pPr>
-                      <a:r>
-                        <a:rPr lang="en-US" sz="1150" b="1" dirty="0">
-                          <a:solidFill>
-                            <a:srgbClr val="E4E6ED"/>
-                          </a:solidFill>
-                          <a:latin typeface="Calibri" pitchFamily="34" charset="0"/>
-                          <a:ea typeface="Calibri" pitchFamily="34" charset="-122"/>
-                          <a:cs typeface="Calibri" pitchFamily="34" charset="-120"/>
-                        </a:rPr>
-                        <a:t>2</a:t>
-                      </a:r>
-                      <a:endParaRPr lang="en-US" sz="1150" dirty="0">
-                        <a:latin typeface="Calibri" charset="0"/>
-                        <a:ea typeface="Calibri" charset="0"/>
-                        <a:cs typeface="Calibri" charset="0"/>
-                      </a:endParaRPr>
-                    </a:p>
-                  </a:txBody>
-                  <a:tcPr marL="91440" marR="91440" marT="45720" marB="45720">
-                    <a:lnL w="6350" cap="flat" cmpd="sng" algn="ctr">
-                      <a:solidFill>
-                        <a:srgbClr val="2A2E3B"/>
-                      </a:solidFill>
-                      <a:prstDash val="solid"/>
-                      <a:round/>
-                      <a:headEnd type="none" w="med" len="med"/>
-                      <a:tailEnd type="none" w="med" len="med"/>
-                    </a:lnL>
-                    <a:lnR w="6350" cap="flat" cmpd="sng" algn="ctr">
-                      <a:solidFill>
-                        <a:srgbClr val="2A2E3B"/>
-                      </a:solidFill>
-                      <a:prstDash val="solid"/>
-                      <a:round/>
-                      <a:headEnd type="none" w="med" len="med"/>
-                      <a:tailEnd type="none" w="med" len="med"/>
-                    </a:lnR>
-                    <a:lnT w="6350" cap="flat" cmpd="sng" algn="ctr">
-                      <a:solidFill>
-                        <a:srgbClr val="2A2E3B"/>
-                      </a:solidFill>
-                      <a:prstDash val="solid"/>
-                      <a:round/>
-                      <a:headEnd type="none" w="med" len="med"/>
-                      <a:tailEnd type="none" w="med" len="med"/>
-                    </a:lnT>
-                    <a:lnB w="6350" cap="flat" cmpd="sng" algn="ctr">
-                      <a:solidFill>
-                        <a:srgbClr val="2A2E3B"/>
-                      </a:solidFill>
-                      <a:prstDash val="solid"/>
-                      <a:round/>
-                      <a:headEnd type="none" w="med" len="med"/>
-                      <a:tailEnd type="none" w="med" len="med"/>
-                    </a:lnB>
-                    <a:solidFill>
-                      <a:srgbClr val="222632"/>
-                    </a:solidFill>
-                  </a:tcPr>
-                </a:tc>
-              </a:tr>
             </a:tbl>
           </a:graphicData>
         </a:graphic>
@@ -23562,8 +23288,8 @@
         </p:nvSpPr>
         <p:spPr>
           <a:xfrm>
-            <a:off x="6400800" y="3675888"/>
-            <a:ext cx="5303520" cy="457200"/>
+            <a:off x="6400800" y="3200400"/>
+            <a:ext cx="5303520" cy="228600"/>
           </a:xfrm>
           <a:prstGeom prst="rect">
             <a:avLst/>
@@ -23579,21 +23305,7 @@
               <a:buNone/>
             </a:pPr>
             <a:r>
-              <a:rPr lang="en-US" sz="1100" b="1" dirty="0">
-                <a:solidFill>
-                  <a:srgbClr val="E4E6ED"/>
-                </a:solidFill>
-                <a:latin typeface="Calibri" pitchFamily="34" charset="0"/>
-                <a:ea typeface="Calibri" pitchFamily="34" charset="-122"/>
-                <a:cs typeface="Calibri" pitchFamily="34" charset="-120"/>
-              </a:rPr>
-              <a:t>Reply rate 0.6%</a:t>
-            </a:r>
-            <a:pPr indent="0" marL="0">
-              <a:buNone/>
-            </a:pPr>
-            <a:r>
-              <a:rPr lang="en-US" sz="1000" dirty="0">
+              <a:rPr lang="en-US" sz="1050" b="1" spc="100" kern="0" dirty="0">
                 <a:solidFill>
                   <a:srgbClr val="8B8FA3"/>
                 </a:solidFill>
@@ -23601,9 +23313,9 @@
                 <a:ea typeface="Calibri" pitchFamily="34" charset="-122"/>
                 <a:cs typeface="Calibri" pitchFamily="34" charset="-120"/>
               </a:rPr>
-              <a:t>  ·  HubSpot also: 62 meetings, 0 calls  ·  Tiers: Gold 3 (498) · Bronze 17 (1,115) · Prospect 12 (975)</a:t>
-            </a:r>
-            <a:endParaRPr lang="en-US" sz="1100" dirty="0"/>
+              <a:t>REPLY RATE — WARM (1:1) vs COLD (CADENCE)</a:t>
+            </a:r>
+            <a:endParaRPr lang="en-US" sz="1050" dirty="0"/>
           </a:p>
         </p:txBody>
       </p:sp>
@@ -23615,8 +23327,114 @@
         </p:nvSpPr>
         <p:spPr>
           <a:xfrm>
-            <a:off x="6400800" y="4224528"/>
-            <a:ext cx="5303520" cy="1143000"/>
+            <a:off x="6400800" y="3474720"/>
+            <a:ext cx="5303520" cy="256032"/>
+          </a:xfrm>
+          <a:prstGeom prst="rect">
+            <a:avLst/>
+          </a:prstGeom>
+          <a:noFill/>
+          <a:ln/>
+        </p:spPr>
+        <p:txBody>
+          <a:bodyPr wrap="square" rtlCol="0" anchor="ctr"/>
+          <a:lstStyle/>
+          <a:p>
+            <a:pPr indent="0" marL="0">
+              <a:buNone/>
+            </a:pPr>
+            <a:r>
+              <a:rPr lang="en-US" sz="1200" b="1" dirty="0">
+                <a:solidFill>
+                  <a:srgbClr val="00B894"/>
+                </a:solidFill>
+                <a:latin typeface="Calibri" pitchFamily="34" charset="0"/>
+                <a:ea typeface="Calibri" pitchFamily="34" charset="-122"/>
+                <a:cs typeface="Calibri" pitchFamily="34" charset="-120"/>
+              </a:rPr>
+              <a:t>● Warm · HubSpot 1:1:  ~30%</a:t>
+            </a:r>
+            <a:pPr indent="0" marL="0">
+              <a:buNone/>
+            </a:pPr>
+            <a:r>
+              <a:rPr lang="en-US" sz="1050" dirty="0">
+                <a:solidFill>
+                  <a:srgbClr val="8B8FA3"/>
+                </a:solidFill>
+                <a:latin typeface="Calibri" pitchFamily="34" charset="0"/>
+                <a:ea typeface="Calibri" pitchFamily="34" charset="-122"/>
+                <a:cs typeface="Calibri" pitchFamily="34" charset="-120"/>
+              </a:rPr>
+              <a:t>   93 replies on 313 sent</a:t>
+            </a:r>
+            <a:endParaRPr lang="en-US" sz="1200" dirty="0"/>
+          </a:p>
+        </p:txBody>
+      </p:sp>
+      <p:sp>
+        <p:nvSpPr>
+          <p:cNvPr id="14" name="Text 11"/>
+          <p:cNvSpPr/>
+          <p:nvPr/>
+        </p:nvSpPr>
+        <p:spPr>
+          <a:xfrm>
+            <a:off x="6400800" y="3767328"/>
+            <a:ext cx="5303520" cy="365760"/>
+          </a:xfrm>
+          <a:prstGeom prst="rect">
+            <a:avLst/>
+          </a:prstGeom>
+          <a:noFill/>
+          <a:ln/>
+        </p:spPr>
+        <p:txBody>
+          <a:bodyPr wrap="square" rtlCol="0" anchor="ctr"/>
+          <a:lstStyle/>
+          <a:p>
+            <a:pPr indent="0" marL="0">
+              <a:buNone/>
+            </a:pPr>
+            <a:r>
+              <a:rPr lang="en-US" sz="1200" b="1" dirty="0">
+                <a:solidFill>
+                  <a:srgbClr val="E17055"/>
+                </a:solidFill>
+                <a:latin typeface="Calibri" pitchFamily="34" charset="0"/>
+                <a:ea typeface="Calibri" pitchFamily="34" charset="-122"/>
+                <a:cs typeface="Calibri" pitchFamily="34" charset="-120"/>
+              </a:rPr>
+              <a:t>● Cold · CMS cadence:  0.6%</a:t>
+            </a:r>
+            <a:pPr indent="0" marL="0">
+              <a:buNone/>
+            </a:pPr>
+            <a:r>
+              <a:rPr lang="en-US" sz="1000" dirty="0">
+                <a:solidFill>
+                  <a:srgbClr val="8B8FA3"/>
+                </a:solidFill>
+                <a:latin typeface="Calibri" pitchFamily="34" charset="0"/>
+                <a:ea typeface="Calibri" pitchFamily="34" charset="-122"/>
+                <a:cs typeface="Calibri" pitchFamily="34" charset="-120"/>
+              </a:rPr>
+              <a:t>   2 replies · Gold 3 (498) · Bronze 17 (1,115) · Prospect 12 (975)</a:t>
+            </a:r>
+            <a:endParaRPr lang="en-US" sz="1200" dirty="0"/>
+          </a:p>
+        </p:txBody>
+      </p:sp>
+      <p:sp>
+        <p:nvSpPr>
+          <p:cNvPr id="15" name="Text 12"/>
+          <p:cNvSpPr/>
+          <p:nvPr/>
+        </p:nvSpPr>
+        <p:spPr>
+          <a:xfrm>
+            <a:off x="6400800" y="4206240"/>
+            <a:ext cx="5303520" cy="1188720"/>
           </a:xfrm>
           <a:prstGeom prst="rect">
             <a:avLst/>
@@ -23654,7 +23472,7 @@
                 <a:ea typeface="Calibri" pitchFamily="34" charset="-122"/>
                 <a:cs typeface="Calibri" pitchFamily="34" charset="-120"/>
               </a:rPr>
-              <a:t>3,487 total emails but low-yield — 427 reached, 0.6% reply, 2 replies — skewed to Bronze/Prospect (Gold just 3 accts). Cadence on autopilot; the KAM pivot redirects effort to the Gold base.</a:t>
+              <a:t>warm 1:1 emails reply ~50× the cold cadence (30% vs 0.6%). 3,487 sent but cold volume is near-dead and skewed to Bronze/Prospect — the KAM case for working warm Gold relationships, not cold volume.</a:t>
             </a:r>
             <a:endParaRPr lang="en-US" sz="1200" dirty="0"/>
           </a:p>
@@ -23662,7 +23480,7 @@
       </p:sp>
       <p:sp>
         <p:nvSpPr>
-          <p:cNvPr id="14" name="Shape 11"/>
+          <p:cNvPr id="16" name="Shape 13"/>
           <p:cNvSpPr/>
           <p:nvPr/>
         </p:nvSpPr>
@@ -23689,7 +23507,7 @@
       </p:sp>
       <p:sp>
         <p:nvSpPr>
-          <p:cNvPr id="15" name="Text 12"/>
+          <p:cNvPr id="17" name="Text 14"/>
           <p:cNvSpPr/>
           <p:nvPr/>
         </p:nvSpPr>

</xml_diff>

<commit_message>
S9: feature CMS account-level reply rate (6% — 2 of 32 accounts)
Co-Authored-By: Claude Opus 4.8 <noreply@anthropic.com>
</commit_message>
<xml_diff>
--- a/June_2026_NAM_MBR.pptx
+++ b/June_2026_NAM_MBR.pptx
@@ -23405,7 +23405,7 @@
                 <a:ea typeface="Calibri" pitchFamily="34" charset="-122"/>
                 <a:cs typeface="Calibri" pitchFamily="34" charset="-120"/>
               </a:rPr>
-              <a:t>● Cold · CMS cadence:  0.6%</a:t>
+              <a:t>● Cold · CMS cadence:  6% by account</a:t>
             </a:r>
             <a:pPr indent="0" marL="0">
               <a:buNone/>
@@ -23419,7 +23419,7 @@
                 <a:ea typeface="Calibri" pitchFamily="34" charset="-122"/>
                 <a:cs typeface="Calibri" pitchFamily="34" charset="-120"/>
               </a:rPr>
-              <a:t>   2 replies · Gold 3 (498) · Bronze 17 (1,115) · Prospect 12 (975)</a:t>
+              <a:t>   2 of 32 touched · 0.6% by contact</a:t>
             </a:r>
             <a:endParaRPr lang="en-US" sz="1200" dirty="0"/>
           </a:p>
@@ -23472,7 +23472,7 @@
                 <a:ea typeface="Calibri" pitchFamily="34" charset="-122"/>
                 <a:cs typeface="Calibri" pitchFamily="34" charset="-120"/>
               </a:rPr>
-              <a:t>warm 1:1 emails reply ~50× the cold cadence (30% vs 0.6%). 3,487 sent but cold volume is near-dead and skewed to Bronze/Prospect — the KAM case for working warm Gold relationships, not cold volume.</a:t>
+              <a:t>warm 1:1 replies ~30% vs cold cadence just ~6% of touched accounts (2 of 32). 3,487 emails sent but cold engagement is near-dead — the KAM case for working warm Gold relationships, not cold volume.</a:t>
             </a:r>
             <a:endParaRPr lang="en-US" sz="1200" dirty="0"/>
           </a:p>

</xml_diff>